<commit_message>
Rett justering, lesbarhet og filstørrelse i slidemalene
Funnet ved å rendre hver slide og se på dem, ikke ved å lese koden:

- Logoene hadde 12,5 % gjennomsiktig luft i sidene, så venstrekanten deres
  ikke sto på linje med teksten under. Luften klippes nå bort i
  prepare-media.py, og logoen plasseres etter synlig merke.
- Rød kicker over foto (forside og helflate-bilde) var for svak til å leses
  bakerst i salen. Satt til hvit.
- Bildene lå inne i full oppløsning: 39 MB fil. Beskjæres og skaleres nå til
  visningsstørrelse, 1,4 MB.
- Portrettene beskjæres litt over midten, ellers kuttet utsnittet ansiktene.
- Tallrekken og seksjonsskillet var topptunge, senket for balanse.

Nytt: contact-sheet.py setter alle slidene i ett rutenett, og export-pdf.ps1
lager PDF for deling til folk som mangler Replica-fonten.
</commit_message>
<xml_diff>
--- a/pptx-templates/Startuplab-slidemaler.pptx
+++ b/pptx-templates/Startuplab-slidemaler.pptx
@@ -2186,7 +2186,7 @@
             <a:r>
               <a:rPr lang="en-US" sz="1500" b="1" spc="250" kern="0" dirty="0">
                 <a:solidFill>
-                  <a:srgbClr val="FF3333"/>
+                  <a:srgbClr val="FFFFFF"/>
                 </a:solidFill>
                 <a:latin typeface="Inter" pitchFamily="34" charset="0"/>
                 <a:ea typeface="Inter" pitchFamily="34" charset="-122"/>
@@ -2276,7 +2276,7 @@
       </p:sp>
       <p:pic>
         <p:nvPicPr>
-          <p:cNvPr id="6" name="Image 1" descr="C:\Code\Work\startuplab-partner-presentation\brand-profile\logo\png\SL_signature_white.png">    </p:cNvPr>
+          <p:cNvPr id="6" name="Image 1" descr="C:\Code\Work\startuplab-partner-presentation\pptx-templates\media\logo-white.png">    </p:cNvPr>
           <p:cNvPicPr>
             <a:picLocks noChangeAspect="1"/>
           </p:cNvPicPr>
@@ -2291,7 +2291,7 @@
         <p:spPr>
           <a:xfrm>
             <a:off x="777240" y="6035040"/>
-            <a:ext cx="731056" cy="384048"/>
+            <a:ext cx="843006" cy="310896"/>
           </a:xfrm>
           <a:prstGeom prst="rect">
             <a:avLst/>
@@ -2526,7 +2526,7 @@
       </p:sp>
       <p:pic>
         <p:nvPicPr>
-          <p:cNvPr id="4" name="Image 0" descr="C:\Code\Work\startuplab-partner-presentation\brand-profile\logo\png\SL_signature_white.png">    </p:cNvPr>
+          <p:cNvPr id="4" name="Image 0" descr="C:\Code\Work\startuplab-partner-presentation\pptx-templates\media\logo-white.png">    </p:cNvPr>
           <p:cNvPicPr>
             <a:picLocks noChangeAspect="1"/>
           </p:cNvPicPr>
@@ -2541,7 +2541,7 @@
         <p:spPr>
           <a:xfrm>
             <a:off x="777240" y="6035040"/>
-            <a:ext cx="731056" cy="384048"/>
+            <a:ext cx="843006" cy="310896"/>
           </a:xfrm>
           <a:prstGeom prst="rect">
             <a:avLst/>
@@ -2725,7 +2725,7 @@
       </p:pic>
       <p:pic>
         <p:nvPicPr>
-          <p:cNvPr id="6" name="Image 1" descr="C:\Code\Work\startuplab-partner-presentation\brand-profile\logo\png\SL_signature_red.png">    </p:cNvPr>
+          <p:cNvPr id="6" name="Image 1" descr="C:\Code\Work\startuplab-partner-presentation\pptx-templates\media\logo-red.png">    </p:cNvPr>
           <p:cNvPicPr>
             <a:picLocks noChangeAspect="1"/>
           </p:cNvPicPr>
@@ -2740,7 +2740,7 @@
         <p:spPr>
           <a:xfrm>
             <a:off x="777240" y="6035040"/>
-            <a:ext cx="731056" cy="384048"/>
+            <a:ext cx="843006" cy="310896"/>
           </a:xfrm>
           <a:prstGeom prst="rect">
             <a:avLst/>
@@ -3342,7 +3342,7 @@
       </p:sp>
       <p:pic>
         <p:nvPicPr>
-          <p:cNvPr id="16" name="Image 0" descr="C:\Code\Work\startuplab-partner-presentation\brand-profile\logo\png\SL_signature_red.png">    </p:cNvPr>
+          <p:cNvPr id="16" name="Image 0" descr="C:\Code\Work\startuplab-partner-presentation\pptx-templates\media\logo-red.png">    </p:cNvPr>
           <p:cNvPicPr>
             <a:picLocks noChangeAspect="1"/>
           </p:cNvPicPr>
@@ -3357,7 +3357,7 @@
         <p:spPr>
           <a:xfrm>
             <a:off x="777240" y="6035040"/>
-            <a:ext cx="731056" cy="384048"/>
+            <a:ext cx="843006" cy="310896"/>
           </a:xfrm>
           <a:prstGeom prst="rect">
             <a:avLst/>
@@ -3964,7 +3964,7 @@
       </p:sp>
       <p:pic>
         <p:nvPicPr>
-          <p:cNvPr id="17" name="Image 3" descr="C:\Code\Work\startuplab-partner-presentation\brand-profile\logo\png\SL_signature_red.png">    </p:cNvPr>
+          <p:cNvPr id="17" name="Image 3" descr="C:\Code\Work\startuplab-partner-presentation\pptx-templates\media\logo-red.png">    </p:cNvPr>
           <p:cNvPicPr>
             <a:picLocks noChangeAspect="1"/>
           </p:cNvPicPr>
@@ -3979,7 +3979,7 @@
         <p:spPr>
           <a:xfrm>
             <a:off x="777240" y="6035040"/>
-            <a:ext cx="731056" cy="384048"/>
+            <a:ext cx="843006" cy="310896"/>
           </a:xfrm>
           <a:prstGeom prst="rect">
             <a:avLst/>
@@ -4172,7 +4172,7 @@
       </p:sp>
       <p:pic>
         <p:nvPicPr>
-          <p:cNvPr id="7" name="Image 0" descr="C:\Code\Work\startuplab-partner-presentation\brand-profile\logo\png\SL_signature_white.png">    </p:cNvPr>
+          <p:cNvPr id="7" name="Image 0" descr="C:\Code\Work\startuplab-partner-presentation\pptx-templates\media\logo-white.png">    </p:cNvPr>
           <p:cNvPicPr>
             <a:picLocks noChangeAspect="1"/>
           </p:cNvPicPr>
@@ -4187,7 +4187,7 @@
         <p:spPr>
           <a:xfrm>
             <a:off x="777240" y="6035040"/>
-            <a:ext cx="731056" cy="384048"/>
+            <a:ext cx="843006" cy="310896"/>
           </a:xfrm>
           <a:prstGeom prst="rect">
             <a:avLst/>
@@ -4228,7 +4228,7 @@
       </p:grpSpPr>
       <p:pic>
         <p:nvPicPr>
-          <p:cNvPr id="2" name="Image 0" descr="C:\Code\Work\startuplab-partner-presentation\brand-profile\logo\png\SL_signature_white.png">    </p:cNvPr>
+          <p:cNvPr id="2" name="Image 0" descr="C:\Code\Work\startuplab-partner-presentation\pptx-templates\media\logo-white.png">    </p:cNvPr>
           <p:cNvPicPr>
             <a:picLocks noChangeAspect="1"/>
           </p:cNvPicPr>
@@ -4243,7 +4243,7 @@
         <p:spPr>
           <a:xfrm>
             <a:off x="777240" y="2331720"/>
-            <a:ext cx="4206240" cy="2209678"/>
+            <a:ext cx="4206240" cy="1551237"/>
           </a:xfrm>
           <a:prstGeom prst="rect">
             <a:avLst/>
@@ -4911,7 +4911,7 @@
       </p:sp>
       <p:pic>
         <p:nvPicPr>
-          <p:cNvPr id="16" name="Image 0" descr="C:\Code\Work\startuplab-partner-presentation\brand-profile\logo\png\SL_signature_red.png">    </p:cNvPr>
+          <p:cNvPr id="16" name="Image 0" descr="C:\Code\Work\startuplab-partner-presentation\pptx-templates\media\logo-red.png">    </p:cNvPr>
           <p:cNvPicPr>
             <a:picLocks noChangeAspect="1"/>
           </p:cNvPicPr>
@@ -4926,7 +4926,7 @@
         <p:spPr>
           <a:xfrm>
             <a:off x="777240" y="6035040"/>
-            <a:ext cx="731056" cy="384048"/>
+            <a:ext cx="843006" cy="310896"/>
           </a:xfrm>
           <a:prstGeom prst="rect">
             <a:avLst/>
@@ -5068,7 +5068,7 @@
       </p:sp>
       <p:pic>
         <p:nvPicPr>
-          <p:cNvPr id="4" name="Image 0" descr="C:\Code\Work\startuplab-partner-presentation\brand-profile\logo\png\SL_signature_white.png">    </p:cNvPr>
+          <p:cNvPr id="4" name="Image 0" descr="C:\Code\Work\startuplab-partner-presentation\pptx-templates\media\logo-white.png">    </p:cNvPr>
           <p:cNvPicPr>
             <a:picLocks noChangeAspect="1"/>
           </p:cNvPicPr>
@@ -5083,7 +5083,7 @@
         <p:spPr>
           <a:xfrm>
             <a:off x="777240" y="6035040"/>
-            <a:ext cx="731056" cy="384048"/>
+            <a:ext cx="843006" cy="310896"/>
           </a:xfrm>
           <a:prstGeom prst="rect">
             <a:avLst/>
@@ -5309,7 +5309,7 @@
       </p:sp>
       <p:pic>
         <p:nvPicPr>
-          <p:cNvPr id="6" name="Image 0" descr="C:\Code\Work\startuplab-partner-presentation\brand-profile\logo\png\SL_signature_white.png">    </p:cNvPr>
+          <p:cNvPr id="6" name="Image 0" descr="C:\Code\Work\startuplab-partner-presentation\pptx-templates\media\logo-white.png">    </p:cNvPr>
           <p:cNvPicPr>
             <a:picLocks noChangeAspect="1"/>
           </p:cNvPicPr>
@@ -5324,7 +5324,7 @@
         <p:spPr>
           <a:xfrm>
             <a:off x="777240" y="6035040"/>
-            <a:ext cx="731056" cy="384048"/>
+            <a:ext cx="843006" cy="310896"/>
           </a:xfrm>
           <a:prstGeom prst="rect">
             <a:avLst/>
@@ -5732,7 +5732,7 @@
       </p:sp>
       <p:pic>
         <p:nvPicPr>
-          <p:cNvPr id="10" name="Image 0" descr="C:\Code\Work\startuplab-partner-presentation\brand-profile\logo\png\SL_signature_red.png">    </p:cNvPr>
+          <p:cNvPr id="10" name="Image 0" descr="C:\Code\Work\startuplab-partner-presentation\pptx-templates\media\logo-red.png">    </p:cNvPr>
           <p:cNvPicPr>
             <a:picLocks noChangeAspect="1"/>
           </p:cNvPicPr>
@@ -5747,7 +5747,7 @@
         <p:spPr>
           <a:xfrm>
             <a:off x="777240" y="6035040"/>
-            <a:ext cx="731056" cy="384048"/>
+            <a:ext cx="843006" cy="310896"/>
           </a:xfrm>
           <a:prstGeom prst="rect">
             <a:avLst/>
@@ -5851,7 +5851,7 @@
             <a:r>
               <a:rPr lang="en-US" sz="1500" b="1" spc="250" kern="0" dirty="0">
                 <a:solidFill>
-                  <a:srgbClr val="FF3333"/>
+                  <a:srgbClr val="FFFFFF"/>
                 </a:solidFill>
                 <a:latin typeface="Inter" pitchFamily="34" charset="0"/>
                 <a:ea typeface="Inter" pitchFamily="34" charset="-122"/>
@@ -5927,7 +5927,7 @@
       </p:sp>
       <p:pic>
         <p:nvPicPr>
-          <p:cNvPr id="6" name="Image 1" descr="C:\Code\Work\startuplab-partner-presentation\brand-profile\logo\png\SL_signature_white.png">    </p:cNvPr>
+          <p:cNvPr id="6" name="Image 1" descr="C:\Code\Work\startuplab-partner-presentation\pptx-templates\media\logo-white.png">    </p:cNvPr>
           <p:cNvPicPr>
             <a:picLocks noChangeAspect="1"/>
           </p:cNvPicPr>
@@ -5942,7 +5942,7 @@
         <p:spPr>
           <a:xfrm>
             <a:off x="777240" y="6035040"/>
-            <a:ext cx="731056" cy="384048"/>
+            <a:ext cx="843006" cy="310896"/>
           </a:xfrm>
           <a:prstGeom prst="rect">
             <a:avLst/>
@@ -6166,7 +6166,7 @@
       </p:sp>
       <p:pic>
         <p:nvPicPr>
-          <p:cNvPr id="6" name="Image 1" descr="C:\Code\Work\startuplab-partner-presentation\brand-profile\logo\png\SL_signature_red.png">    </p:cNvPr>
+          <p:cNvPr id="6" name="Image 1" descr="C:\Code\Work\startuplab-partner-presentation\pptx-templates\media\logo-red.png">    </p:cNvPr>
           <p:cNvPicPr>
             <a:picLocks noChangeAspect="1"/>
           </p:cNvPicPr>
@@ -6181,7 +6181,7 @@
         <p:spPr>
           <a:xfrm>
             <a:off x="777240" y="6035040"/>
-            <a:ext cx="731056" cy="384048"/>
+            <a:ext cx="843006" cy="310896"/>
           </a:xfrm>
           <a:prstGeom prst="rect">
             <a:avLst/>
@@ -6740,7 +6740,7 @@
       </p:sp>
       <p:pic>
         <p:nvPicPr>
-          <p:cNvPr id="19" name="Image 5" descr="C:\Code\Work\startuplab-partner-presentation\brand-profile\logo\png\SL_signature_white.png">    </p:cNvPr>
+          <p:cNvPr id="19" name="Image 5" descr="C:\Code\Work\startuplab-partner-presentation\pptx-templates\media\logo-white.png">    </p:cNvPr>
           <p:cNvPicPr>
             <a:picLocks noChangeAspect="1"/>
           </p:cNvPicPr>
@@ -6755,7 +6755,7 @@
         <p:spPr>
           <a:xfrm>
             <a:off x="777240" y="6035040"/>
-            <a:ext cx="731056" cy="384048"/>
+            <a:ext cx="843006" cy="310896"/>
           </a:xfrm>
           <a:prstGeom prst="rect">
             <a:avLst/>
@@ -7614,7 +7614,7 @@
       </p:sp>
       <p:pic>
         <p:nvPicPr>
-          <p:cNvPr id="22" name="Image 0" descr="C:\Code\Work\startuplab-partner-presentation\brand-profile\logo\png\SL_signature_red.png">    </p:cNvPr>
+          <p:cNvPr id="22" name="Image 0" descr="C:\Code\Work\startuplab-partner-presentation\pptx-templates\media\logo-red.png">    </p:cNvPr>
           <p:cNvPicPr>
             <a:picLocks noChangeAspect="1"/>
           </p:cNvPicPr>
@@ -7629,7 +7629,7 @@
         <p:spPr>
           <a:xfrm>
             <a:off x="777240" y="6035040"/>
-            <a:ext cx="731056" cy="384048"/>
+            <a:ext cx="843006" cy="310896"/>
           </a:xfrm>
           <a:prstGeom prst="rect">
             <a:avLst/>

</xml_diff>

<commit_message>
Legg til bilderad-mal med tre store liggende bilder
Overskrift, tre liggende hovedbilder på rad og bildetekst under hvert.
Teksten ligger under bildet, ikke oppå, så den beholder full kontrast og kan
leses fra bakerste rad: overskrift 20pt hvit, forklaring 18pt grå.

Mørk bakgrunn med vilje. Den bryter opp tre lyse slides på rad midt i settet,
og hvit tekst på nær-sort gir høyere kontrast enn grå på hvitt.

prepare-media.py harmoniserer nå i to styrker: programkortene trekkes helt til
felles toneleie fordi de skal være en dempet, ensartet rad, mens hovedbildene
bare trekkes 60 prosent av veien. Trekkes et kveldsbilde helt opp til snittet,
blir det flatt.
</commit_message>
<xml_diff>
--- a/pptx-templates/Startuplab-slidemaler.pptx
+++ b/pptx-templates/Startuplab-slidemaler.pptx
@@ -20,9 +20,10 @@
     <p:sldId id="268" r:id="rId14"/>
     <p:sldId id="269" r:id="rId15"/>
     <p:sldId id="270" r:id="rId16"/>
+    <p:sldId id="271" r:id="rId17"/>
   </p:sldIdLst>
   <p:notesMasterIdLst>
-    <p:notesMasterId r:id="rId17"/>
+    <p:notesMasterId r:id="rId18"/>
   </p:notesMasterIdLst>
   <p:sldSz cx="12192000" cy="6858000"/>
   <p:notesSz cx="6858000" cy="12192000"/>
@@ -780,7 +781,7 @@
           <a:p>
             <a:r>
               <a:rPr lang="en-US" dirty="0"/>
-              <a:t>PROSESS. Det røde tallet viser hvor i løpet du er. Flytt den røde fargen til neste steg hvis du gjenbruker sliden lenger ut i presentasjonen.</a:t>
+              <a:t>BILDERAD. Bildeteksten ligger under bildet, ikke oppå det, nettopp for å være lesbar fra bakerste rad. Overskriften i hvitt er 20 pt, forklaringen 18 pt. Bytt bilde: høyreklikk &gt; Endre bilde, utsnittet beholdes. Vil du ha fire bilder i stedet for tre: marker et bilde med tekstene under, kopier settet, og sett bildebredden til 2,6 tommer på alle fire. Hold forklaringen til to linjer, ellers treffer den logoen. Kjør prepare-media.py på nye bilder, så legges de i samme lysstyrke som de andre.</a:t>
             </a:r>
             <a:endParaRPr lang="en-US" dirty="0"/>
           </a:p>
@@ -868,7 +869,7 @@
           <a:p>
             <a:r>
               <a:rPr lang="en-US" dirty="0"/>
-              <a:t>FOLK. Fire portretter spenner fra marg til marg. Bytt portrett: høyreklikk &gt; Endre bilde, den runde masken følger med. Den grå sirkelen er en ledig plass. Sjekk at rollene stemmer før du presenterer.</a:t>
+              <a:t>PROSESS. Det røde tallet viser hvor i løpet du er. Flytt den røde fargen til neste steg hvis du gjenbruker sliden lenger ut i presentasjonen.</a:t>
             </a:r>
             <a:endParaRPr lang="en-US" dirty="0"/>
           </a:p>
@@ -956,7 +957,7 @@
           <a:p>
             <a:r>
               <a:rPr lang="en-US" dirty="0"/>
-              <a:t>FILM. Slik legger du inn filmen: Sett inn &gt; Video &gt; Denne enheten. Dra filmen så den dekker hele flaten, høyreklikk &gt; Send bakover slik at tittelen og avspillingsmerket blir liggende oppå. Under Avspilling velger du Start automatisk hvis den skal gå av seg selv. Slett den røde sirkelen og trekanten når den ekte filmen er på plass.</a:t>
+              <a:t>FOLK. Fire portretter spenner fra marg til marg. Bytt portrett: høyreklikk &gt; Endre bilde, den runde masken følger med. Den grå sirkelen er en ledig plass. Sjekk at rollene stemmer før du presenterer.</a:t>
             </a:r>
             <a:endParaRPr lang="en-US" dirty="0"/>
           </a:p>
@@ -1044,7 +1045,7 @@
           <a:p>
             <a:r>
               <a:rPr lang="en-US" dirty="0"/>
-              <a:t>AVSLUTNING. La den stå på skjermen mens du tar spørsmål. Legg til e-post eller kontaktperson på linjen under nettadressen hvis salen skal kunne følge opp.</a:t>
+              <a:t>FILM. Slik legger du inn filmen: Sett inn &gt; Video &gt; Denne enheten. Dra filmen så den dekker hele flaten, høyreklikk &gt; Send bakover slik at tittelen og avspillingsmerket blir liggende oppå. Under Avspilling velger du Start automatisk hvis den skal gå av seg selv. Slett den røde sirkelen og trekanten når den ekte filmen er på plass.</a:t>
             </a:r>
             <a:endParaRPr lang="en-US" dirty="0"/>
           </a:p>
@@ -1068,6 +1069,94 @@
             <a:fld id="{F7021451-1387-4CA6-816F-3879F97B5CBC}" type="slidenum">
               <a:rPr lang="en-US"/>
               <a:t>15</a:t>
+            </a:fld>
+            <a:endParaRPr lang="en-US"/>
+          </a:p>
+        </p:txBody>
+      </p:sp>
+    </p:spTree>
+    <p:extLst>
+      <p:ext uri="{BB962C8B-B14F-4D97-AF65-F5344CB8AC3E}">
+        <p14:creationId xmlns:p14="http://schemas.microsoft.com/office/powerpoint/2010/main" val="1024086991"/>
+      </p:ext>
+    </p:extLst>
+  </p:cSld>
+  <p:clrMapOvr>
+    <a:masterClrMapping/>
+  </p:clrMapOvr>
+</p:notes>
+</file>
+
+<file path=ppt/notesSlides/notesSlide16.xml><?xml version="1.0" encoding="utf-8"?>
+<p:notes xmlns:a="http://schemas.openxmlformats.org/drawingml/2006/main" xmlns:r="http://schemas.openxmlformats.org/officeDocument/2006/relationships" xmlns:p="http://schemas.openxmlformats.org/presentationml/2006/main">
+  <p:cSld>
+    <p:spTree>
+      <p:nvGrpSpPr>
+        <p:cNvPr id="1" name=""/>
+        <p:cNvGrpSpPr/>
+        <p:nvPr/>
+      </p:nvGrpSpPr>
+      <p:grpSpPr>
+        <a:xfrm>
+          <a:off x="0" y="0"/>
+          <a:ext cx="0" cy="0"/>
+          <a:chOff x="0" y="0"/>
+          <a:chExt cx="0" cy="0"/>
+        </a:xfrm>
+      </p:grpSpPr>
+      <p:sp>
+        <p:nvSpPr>
+          <p:cNvPr id="2" name="Slide Image Placeholder 1"/>
+          <p:cNvSpPr>
+            <a:spLocks noGrp="1" noRot="1" noChangeAspect="1"/>
+          </p:cNvSpPr>
+          <p:nvPr>
+            <p:ph type="sldImg"/>
+          </p:nvPr>
+        </p:nvSpPr>
+        <p:spPr/>
+      </p:sp>
+      <p:sp>
+        <p:nvSpPr>
+          <p:cNvPr id="3" name="Notes Placeholder 2"/>
+          <p:cNvSpPr>
+            <a:spLocks noGrp="1"/>
+          </p:cNvSpPr>
+          <p:nvPr>
+            <p:ph type="body" idx="1"/>
+          </p:nvPr>
+        </p:nvSpPr>
+        <p:spPr/>
+        <p:txBody>
+          <a:bodyPr/>
+          <a:lstStyle/>
+          <a:p>
+            <a:r>
+              <a:rPr lang="en-US" dirty="0"/>
+              <a:t>AVSLUTNING. La den stå på skjermen mens du tar spørsmål. Legg til e-post eller kontaktperson på linjen under nettadressen hvis salen skal kunne følge opp.</a:t>
+            </a:r>
+            <a:endParaRPr lang="en-US" dirty="0"/>
+          </a:p>
+        </p:txBody>
+      </p:sp>
+      <p:sp>
+        <p:nvSpPr>
+          <p:cNvPr id="4" name="Slide Number Placeholder 3"/>
+          <p:cNvSpPr>
+            <a:spLocks noGrp="1"/>
+          </p:cNvSpPr>
+          <p:nvPr>
+            <p:ph type="sldNum" sz="quarter" idx="10"/>
+          </p:nvPr>
+        </p:nvSpPr>
+        <p:spPr/>
+        <p:txBody>
+          <a:bodyPr/>
+          <a:lstStyle/>
+          <a:p>
+            <a:fld id="{F7021451-1387-4CA6-816F-3879F97B5CBC}" type="slidenum">
+              <a:rPr lang="en-US"/>
+              <a:t>16</a:t>
             </a:fld>
             <a:endParaRPr lang="en-US"/>
           </a:p>
@@ -2825,7 +2914,7 @@
     <p:bg>
       <p:bgPr>
         <a:solidFill>
-          <a:srgbClr val="FFFFFF"/>
+          <a:srgbClr val="131415"/>
         </a:solidFill>
       </p:bgPr>
     </p:bg>
@@ -2876,7 +2965,7 @@
                 <a:ea typeface="Inter" pitchFamily="34" charset="-122"/>
                 <a:cs typeface="Inter" pitchFamily="34" charset="-120"/>
               </a:rPr>
-              <a:t>SLIK GÅR VI FREM</a:t>
+              <a:t>ÅRET I BILDER</a:t>
             </a:r>
             <a:endParaRPr lang="en-US" sz="1600" dirty="0"/>
           </a:p>
@@ -2912,106 +3001,107 @@
             <a:r>
               <a:rPr lang="en-US" sz="4000" b="1" dirty="0">
                 <a:solidFill>
-                  <a:srgbClr val="131415"/>
+                  <a:srgbClr val="FFFFFF"/>
                 </a:solidFill>
                 <a:latin typeface="Replica LL TT" pitchFamily="34" charset="0"/>
                 <a:ea typeface="Replica LL TT" pitchFamily="34" charset="-122"/>
                 <a:cs typeface="Replica LL TT" pitchFamily="34" charset="-120"/>
               </a:rPr>
-              <a:t>Fire steg fra idé til pilot</a:t>
-            </a:r>
-            <a:endParaRPr lang="en-US" sz="4000" dirty="0"/>
-          </a:p>
-        </p:txBody>
-      </p:sp>
-      <p:sp>
-        <p:nvSpPr>
-          <p:cNvPr id="4" name="Text 2"/>
-          <p:cNvSpPr/>
-          <p:nvPr/>
-        </p:nvSpPr>
-        <p:spPr>
-          <a:xfrm>
-            <a:off x="777240" y="2423160"/>
-            <a:ext cx="2247824" cy="914400"/>
-          </a:xfrm>
-          <a:prstGeom prst="rect">
-            <a:avLst/>
-          </a:prstGeom>
-          <a:noFill/>
-          <a:ln/>
-        </p:spPr>
-        <p:txBody>
-          <a:bodyPr wrap="square" lIns="0" tIns="0" rIns="0" bIns="0" rtlCol="0" anchor="t"/>
-          <a:lstStyle/>
-          <a:p>
-            <a:pPr indent="0" marL="0">
-              <a:buNone/>
-            </a:pPr>
-            <a:r>
-              <a:rPr lang="en-US" sz="5600" dirty="0">
+              <a:t>Tre øyeblikk fra </a:t>
+            </a:r>
+            <a:pPr indent="0" marL="0">
+              <a:lnSpc>
+                <a:spcPct val="100000"/>
+              </a:lnSpc>
+              <a:buNone/>
+            </a:pPr>
+            <a:r>
+              <a:rPr lang="en-US" sz="4000" b="1" dirty="0">
                 <a:solidFill>
                   <a:srgbClr val="FF3333"/>
-                </a:solidFill>
-                <a:latin typeface="Replica LL TT Heavy" pitchFamily="34" charset="0"/>
-                <a:ea typeface="Replica LL TT Heavy" pitchFamily="34" charset="-122"/>
-                <a:cs typeface="Replica LL TT Heavy" pitchFamily="34" charset="-120"/>
-              </a:rPr>
-              <a:t>01</a:t>
-            </a:r>
-            <a:endParaRPr lang="en-US" sz="5600" dirty="0"/>
-          </a:p>
-        </p:txBody>
-      </p:sp>
-      <p:sp>
-        <p:nvSpPr>
-          <p:cNvPr id="5" name="Text 3"/>
-          <p:cNvSpPr/>
-          <p:nvPr/>
-        </p:nvSpPr>
-        <p:spPr>
-          <a:xfrm>
-            <a:off x="777240" y="3355848"/>
-            <a:ext cx="2247824" cy="457200"/>
-          </a:xfrm>
-          <a:prstGeom prst="rect">
-            <a:avLst/>
-          </a:prstGeom>
-          <a:noFill/>
-          <a:ln/>
-        </p:spPr>
-        <p:txBody>
-          <a:bodyPr wrap="square" lIns="0" tIns="0" rIns="0" bIns="0" rtlCol="0" anchor="ctr"/>
-          <a:lstStyle/>
-          <a:p>
-            <a:pPr indent="0" marL="0">
-              <a:buNone/>
-            </a:pPr>
-            <a:r>
-              <a:rPr lang="en-US" sz="2500" b="1" dirty="0">
-                <a:solidFill>
-                  <a:srgbClr val="131415"/>
                 </a:solidFill>
                 <a:latin typeface="Replica LL TT" pitchFamily="34" charset="0"/>
                 <a:ea typeface="Replica LL TT" pitchFamily="34" charset="-122"/>
                 <a:cs typeface="Replica LL TT" pitchFamily="34" charset="-120"/>
               </a:rPr>
-              <a:t>Kartlegg</a:t>
-            </a:r>
-            <a:endParaRPr lang="en-US" sz="2500" dirty="0"/>
-          </a:p>
-        </p:txBody>
-      </p:sp>
-      <p:sp>
-        <p:nvSpPr>
-          <p:cNvPr id="6" name="Text 4"/>
-          <p:cNvSpPr/>
-          <p:nvPr/>
-        </p:nvSpPr>
-        <p:spPr>
-          <a:xfrm>
-            <a:off x="777240" y="3840480"/>
-            <a:ext cx="2247824" cy="1005840"/>
+              <a:t>2025</a:t>
+            </a:r>
+            <a:endParaRPr lang="en-US" sz="4000" dirty="0"/>
+          </a:p>
+        </p:txBody>
+      </p:sp>
+      <p:pic>
+        <p:nvPicPr>
+          <p:cNvPr id="4" name="Image 0" descr="C:\Code\Work\startuplab-partner-presentation\pptx-templates\media\row-1.jpg">    </p:cNvPr>
+          <p:cNvPicPr>
+            <a:picLocks noChangeAspect="1"/>
+          </p:cNvPicPr>
+          <p:nvPr/>
+        </p:nvPicPr>
+        <p:blipFill>
+          <a:blip r:embed="rId1"/>
+          <a:srcRect l="0" r="0" t="0" b="0"/>
+          <a:stretch/>
+        </p:blipFill>
+        <p:spPr>
+          <a:xfrm>
+            <a:off x="777240" y="2240280"/>
+            <a:ext cx="3301898" cy="2201266"/>
+          </a:xfrm>
+          <a:prstGeom prst="rect">
+            <a:avLst/>
+          </a:prstGeom>
+        </p:spPr>
+      </p:pic>
+      <p:sp>
+        <p:nvSpPr>
+          <p:cNvPr id="5" name="Text 2"/>
+          <p:cNvSpPr/>
+          <p:nvPr/>
+        </p:nvSpPr>
+        <p:spPr>
+          <a:xfrm>
+            <a:off x="777240" y="4624426"/>
+            <a:ext cx="3301898" cy="420624"/>
+          </a:xfrm>
+          <a:prstGeom prst="rect">
+            <a:avLst/>
+          </a:prstGeom>
+          <a:noFill/>
+          <a:ln/>
+        </p:spPr>
+        <p:txBody>
+          <a:bodyPr wrap="square" lIns="0" tIns="0" rIns="0" bIns="0" rtlCol="0" anchor="ctr"/>
+          <a:lstStyle/>
+          <a:p>
+            <a:pPr indent="0" marL="0">
+              <a:buNone/>
+            </a:pPr>
+            <a:r>
+              <a:rPr lang="en-US" sz="2000" b="1" dirty="0">
+                <a:solidFill>
+                  <a:srgbClr val="FFFFFF"/>
+                </a:solidFill>
+                <a:latin typeface="Replica LL TT" pitchFamily="34" charset="0"/>
+                <a:ea typeface="Replica LL TT" pitchFamily="34" charset="-122"/>
+                <a:cs typeface="Replica LL TT" pitchFamily="34" charset="-120"/>
+              </a:rPr>
+              <a:t>Fullt hus</a:t>
+            </a:r>
+            <a:endParaRPr lang="en-US" sz="2000" dirty="0"/>
+          </a:p>
+        </p:txBody>
+      </p:sp>
+      <p:sp>
+        <p:nvSpPr>
+          <p:cNvPr id="6" name="Text 3"/>
+          <p:cNvSpPr/>
+          <p:nvPr/>
+        </p:nvSpPr>
+        <p:spPr>
+          <a:xfrm>
+            <a:off x="777240" y="5063338"/>
+            <a:ext cx="3301898" cy="658368"/>
           </a:xfrm>
           <a:prstGeom prst="rect">
             <a:avLst/>
@@ -3032,67 +3122,51 @@
             <a:r>
               <a:rPr lang="en-US" sz="1800" dirty="0">
                 <a:solidFill>
-                  <a:srgbClr val="5A6166"/>
+                  <a:srgbClr val="9BA1A5"/>
                 </a:solidFill>
                 <a:latin typeface="Inter" pitchFamily="34" charset="0"/>
                 <a:ea typeface="Inter" pitchFamily="34" charset="-122"/>
                 <a:cs typeface="Inter" pitchFamily="34" charset="-120"/>
               </a:rPr>
-              <a:t>Vi finner utfordringen som er verdt å løse.</a:t>
+              <a:t>Over 400 deltakere på Demo Day i Forskningsparken.</a:t>
             </a:r>
             <a:endParaRPr lang="en-US" sz="1800" dirty="0"/>
           </a:p>
         </p:txBody>
       </p:sp>
-      <p:sp>
-        <p:nvSpPr>
-          <p:cNvPr id="7" name="Text 5"/>
-          <p:cNvSpPr/>
-          <p:nvPr/>
-        </p:nvSpPr>
-        <p:spPr>
-          <a:xfrm>
-            <a:off x="3573704" y="2423160"/>
-            <a:ext cx="2247824" cy="914400"/>
-          </a:xfrm>
-          <a:prstGeom prst="rect">
-            <a:avLst/>
-          </a:prstGeom>
-          <a:noFill/>
-          <a:ln/>
-        </p:spPr>
-        <p:txBody>
-          <a:bodyPr wrap="square" lIns="0" tIns="0" rIns="0" bIns="0" rtlCol="0" anchor="t"/>
-          <a:lstStyle/>
-          <a:p>
-            <a:pPr indent="0" marL="0">
-              <a:buNone/>
-            </a:pPr>
-            <a:r>
-              <a:rPr lang="en-US" sz="5600" dirty="0">
-                <a:solidFill>
-                  <a:srgbClr val="5A6166"/>
-                </a:solidFill>
-                <a:latin typeface="Replica LL TT Heavy" pitchFamily="34" charset="0"/>
-                <a:ea typeface="Replica LL TT Heavy" pitchFamily="34" charset="-122"/>
-                <a:cs typeface="Replica LL TT Heavy" pitchFamily="34" charset="-120"/>
-              </a:rPr>
-              <a:t>02</a:t>
-            </a:r>
-            <a:endParaRPr lang="en-US" sz="5600" dirty="0"/>
-          </a:p>
-        </p:txBody>
-      </p:sp>
-      <p:sp>
-        <p:nvSpPr>
-          <p:cNvPr id="8" name="Text 6"/>
-          <p:cNvSpPr/>
-          <p:nvPr/>
-        </p:nvSpPr>
-        <p:spPr>
-          <a:xfrm>
-            <a:off x="3573704" y="3355848"/>
-            <a:ext cx="2247824" cy="457200"/>
+      <p:pic>
+        <p:nvPicPr>
+          <p:cNvPr id="7" name="Image 1" descr="C:\Code\Work\startuplab-partner-presentation\pptx-templates\media\row-2.jpg">    </p:cNvPr>
+          <p:cNvPicPr>
+            <a:picLocks noChangeAspect="1"/>
+          </p:cNvPicPr>
+          <p:nvPr/>
+        </p:nvPicPr>
+        <p:blipFill>
+          <a:blip r:embed="rId2"/>
+          <a:srcRect l="0" r="0" t="0" b="0"/>
+          <a:stretch/>
+        </p:blipFill>
+        <p:spPr>
+          <a:xfrm>
+            <a:off x="4444898" y="2240280"/>
+            <a:ext cx="3301898" cy="2201266"/>
+          </a:xfrm>
+          <a:prstGeom prst="rect">
+            <a:avLst/>
+          </a:prstGeom>
+        </p:spPr>
+      </p:pic>
+      <p:sp>
+        <p:nvSpPr>
+          <p:cNvPr id="8" name="Text 4"/>
+          <p:cNvSpPr/>
+          <p:nvPr/>
+        </p:nvSpPr>
+        <p:spPr>
+          <a:xfrm>
+            <a:off x="4444898" y="4624426"/>
+            <a:ext cx="3301898" cy="420624"/>
           </a:xfrm>
           <a:prstGeom prst="rect">
             <a:avLst/>
@@ -3108,30 +3182,30 @@
               <a:buNone/>
             </a:pPr>
             <a:r>
-              <a:rPr lang="en-US" sz="2500" b="1" dirty="0">
-                <a:solidFill>
-                  <a:srgbClr val="131415"/>
+              <a:rPr lang="en-US" sz="2000" b="1" dirty="0">
+                <a:solidFill>
+                  <a:srgbClr val="FFFFFF"/>
                 </a:solidFill>
                 <a:latin typeface="Replica LL TT" pitchFamily="34" charset="0"/>
                 <a:ea typeface="Replica LL TT" pitchFamily="34" charset="-122"/>
                 <a:cs typeface="Replica LL TT" pitchFamily="34" charset="-120"/>
               </a:rPr>
-              <a:t>Match</a:t>
-            </a:r>
-            <a:endParaRPr lang="en-US" sz="2500" dirty="0"/>
-          </a:p>
-        </p:txBody>
-      </p:sp>
-      <p:sp>
-        <p:nvSpPr>
-          <p:cNvPr id="9" name="Text 7"/>
-          <p:cNvSpPr/>
-          <p:nvPr/>
-        </p:nvSpPr>
-        <p:spPr>
-          <a:xfrm>
-            <a:off x="3573704" y="3840480"/>
-            <a:ext cx="2247824" cy="1005840"/>
+              <a:t>Nye koblinger</a:t>
+            </a:r>
+            <a:endParaRPr lang="en-US" sz="2000" dirty="0"/>
+          </a:p>
+        </p:txBody>
+      </p:sp>
+      <p:sp>
+        <p:nvSpPr>
+          <p:cNvPr id="9" name="Text 5"/>
+          <p:cNvSpPr/>
+          <p:nvPr/>
+        </p:nvSpPr>
+        <p:spPr>
+          <a:xfrm>
+            <a:off x="4444898" y="5063338"/>
+            <a:ext cx="3301898" cy="658368"/>
           </a:xfrm>
           <a:prstGeom prst="rect">
             <a:avLst/>
@@ -3152,67 +3226,51 @@
             <a:r>
               <a:rPr lang="en-US" sz="1800" dirty="0">
                 <a:solidFill>
-                  <a:srgbClr val="5A6166"/>
+                  <a:srgbClr val="9BA1A5"/>
                 </a:solidFill>
                 <a:latin typeface="Inter" pitchFamily="34" charset="0"/>
                 <a:ea typeface="Inter" pitchFamily="34" charset="-122"/>
                 <a:cs typeface="Inter" pitchFamily="34" charset="-120"/>
               </a:rPr>
-              <a:t>Vi henter inn selskapene som treffer den.</a:t>
+              <a:t>Partnere og gründere møttes på tolv matchmaking-runder.</a:t>
             </a:r>
             <a:endParaRPr lang="en-US" sz="1800" dirty="0"/>
           </a:p>
         </p:txBody>
       </p:sp>
-      <p:sp>
-        <p:nvSpPr>
-          <p:cNvPr id="10" name="Text 8"/>
-          <p:cNvSpPr/>
-          <p:nvPr/>
-        </p:nvSpPr>
-        <p:spPr>
-          <a:xfrm>
-            <a:off x="6370168" y="2423160"/>
-            <a:ext cx="2247824" cy="914400"/>
-          </a:xfrm>
-          <a:prstGeom prst="rect">
-            <a:avLst/>
-          </a:prstGeom>
-          <a:noFill/>
-          <a:ln/>
-        </p:spPr>
-        <p:txBody>
-          <a:bodyPr wrap="square" lIns="0" tIns="0" rIns="0" bIns="0" rtlCol="0" anchor="t"/>
-          <a:lstStyle/>
-          <a:p>
-            <a:pPr indent="0" marL="0">
-              <a:buNone/>
-            </a:pPr>
-            <a:r>
-              <a:rPr lang="en-US" sz="5600" dirty="0">
-                <a:solidFill>
-                  <a:srgbClr val="5A6166"/>
-                </a:solidFill>
-                <a:latin typeface="Replica LL TT Heavy" pitchFamily="34" charset="0"/>
-                <a:ea typeface="Replica LL TT Heavy" pitchFamily="34" charset="-122"/>
-                <a:cs typeface="Replica LL TT Heavy" pitchFamily="34" charset="-120"/>
-              </a:rPr>
-              <a:t>03</a:t>
-            </a:r>
-            <a:endParaRPr lang="en-US" sz="5600" dirty="0"/>
-          </a:p>
-        </p:txBody>
-      </p:sp>
-      <p:sp>
-        <p:nvSpPr>
-          <p:cNvPr id="11" name="Text 9"/>
-          <p:cNvSpPr/>
-          <p:nvPr/>
-        </p:nvSpPr>
-        <p:spPr>
-          <a:xfrm>
-            <a:off x="6370168" y="3355848"/>
-            <a:ext cx="2247824" cy="457200"/>
+      <p:pic>
+        <p:nvPicPr>
+          <p:cNvPr id="10" name="Image 2" descr="C:\Code\Work\startuplab-partner-presentation\pptx-templates\media\row-3.jpg">    </p:cNvPr>
+          <p:cNvPicPr>
+            <a:picLocks noChangeAspect="1"/>
+          </p:cNvPicPr>
+          <p:nvPr/>
+        </p:nvPicPr>
+        <p:blipFill>
+          <a:blip r:embed="rId3"/>
+          <a:srcRect l="0" r="0" t="0" b="0"/>
+          <a:stretch/>
+        </p:blipFill>
+        <p:spPr>
+          <a:xfrm>
+            <a:off x="8112557" y="2240280"/>
+            <a:ext cx="3301898" cy="2201266"/>
+          </a:xfrm>
+          <a:prstGeom prst="rect">
+            <a:avLst/>
+          </a:prstGeom>
+        </p:spPr>
+      </p:pic>
+      <p:sp>
+        <p:nvSpPr>
+          <p:cNvPr id="11" name="Text 6"/>
+          <p:cNvSpPr/>
+          <p:nvPr/>
+        </p:nvSpPr>
+        <p:spPr>
+          <a:xfrm>
+            <a:off x="8112557" y="4624426"/>
+            <a:ext cx="3301898" cy="420624"/>
           </a:xfrm>
           <a:prstGeom prst="rect">
             <a:avLst/>
@@ -3228,30 +3286,30 @@
               <a:buNone/>
             </a:pPr>
             <a:r>
-              <a:rPr lang="en-US" sz="2500" b="1" dirty="0">
-                <a:solidFill>
-                  <a:srgbClr val="131415"/>
+              <a:rPr lang="en-US" sz="2000" b="1" dirty="0">
+                <a:solidFill>
+                  <a:srgbClr val="FFFFFF"/>
                 </a:solidFill>
                 <a:latin typeface="Replica LL TT" pitchFamily="34" charset="0"/>
                 <a:ea typeface="Replica LL TT" pitchFamily="34" charset="-122"/>
                 <a:cs typeface="Replica LL TT" pitchFamily="34" charset="-120"/>
               </a:rPr>
-              <a:t>Pilot</a:t>
-            </a:r>
-            <a:endParaRPr lang="en-US" sz="2500" dirty="0"/>
-          </a:p>
-        </p:txBody>
-      </p:sp>
-      <p:sp>
-        <p:nvSpPr>
-          <p:cNvPr id="12" name="Text 10"/>
-          <p:cNvSpPr/>
-          <p:nvPr/>
-        </p:nvSpPr>
-        <p:spPr>
-          <a:xfrm>
-            <a:off x="6370168" y="3840480"/>
-            <a:ext cx="2247824" cy="1005840"/>
+              <a:t>Ut i felt</a:t>
+            </a:r>
+            <a:endParaRPr lang="en-US" sz="2000" dirty="0"/>
+          </a:p>
+        </p:txBody>
+      </p:sp>
+      <p:sp>
+        <p:nvSpPr>
+          <p:cNvPr id="12" name="Text 7"/>
+          <p:cNvSpPr/>
+          <p:nvPr/>
+        </p:nvSpPr>
+        <p:spPr>
+          <a:xfrm>
+            <a:off x="8112557" y="5063338"/>
+            <a:ext cx="3301898" cy="658368"/>
           </a:xfrm>
           <a:prstGeom prst="rect">
             <a:avLst/>
@@ -3272,133 +3330,13 @@
             <a:r>
               <a:rPr lang="en-US" sz="1800" dirty="0">
                 <a:solidFill>
-                  <a:srgbClr val="5A6166"/>
+                  <a:srgbClr val="9BA1A5"/>
                 </a:solidFill>
                 <a:latin typeface="Inter" pitchFamily="34" charset="0"/>
                 <a:ea typeface="Inter" pitchFamily="34" charset="-122"/>
                 <a:cs typeface="Inter" pitchFamily="34" charset="-120"/>
               </a:rPr>
-              <a:t>Vi rigger et forsøk med tydelige kriterier.</a:t>
-            </a:r>
-            <a:endParaRPr lang="en-US" sz="1800" dirty="0"/>
-          </a:p>
-        </p:txBody>
-      </p:sp>
-      <p:sp>
-        <p:nvSpPr>
-          <p:cNvPr id="13" name="Text 11"/>
-          <p:cNvSpPr/>
-          <p:nvPr/>
-        </p:nvSpPr>
-        <p:spPr>
-          <a:xfrm>
-            <a:off x="9166631" y="2423160"/>
-            <a:ext cx="2247824" cy="914400"/>
-          </a:xfrm>
-          <a:prstGeom prst="rect">
-            <a:avLst/>
-          </a:prstGeom>
-          <a:noFill/>
-          <a:ln/>
-        </p:spPr>
-        <p:txBody>
-          <a:bodyPr wrap="square" lIns="0" tIns="0" rIns="0" bIns="0" rtlCol="0" anchor="t"/>
-          <a:lstStyle/>
-          <a:p>
-            <a:pPr indent="0" marL="0">
-              <a:buNone/>
-            </a:pPr>
-            <a:r>
-              <a:rPr lang="en-US" sz="5600" dirty="0">
-                <a:solidFill>
-                  <a:srgbClr val="5A6166"/>
-                </a:solidFill>
-                <a:latin typeface="Replica LL TT Heavy" pitchFamily="34" charset="0"/>
-                <a:ea typeface="Replica LL TT Heavy" pitchFamily="34" charset="-122"/>
-                <a:cs typeface="Replica LL TT Heavy" pitchFamily="34" charset="-120"/>
-              </a:rPr>
-              <a:t>04</a:t>
-            </a:r>
-            <a:endParaRPr lang="en-US" sz="5600" dirty="0"/>
-          </a:p>
-        </p:txBody>
-      </p:sp>
-      <p:sp>
-        <p:nvSpPr>
-          <p:cNvPr id="14" name="Text 12"/>
-          <p:cNvSpPr/>
-          <p:nvPr/>
-        </p:nvSpPr>
-        <p:spPr>
-          <a:xfrm>
-            <a:off x="9166631" y="3355848"/>
-            <a:ext cx="2247824" cy="457200"/>
-          </a:xfrm>
-          <a:prstGeom prst="rect">
-            <a:avLst/>
-          </a:prstGeom>
-          <a:noFill/>
-          <a:ln/>
-        </p:spPr>
-        <p:txBody>
-          <a:bodyPr wrap="square" lIns="0" tIns="0" rIns="0" bIns="0" rtlCol="0" anchor="ctr"/>
-          <a:lstStyle/>
-          <a:p>
-            <a:pPr indent="0" marL="0">
-              <a:buNone/>
-            </a:pPr>
-            <a:r>
-              <a:rPr lang="en-US" sz="2500" b="1" dirty="0">
-                <a:solidFill>
-                  <a:srgbClr val="131415"/>
-                </a:solidFill>
-                <a:latin typeface="Replica LL TT" pitchFamily="34" charset="0"/>
-                <a:ea typeface="Replica LL TT" pitchFamily="34" charset="-122"/>
-                <a:cs typeface="Replica LL TT" pitchFamily="34" charset="-120"/>
-              </a:rPr>
-              <a:t>Skaler</a:t>
-            </a:r>
-            <a:endParaRPr lang="en-US" sz="2500" dirty="0"/>
-          </a:p>
-        </p:txBody>
-      </p:sp>
-      <p:sp>
-        <p:nvSpPr>
-          <p:cNvPr id="15" name="Text 13"/>
-          <p:cNvSpPr/>
-          <p:nvPr/>
-        </p:nvSpPr>
-        <p:spPr>
-          <a:xfrm>
-            <a:off x="9166631" y="3840480"/>
-            <a:ext cx="2247824" cy="1005840"/>
-          </a:xfrm>
-          <a:prstGeom prst="rect">
-            <a:avLst/>
-          </a:prstGeom>
-          <a:noFill/>
-          <a:ln/>
-        </p:spPr>
-        <p:txBody>
-          <a:bodyPr wrap="square" lIns="0" tIns="0" rIns="0" bIns="0" rtlCol="0" anchor="t"/>
-          <a:lstStyle/>
-          <a:p>
-            <a:pPr indent="0" marL="0">
-              <a:lnSpc>
-                <a:spcPct val="130000"/>
-              </a:lnSpc>
-              <a:buNone/>
-            </a:pPr>
-            <a:r>
-              <a:rPr lang="en-US" sz="1800" dirty="0">
-                <a:solidFill>
-                  <a:srgbClr val="5A6166"/>
-                </a:solidFill>
-                <a:latin typeface="Inter" pitchFamily="34" charset="0"/>
-                <a:ea typeface="Inter" pitchFamily="34" charset="-122"/>
-                <a:cs typeface="Inter" pitchFamily="34" charset="-120"/>
-              </a:rPr>
-              <a:t>Det som virker, settes i drift.</a:t>
+              <a:t>Befaring med partnerne i Energy-programmet.</a:t>
             </a:r>
             <a:endParaRPr lang="en-US" sz="1800" dirty="0"/>
           </a:p>
@@ -3406,14 +3344,14 @@
       </p:sp>
       <p:pic>
         <p:nvPicPr>
-          <p:cNvPr id="16" name="Image 0" descr="C:\Code\Work\startuplab-partner-presentation\pptx-templates\media\logo-red.png">    </p:cNvPr>
+          <p:cNvPr id="13" name="Image 3" descr="C:\Code\Work\startuplab-partner-presentation\pptx-templates\media\logo-white.png">    </p:cNvPr>
           <p:cNvPicPr>
             <a:picLocks noChangeAspect="1"/>
           </p:cNvPicPr>
           <p:nvPr/>
         </p:nvPicPr>
         <p:blipFill>
-          <a:blip r:embed="rId1"/>
+          <a:blip r:embed="rId4"/>
           <a:stretch>
             <a:fillRect/>
           </a:stretch>
@@ -3493,7 +3431,7 @@
                 <a:ea typeface="Inter" pitchFamily="34" charset="-122"/>
                 <a:cs typeface="Inter" pitchFamily="34" charset="-120"/>
               </a:rPr>
-              <a:t>TEAMET</a:t>
+              <a:t>SLIK GÅR VI FREM</a:t>
             </a:r>
             <a:endParaRPr lang="en-US" sz="1600" dirty="0"/>
           </a:p>
@@ -3535,32 +3473,495 @@
                 <a:ea typeface="Replica LL TT" pitchFamily="34" charset="-122"/>
                 <a:cs typeface="Replica LL TT" pitchFamily="34" charset="-120"/>
               </a:rPr>
-              <a:t>Folkene du kommer til å </a:t>
-            </a:r>
-            <a:pPr indent="0" marL="0">
-              <a:lnSpc>
-                <a:spcPct val="100000"/>
-              </a:lnSpc>
-              <a:buNone/>
-            </a:pPr>
-            <a:r>
-              <a:rPr lang="en-US" sz="4000" b="1" dirty="0">
+              <a:t>Fire steg fra idé til pilot</a:t>
+            </a:r>
+            <a:endParaRPr lang="en-US" sz="4000" dirty="0"/>
+          </a:p>
+        </p:txBody>
+      </p:sp>
+      <p:sp>
+        <p:nvSpPr>
+          <p:cNvPr id="4" name="Text 2"/>
+          <p:cNvSpPr/>
+          <p:nvPr/>
+        </p:nvSpPr>
+        <p:spPr>
+          <a:xfrm>
+            <a:off x="777240" y="2423160"/>
+            <a:ext cx="2247824" cy="914400"/>
+          </a:xfrm>
+          <a:prstGeom prst="rect">
+            <a:avLst/>
+          </a:prstGeom>
+          <a:noFill/>
+          <a:ln/>
+        </p:spPr>
+        <p:txBody>
+          <a:bodyPr wrap="square" lIns="0" tIns="0" rIns="0" bIns="0" rtlCol="0" anchor="t"/>
+          <a:lstStyle/>
+          <a:p>
+            <a:pPr indent="0" marL="0">
+              <a:buNone/>
+            </a:pPr>
+            <a:r>
+              <a:rPr lang="en-US" sz="5600" dirty="0">
                 <a:solidFill>
                   <a:srgbClr val="FF3333"/>
+                </a:solidFill>
+                <a:latin typeface="Replica LL TT Heavy" pitchFamily="34" charset="0"/>
+                <a:ea typeface="Replica LL TT Heavy" pitchFamily="34" charset="-122"/>
+                <a:cs typeface="Replica LL TT Heavy" pitchFamily="34" charset="-120"/>
+              </a:rPr>
+              <a:t>01</a:t>
+            </a:r>
+            <a:endParaRPr lang="en-US" sz="5600" dirty="0"/>
+          </a:p>
+        </p:txBody>
+      </p:sp>
+      <p:sp>
+        <p:nvSpPr>
+          <p:cNvPr id="5" name="Text 3"/>
+          <p:cNvSpPr/>
+          <p:nvPr/>
+        </p:nvSpPr>
+        <p:spPr>
+          <a:xfrm>
+            <a:off x="777240" y="3355848"/>
+            <a:ext cx="2247824" cy="457200"/>
+          </a:xfrm>
+          <a:prstGeom prst="rect">
+            <a:avLst/>
+          </a:prstGeom>
+          <a:noFill/>
+          <a:ln/>
+        </p:spPr>
+        <p:txBody>
+          <a:bodyPr wrap="square" lIns="0" tIns="0" rIns="0" bIns="0" rtlCol="0" anchor="ctr"/>
+          <a:lstStyle/>
+          <a:p>
+            <a:pPr indent="0" marL="0">
+              <a:buNone/>
+            </a:pPr>
+            <a:r>
+              <a:rPr lang="en-US" sz="2500" b="1" dirty="0">
+                <a:solidFill>
+                  <a:srgbClr val="131415"/>
                 </a:solidFill>
                 <a:latin typeface="Replica LL TT" pitchFamily="34" charset="0"/>
                 <a:ea typeface="Replica LL TT" pitchFamily="34" charset="-122"/>
                 <a:cs typeface="Replica LL TT" pitchFamily="34" charset="-120"/>
               </a:rPr>
-              <a:t>jobbe med</a:t>
-            </a:r>
-            <a:endParaRPr lang="en-US" sz="4000" dirty="0"/>
+              <a:t>Kartlegg</a:t>
+            </a:r>
+            <a:endParaRPr lang="en-US" sz="2500" dirty="0"/>
+          </a:p>
+        </p:txBody>
+      </p:sp>
+      <p:sp>
+        <p:nvSpPr>
+          <p:cNvPr id="6" name="Text 4"/>
+          <p:cNvSpPr/>
+          <p:nvPr/>
+        </p:nvSpPr>
+        <p:spPr>
+          <a:xfrm>
+            <a:off x="777240" y="3840480"/>
+            <a:ext cx="2247824" cy="1005840"/>
+          </a:xfrm>
+          <a:prstGeom prst="rect">
+            <a:avLst/>
+          </a:prstGeom>
+          <a:noFill/>
+          <a:ln/>
+        </p:spPr>
+        <p:txBody>
+          <a:bodyPr wrap="square" lIns="0" tIns="0" rIns="0" bIns="0" rtlCol="0" anchor="t"/>
+          <a:lstStyle/>
+          <a:p>
+            <a:pPr indent="0" marL="0">
+              <a:lnSpc>
+                <a:spcPct val="130000"/>
+              </a:lnSpc>
+              <a:buNone/>
+            </a:pPr>
+            <a:r>
+              <a:rPr lang="en-US" sz="1800" dirty="0">
+                <a:solidFill>
+                  <a:srgbClr val="5A6166"/>
+                </a:solidFill>
+                <a:latin typeface="Inter" pitchFamily="34" charset="0"/>
+                <a:ea typeface="Inter" pitchFamily="34" charset="-122"/>
+                <a:cs typeface="Inter" pitchFamily="34" charset="-120"/>
+              </a:rPr>
+              <a:t>Vi finner utfordringen som er verdt å løse.</a:t>
+            </a:r>
+            <a:endParaRPr lang="en-US" sz="1800" dirty="0"/>
+          </a:p>
+        </p:txBody>
+      </p:sp>
+      <p:sp>
+        <p:nvSpPr>
+          <p:cNvPr id="7" name="Text 5"/>
+          <p:cNvSpPr/>
+          <p:nvPr/>
+        </p:nvSpPr>
+        <p:spPr>
+          <a:xfrm>
+            <a:off x="3573704" y="2423160"/>
+            <a:ext cx="2247824" cy="914400"/>
+          </a:xfrm>
+          <a:prstGeom prst="rect">
+            <a:avLst/>
+          </a:prstGeom>
+          <a:noFill/>
+          <a:ln/>
+        </p:spPr>
+        <p:txBody>
+          <a:bodyPr wrap="square" lIns="0" tIns="0" rIns="0" bIns="0" rtlCol="0" anchor="t"/>
+          <a:lstStyle/>
+          <a:p>
+            <a:pPr indent="0" marL="0">
+              <a:buNone/>
+            </a:pPr>
+            <a:r>
+              <a:rPr lang="en-US" sz="5600" dirty="0">
+                <a:solidFill>
+                  <a:srgbClr val="5A6166"/>
+                </a:solidFill>
+                <a:latin typeface="Replica LL TT Heavy" pitchFamily="34" charset="0"/>
+                <a:ea typeface="Replica LL TT Heavy" pitchFamily="34" charset="-122"/>
+                <a:cs typeface="Replica LL TT Heavy" pitchFamily="34" charset="-120"/>
+              </a:rPr>
+              <a:t>02</a:t>
+            </a:r>
+            <a:endParaRPr lang="en-US" sz="5600" dirty="0"/>
+          </a:p>
+        </p:txBody>
+      </p:sp>
+      <p:sp>
+        <p:nvSpPr>
+          <p:cNvPr id="8" name="Text 6"/>
+          <p:cNvSpPr/>
+          <p:nvPr/>
+        </p:nvSpPr>
+        <p:spPr>
+          <a:xfrm>
+            <a:off x="3573704" y="3355848"/>
+            <a:ext cx="2247824" cy="457200"/>
+          </a:xfrm>
+          <a:prstGeom prst="rect">
+            <a:avLst/>
+          </a:prstGeom>
+          <a:noFill/>
+          <a:ln/>
+        </p:spPr>
+        <p:txBody>
+          <a:bodyPr wrap="square" lIns="0" tIns="0" rIns="0" bIns="0" rtlCol="0" anchor="ctr"/>
+          <a:lstStyle/>
+          <a:p>
+            <a:pPr indent="0" marL="0">
+              <a:buNone/>
+            </a:pPr>
+            <a:r>
+              <a:rPr lang="en-US" sz="2500" b="1" dirty="0">
+                <a:solidFill>
+                  <a:srgbClr val="131415"/>
+                </a:solidFill>
+                <a:latin typeface="Replica LL TT" pitchFamily="34" charset="0"/>
+                <a:ea typeface="Replica LL TT" pitchFamily="34" charset="-122"/>
+                <a:cs typeface="Replica LL TT" pitchFamily="34" charset="-120"/>
+              </a:rPr>
+              <a:t>Match</a:t>
+            </a:r>
+            <a:endParaRPr lang="en-US" sz="2500" dirty="0"/>
+          </a:p>
+        </p:txBody>
+      </p:sp>
+      <p:sp>
+        <p:nvSpPr>
+          <p:cNvPr id="9" name="Text 7"/>
+          <p:cNvSpPr/>
+          <p:nvPr/>
+        </p:nvSpPr>
+        <p:spPr>
+          <a:xfrm>
+            <a:off x="3573704" y="3840480"/>
+            <a:ext cx="2247824" cy="1005840"/>
+          </a:xfrm>
+          <a:prstGeom prst="rect">
+            <a:avLst/>
+          </a:prstGeom>
+          <a:noFill/>
+          <a:ln/>
+        </p:spPr>
+        <p:txBody>
+          <a:bodyPr wrap="square" lIns="0" tIns="0" rIns="0" bIns="0" rtlCol="0" anchor="t"/>
+          <a:lstStyle/>
+          <a:p>
+            <a:pPr indent="0" marL="0">
+              <a:lnSpc>
+                <a:spcPct val="130000"/>
+              </a:lnSpc>
+              <a:buNone/>
+            </a:pPr>
+            <a:r>
+              <a:rPr lang="en-US" sz="1800" dirty="0">
+                <a:solidFill>
+                  <a:srgbClr val="5A6166"/>
+                </a:solidFill>
+                <a:latin typeface="Inter" pitchFamily="34" charset="0"/>
+                <a:ea typeface="Inter" pitchFamily="34" charset="-122"/>
+                <a:cs typeface="Inter" pitchFamily="34" charset="-120"/>
+              </a:rPr>
+              <a:t>Vi henter inn selskapene som treffer den.</a:t>
+            </a:r>
+            <a:endParaRPr lang="en-US" sz="1800" dirty="0"/>
+          </a:p>
+        </p:txBody>
+      </p:sp>
+      <p:sp>
+        <p:nvSpPr>
+          <p:cNvPr id="10" name="Text 8"/>
+          <p:cNvSpPr/>
+          <p:nvPr/>
+        </p:nvSpPr>
+        <p:spPr>
+          <a:xfrm>
+            <a:off x="6370168" y="2423160"/>
+            <a:ext cx="2247824" cy="914400"/>
+          </a:xfrm>
+          <a:prstGeom prst="rect">
+            <a:avLst/>
+          </a:prstGeom>
+          <a:noFill/>
+          <a:ln/>
+        </p:spPr>
+        <p:txBody>
+          <a:bodyPr wrap="square" lIns="0" tIns="0" rIns="0" bIns="0" rtlCol="0" anchor="t"/>
+          <a:lstStyle/>
+          <a:p>
+            <a:pPr indent="0" marL="0">
+              <a:buNone/>
+            </a:pPr>
+            <a:r>
+              <a:rPr lang="en-US" sz="5600" dirty="0">
+                <a:solidFill>
+                  <a:srgbClr val="5A6166"/>
+                </a:solidFill>
+                <a:latin typeface="Replica LL TT Heavy" pitchFamily="34" charset="0"/>
+                <a:ea typeface="Replica LL TT Heavy" pitchFamily="34" charset="-122"/>
+                <a:cs typeface="Replica LL TT Heavy" pitchFamily="34" charset="-120"/>
+              </a:rPr>
+              <a:t>03</a:t>
+            </a:r>
+            <a:endParaRPr lang="en-US" sz="5600" dirty="0"/>
+          </a:p>
+        </p:txBody>
+      </p:sp>
+      <p:sp>
+        <p:nvSpPr>
+          <p:cNvPr id="11" name="Text 9"/>
+          <p:cNvSpPr/>
+          <p:nvPr/>
+        </p:nvSpPr>
+        <p:spPr>
+          <a:xfrm>
+            <a:off x="6370168" y="3355848"/>
+            <a:ext cx="2247824" cy="457200"/>
+          </a:xfrm>
+          <a:prstGeom prst="rect">
+            <a:avLst/>
+          </a:prstGeom>
+          <a:noFill/>
+          <a:ln/>
+        </p:spPr>
+        <p:txBody>
+          <a:bodyPr wrap="square" lIns="0" tIns="0" rIns="0" bIns="0" rtlCol="0" anchor="ctr"/>
+          <a:lstStyle/>
+          <a:p>
+            <a:pPr indent="0" marL="0">
+              <a:buNone/>
+            </a:pPr>
+            <a:r>
+              <a:rPr lang="en-US" sz="2500" b="1" dirty="0">
+                <a:solidFill>
+                  <a:srgbClr val="131415"/>
+                </a:solidFill>
+                <a:latin typeface="Replica LL TT" pitchFamily="34" charset="0"/>
+                <a:ea typeface="Replica LL TT" pitchFamily="34" charset="-122"/>
+                <a:cs typeface="Replica LL TT" pitchFamily="34" charset="-120"/>
+              </a:rPr>
+              <a:t>Pilot</a:t>
+            </a:r>
+            <a:endParaRPr lang="en-US" sz="2500" dirty="0"/>
+          </a:p>
+        </p:txBody>
+      </p:sp>
+      <p:sp>
+        <p:nvSpPr>
+          <p:cNvPr id="12" name="Text 10"/>
+          <p:cNvSpPr/>
+          <p:nvPr/>
+        </p:nvSpPr>
+        <p:spPr>
+          <a:xfrm>
+            <a:off x="6370168" y="3840480"/>
+            <a:ext cx="2247824" cy="1005840"/>
+          </a:xfrm>
+          <a:prstGeom prst="rect">
+            <a:avLst/>
+          </a:prstGeom>
+          <a:noFill/>
+          <a:ln/>
+        </p:spPr>
+        <p:txBody>
+          <a:bodyPr wrap="square" lIns="0" tIns="0" rIns="0" bIns="0" rtlCol="0" anchor="t"/>
+          <a:lstStyle/>
+          <a:p>
+            <a:pPr indent="0" marL="0">
+              <a:lnSpc>
+                <a:spcPct val="130000"/>
+              </a:lnSpc>
+              <a:buNone/>
+            </a:pPr>
+            <a:r>
+              <a:rPr lang="en-US" sz="1800" dirty="0">
+                <a:solidFill>
+                  <a:srgbClr val="5A6166"/>
+                </a:solidFill>
+                <a:latin typeface="Inter" pitchFamily="34" charset="0"/>
+                <a:ea typeface="Inter" pitchFamily="34" charset="-122"/>
+                <a:cs typeface="Inter" pitchFamily="34" charset="-120"/>
+              </a:rPr>
+              <a:t>Vi rigger et forsøk med tydelige kriterier.</a:t>
+            </a:r>
+            <a:endParaRPr lang="en-US" sz="1800" dirty="0"/>
+          </a:p>
+        </p:txBody>
+      </p:sp>
+      <p:sp>
+        <p:nvSpPr>
+          <p:cNvPr id="13" name="Text 11"/>
+          <p:cNvSpPr/>
+          <p:nvPr/>
+        </p:nvSpPr>
+        <p:spPr>
+          <a:xfrm>
+            <a:off x="9166631" y="2423160"/>
+            <a:ext cx="2247824" cy="914400"/>
+          </a:xfrm>
+          <a:prstGeom prst="rect">
+            <a:avLst/>
+          </a:prstGeom>
+          <a:noFill/>
+          <a:ln/>
+        </p:spPr>
+        <p:txBody>
+          <a:bodyPr wrap="square" lIns="0" tIns="0" rIns="0" bIns="0" rtlCol="0" anchor="t"/>
+          <a:lstStyle/>
+          <a:p>
+            <a:pPr indent="0" marL="0">
+              <a:buNone/>
+            </a:pPr>
+            <a:r>
+              <a:rPr lang="en-US" sz="5600" dirty="0">
+                <a:solidFill>
+                  <a:srgbClr val="5A6166"/>
+                </a:solidFill>
+                <a:latin typeface="Replica LL TT Heavy" pitchFamily="34" charset="0"/>
+                <a:ea typeface="Replica LL TT Heavy" pitchFamily="34" charset="-122"/>
+                <a:cs typeface="Replica LL TT Heavy" pitchFamily="34" charset="-120"/>
+              </a:rPr>
+              <a:t>04</a:t>
+            </a:r>
+            <a:endParaRPr lang="en-US" sz="5600" dirty="0"/>
+          </a:p>
+        </p:txBody>
+      </p:sp>
+      <p:sp>
+        <p:nvSpPr>
+          <p:cNvPr id="14" name="Text 12"/>
+          <p:cNvSpPr/>
+          <p:nvPr/>
+        </p:nvSpPr>
+        <p:spPr>
+          <a:xfrm>
+            <a:off x="9166631" y="3355848"/>
+            <a:ext cx="2247824" cy="457200"/>
+          </a:xfrm>
+          <a:prstGeom prst="rect">
+            <a:avLst/>
+          </a:prstGeom>
+          <a:noFill/>
+          <a:ln/>
+        </p:spPr>
+        <p:txBody>
+          <a:bodyPr wrap="square" lIns="0" tIns="0" rIns="0" bIns="0" rtlCol="0" anchor="ctr"/>
+          <a:lstStyle/>
+          <a:p>
+            <a:pPr indent="0" marL="0">
+              <a:buNone/>
+            </a:pPr>
+            <a:r>
+              <a:rPr lang="en-US" sz="2500" b="1" dirty="0">
+                <a:solidFill>
+                  <a:srgbClr val="131415"/>
+                </a:solidFill>
+                <a:latin typeface="Replica LL TT" pitchFamily="34" charset="0"/>
+                <a:ea typeface="Replica LL TT" pitchFamily="34" charset="-122"/>
+                <a:cs typeface="Replica LL TT" pitchFamily="34" charset="-120"/>
+              </a:rPr>
+              <a:t>Skaler</a:t>
+            </a:r>
+            <a:endParaRPr lang="en-US" sz="2500" dirty="0"/>
+          </a:p>
+        </p:txBody>
+      </p:sp>
+      <p:sp>
+        <p:nvSpPr>
+          <p:cNvPr id="15" name="Text 13"/>
+          <p:cNvSpPr/>
+          <p:nvPr/>
+        </p:nvSpPr>
+        <p:spPr>
+          <a:xfrm>
+            <a:off x="9166631" y="3840480"/>
+            <a:ext cx="2247824" cy="1005840"/>
+          </a:xfrm>
+          <a:prstGeom prst="rect">
+            <a:avLst/>
+          </a:prstGeom>
+          <a:noFill/>
+          <a:ln/>
+        </p:spPr>
+        <p:txBody>
+          <a:bodyPr wrap="square" lIns="0" tIns="0" rIns="0" bIns="0" rtlCol="0" anchor="t"/>
+          <a:lstStyle/>
+          <a:p>
+            <a:pPr indent="0" marL="0">
+              <a:lnSpc>
+                <a:spcPct val="130000"/>
+              </a:lnSpc>
+              <a:buNone/>
+            </a:pPr>
+            <a:r>
+              <a:rPr lang="en-US" sz="1800" dirty="0">
+                <a:solidFill>
+                  <a:srgbClr val="5A6166"/>
+                </a:solidFill>
+                <a:latin typeface="Inter" pitchFamily="34" charset="0"/>
+                <a:ea typeface="Inter" pitchFamily="34" charset="-122"/>
+                <a:cs typeface="Inter" pitchFamily="34" charset="-120"/>
+              </a:rPr>
+              <a:t>Det som virker, settes i drift.</a:t>
+            </a:r>
+            <a:endParaRPr lang="en-US" sz="1800" dirty="0"/>
           </a:p>
         </p:txBody>
       </p:sp>
       <p:pic>
         <p:nvPicPr>
-          <p:cNvPr id="4" name="Image 0" descr="C:\Code\Work\startuplab-partner-presentation\pptx-templates\media\portrait-1.jpg">    </p:cNvPr>
+          <p:cNvPr id="16" name="Image 0" descr="C:\Code\Work\startuplab-partner-presentation\pptx-templates\media\logo-red.png">    </p:cNvPr>
           <p:cNvPicPr>
             <a:picLocks noChangeAspect="1"/>
           </p:cNvPicPr>
@@ -3568,486 +3969,6 @@
         </p:nvPicPr>
         <p:blipFill>
           <a:blip r:embed="rId1"/>
-          <a:srcRect l="0" r="0" t="0" b="0"/>
-          <a:stretch/>
-        </p:blipFill>
-        <p:spPr>
-          <a:xfrm>
-            <a:off x="777240" y="2286000"/>
-            <a:ext cx="2240280" cy="2240280"/>
-          </a:xfrm>
-          <a:prstGeom prst="ellipse">
-            <a:avLst/>
-          </a:prstGeom>
-        </p:spPr>
-      </p:pic>
-      <p:sp>
-        <p:nvSpPr>
-          <p:cNvPr id="5" name="Text 2"/>
-          <p:cNvSpPr/>
-          <p:nvPr/>
-        </p:nvSpPr>
-        <p:spPr>
-          <a:xfrm>
-            <a:off x="777240" y="4727448"/>
-            <a:ext cx="2240280" cy="365760"/>
-          </a:xfrm>
-          <a:prstGeom prst="rect">
-            <a:avLst/>
-          </a:prstGeom>
-          <a:noFill/>
-          <a:ln/>
-        </p:spPr>
-        <p:txBody>
-          <a:bodyPr wrap="square" lIns="0" tIns="0" rIns="0" bIns="0" rtlCol="0" anchor="ctr"/>
-          <a:lstStyle/>
-          <a:p>
-            <a:pPr algn="ctr" indent="0" marL="0">
-              <a:buNone/>
-            </a:pPr>
-            <a:r>
-              <a:rPr lang="en-US" sz="2100" b="1" dirty="0">
-                <a:solidFill>
-                  <a:srgbClr val="131415"/>
-                </a:solidFill>
-                <a:latin typeface="Replica LL TT" pitchFamily="34" charset="0"/>
-                <a:ea typeface="Replica LL TT" pitchFamily="34" charset="-122"/>
-                <a:cs typeface="Replica LL TT" pitchFamily="34" charset="-120"/>
-              </a:rPr>
-              <a:t>Christina Wiig</a:t>
-            </a:r>
-            <a:endParaRPr lang="en-US" sz="2100" dirty="0"/>
-          </a:p>
-        </p:txBody>
-      </p:sp>
-      <p:sp>
-        <p:nvSpPr>
-          <p:cNvPr id="6" name="Text 3"/>
-          <p:cNvSpPr/>
-          <p:nvPr/>
-        </p:nvSpPr>
-        <p:spPr>
-          <a:xfrm>
-            <a:off x="777240" y="5093208"/>
-            <a:ext cx="2240280" cy="694944"/>
-          </a:xfrm>
-          <a:prstGeom prst="rect">
-            <a:avLst/>
-          </a:prstGeom>
-          <a:noFill/>
-          <a:ln/>
-        </p:spPr>
-        <p:txBody>
-          <a:bodyPr wrap="square" lIns="0" tIns="0" rIns="0" bIns="0" rtlCol="0" anchor="t"/>
-          <a:lstStyle/>
-          <a:p>
-            <a:pPr algn="ctr" indent="0" marL="0">
-              <a:lnSpc>
-                <a:spcPct val="115000"/>
-              </a:lnSpc>
-              <a:buNone/>
-            </a:pPr>
-            <a:r>
-              <a:rPr lang="en-US" sz="1800" dirty="0">
-                <a:solidFill>
-                  <a:srgbClr val="5A6166"/>
-                </a:solidFill>
-                <a:latin typeface="Inter" pitchFamily="34" charset="0"/>
-                <a:ea typeface="Inter" pitchFamily="34" charset="-122"/>
-                <a:cs typeface="Inter" pitchFamily="34" charset="-120"/>
-              </a:rPr>
-              <a:t>Head of Corporate Partnerships</a:t>
-            </a:r>
-            <a:endParaRPr lang="en-US" sz="1800" dirty="0"/>
-          </a:p>
-        </p:txBody>
-      </p:sp>
-      <p:pic>
-        <p:nvPicPr>
-          <p:cNvPr id="7" name="Image 1" descr="C:\Code\Work\startuplab-partner-presentation\pptx-templates\media\portrait-2.jpg">    </p:cNvPr>
-          <p:cNvPicPr>
-            <a:picLocks noChangeAspect="1"/>
-          </p:cNvPicPr>
-          <p:nvPr/>
-        </p:nvPicPr>
-        <p:blipFill>
-          <a:blip r:embed="rId2"/>
-          <a:srcRect l="0" r="0" t="0" b="0"/>
-          <a:stretch/>
-        </p:blipFill>
-        <p:spPr>
-          <a:xfrm>
-            <a:off x="3576218" y="2286000"/>
-            <a:ext cx="2240280" cy="2240280"/>
-          </a:xfrm>
-          <a:prstGeom prst="ellipse">
-            <a:avLst/>
-          </a:prstGeom>
-        </p:spPr>
-      </p:pic>
-      <p:sp>
-        <p:nvSpPr>
-          <p:cNvPr id="8" name="Text 4"/>
-          <p:cNvSpPr/>
-          <p:nvPr/>
-        </p:nvSpPr>
-        <p:spPr>
-          <a:xfrm>
-            <a:off x="3576218" y="4727448"/>
-            <a:ext cx="2240280" cy="365760"/>
-          </a:xfrm>
-          <a:prstGeom prst="rect">
-            <a:avLst/>
-          </a:prstGeom>
-          <a:noFill/>
-          <a:ln/>
-        </p:spPr>
-        <p:txBody>
-          <a:bodyPr wrap="square" lIns="0" tIns="0" rIns="0" bIns="0" rtlCol="0" anchor="ctr"/>
-          <a:lstStyle/>
-          <a:p>
-            <a:pPr algn="ctr" indent="0" marL="0">
-              <a:buNone/>
-            </a:pPr>
-            <a:r>
-              <a:rPr lang="en-US" sz="2100" b="1" dirty="0">
-                <a:solidFill>
-                  <a:srgbClr val="131415"/>
-                </a:solidFill>
-                <a:latin typeface="Replica LL TT" pitchFamily="34" charset="0"/>
-                <a:ea typeface="Replica LL TT" pitchFamily="34" charset="-122"/>
-                <a:cs typeface="Replica LL TT" pitchFamily="34" charset="-120"/>
-              </a:rPr>
-              <a:t>Anniken Holst</a:t>
-            </a:r>
-            <a:endParaRPr lang="en-US" sz="2100" dirty="0"/>
-          </a:p>
-        </p:txBody>
-      </p:sp>
-      <p:sp>
-        <p:nvSpPr>
-          <p:cNvPr id="9" name="Text 5"/>
-          <p:cNvSpPr/>
-          <p:nvPr/>
-        </p:nvSpPr>
-        <p:spPr>
-          <a:xfrm>
-            <a:off x="3576218" y="5093208"/>
-            <a:ext cx="2240280" cy="694944"/>
-          </a:xfrm>
-          <a:prstGeom prst="rect">
-            <a:avLst/>
-          </a:prstGeom>
-          <a:noFill/>
-          <a:ln/>
-        </p:spPr>
-        <p:txBody>
-          <a:bodyPr wrap="square" lIns="0" tIns="0" rIns="0" bIns="0" rtlCol="0" anchor="t"/>
-          <a:lstStyle/>
-          <a:p>
-            <a:pPr algn="ctr" indent="0" marL="0">
-              <a:lnSpc>
-                <a:spcPct val="115000"/>
-              </a:lnSpc>
-              <a:buNone/>
-            </a:pPr>
-            <a:r>
-              <a:rPr lang="en-US" sz="1800" dirty="0">
-                <a:solidFill>
-                  <a:srgbClr val="5A6166"/>
-                </a:solidFill>
-                <a:latin typeface="Inter" pitchFamily="34" charset="0"/>
-                <a:ea typeface="Inter" pitchFamily="34" charset="-122"/>
-                <a:cs typeface="Inter" pitchFamily="34" charset="-120"/>
-              </a:rPr>
-              <a:t>Partner Manager</a:t>
-            </a:r>
-            <a:endParaRPr lang="en-US" sz="1800" dirty="0"/>
-          </a:p>
-        </p:txBody>
-      </p:sp>
-      <p:pic>
-        <p:nvPicPr>
-          <p:cNvPr id="10" name="Image 2" descr="C:\Code\Work\startuplab-partner-presentation\pptx-templates\media\portrait-3.jpg">    </p:cNvPr>
-          <p:cNvPicPr>
-            <a:picLocks noChangeAspect="1"/>
-          </p:cNvPicPr>
-          <p:nvPr/>
-        </p:nvPicPr>
-        <p:blipFill>
-          <a:blip r:embed="rId3"/>
-          <a:srcRect l="0" r="0" t="0" b="0"/>
-          <a:stretch/>
-        </p:blipFill>
-        <p:spPr>
-          <a:xfrm>
-            <a:off x="6375197" y="2286000"/>
-            <a:ext cx="2240280" cy="2240280"/>
-          </a:xfrm>
-          <a:prstGeom prst="ellipse">
-            <a:avLst/>
-          </a:prstGeom>
-        </p:spPr>
-      </p:pic>
-      <p:sp>
-        <p:nvSpPr>
-          <p:cNvPr id="11" name="Text 6"/>
-          <p:cNvSpPr/>
-          <p:nvPr/>
-        </p:nvSpPr>
-        <p:spPr>
-          <a:xfrm>
-            <a:off x="6375197" y="4727448"/>
-            <a:ext cx="2240280" cy="365760"/>
-          </a:xfrm>
-          <a:prstGeom prst="rect">
-            <a:avLst/>
-          </a:prstGeom>
-          <a:noFill/>
-          <a:ln/>
-        </p:spPr>
-        <p:txBody>
-          <a:bodyPr wrap="square" lIns="0" tIns="0" rIns="0" bIns="0" rtlCol="0" anchor="ctr"/>
-          <a:lstStyle/>
-          <a:p>
-            <a:pPr algn="ctr" indent="0" marL="0">
-              <a:buNone/>
-            </a:pPr>
-            <a:r>
-              <a:rPr lang="en-US" sz="2100" b="1" dirty="0">
-                <a:solidFill>
-                  <a:srgbClr val="131415"/>
-                </a:solidFill>
-                <a:latin typeface="Replica LL TT" pitchFamily="34" charset="0"/>
-                <a:ea typeface="Replica LL TT" pitchFamily="34" charset="-122"/>
-                <a:cs typeface="Replica LL TT" pitchFamily="34" charset="-120"/>
-              </a:rPr>
-              <a:t>Ola Jacobsen</a:t>
-            </a:r>
-            <a:endParaRPr lang="en-US" sz="2100" dirty="0"/>
-          </a:p>
-        </p:txBody>
-      </p:sp>
-      <p:sp>
-        <p:nvSpPr>
-          <p:cNvPr id="12" name="Text 7"/>
-          <p:cNvSpPr/>
-          <p:nvPr/>
-        </p:nvSpPr>
-        <p:spPr>
-          <a:xfrm>
-            <a:off x="6375197" y="5093208"/>
-            <a:ext cx="2240280" cy="694944"/>
-          </a:xfrm>
-          <a:prstGeom prst="rect">
-            <a:avLst/>
-          </a:prstGeom>
-          <a:noFill/>
-          <a:ln/>
-        </p:spPr>
-        <p:txBody>
-          <a:bodyPr wrap="square" lIns="0" tIns="0" rIns="0" bIns="0" rtlCol="0" anchor="t"/>
-          <a:lstStyle/>
-          <a:p>
-            <a:pPr algn="ctr" indent="0" marL="0">
-              <a:lnSpc>
-                <a:spcPct val="115000"/>
-              </a:lnSpc>
-              <a:buNone/>
-            </a:pPr>
-            <a:r>
-              <a:rPr lang="en-US" sz="1800" dirty="0">
-                <a:solidFill>
-                  <a:srgbClr val="5A6166"/>
-                </a:solidFill>
-                <a:latin typeface="Inter" pitchFamily="34" charset="0"/>
-                <a:ea typeface="Inter" pitchFamily="34" charset="-122"/>
-                <a:cs typeface="Inter" pitchFamily="34" charset="-120"/>
-              </a:rPr>
-              <a:t>Partner Manager</a:t>
-            </a:r>
-            <a:endParaRPr lang="en-US" sz="1800" dirty="0"/>
-          </a:p>
-        </p:txBody>
-      </p:sp>
-      <p:sp>
-        <p:nvSpPr>
-          <p:cNvPr id="13" name="Shape 8"/>
-          <p:cNvSpPr/>
-          <p:nvPr/>
-        </p:nvSpPr>
-        <p:spPr>
-          <a:xfrm>
-            <a:off x="9174175" y="2286000"/>
-            <a:ext cx="2240280" cy="2240280"/>
-          </a:xfrm>
-          <a:prstGeom prst="ellipse">
-            <a:avLst/>
-          </a:prstGeom>
-          <a:solidFill>
-            <a:srgbClr val="F0F0F0"/>
-          </a:solidFill>
-          <a:ln w="12700">
-            <a:solidFill>
-              <a:srgbClr val="D8DCDF"/>
-            </a:solidFill>
-            <a:prstDash val="solid"/>
-          </a:ln>
-        </p:spPr>
-      </p:sp>
-      <p:sp>
-        <p:nvSpPr>
-          <p:cNvPr id="14" name="Text 9"/>
-          <p:cNvSpPr/>
-          <p:nvPr/>
-        </p:nvSpPr>
-        <p:spPr>
-          <a:xfrm>
-            <a:off x="9174175" y="2994660"/>
-            <a:ext cx="2240280" cy="822960"/>
-          </a:xfrm>
-          <a:prstGeom prst="rect">
-            <a:avLst/>
-          </a:prstGeom>
-          <a:noFill/>
-          <a:ln/>
-        </p:spPr>
-        <p:txBody>
-          <a:bodyPr wrap="square" lIns="0" tIns="0" rIns="0" bIns="0" rtlCol="0" anchor="ctr"/>
-          <a:lstStyle/>
-          <a:p>
-            <a:pPr algn="ctr" indent="0" marL="0">
-              <a:lnSpc>
-                <a:spcPct val="120000"/>
-              </a:lnSpc>
-              <a:buNone/>
-            </a:pPr>
-            <a:r>
-              <a:rPr lang="en-US" sz="1800" dirty="0">
-                <a:solidFill>
-                  <a:srgbClr val="5A6166"/>
-                </a:solidFill>
-                <a:latin typeface="Inter" pitchFamily="34" charset="0"/>
-                <a:ea typeface="Inter" pitchFamily="34" charset="-122"/>
-                <a:cs typeface="Inter" pitchFamily="34" charset="-120"/>
-              </a:rPr>
-              <a:t>Sett inn</a:t>
-            </a:r>
-            <a:endParaRPr lang="en-US" sz="1800" dirty="0"/>
-          </a:p>
-          <a:p>
-            <a:pPr algn="ctr" indent="0" marL="0">
-              <a:lnSpc>
-                <a:spcPct val="120000"/>
-              </a:lnSpc>
-              <a:buNone/>
-            </a:pPr>
-            <a:r>
-              <a:rPr lang="en-US" sz="1800" dirty="0">
-                <a:solidFill>
-                  <a:srgbClr val="5A6166"/>
-                </a:solidFill>
-                <a:latin typeface="Inter" pitchFamily="34" charset="0"/>
-                <a:ea typeface="Inter" pitchFamily="34" charset="-122"/>
-                <a:cs typeface="Inter" pitchFamily="34" charset="-120"/>
-              </a:rPr>
-              <a:t>portrett</a:t>
-            </a:r>
-            <a:endParaRPr lang="en-US" sz="1800" dirty="0"/>
-          </a:p>
-        </p:txBody>
-      </p:sp>
-      <p:sp>
-        <p:nvSpPr>
-          <p:cNvPr id="15" name="Text 10"/>
-          <p:cNvSpPr/>
-          <p:nvPr/>
-        </p:nvSpPr>
-        <p:spPr>
-          <a:xfrm>
-            <a:off x="9174175" y="4727448"/>
-            <a:ext cx="2240280" cy="365760"/>
-          </a:xfrm>
-          <a:prstGeom prst="rect">
-            <a:avLst/>
-          </a:prstGeom>
-          <a:noFill/>
-          <a:ln/>
-        </p:spPr>
-        <p:txBody>
-          <a:bodyPr wrap="square" lIns="0" tIns="0" rIns="0" bIns="0" rtlCol="0" anchor="ctr"/>
-          <a:lstStyle/>
-          <a:p>
-            <a:pPr algn="ctr" indent="0" marL="0">
-              <a:buNone/>
-            </a:pPr>
-            <a:r>
-              <a:rPr lang="en-US" sz="2100" b="1" dirty="0">
-                <a:solidFill>
-                  <a:srgbClr val="131415"/>
-                </a:solidFill>
-                <a:latin typeface="Replica LL TT" pitchFamily="34" charset="0"/>
-                <a:ea typeface="Replica LL TT" pitchFamily="34" charset="-122"/>
-                <a:cs typeface="Replica LL TT" pitchFamily="34" charset="-120"/>
-              </a:rPr>
-              <a:t>Navn Navnesen</a:t>
-            </a:r>
-            <a:endParaRPr lang="en-US" sz="2100" dirty="0"/>
-          </a:p>
-        </p:txBody>
-      </p:sp>
-      <p:sp>
-        <p:nvSpPr>
-          <p:cNvPr id="16" name="Text 11"/>
-          <p:cNvSpPr/>
-          <p:nvPr/>
-        </p:nvSpPr>
-        <p:spPr>
-          <a:xfrm>
-            <a:off x="9174175" y="5093208"/>
-            <a:ext cx="2240280" cy="694944"/>
-          </a:xfrm>
-          <a:prstGeom prst="rect">
-            <a:avLst/>
-          </a:prstGeom>
-          <a:noFill/>
-          <a:ln/>
-        </p:spPr>
-        <p:txBody>
-          <a:bodyPr wrap="square" lIns="0" tIns="0" rIns="0" bIns="0" rtlCol="0" anchor="t"/>
-          <a:lstStyle/>
-          <a:p>
-            <a:pPr algn="ctr" indent="0" marL="0">
-              <a:lnSpc>
-                <a:spcPct val="115000"/>
-              </a:lnSpc>
-              <a:buNone/>
-            </a:pPr>
-            <a:r>
-              <a:rPr lang="en-US" sz="1800" dirty="0">
-                <a:solidFill>
-                  <a:srgbClr val="5A6166"/>
-                </a:solidFill>
-                <a:latin typeface="Inter" pitchFamily="34" charset="0"/>
-                <a:ea typeface="Inter" pitchFamily="34" charset="-122"/>
-                <a:cs typeface="Inter" pitchFamily="34" charset="-120"/>
-              </a:rPr>
-              <a:t>Rolle her</a:t>
-            </a:r>
-            <a:endParaRPr lang="en-US" sz="1800" dirty="0"/>
-          </a:p>
-        </p:txBody>
-      </p:sp>
-      <p:pic>
-        <p:nvPicPr>
-          <p:cNvPr id="17" name="Image 3" descr="C:\Code\Work\startuplab-partner-presentation\pptx-templates\media\logo-red.png">    </p:cNvPr>
-          <p:cNvPicPr>
-            <a:picLocks noChangeAspect="1"/>
-          </p:cNvPicPr>
-          <p:nvPr/>
-        </p:nvPicPr>
-        <p:blipFill>
-          <a:blip r:embed="rId4"/>
           <a:stretch>
             <a:fillRect/>
           </a:stretch>
@@ -4073,6 +3994,640 @@
 <file path=ppt/slides/slide14.xml><?xml version="1.0" encoding="utf-8"?>
 <p:sld xmlns:a="http://schemas.openxmlformats.org/drawingml/2006/main" xmlns:r="http://schemas.openxmlformats.org/officeDocument/2006/relationships" xmlns:p="http://schemas.openxmlformats.org/presentationml/2006/main">
   <p:cSld name="Slide 14">
+    <p:bg>
+      <p:bgPr>
+        <a:solidFill>
+          <a:srgbClr val="FFFFFF"/>
+        </a:solidFill>
+      </p:bgPr>
+    </p:bg>
+    <p:spTree>
+      <p:nvGrpSpPr>
+        <p:cNvPr id="1" name=""/>
+        <p:cNvGrpSpPr/>
+        <p:nvPr/>
+      </p:nvGrpSpPr>
+      <p:grpSpPr>
+        <a:xfrm>
+          <a:off x="0" y="0"/>
+          <a:ext cx="0" cy="0"/>
+          <a:chOff x="0" y="0"/>
+          <a:chExt cx="0" cy="0"/>
+        </a:xfrm>
+      </p:grpSpPr>
+      <p:sp>
+        <p:nvSpPr>
+          <p:cNvPr id="2" name="Text 0"/>
+          <p:cNvSpPr/>
+          <p:nvPr/>
+        </p:nvSpPr>
+        <p:spPr>
+          <a:xfrm>
+            <a:off x="777240" y="713232"/>
+            <a:ext cx="8229600" cy="292608"/>
+          </a:xfrm>
+          <a:prstGeom prst="rect">
+            <a:avLst/>
+          </a:prstGeom>
+          <a:noFill/>
+          <a:ln/>
+        </p:spPr>
+        <p:txBody>
+          <a:bodyPr wrap="square" lIns="0" tIns="0" rIns="0" bIns="0" rtlCol="0" anchor="ctr"/>
+          <a:lstStyle/>
+          <a:p>
+            <a:pPr indent="0" marL="0">
+              <a:buNone/>
+            </a:pPr>
+            <a:r>
+              <a:rPr lang="en-US" sz="1600" b="1" spc="250" kern="0" dirty="0">
+                <a:solidFill>
+                  <a:srgbClr val="FF3333"/>
+                </a:solidFill>
+                <a:latin typeface="Inter" pitchFamily="34" charset="0"/>
+                <a:ea typeface="Inter" pitchFamily="34" charset="-122"/>
+                <a:cs typeface="Inter" pitchFamily="34" charset="-120"/>
+              </a:rPr>
+              <a:t>TEAMET</a:t>
+            </a:r>
+            <a:endParaRPr lang="en-US" sz="1600" dirty="0"/>
+          </a:p>
+        </p:txBody>
+      </p:sp>
+      <p:sp>
+        <p:nvSpPr>
+          <p:cNvPr id="3" name="Text 1"/>
+          <p:cNvSpPr/>
+          <p:nvPr/>
+        </p:nvSpPr>
+        <p:spPr>
+          <a:xfrm>
+            <a:off x="777240" y="1051560"/>
+            <a:ext cx="10424160" cy="777240"/>
+          </a:xfrm>
+          <a:prstGeom prst="rect">
+            <a:avLst/>
+          </a:prstGeom>
+          <a:noFill/>
+          <a:ln/>
+        </p:spPr>
+        <p:txBody>
+          <a:bodyPr wrap="square" lIns="0" tIns="0" rIns="0" bIns="0" rtlCol="0" anchor="t"/>
+          <a:lstStyle/>
+          <a:p>
+            <a:pPr indent="0" marL="0">
+              <a:lnSpc>
+                <a:spcPct val="100000"/>
+              </a:lnSpc>
+              <a:buNone/>
+            </a:pPr>
+            <a:r>
+              <a:rPr lang="en-US" sz="4000" b="1" dirty="0">
+                <a:solidFill>
+                  <a:srgbClr val="131415"/>
+                </a:solidFill>
+                <a:latin typeface="Replica LL TT" pitchFamily="34" charset="0"/>
+                <a:ea typeface="Replica LL TT" pitchFamily="34" charset="-122"/>
+                <a:cs typeface="Replica LL TT" pitchFamily="34" charset="-120"/>
+              </a:rPr>
+              <a:t>Folkene du kommer til å </a:t>
+            </a:r>
+            <a:pPr indent="0" marL="0">
+              <a:lnSpc>
+                <a:spcPct val="100000"/>
+              </a:lnSpc>
+              <a:buNone/>
+            </a:pPr>
+            <a:r>
+              <a:rPr lang="en-US" sz="4000" b="1" dirty="0">
+                <a:solidFill>
+                  <a:srgbClr val="FF3333"/>
+                </a:solidFill>
+                <a:latin typeface="Replica LL TT" pitchFamily="34" charset="0"/>
+                <a:ea typeface="Replica LL TT" pitchFamily="34" charset="-122"/>
+                <a:cs typeface="Replica LL TT" pitchFamily="34" charset="-120"/>
+              </a:rPr>
+              <a:t>jobbe med</a:t>
+            </a:r>
+            <a:endParaRPr lang="en-US" sz="4000" dirty="0"/>
+          </a:p>
+        </p:txBody>
+      </p:sp>
+      <p:pic>
+        <p:nvPicPr>
+          <p:cNvPr id="4" name="Image 0" descr="C:\Code\Work\startuplab-partner-presentation\pptx-templates\media\portrait-1.jpg">    </p:cNvPr>
+          <p:cNvPicPr>
+            <a:picLocks noChangeAspect="1"/>
+          </p:cNvPicPr>
+          <p:nvPr/>
+        </p:nvPicPr>
+        <p:blipFill>
+          <a:blip r:embed="rId1"/>
+          <a:srcRect l="0" r="0" t="0" b="0"/>
+          <a:stretch/>
+        </p:blipFill>
+        <p:spPr>
+          <a:xfrm>
+            <a:off x="777240" y="2286000"/>
+            <a:ext cx="2240280" cy="2240280"/>
+          </a:xfrm>
+          <a:prstGeom prst="ellipse">
+            <a:avLst/>
+          </a:prstGeom>
+        </p:spPr>
+      </p:pic>
+      <p:sp>
+        <p:nvSpPr>
+          <p:cNvPr id="5" name="Text 2"/>
+          <p:cNvSpPr/>
+          <p:nvPr/>
+        </p:nvSpPr>
+        <p:spPr>
+          <a:xfrm>
+            <a:off x="777240" y="4727448"/>
+            <a:ext cx="2240280" cy="365760"/>
+          </a:xfrm>
+          <a:prstGeom prst="rect">
+            <a:avLst/>
+          </a:prstGeom>
+          <a:noFill/>
+          <a:ln/>
+        </p:spPr>
+        <p:txBody>
+          <a:bodyPr wrap="square" lIns="0" tIns="0" rIns="0" bIns="0" rtlCol="0" anchor="ctr"/>
+          <a:lstStyle/>
+          <a:p>
+            <a:pPr algn="ctr" indent="0" marL="0">
+              <a:buNone/>
+            </a:pPr>
+            <a:r>
+              <a:rPr lang="en-US" sz="2100" b="1" dirty="0">
+                <a:solidFill>
+                  <a:srgbClr val="131415"/>
+                </a:solidFill>
+                <a:latin typeface="Replica LL TT" pitchFamily="34" charset="0"/>
+                <a:ea typeface="Replica LL TT" pitchFamily="34" charset="-122"/>
+                <a:cs typeface="Replica LL TT" pitchFamily="34" charset="-120"/>
+              </a:rPr>
+              <a:t>Christina Wiig</a:t>
+            </a:r>
+            <a:endParaRPr lang="en-US" sz="2100" dirty="0"/>
+          </a:p>
+        </p:txBody>
+      </p:sp>
+      <p:sp>
+        <p:nvSpPr>
+          <p:cNvPr id="6" name="Text 3"/>
+          <p:cNvSpPr/>
+          <p:nvPr/>
+        </p:nvSpPr>
+        <p:spPr>
+          <a:xfrm>
+            <a:off x="777240" y="5093208"/>
+            <a:ext cx="2240280" cy="694944"/>
+          </a:xfrm>
+          <a:prstGeom prst="rect">
+            <a:avLst/>
+          </a:prstGeom>
+          <a:noFill/>
+          <a:ln/>
+        </p:spPr>
+        <p:txBody>
+          <a:bodyPr wrap="square" lIns="0" tIns="0" rIns="0" bIns="0" rtlCol="0" anchor="t"/>
+          <a:lstStyle/>
+          <a:p>
+            <a:pPr algn="ctr" indent="0" marL="0">
+              <a:lnSpc>
+                <a:spcPct val="115000"/>
+              </a:lnSpc>
+              <a:buNone/>
+            </a:pPr>
+            <a:r>
+              <a:rPr lang="en-US" sz="1800" dirty="0">
+                <a:solidFill>
+                  <a:srgbClr val="5A6166"/>
+                </a:solidFill>
+                <a:latin typeface="Inter" pitchFamily="34" charset="0"/>
+                <a:ea typeface="Inter" pitchFamily="34" charset="-122"/>
+                <a:cs typeface="Inter" pitchFamily="34" charset="-120"/>
+              </a:rPr>
+              <a:t>Head of Corporate Partnerships</a:t>
+            </a:r>
+            <a:endParaRPr lang="en-US" sz="1800" dirty="0"/>
+          </a:p>
+        </p:txBody>
+      </p:sp>
+      <p:pic>
+        <p:nvPicPr>
+          <p:cNvPr id="7" name="Image 1" descr="C:\Code\Work\startuplab-partner-presentation\pptx-templates\media\portrait-2.jpg">    </p:cNvPr>
+          <p:cNvPicPr>
+            <a:picLocks noChangeAspect="1"/>
+          </p:cNvPicPr>
+          <p:nvPr/>
+        </p:nvPicPr>
+        <p:blipFill>
+          <a:blip r:embed="rId2"/>
+          <a:srcRect l="0" r="0" t="0" b="0"/>
+          <a:stretch/>
+        </p:blipFill>
+        <p:spPr>
+          <a:xfrm>
+            <a:off x="3576218" y="2286000"/>
+            <a:ext cx="2240280" cy="2240280"/>
+          </a:xfrm>
+          <a:prstGeom prst="ellipse">
+            <a:avLst/>
+          </a:prstGeom>
+        </p:spPr>
+      </p:pic>
+      <p:sp>
+        <p:nvSpPr>
+          <p:cNvPr id="8" name="Text 4"/>
+          <p:cNvSpPr/>
+          <p:nvPr/>
+        </p:nvSpPr>
+        <p:spPr>
+          <a:xfrm>
+            <a:off x="3576218" y="4727448"/>
+            <a:ext cx="2240280" cy="365760"/>
+          </a:xfrm>
+          <a:prstGeom prst="rect">
+            <a:avLst/>
+          </a:prstGeom>
+          <a:noFill/>
+          <a:ln/>
+        </p:spPr>
+        <p:txBody>
+          <a:bodyPr wrap="square" lIns="0" tIns="0" rIns="0" bIns="0" rtlCol="0" anchor="ctr"/>
+          <a:lstStyle/>
+          <a:p>
+            <a:pPr algn="ctr" indent="0" marL="0">
+              <a:buNone/>
+            </a:pPr>
+            <a:r>
+              <a:rPr lang="en-US" sz="2100" b="1" dirty="0">
+                <a:solidFill>
+                  <a:srgbClr val="131415"/>
+                </a:solidFill>
+                <a:latin typeface="Replica LL TT" pitchFamily="34" charset="0"/>
+                <a:ea typeface="Replica LL TT" pitchFamily="34" charset="-122"/>
+                <a:cs typeface="Replica LL TT" pitchFamily="34" charset="-120"/>
+              </a:rPr>
+              <a:t>Anniken Holst</a:t>
+            </a:r>
+            <a:endParaRPr lang="en-US" sz="2100" dirty="0"/>
+          </a:p>
+        </p:txBody>
+      </p:sp>
+      <p:sp>
+        <p:nvSpPr>
+          <p:cNvPr id="9" name="Text 5"/>
+          <p:cNvSpPr/>
+          <p:nvPr/>
+        </p:nvSpPr>
+        <p:spPr>
+          <a:xfrm>
+            <a:off x="3576218" y="5093208"/>
+            <a:ext cx="2240280" cy="694944"/>
+          </a:xfrm>
+          <a:prstGeom prst="rect">
+            <a:avLst/>
+          </a:prstGeom>
+          <a:noFill/>
+          <a:ln/>
+        </p:spPr>
+        <p:txBody>
+          <a:bodyPr wrap="square" lIns="0" tIns="0" rIns="0" bIns="0" rtlCol="0" anchor="t"/>
+          <a:lstStyle/>
+          <a:p>
+            <a:pPr algn="ctr" indent="0" marL="0">
+              <a:lnSpc>
+                <a:spcPct val="115000"/>
+              </a:lnSpc>
+              <a:buNone/>
+            </a:pPr>
+            <a:r>
+              <a:rPr lang="en-US" sz="1800" dirty="0">
+                <a:solidFill>
+                  <a:srgbClr val="5A6166"/>
+                </a:solidFill>
+                <a:latin typeface="Inter" pitchFamily="34" charset="0"/>
+                <a:ea typeface="Inter" pitchFamily="34" charset="-122"/>
+                <a:cs typeface="Inter" pitchFamily="34" charset="-120"/>
+              </a:rPr>
+              <a:t>Partner Manager</a:t>
+            </a:r>
+            <a:endParaRPr lang="en-US" sz="1800" dirty="0"/>
+          </a:p>
+        </p:txBody>
+      </p:sp>
+      <p:pic>
+        <p:nvPicPr>
+          <p:cNvPr id="10" name="Image 2" descr="C:\Code\Work\startuplab-partner-presentation\pptx-templates\media\portrait-3.jpg">    </p:cNvPr>
+          <p:cNvPicPr>
+            <a:picLocks noChangeAspect="1"/>
+          </p:cNvPicPr>
+          <p:nvPr/>
+        </p:nvPicPr>
+        <p:blipFill>
+          <a:blip r:embed="rId3"/>
+          <a:srcRect l="0" r="0" t="0" b="0"/>
+          <a:stretch/>
+        </p:blipFill>
+        <p:spPr>
+          <a:xfrm>
+            <a:off x="6375197" y="2286000"/>
+            <a:ext cx="2240280" cy="2240280"/>
+          </a:xfrm>
+          <a:prstGeom prst="ellipse">
+            <a:avLst/>
+          </a:prstGeom>
+        </p:spPr>
+      </p:pic>
+      <p:sp>
+        <p:nvSpPr>
+          <p:cNvPr id="11" name="Text 6"/>
+          <p:cNvSpPr/>
+          <p:nvPr/>
+        </p:nvSpPr>
+        <p:spPr>
+          <a:xfrm>
+            <a:off x="6375197" y="4727448"/>
+            <a:ext cx="2240280" cy="365760"/>
+          </a:xfrm>
+          <a:prstGeom prst="rect">
+            <a:avLst/>
+          </a:prstGeom>
+          <a:noFill/>
+          <a:ln/>
+        </p:spPr>
+        <p:txBody>
+          <a:bodyPr wrap="square" lIns="0" tIns="0" rIns="0" bIns="0" rtlCol="0" anchor="ctr"/>
+          <a:lstStyle/>
+          <a:p>
+            <a:pPr algn="ctr" indent="0" marL="0">
+              <a:buNone/>
+            </a:pPr>
+            <a:r>
+              <a:rPr lang="en-US" sz="2100" b="1" dirty="0">
+                <a:solidFill>
+                  <a:srgbClr val="131415"/>
+                </a:solidFill>
+                <a:latin typeface="Replica LL TT" pitchFamily="34" charset="0"/>
+                <a:ea typeface="Replica LL TT" pitchFamily="34" charset="-122"/>
+                <a:cs typeface="Replica LL TT" pitchFamily="34" charset="-120"/>
+              </a:rPr>
+              <a:t>Ola Jacobsen</a:t>
+            </a:r>
+            <a:endParaRPr lang="en-US" sz="2100" dirty="0"/>
+          </a:p>
+        </p:txBody>
+      </p:sp>
+      <p:sp>
+        <p:nvSpPr>
+          <p:cNvPr id="12" name="Text 7"/>
+          <p:cNvSpPr/>
+          <p:nvPr/>
+        </p:nvSpPr>
+        <p:spPr>
+          <a:xfrm>
+            <a:off x="6375197" y="5093208"/>
+            <a:ext cx="2240280" cy="694944"/>
+          </a:xfrm>
+          <a:prstGeom prst="rect">
+            <a:avLst/>
+          </a:prstGeom>
+          <a:noFill/>
+          <a:ln/>
+        </p:spPr>
+        <p:txBody>
+          <a:bodyPr wrap="square" lIns="0" tIns="0" rIns="0" bIns="0" rtlCol="0" anchor="t"/>
+          <a:lstStyle/>
+          <a:p>
+            <a:pPr algn="ctr" indent="0" marL="0">
+              <a:lnSpc>
+                <a:spcPct val="115000"/>
+              </a:lnSpc>
+              <a:buNone/>
+            </a:pPr>
+            <a:r>
+              <a:rPr lang="en-US" sz="1800" dirty="0">
+                <a:solidFill>
+                  <a:srgbClr val="5A6166"/>
+                </a:solidFill>
+                <a:latin typeface="Inter" pitchFamily="34" charset="0"/>
+                <a:ea typeface="Inter" pitchFamily="34" charset="-122"/>
+                <a:cs typeface="Inter" pitchFamily="34" charset="-120"/>
+              </a:rPr>
+              <a:t>Partner Manager</a:t>
+            </a:r>
+            <a:endParaRPr lang="en-US" sz="1800" dirty="0"/>
+          </a:p>
+        </p:txBody>
+      </p:sp>
+      <p:sp>
+        <p:nvSpPr>
+          <p:cNvPr id="13" name="Shape 8"/>
+          <p:cNvSpPr/>
+          <p:nvPr/>
+        </p:nvSpPr>
+        <p:spPr>
+          <a:xfrm>
+            <a:off x="9174175" y="2286000"/>
+            <a:ext cx="2240280" cy="2240280"/>
+          </a:xfrm>
+          <a:prstGeom prst="ellipse">
+            <a:avLst/>
+          </a:prstGeom>
+          <a:solidFill>
+            <a:srgbClr val="F0F0F0"/>
+          </a:solidFill>
+          <a:ln w="12700">
+            <a:solidFill>
+              <a:srgbClr val="D8DCDF"/>
+            </a:solidFill>
+            <a:prstDash val="solid"/>
+          </a:ln>
+        </p:spPr>
+      </p:sp>
+      <p:sp>
+        <p:nvSpPr>
+          <p:cNvPr id="14" name="Text 9"/>
+          <p:cNvSpPr/>
+          <p:nvPr/>
+        </p:nvSpPr>
+        <p:spPr>
+          <a:xfrm>
+            <a:off x="9174175" y="2994660"/>
+            <a:ext cx="2240280" cy="822960"/>
+          </a:xfrm>
+          <a:prstGeom prst="rect">
+            <a:avLst/>
+          </a:prstGeom>
+          <a:noFill/>
+          <a:ln/>
+        </p:spPr>
+        <p:txBody>
+          <a:bodyPr wrap="square" lIns="0" tIns="0" rIns="0" bIns="0" rtlCol="0" anchor="ctr"/>
+          <a:lstStyle/>
+          <a:p>
+            <a:pPr algn="ctr" indent="0" marL="0">
+              <a:lnSpc>
+                <a:spcPct val="120000"/>
+              </a:lnSpc>
+              <a:buNone/>
+            </a:pPr>
+            <a:r>
+              <a:rPr lang="en-US" sz="1800" dirty="0">
+                <a:solidFill>
+                  <a:srgbClr val="5A6166"/>
+                </a:solidFill>
+                <a:latin typeface="Inter" pitchFamily="34" charset="0"/>
+                <a:ea typeface="Inter" pitchFamily="34" charset="-122"/>
+                <a:cs typeface="Inter" pitchFamily="34" charset="-120"/>
+              </a:rPr>
+              <a:t>Sett inn</a:t>
+            </a:r>
+            <a:endParaRPr lang="en-US" sz="1800" dirty="0"/>
+          </a:p>
+          <a:p>
+            <a:pPr algn="ctr" indent="0" marL="0">
+              <a:lnSpc>
+                <a:spcPct val="120000"/>
+              </a:lnSpc>
+              <a:buNone/>
+            </a:pPr>
+            <a:r>
+              <a:rPr lang="en-US" sz="1800" dirty="0">
+                <a:solidFill>
+                  <a:srgbClr val="5A6166"/>
+                </a:solidFill>
+                <a:latin typeface="Inter" pitchFamily="34" charset="0"/>
+                <a:ea typeface="Inter" pitchFamily="34" charset="-122"/>
+                <a:cs typeface="Inter" pitchFamily="34" charset="-120"/>
+              </a:rPr>
+              <a:t>portrett</a:t>
+            </a:r>
+            <a:endParaRPr lang="en-US" sz="1800" dirty="0"/>
+          </a:p>
+        </p:txBody>
+      </p:sp>
+      <p:sp>
+        <p:nvSpPr>
+          <p:cNvPr id="15" name="Text 10"/>
+          <p:cNvSpPr/>
+          <p:nvPr/>
+        </p:nvSpPr>
+        <p:spPr>
+          <a:xfrm>
+            <a:off x="9174175" y="4727448"/>
+            <a:ext cx="2240280" cy="365760"/>
+          </a:xfrm>
+          <a:prstGeom prst="rect">
+            <a:avLst/>
+          </a:prstGeom>
+          <a:noFill/>
+          <a:ln/>
+        </p:spPr>
+        <p:txBody>
+          <a:bodyPr wrap="square" lIns="0" tIns="0" rIns="0" bIns="0" rtlCol="0" anchor="ctr"/>
+          <a:lstStyle/>
+          <a:p>
+            <a:pPr algn="ctr" indent="0" marL="0">
+              <a:buNone/>
+            </a:pPr>
+            <a:r>
+              <a:rPr lang="en-US" sz="2100" b="1" dirty="0">
+                <a:solidFill>
+                  <a:srgbClr val="131415"/>
+                </a:solidFill>
+                <a:latin typeface="Replica LL TT" pitchFamily="34" charset="0"/>
+                <a:ea typeface="Replica LL TT" pitchFamily="34" charset="-122"/>
+                <a:cs typeface="Replica LL TT" pitchFamily="34" charset="-120"/>
+              </a:rPr>
+              <a:t>Navn Navnesen</a:t>
+            </a:r>
+            <a:endParaRPr lang="en-US" sz="2100" dirty="0"/>
+          </a:p>
+        </p:txBody>
+      </p:sp>
+      <p:sp>
+        <p:nvSpPr>
+          <p:cNvPr id="16" name="Text 11"/>
+          <p:cNvSpPr/>
+          <p:nvPr/>
+        </p:nvSpPr>
+        <p:spPr>
+          <a:xfrm>
+            <a:off x="9174175" y="5093208"/>
+            <a:ext cx="2240280" cy="694944"/>
+          </a:xfrm>
+          <a:prstGeom prst="rect">
+            <a:avLst/>
+          </a:prstGeom>
+          <a:noFill/>
+          <a:ln/>
+        </p:spPr>
+        <p:txBody>
+          <a:bodyPr wrap="square" lIns="0" tIns="0" rIns="0" bIns="0" rtlCol="0" anchor="t"/>
+          <a:lstStyle/>
+          <a:p>
+            <a:pPr algn="ctr" indent="0" marL="0">
+              <a:lnSpc>
+                <a:spcPct val="115000"/>
+              </a:lnSpc>
+              <a:buNone/>
+            </a:pPr>
+            <a:r>
+              <a:rPr lang="en-US" sz="1800" dirty="0">
+                <a:solidFill>
+                  <a:srgbClr val="5A6166"/>
+                </a:solidFill>
+                <a:latin typeface="Inter" pitchFamily="34" charset="0"/>
+                <a:ea typeface="Inter" pitchFamily="34" charset="-122"/>
+                <a:cs typeface="Inter" pitchFamily="34" charset="-120"/>
+              </a:rPr>
+              <a:t>Rolle her</a:t>
+            </a:r>
+            <a:endParaRPr lang="en-US" sz="1800" dirty="0"/>
+          </a:p>
+        </p:txBody>
+      </p:sp>
+      <p:pic>
+        <p:nvPicPr>
+          <p:cNvPr id="17" name="Image 3" descr="C:\Code\Work\startuplab-partner-presentation\pptx-templates\media\logo-red.png">    </p:cNvPr>
+          <p:cNvPicPr>
+            <a:picLocks noChangeAspect="1"/>
+          </p:cNvPicPr>
+          <p:nvPr/>
+        </p:nvPicPr>
+        <p:blipFill>
+          <a:blip r:embed="rId4"/>
+          <a:stretch>
+            <a:fillRect/>
+          </a:stretch>
+        </p:blipFill>
+        <p:spPr>
+          <a:xfrm>
+            <a:off x="777240" y="6035040"/>
+            <a:ext cx="843006" cy="310896"/>
+          </a:xfrm>
+          <a:prstGeom prst="rect">
+            <a:avLst/>
+          </a:prstGeom>
+        </p:spPr>
+      </p:pic>
+    </p:spTree>
+  </p:cSld>
+  <p:clrMapOvr>
+    <a:masterClrMapping/>
+  </p:clrMapOvr>
+</p:sld>
+</file>
+
+<file path=ppt/slides/slide15.xml><?xml version="1.0" encoding="utf-8"?>
+<p:sld xmlns:a="http://schemas.openxmlformats.org/drawingml/2006/main" xmlns:r="http://schemas.openxmlformats.org/officeDocument/2006/relationships" xmlns:p="http://schemas.openxmlformats.org/presentationml/2006/main">
+  <p:cSld name="Slide 15">
     <p:bg>
       <p:bgPr>
         <a:solidFill>
@@ -4278,9 +4833,9 @@
 </p:sld>
 </file>
 
-<file path=ppt/slides/slide15.xml><?xml version="1.0" encoding="utf-8"?>
+<file path=ppt/slides/slide16.xml><?xml version="1.0" encoding="utf-8"?>
 <p:sld xmlns:a="http://schemas.openxmlformats.org/drawingml/2006/main" xmlns:r="http://schemas.openxmlformats.org/officeDocument/2006/relationships" xmlns:p="http://schemas.openxmlformats.org/presentationml/2006/main">
-  <p:cSld name="Slide 15">
+  <p:cSld name="Slide 16">
     <p:bg>
       <p:bgPr>
         <a:solidFill>

</xml_diff>

<commit_message>
Legg til mal med fire bilder i rutenett og tekst på siden
Fire liggende bilder i 2x2 til høyre, all teksten samlet til venstre. Følger
samme vertikale rytme som «tekst og bilde», så de to delte oppsettene
harmonerer. Rutenettets høyre kant flukter med margen, toppen med kickeren.

Fikser samtidig en feil i accented(): et linjeskift rett foran et farget ord
ga en tom tekstbit, og en tom tekstbit gjør at PowerPoint nekter å åpne fila
i det hele tatt. XSD-validering og python-pptx godtok fila, så det var bare
render-steget som fanget det. Feilen lå latent i alle malene og ville truffet
en tittel skrevet som "...gjorde\n[mest] av".
</commit_message>
<xml_diff>
--- a/pptx-templates/Startuplab-slidemaler.pptx
+++ b/pptx-templates/Startuplab-slidemaler.pptx
@@ -21,9 +21,10 @@
     <p:sldId id="269" r:id="rId15"/>
     <p:sldId id="270" r:id="rId16"/>
     <p:sldId id="271" r:id="rId17"/>
+    <p:sldId id="272" r:id="rId18"/>
   </p:sldIdLst>
   <p:notesMasterIdLst>
-    <p:notesMasterId r:id="rId18"/>
+    <p:notesMasterId r:id="rId19"/>
   </p:notesMasterIdLst>
   <p:sldSz cx="12192000" cy="6858000"/>
   <p:notesSz cx="6858000" cy="12192000"/>
@@ -605,7 +606,7 @@
           <a:p>
             <a:r>
               <a:rPr lang="en-US" dirty="0"/>
-              <a:t>UTSAGN. Én setning, maks tre linjer. Dette er sliden du lar henge i stillhet et par sekunder før du snakker videre.</a:t>
+              <a:t>TEKST OG BILDERUTENETT. Fire liggende bilder i 2x2 med forklaringen samlet på venstre side, i stedet for bildetekst under hvert bilde. Bytt bilde: høyreklikk &gt; Endre bilde, utsnittet beholdes. Vil du ha bildene til venstre og teksten til høyre: marker alle fire bildene og dra dem over, og flytt tekstblokken motsatt vei. Kjør prepare-media.py på nye bilder, så får de samme lysstyrke som de andre.</a:t>
             </a:r>
             <a:endParaRPr lang="en-US" dirty="0"/>
           </a:p>
@@ -693,7 +694,7 @@
           <a:p>
             <a:r>
               <a:rPr lang="en-US" dirty="0"/>
-              <a:t>SITAT. Hold sitatet under 25 ord, ellers slutter salen å lese før du er ferdig å snakke. Både sitatet og navnet er plassholdere: bytt dem før du presenterer. Sirkelen er rundt maskert, så et innsatt portrett beholder formen.</a:t>
+              <a:t>UTSAGN. Én setning, maks tre linjer. Dette er sliden du lar henge i stillhet et par sekunder før du snakker videre.</a:t>
             </a:r>
             <a:endParaRPr lang="en-US" dirty="0"/>
           </a:p>
@@ -781,7 +782,7 @@
           <a:p>
             <a:r>
               <a:rPr lang="en-US" dirty="0"/>
-              <a:t>BILDERAD. Bildeteksten ligger under bildet, ikke oppå det, nettopp for å være lesbar fra bakerste rad. Overskriften i hvitt er 20 pt, forklaringen 18 pt. Bytt bilde: høyreklikk &gt; Endre bilde, utsnittet beholdes. Vil du ha fire bilder i stedet for tre: marker et bilde med tekstene under, kopier settet, og sett bildebredden til 2,6 tommer på alle fire. Hold forklaringen til to linjer, ellers treffer den logoen. Kjør prepare-media.py på nye bilder, så legges de i samme lysstyrke som de andre.</a:t>
+              <a:t>SITAT. Hold sitatet under 25 ord, ellers slutter salen å lese før du er ferdig å snakke. Både sitatet og navnet er plassholdere: bytt dem før du presenterer. Sirkelen er rundt maskert, så et innsatt portrett beholder formen.</a:t>
             </a:r>
             <a:endParaRPr lang="en-US" dirty="0"/>
           </a:p>
@@ -869,7 +870,7 @@
           <a:p>
             <a:r>
               <a:rPr lang="en-US" dirty="0"/>
-              <a:t>PROSESS. Det røde tallet viser hvor i løpet du er. Flytt den røde fargen til neste steg hvis du gjenbruker sliden lenger ut i presentasjonen.</a:t>
+              <a:t>BILDERAD. Bildeteksten ligger under bildet, ikke oppå det, nettopp for å være lesbar fra bakerste rad. Overskriften i hvitt er 20 pt, forklaringen 18 pt. Bytt bilde: høyreklikk &gt; Endre bilde, utsnittet beholdes. Vil du ha fire bilder i stedet for tre: marker et bilde med tekstene under, kopier settet, og sett bildebredden til 2,6 tommer på alle fire. Hold forklaringen til to linjer, ellers treffer den logoen. Kjør prepare-media.py på nye bilder, så legges de i samme lysstyrke som de andre.</a:t>
             </a:r>
             <a:endParaRPr lang="en-US" dirty="0"/>
           </a:p>
@@ -957,7 +958,7 @@
           <a:p>
             <a:r>
               <a:rPr lang="en-US" dirty="0"/>
-              <a:t>FOLK. Fire portretter spenner fra marg til marg. Bytt portrett: høyreklikk &gt; Endre bilde, den runde masken følger med. Den grå sirkelen er en ledig plass. Sjekk at rollene stemmer før du presenterer.</a:t>
+              <a:t>PROSESS. Det røde tallet viser hvor i løpet du er. Flytt den røde fargen til neste steg hvis du gjenbruker sliden lenger ut i presentasjonen.</a:t>
             </a:r>
             <a:endParaRPr lang="en-US" dirty="0"/>
           </a:p>
@@ -1045,7 +1046,7 @@
           <a:p>
             <a:r>
               <a:rPr lang="en-US" dirty="0"/>
-              <a:t>FILM. Slik legger du inn filmen: Sett inn &gt; Video &gt; Denne enheten. Dra filmen så den dekker hele flaten, høyreklikk &gt; Send bakover slik at tittelen og avspillingsmerket blir liggende oppå. Under Avspilling velger du Start automatisk hvis den skal gå av seg selv. Slett den røde sirkelen og trekanten når den ekte filmen er på plass.</a:t>
+              <a:t>FOLK. Fire portretter spenner fra marg til marg. Bytt portrett: høyreklikk &gt; Endre bilde, den runde masken følger med. Den grå sirkelen er en ledig plass. Sjekk at rollene stemmer før du presenterer.</a:t>
             </a:r>
             <a:endParaRPr lang="en-US" dirty="0"/>
           </a:p>
@@ -1133,7 +1134,7 @@
           <a:p>
             <a:r>
               <a:rPr lang="en-US" dirty="0"/>
-              <a:t>AVSLUTNING. La den stå på skjermen mens du tar spørsmål. Legg til e-post eller kontaktperson på linjen under nettadressen hvis salen skal kunne følge opp.</a:t>
+              <a:t>FILM. Slik legger du inn filmen: Sett inn &gt; Video &gt; Denne enheten. Dra filmen så den dekker hele flaten, høyreklikk &gt; Send bakover slik at tittelen og avspillingsmerket blir liggende oppå. Under Avspilling velger du Start automatisk hvis den skal gå av seg selv. Slett den røde sirkelen og trekanten når den ekte filmen er på plass.</a:t>
             </a:r>
             <a:endParaRPr lang="en-US" dirty="0"/>
           </a:p>
@@ -1157,6 +1158,94 @@
             <a:fld id="{F7021451-1387-4CA6-816F-3879F97B5CBC}" type="slidenum">
               <a:rPr lang="en-US"/>
               <a:t>16</a:t>
+            </a:fld>
+            <a:endParaRPr lang="en-US"/>
+          </a:p>
+        </p:txBody>
+      </p:sp>
+    </p:spTree>
+    <p:extLst>
+      <p:ext uri="{BB962C8B-B14F-4D97-AF65-F5344CB8AC3E}">
+        <p14:creationId xmlns:p14="http://schemas.microsoft.com/office/powerpoint/2010/main" val="1024086991"/>
+      </p:ext>
+    </p:extLst>
+  </p:cSld>
+  <p:clrMapOvr>
+    <a:masterClrMapping/>
+  </p:clrMapOvr>
+</p:notes>
+</file>
+
+<file path=ppt/notesSlides/notesSlide17.xml><?xml version="1.0" encoding="utf-8"?>
+<p:notes xmlns:a="http://schemas.openxmlformats.org/drawingml/2006/main" xmlns:r="http://schemas.openxmlformats.org/officeDocument/2006/relationships" xmlns:p="http://schemas.openxmlformats.org/presentationml/2006/main">
+  <p:cSld>
+    <p:spTree>
+      <p:nvGrpSpPr>
+        <p:cNvPr id="1" name=""/>
+        <p:cNvGrpSpPr/>
+        <p:nvPr/>
+      </p:nvGrpSpPr>
+      <p:grpSpPr>
+        <a:xfrm>
+          <a:off x="0" y="0"/>
+          <a:ext cx="0" cy="0"/>
+          <a:chOff x="0" y="0"/>
+          <a:chExt cx="0" cy="0"/>
+        </a:xfrm>
+      </p:grpSpPr>
+      <p:sp>
+        <p:nvSpPr>
+          <p:cNvPr id="2" name="Slide Image Placeholder 1"/>
+          <p:cNvSpPr>
+            <a:spLocks noGrp="1" noRot="1" noChangeAspect="1"/>
+          </p:cNvSpPr>
+          <p:nvPr>
+            <p:ph type="sldImg"/>
+          </p:nvPr>
+        </p:nvSpPr>
+        <p:spPr/>
+      </p:sp>
+      <p:sp>
+        <p:nvSpPr>
+          <p:cNvPr id="3" name="Notes Placeholder 2"/>
+          <p:cNvSpPr>
+            <a:spLocks noGrp="1"/>
+          </p:cNvSpPr>
+          <p:nvPr>
+            <p:ph type="body" idx="1"/>
+          </p:nvPr>
+        </p:nvSpPr>
+        <p:spPr/>
+        <p:txBody>
+          <a:bodyPr/>
+          <a:lstStyle/>
+          <a:p>
+            <a:r>
+              <a:rPr lang="en-US" dirty="0"/>
+              <a:t>AVSLUTNING. La den stå på skjermen mens du tar spørsmål. Legg til e-post eller kontaktperson på linjen under nettadressen hvis salen skal kunne følge opp.</a:t>
+            </a:r>
+            <a:endParaRPr lang="en-US" dirty="0"/>
+          </a:p>
+        </p:txBody>
+      </p:sp>
+      <p:sp>
+        <p:nvSpPr>
+          <p:cNvPr id="4" name="Slide Number Placeholder 3"/>
+          <p:cNvSpPr>
+            <a:spLocks noGrp="1"/>
+          </p:cNvSpPr>
+          <p:nvPr>
+            <p:ph type="sldNum" sz="quarter" idx="10"/>
+          </p:nvPr>
+        </p:nvSpPr>
+        <p:spPr/>
+        <p:txBody>
+          <a:bodyPr/>
+          <a:lstStyle/>
+          <a:p>
+            <a:fld id="{F7021451-1387-4CA6-816F-3879F97B5CBC}" type="slidenum">
+              <a:rPr lang="en-US"/>
+              <a:t>17</a:t>
             </a:fld>
             <a:endParaRPr lang="en-US"/>
           </a:p>
@@ -2440,6 +2529,314 @@
     <p:bg>
       <p:bgPr>
         <a:solidFill>
+          <a:srgbClr val="FFFFFF"/>
+        </a:solidFill>
+      </p:bgPr>
+    </p:bg>
+    <p:spTree>
+      <p:nvGrpSpPr>
+        <p:cNvPr id="1" name=""/>
+        <p:cNvGrpSpPr/>
+        <p:nvPr/>
+      </p:nvGrpSpPr>
+      <p:grpSpPr>
+        <a:xfrm>
+          <a:off x="0" y="0"/>
+          <a:ext cx="0" cy="0"/>
+          <a:chOff x="0" y="0"/>
+          <a:chExt cx="0" cy="0"/>
+        </a:xfrm>
+      </p:grpSpPr>
+      <p:sp>
+        <p:nvSpPr>
+          <p:cNvPr id="2" name="Text 0"/>
+          <p:cNvSpPr/>
+          <p:nvPr/>
+        </p:nvSpPr>
+        <p:spPr>
+          <a:xfrm>
+            <a:off x="777240" y="1783080"/>
+            <a:ext cx="4389120" cy="292608"/>
+          </a:xfrm>
+          <a:prstGeom prst="rect">
+            <a:avLst/>
+          </a:prstGeom>
+          <a:noFill/>
+          <a:ln/>
+        </p:spPr>
+        <p:txBody>
+          <a:bodyPr wrap="square" lIns="0" tIns="0" rIns="0" bIns="0" rtlCol="0" anchor="ctr"/>
+          <a:lstStyle/>
+          <a:p>
+            <a:pPr indent="0" marL="0">
+              <a:buNone/>
+            </a:pPr>
+            <a:r>
+              <a:rPr lang="en-US" sz="1600" b="1" spc="250" kern="0" dirty="0">
+                <a:solidFill>
+                  <a:srgbClr val="FF3333"/>
+                </a:solidFill>
+                <a:latin typeface="Inter" pitchFamily="34" charset="0"/>
+                <a:ea typeface="Inter" pitchFamily="34" charset="-122"/>
+                <a:cs typeface="Inter" pitchFamily="34" charset="-120"/>
+              </a:rPr>
+              <a:t>ÅRET SOM GIKK</a:t>
+            </a:r>
+            <a:endParaRPr lang="en-US" sz="1600" dirty="0"/>
+          </a:p>
+        </p:txBody>
+      </p:sp>
+      <p:sp>
+        <p:nvSpPr>
+          <p:cNvPr id="3" name="Text 1"/>
+          <p:cNvSpPr/>
+          <p:nvPr/>
+        </p:nvSpPr>
+        <p:spPr>
+          <a:xfrm>
+            <a:off x="777240" y="2176272"/>
+            <a:ext cx="4297680" cy="1371600"/>
+          </a:xfrm>
+          <a:prstGeom prst="rect">
+            <a:avLst/>
+          </a:prstGeom>
+          <a:noFill/>
+          <a:ln/>
+        </p:spPr>
+        <p:txBody>
+          <a:bodyPr wrap="square" lIns="0" tIns="0" rIns="0" bIns="0" rtlCol="0" anchor="t"/>
+          <a:lstStyle/>
+          <a:p>
+            <a:pPr indent="0" marL="0">
+              <a:lnSpc>
+                <a:spcPct val="102000"/>
+              </a:lnSpc>
+              <a:buNone/>
+            </a:pPr>
+            <a:r>
+              <a:rPr lang="en-US" sz="3400" b="1" dirty="0">
+                <a:solidFill>
+                  <a:srgbClr val="131415"/>
+                </a:solidFill>
+                <a:latin typeface="Replica LL TT" pitchFamily="34" charset="0"/>
+                <a:ea typeface="Replica LL TT" pitchFamily="34" charset="-122"/>
+                <a:cs typeface="Replica LL TT" pitchFamily="34" charset="-120"/>
+              </a:rPr>
+              <a:t>Fire ting vi gjorde</a:t>
+            </a:r>
+            <a:endParaRPr lang="en-US" sz="3400" dirty="0"/>
+          </a:p>
+          <a:p>
+            <a:pPr indent="0" marL="0">
+              <a:lnSpc>
+                <a:spcPct val="102000"/>
+              </a:lnSpc>
+              <a:buNone/>
+            </a:pPr>
+            <a:r>
+              <a:rPr lang="en-US" sz="3400" b="1" dirty="0">
+                <a:solidFill>
+                  <a:srgbClr val="FF3333"/>
+                </a:solidFill>
+                <a:latin typeface="Replica LL TT" pitchFamily="34" charset="0"/>
+                <a:ea typeface="Replica LL TT" pitchFamily="34" charset="-122"/>
+                <a:cs typeface="Replica LL TT" pitchFamily="34" charset="-120"/>
+              </a:rPr>
+              <a:t>mest</a:t>
+            </a:r>
+            <a:pPr indent="0" marL="0">
+              <a:lnSpc>
+                <a:spcPct val="102000"/>
+              </a:lnSpc>
+              <a:buNone/>
+            </a:pPr>
+            <a:r>
+              <a:rPr lang="en-US" sz="3400" b="1" dirty="0">
+                <a:solidFill>
+                  <a:srgbClr val="131415"/>
+                </a:solidFill>
+                <a:latin typeface="Replica LL TT" pitchFamily="34" charset="0"/>
+                <a:ea typeface="Replica LL TT" pitchFamily="34" charset="-122"/>
+                <a:cs typeface="Replica LL TT" pitchFamily="34" charset="-120"/>
+              </a:rPr>
+              <a:t> av</a:t>
+            </a:r>
+            <a:endParaRPr lang="en-US" sz="3400" dirty="0"/>
+          </a:p>
+        </p:txBody>
+      </p:sp>
+      <p:sp>
+        <p:nvSpPr>
+          <p:cNvPr id="4" name="Text 2"/>
+          <p:cNvSpPr/>
+          <p:nvPr/>
+        </p:nvSpPr>
+        <p:spPr>
+          <a:xfrm>
+            <a:off x="777240" y="3794760"/>
+            <a:ext cx="4206240" cy="1463040"/>
+          </a:xfrm>
+          <a:prstGeom prst="rect">
+            <a:avLst/>
+          </a:prstGeom>
+          <a:noFill/>
+          <a:ln/>
+        </p:spPr>
+        <p:txBody>
+          <a:bodyPr wrap="square" lIns="0" tIns="0" rIns="0" bIns="0" rtlCol="0" anchor="t"/>
+          <a:lstStyle/>
+          <a:p>
+            <a:pPr indent="0" marL="0">
+              <a:lnSpc>
+                <a:spcPct val="140000"/>
+              </a:lnSpc>
+              <a:buNone/>
+            </a:pPr>
+            <a:r>
+              <a:rPr lang="en-US" sz="2000" dirty="0">
+                <a:solidFill>
+                  <a:srgbClr val="131415"/>
+                </a:solidFill>
+                <a:latin typeface="Inter" pitchFamily="34" charset="0"/>
+                <a:ea typeface="Inter" pitchFamily="34" charset="-122"/>
+                <a:cs typeface="Inter" pitchFamily="34" charset="-120"/>
+              </a:rPr>
+              <a:t>Samlinger, befaringer og matchmaking gjennom hele året. 42 arrangementer i alt.</a:t>
+            </a:r>
+            <a:endParaRPr lang="en-US" sz="2000" dirty="0"/>
+          </a:p>
+        </p:txBody>
+      </p:sp>
+      <p:pic>
+        <p:nvPicPr>
+          <p:cNvPr id="5" name="Image 0" descr="C:\Code\Work\startuplab-partner-presentation\pptx-templates\media\grid-1.jpg">    </p:cNvPr>
+          <p:cNvPicPr>
+            <a:picLocks noChangeAspect="1"/>
+          </p:cNvPicPr>
+          <p:nvPr/>
+        </p:nvPicPr>
+        <p:blipFill>
+          <a:blip r:embed="rId1"/>
+          <a:srcRect l="0" r="0" t="0" b="0"/>
+          <a:stretch/>
+        </p:blipFill>
+        <p:spPr>
+          <a:xfrm>
+            <a:off x="5577840" y="1783080"/>
+            <a:ext cx="2781148" cy="1854098"/>
+          </a:xfrm>
+          <a:prstGeom prst="rect">
+            <a:avLst/>
+          </a:prstGeom>
+        </p:spPr>
+      </p:pic>
+      <p:pic>
+        <p:nvPicPr>
+          <p:cNvPr id="6" name="Image 1" descr="C:\Code\Work\startuplab-partner-presentation\pptx-templates\media\grid-2.jpg">    </p:cNvPr>
+          <p:cNvPicPr>
+            <a:picLocks noChangeAspect="1"/>
+          </p:cNvPicPr>
+          <p:nvPr/>
+        </p:nvPicPr>
+        <p:blipFill>
+          <a:blip r:embed="rId2"/>
+          <a:srcRect l="0" r="0" t="0" b="0"/>
+          <a:stretch/>
+        </p:blipFill>
+        <p:spPr>
+          <a:xfrm>
+            <a:off x="8633308" y="1783080"/>
+            <a:ext cx="2781148" cy="1854098"/>
+          </a:xfrm>
+          <a:prstGeom prst="rect">
+            <a:avLst/>
+          </a:prstGeom>
+        </p:spPr>
+      </p:pic>
+      <p:pic>
+        <p:nvPicPr>
+          <p:cNvPr id="7" name="Image 2" descr="C:\Code\Work\startuplab-partner-presentation\pptx-templates\media\grid-3.jpg">    </p:cNvPr>
+          <p:cNvPicPr>
+            <a:picLocks noChangeAspect="1"/>
+          </p:cNvPicPr>
+          <p:nvPr/>
+        </p:nvPicPr>
+        <p:blipFill>
+          <a:blip r:embed="rId3"/>
+          <a:srcRect l="0" r="0" t="0" b="0"/>
+          <a:stretch/>
+        </p:blipFill>
+        <p:spPr>
+          <a:xfrm>
+            <a:off x="5577840" y="3911498"/>
+            <a:ext cx="2781148" cy="1854098"/>
+          </a:xfrm>
+          <a:prstGeom prst="rect">
+            <a:avLst/>
+          </a:prstGeom>
+        </p:spPr>
+      </p:pic>
+      <p:pic>
+        <p:nvPicPr>
+          <p:cNvPr id="8" name="Image 3" descr="C:\Code\Work\startuplab-partner-presentation\pptx-templates\media\grid-4.jpg">    </p:cNvPr>
+          <p:cNvPicPr>
+            <a:picLocks noChangeAspect="1"/>
+          </p:cNvPicPr>
+          <p:nvPr/>
+        </p:nvPicPr>
+        <p:blipFill>
+          <a:blip r:embed="rId4"/>
+          <a:srcRect l="0" r="0" t="0" b="0"/>
+          <a:stretch/>
+        </p:blipFill>
+        <p:spPr>
+          <a:xfrm>
+            <a:off x="8633308" y="3911498"/>
+            <a:ext cx="2781148" cy="1854098"/>
+          </a:xfrm>
+          <a:prstGeom prst="rect">
+            <a:avLst/>
+          </a:prstGeom>
+        </p:spPr>
+      </p:pic>
+      <p:pic>
+        <p:nvPicPr>
+          <p:cNvPr id="9" name="Image 4" descr="C:\Code\Work\startuplab-partner-presentation\pptx-templates\media\logo-red.png">    </p:cNvPr>
+          <p:cNvPicPr>
+            <a:picLocks noChangeAspect="1"/>
+          </p:cNvPicPr>
+          <p:nvPr/>
+        </p:nvPicPr>
+        <p:blipFill>
+          <a:blip r:embed="rId5"/>
+          <a:stretch>
+            <a:fillRect/>
+          </a:stretch>
+        </p:blipFill>
+        <p:spPr>
+          <a:xfrm>
+            <a:off x="777240" y="6035040"/>
+            <a:ext cx="843006" cy="310896"/>
+          </a:xfrm>
+          <a:prstGeom prst="rect">
+            <a:avLst/>
+          </a:prstGeom>
+        </p:spPr>
+      </p:pic>
+    </p:spTree>
+  </p:cSld>
+  <p:clrMapOvr>
+    <a:masterClrMapping/>
+  </p:clrMapOvr>
+</p:sld>
+</file>
+
+<file path=ppt/slides/slide11.xml><?xml version="1.0" encoding="utf-8"?>
+<p:sld xmlns:a="http://schemas.openxmlformats.org/drawingml/2006/main" xmlns:r="http://schemas.openxmlformats.org/officeDocument/2006/relationships" xmlns:p="http://schemas.openxmlformats.org/presentationml/2006/main">
+  <p:cSld name="Slide 11">
+    <p:bg>
+      <p:bgPr>
+        <a:solidFill>
           <a:srgbClr val="131415"/>
         </a:solidFill>
       </p:bgPr>
@@ -2645,9 +3042,9 @@
 </p:sld>
 </file>
 
-<file path=ppt/slides/slide11.xml><?xml version="1.0" encoding="utf-8"?>
+<file path=ppt/slides/slide12.xml><?xml version="1.0" encoding="utf-8"?>
 <p:sld xmlns:a="http://schemas.openxmlformats.org/drawingml/2006/main" xmlns:r="http://schemas.openxmlformats.org/officeDocument/2006/relationships" xmlns:p="http://schemas.openxmlformats.org/presentationml/2006/main">
-  <p:cSld name="Slide 11">
+  <p:cSld name="Slide 12">
     <p:bg>
       <p:bgPr>
         <a:solidFill>
@@ -2908,9 +3305,9 @@
 </p:sld>
 </file>
 
-<file path=ppt/slides/slide12.xml><?xml version="1.0" encoding="utf-8"?>
+<file path=ppt/slides/slide13.xml><?xml version="1.0" encoding="utf-8"?>
 <p:sld xmlns:a="http://schemas.openxmlformats.org/drawingml/2006/main" xmlns:r="http://schemas.openxmlformats.org/officeDocument/2006/relationships" xmlns:p="http://schemas.openxmlformats.org/presentationml/2006/main">
-  <p:cSld name="Slide 12">
+  <p:cSld name="Slide 13">
     <p:bg>
       <p:bgPr>
         <a:solidFill>
@@ -3352,623 +3749,6 @@
         </p:nvPicPr>
         <p:blipFill>
           <a:blip r:embed="rId4"/>
-          <a:stretch>
-            <a:fillRect/>
-          </a:stretch>
-        </p:blipFill>
-        <p:spPr>
-          <a:xfrm>
-            <a:off x="777240" y="6035040"/>
-            <a:ext cx="843006" cy="310896"/>
-          </a:xfrm>
-          <a:prstGeom prst="rect">
-            <a:avLst/>
-          </a:prstGeom>
-        </p:spPr>
-      </p:pic>
-    </p:spTree>
-  </p:cSld>
-  <p:clrMapOvr>
-    <a:masterClrMapping/>
-  </p:clrMapOvr>
-</p:sld>
-</file>
-
-<file path=ppt/slides/slide13.xml><?xml version="1.0" encoding="utf-8"?>
-<p:sld xmlns:a="http://schemas.openxmlformats.org/drawingml/2006/main" xmlns:r="http://schemas.openxmlformats.org/officeDocument/2006/relationships" xmlns:p="http://schemas.openxmlformats.org/presentationml/2006/main">
-  <p:cSld name="Slide 13">
-    <p:bg>
-      <p:bgPr>
-        <a:solidFill>
-          <a:srgbClr val="FFFFFF"/>
-        </a:solidFill>
-      </p:bgPr>
-    </p:bg>
-    <p:spTree>
-      <p:nvGrpSpPr>
-        <p:cNvPr id="1" name=""/>
-        <p:cNvGrpSpPr/>
-        <p:nvPr/>
-      </p:nvGrpSpPr>
-      <p:grpSpPr>
-        <a:xfrm>
-          <a:off x="0" y="0"/>
-          <a:ext cx="0" cy="0"/>
-          <a:chOff x="0" y="0"/>
-          <a:chExt cx="0" cy="0"/>
-        </a:xfrm>
-      </p:grpSpPr>
-      <p:sp>
-        <p:nvSpPr>
-          <p:cNvPr id="2" name="Text 0"/>
-          <p:cNvSpPr/>
-          <p:nvPr/>
-        </p:nvSpPr>
-        <p:spPr>
-          <a:xfrm>
-            <a:off x="777240" y="713232"/>
-            <a:ext cx="8229600" cy="292608"/>
-          </a:xfrm>
-          <a:prstGeom prst="rect">
-            <a:avLst/>
-          </a:prstGeom>
-          <a:noFill/>
-          <a:ln/>
-        </p:spPr>
-        <p:txBody>
-          <a:bodyPr wrap="square" lIns="0" tIns="0" rIns="0" bIns="0" rtlCol="0" anchor="ctr"/>
-          <a:lstStyle/>
-          <a:p>
-            <a:pPr indent="0" marL="0">
-              <a:buNone/>
-            </a:pPr>
-            <a:r>
-              <a:rPr lang="en-US" sz="1600" b="1" spc="250" kern="0" dirty="0">
-                <a:solidFill>
-                  <a:srgbClr val="FF3333"/>
-                </a:solidFill>
-                <a:latin typeface="Inter" pitchFamily="34" charset="0"/>
-                <a:ea typeface="Inter" pitchFamily="34" charset="-122"/>
-                <a:cs typeface="Inter" pitchFamily="34" charset="-120"/>
-              </a:rPr>
-              <a:t>SLIK GÅR VI FREM</a:t>
-            </a:r>
-            <a:endParaRPr lang="en-US" sz="1600" dirty="0"/>
-          </a:p>
-        </p:txBody>
-      </p:sp>
-      <p:sp>
-        <p:nvSpPr>
-          <p:cNvPr id="3" name="Text 1"/>
-          <p:cNvSpPr/>
-          <p:nvPr/>
-        </p:nvSpPr>
-        <p:spPr>
-          <a:xfrm>
-            <a:off x="777240" y="1051560"/>
-            <a:ext cx="10424160" cy="777240"/>
-          </a:xfrm>
-          <a:prstGeom prst="rect">
-            <a:avLst/>
-          </a:prstGeom>
-          <a:noFill/>
-          <a:ln/>
-        </p:spPr>
-        <p:txBody>
-          <a:bodyPr wrap="square" lIns="0" tIns="0" rIns="0" bIns="0" rtlCol="0" anchor="t"/>
-          <a:lstStyle/>
-          <a:p>
-            <a:pPr indent="0" marL="0">
-              <a:lnSpc>
-                <a:spcPct val="100000"/>
-              </a:lnSpc>
-              <a:buNone/>
-            </a:pPr>
-            <a:r>
-              <a:rPr lang="en-US" sz="4000" b="1" dirty="0">
-                <a:solidFill>
-                  <a:srgbClr val="131415"/>
-                </a:solidFill>
-                <a:latin typeface="Replica LL TT" pitchFamily="34" charset="0"/>
-                <a:ea typeface="Replica LL TT" pitchFamily="34" charset="-122"/>
-                <a:cs typeface="Replica LL TT" pitchFamily="34" charset="-120"/>
-              </a:rPr>
-              <a:t>Fire steg fra idé til pilot</a:t>
-            </a:r>
-            <a:endParaRPr lang="en-US" sz="4000" dirty="0"/>
-          </a:p>
-        </p:txBody>
-      </p:sp>
-      <p:sp>
-        <p:nvSpPr>
-          <p:cNvPr id="4" name="Text 2"/>
-          <p:cNvSpPr/>
-          <p:nvPr/>
-        </p:nvSpPr>
-        <p:spPr>
-          <a:xfrm>
-            <a:off x="777240" y="2423160"/>
-            <a:ext cx="2247824" cy="914400"/>
-          </a:xfrm>
-          <a:prstGeom prst="rect">
-            <a:avLst/>
-          </a:prstGeom>
-          <a:noFill/>
-          <a:ln/>
-        </p:spPr>
-        <p:txBody>
-          <a:bodyPr wrap="square" lIns="0" tIns="0" rIns="0" bIns="0" rtlCol="0" anchor="t"/>
-          <a:lstStyle/>
-          <a:p>
-            <a:pPr indent="0" marL="0">
-              <a:buNone/>
-            </a:pPr>
-            <a:r>
-              <a:rPr lang="en-US" sz="5600" dirty="0">
-                <a:solidFill>
-                  <a:srgbClr val="FF3333"/>
-                </a:solidFill>
-                <a:latin typeface="Replica LL TT Heavy" pitchFamily="34" charset="0"/>
-                <a:ea typeface="Replica LL TT Heavy" pitchFamily="34" charset="-122"/>
-                <a:cs typeface="Replica LL TT Heavy" pitchFamily="34" charset="-120"/>
-              </a:rPr>
-              <a:t>01</a:t>
-            </a:r>
-            <a:endParaRPr lang="en-US" sz="5600" dirty="0"/>
-          </a:p>
-        </p:txBody>
-      </p:sp>
-      <p:sp>
-        <p:nvSpPr>
-          <p:cNvPr id="5" name="Text 3"/>
-          <p:cNvSpPr/>
-          <p:nvPr/>
-        </p:nvSpPr>
-        <p:spPr>
-          <a:xfrm>
-            <a:off x="777240" y="3355848"/>
-            <a:ext cx="2247824" cy="457200"/>
-          </a:xfrm>
-          <a:prstGeom prst="rect">
-            <a:avLst/>
-          </a:prstGeom>
-          <a:noFill/>
-          <a:ln/>
-        </p:spPr>
-        <p:txBody>
-          <a:bodyPr wrap="square" lIns="0" tIns="0" rIns="0" bIns="0" rtlCol="0" anchor="ctr"/>
-          <a:lstStyle/>
-          <a:p>
-            <a:pPr indent="0" marL="0">
-              <a:buNone/>
-            </a:pPr>
-            <a:r>
-              <a:rPr lang="en-US" sz="2500" b="1" dirty="0">
-                <a:solidFill>
-                  <a:srgbClr val="131415"/>
-                </a:solidFill>
-                <a:latin typeface="Replica LL TT" pitchFamily="34" charset="0"/>
-                <a:ea typeface="Replica LL TT" pitchFamily="34" charset="-122"/>
-                <a:cs typeface="Replica LL TT" pitchFamily="34" charset="-120"/>
-              </a:rPr>
-              <a:t>Kartlegg</a:t>
-            </a:r>
-            <a:endParaRPr lang="en-US" sz="2500" dirty="0"/>
-          </a:p>
-        </p:txBody>
-      </p:sp>
-      <p:sp>
-        <p:nvSpPr>
-          <p:cNvPr id="6" name="Text 4"/>
-          <p:cNvSpPr/>
-          <p:nvPr/>
-        </p:nvSpPr>
-        <p:spPr>
-          <a:xfrm>
-            <a:off x="777240" y="3840480"/>
-            <a:ext cx="2247824" cy="1005840"/>
-          </a:xfrm>
-          <a:prstGeom prst="rect">
-            <a:avLst/>
-          </a:prstGeom>
-          <a:noFill/>
-          <a:ln/>
-        </p:spPr>
-        <p:txBody>
-          <a:bodyPr wrap="square" lIns="0" tIns="0" rIns="0" bIns="0" rtlCol="0" anchor="t"/>
-          <a:lstStyle/>
-          <a:p>
-            <a:pPr indent="0" marL="0">
-              <a:lnSpc>
-                <a:spcPct val="130000"/>
-              </a:lnSpc>
-              <a:buNone/>
-            </a:pPr>
-            <a:r>
-              <a:rPr lang="en-US" sz="1800" dirty="0">
-                <a:solidFill>
-                  <a:srgbClr val="5A6166"/>
-                </a:solidFill>
-                <a:latin typeface="Inter" pitchFamily="34" charset="0"/>
-                <a:ea typeface="Inter" pitchFamily="34" charset="-122"/>
-                <a:cs typeface="Inter" pitchFamily="34" charset="-120"/>
-              </a:rPr>
-              <a:t>Vi finner utfordringen som er verdt å løse.</a:t>
-            </a:r>
-            <a:endParaRPr lang="en-US" sz="1800" dirty="0"/>
-          </a:p>
-        </p:txBody>
-      </p:sp>
-      <p:sp>
-        <p:nvSpPr>
-          <p:cNvPr id="7" name="Text 5"/>
-          <p:cNvSpPr/>
-          <p:nvPr/>
-        </p:nvSpPr>
-        <p:spPr>
-          <a:xfrm>
-            <a:off x="3573704" y="2423160"/>
-            <a:ext cx="2247824" cy="914400"/>
-          </a:xfrm>
-          <a:prstGeom prst="rect">
-            <a:avLst/>
-          </a:prstGeom>
-          <a:noFill/>
-          <a:ln/>
-        </p:spPr>
-        <p:txBody>
-          <a:bodyPr wrap="square" lIns="0" tIns="0" rIns="0" bIns="0" rtlCol="0" anchor="t"/>
-          <a:lstStyle/>
-          <a:p>
-            <a:pPr indent="0" marL="0">
-              <a:buNone/>
-            </a:pPr>
-            <a:r>
-              <a:rPr lang="en-US" sz="5600" dirty="0">
-                <a:solidFill>
-                  <a:srgbClr val="5A6166"/>
-                </a:solidFill>
-                <a:latin typeface="Replica LL TT Heavy" pitchFamily="34" charset="0"/>
-                <a:ea typeface="Replica LL TT Heavy" pitchFamily="34" charset="-122"/>
-                <a:cs typeface="Replica LL TT Heavy" pitchFamily="34" charset="-120"/>
-              </a:rPr>
-              <a:t>02</a:t>
-            </a:r>
-            <a:endParaRPr lang="en-US" sz="5600" dirty="0"/>
-          </a:p>
-        </p:txBody>
-      </p:sp>
-      <p:sp>
-        <p:nvSpPr>
-          <p:cNvPr id="8" name="Text 6"/>
-          <p:cNvSpPr/>
-          <p:nvPr/>
-        </p:nvSpPr>
-        <p:spPr>
-          <a:xfrm>
-            <a:off x="3573704" y="3355848"/>
-            <a:ext cx="2247824" cy="457200"/>
-          </a:xfrm>
-          <a:prstGeom prst="rect">
-            <a:avLst/>
-          </a:prstGeom>
-          <a:noFill/>
-          <a:ln/>
-        </p:spPr>
-        <p:txBody>
-          <a:bodyPr wrap="square" lIns="0" tIns="0" rIns="0" bIns="0" rtlCol="0" anchor="ctr"/>
-          <a:lstStyle/>
-          <a:p>
-            <a:pPr indent="0" marL="0">
-              <a:buNone/>
-            </a:pPr>
-            <a:r>
-              <a:rPr lang="en-US" sz="2500" b="1" dirty="0">
-                <a:solidFill>
-                  <a:srgbClr val="131415"/>
-                </a:solidFill>
-                <a:latin typeface="Replica LL TT" pitchFamily="34" charset="0"/>
-                <a:ea typeface="Replica LL TT" pitchFamily="34" charset="-122"/>
-                <a:cs typeface="Replica LL TT" pitchFamily="34" charset="-120"/>
-              </a:rPr>
-              <a:t>Match</a:t>
-            </a:r>
-            <a:endParaRPr lang="en-US" sz="2500" dirty="0"/>
-          </a:p>
-        </p:txBody>
-      </p:sp>
-      <p:sp>
-        <p:nvSpPr>
-          <p:cNvPr id="9" name="Text 7"/>
-          <p:cNvSpPr/>
-          <p:nvPr/>
-        </p:nvSpPr>
-        <p:spPr>
-          <a:xfrm>
-            <a:off x="3573704" y="3840480"/>
-            <a:ext cx="2247824" cy="1005840"/>
-          </a:xfrm>
-          <a:prstGeom prst="rect">
-            <a:avLst/>
-          </a:prstGeom>
-          <a:noFill/>
-          <a:ln/>
-        </p:spPr>
-        <p:txBody>
-          <a:bodyPr wrap="square" lIns="0" tIns="0" rIns="0" bIns="0" rtlCol="0" anchor="t"/>
-          <a:lstStyle/>
-          <a:p>
-            <a:pPr indent="0" marL="0">
-              <a:lnSpc>
-                <a:spcPct val="130000"/>
-              </a:lnSpc>
-              <a:buNone/>
-            </a:pPr>
-            <a:r>
-              <a:rPr lang="en-US" sz="1800" dirty="0">
-                <a:solidFill>
-                  <a:srgbClr val="5A6166"/>
-                </a:solidFill>
-                <a:latin typeface="Inter" pitchFamily="34" charset="0"/>
-                <a:ea typeface="Inter" pitchFamily="34" charset="-122"/>
-                <a:cs typeface="Inter" pitchFamily="34" charset="-120"/>
-              </a:rPr>
-              <a:t>Vi henter inn selskapene som treffer den.</a:t>
-            </a:r>
-            <a:endParaRPr lang="en-US" sz="1800" dirty="0"/>
-          </a:p>
-        </p:txBody>
-      </p:sp>
-      <p:sp>
-        <p:nvSpPr>
-          <p:cNvPr id="10" name="Text 8"/>
-          <p:cNvSpPr/>
-          <p:nvPr/>
-        </p:nvSpPr>
-        <p:spPr>
-          <a:xfrm>
-            <a:off x="6370168" y="2423160"/>
-            <a:ext cx="2247824" cy="914400"/>
-          </a:xfrm>
-          <a:prstGeom prst="rect">
-            <a:avLst/>
-          </a:prstGeom>
-          <a:noFill/>
-          <a:ln/>
-        </p:spPr>
-        <p:txBody>
-          <a:bodyPr wrap="square" lIns="0" tIns="0" rIns="0" bIns="0" rtlCol="0" anchor="t"/>
-          <a:lstStyle/>
-          <a:p>
-            <a:pPr indent="0" marL="0">
-              <a:buNone/>
-            </a:pPr>
-            <a:r>
-              <a:rPr lang="en-US" sz="5600" dirty="0">
-                <a:solidFill>
-                  <a:srgbClr val="5A6166"/>
-                </a:solidFill>
-                <a:latin typeface="Replica LL TT Heavy" pitchFamily="34" charset="0"/>
-                <a:ea typeface="Replica LL TT Heavy" pitchFamily="34" charset="-122"/>
-                <a:cs typeface="Replica LL TT Heavy" pitchFamily="34" charset="-120"/>
-              </a:rPr>
-              <a:t>03</a:t>
-            </a:r>
-            <a:endParaRPr lang="en-US" sz="5600" dirty="0"/>
-          </a:p>
-        </p:txBody>
-      </p:sp>
-      <p:sp>
-        <p:nvSpPr>
-          <p:cNvPr id="11" name="Text 9"/>
-          <p:cNvSpPr/>
-          <p:nvPr/>
-        </p:nvSpPr>
-        <p:spPr>
-          <a:xfrm>
-            <a:off x="6370168" y="3355848"/>
-            <a:ext cx="2247824" cy="457200"/>
-          </a:xfrm>
-          <a:prstGeom prst="rect">
-            <a:avLst/>
-          </a:prstGeom>
-          <a:noFill/>
-          <a:ln/>
-        </p:spPr>
-        <p:txBody>
-          <a:bodyPr wrap="square" lIns="0" tIns="0" rIns="0" bIns="0" rtlCol="0" anchor="ctr"/>
-          <a:lstStyle/>
-          <a:p>
-            <a:pPr indent="0" marL="0">
-              <a:buNone/>
-            </a:pPr>
-            <a:r>
-              <a:rPr lang="en-US" sz="2500" b="1" dirty="0">
-                <a:solidFill>
-                  <a:srgbClr val="131415"/>
-                </a:solidFill>
-                <a:latin typeface="Replica LL TT" pitchFamily="34" charset="0"/>
-                <a:ea typeface="Replica LL TT" pitchFamily="34" charset="-122"/>
-                <a:cs typeface="Replica LL TT" pitchFamily="34" charset="-120"/>
-              </a:rPr>
-              <a:t>Pilot</a:t>
-            </a:r>
-            <a:endParaRPr lang="en-US" sz="2500" dirty="0"/>
-          </a:p>
-        </p:txBody>
-      </p:sp>
-      <p:sp>
-        <p:nvSpPr>
-          <p:cNvPr id="12" name="Text 10"/>
-          <p:cNvSpPr/>
-          <p:nvPr/>
-        </p:nvSpPr>
-        <p:spPr>
-          <a:xfrm>
-            <a:off x="6370168" y="3840480"/>
-            <a:ext cx="2247824" cy="1005840"/>
-          </a:xfrm>
-          <a:prstGeom prst="rect">
-            <a:avLst/>
-          </a:prstGeom>
-          <a:noFill/>
-          <a:ln/>
-        </p:spPr>
-        <p:txBody>
-          <a:bodyPr wrap="square" lIns="0" tIns="0" rIns="0" bIns="0" rtlCol="0" anchor="t"/>
-          <a:lstStyle/>
-          <a:p>
-            <a:pPr indent="0" marL="0">
-              <a:lnSpc>
-                <a:spcPct val="130000"/>
-              </a:lnSpc>
-              <a:buNone/>
-            </a:pPr>
-            <a:r>
-              <a:rPr lang="en-US" sz="1800" dirty="0">
-                <a:solidFill>
-                  <a:srgbClr val="5A6166"/>
-                </a:solidFill>
-                <a:latin typeface="Inter" pitchFamily="34" charset="0"/>
-                <a:ea typeface="Inter" pitchFamily="34" charset="-122"/>
-                <a:cs typeface="Inter" pitchFamily="34" charset="-120"/>
-              </a:rPr>
-              <a:t>Vi rigger et forsøk med tydelige kriterier.</a:t>
-            </a:r>
-            <a:endParaRPr lang="en-US" sz="1800" dirty="0"/>
-          </a:p>
-        </p:txBody>
-      </p:sp>
-      <p:sp>
-        <p:nvSpPr>
-          <p:cNvPr id="13" name="Text 11"/>
-          <p:cNvSpPr/>
-          <p:nvPr/>
-        </p:nvSpPr>
-        <p:spPr>
-          <a:xfrm>
-            <a:off x="9166631" y="2423160"/>
-            <a:ext cx="2247824" cy="914400"/>
-          </a:xfrm>
-          <a:prstGeom prst="rect">
-            <a:avLst/>
-          </a:prstGeom>
-          <a:noFill/>
-          <a:ln/>
-        </p:spPr>
-        <p:txBody>
-          <a:bodyPr wrap="square" lIns="0" tIns="0" rIns="0" bIns="0" rtlCol="0" anchor="t"/>
-          <a:lstStyle/>
-          <a:p>
-            <a:pPr indent="0" marL="0">
-              <a:buNone/>
-            </a:pPr>
-            <a:r>
-              <a:rPr lang="en-US" sz="5600" dirty="0">
-                <a:solidFill>
-                  <a:srgbClr val="5A6166"/>
-                </a:solidFill>
-                <a:latin typeface="Replica LL TT Heavy" pitchFamily="34" charset="0"/>
-                <a:ea typeface="Replica LL TT Heavy" pitchFamily="34" charset="-122"/>
-                <a:cs typeface="Replica LL TT Heavy" pitchFamily="34" charset="-120"/>
-              </a:rPr>
-              <a:t>04</a:t>
-            </a:r>
-            <a:endParaRPr lang="en-US" sz="5600" dirty="0"/>
-          </a:p>
-        </p:txBody>
-      </p:sp>
-      <p:sp>
-        <p:nvSpPr>
-          <p:cNvPr id="14" name="Text 12"/>
-          <p:cNvSpPr/>
-          <p:nvPr/>
-        </p:nvSpPr>
-        <p:spPr>
-          <a:xfrm>
-            <a:off x="9166631" y="3355848"/>
-            <a:ext cx="2247824" cy="457200"/>
-          </a:xfrm>
-          <a:prstGeom prst="rect">
-            <a:avLst/>
-          </a:prstGeom>
-          <a:noFill/>
-          <a:ln/>
-        </p:spPr>
-        <p:txBody>
-          <a:bodyPr wrap="square" lIns="0" tIns="0" rIns="0" bIns="0" rtlCol="0" anchor="ctr"/>
-          <a:lstStyle/>
-          <a:p>
-            <a:pPr indent="0" marL="0">
-              <a:buNone/>
-            </a:pPr>
-            <a:r>
-              <a:rPr lang="en-US" sz="2500" b="1" dirty="0">
-                <a:solidFill>
-                  <a:srgbClr val="131415"/>
-                </a:solidFill>
-                <a:latin typeface="Replica LL TT" pitchFamily="34" charset="0"/>
-                <a:ea typeface="Replica LL TT" pitchFamily="34" charset="-122"/>
-                <a:cs typeface="Replica LL TT" pitchFamily="34" charset="-120"/>
-              </a:rPr>
-              <a:t>Skaler</a:t>
-            </a:r>
-            <a:endParaRPr lang="en-US" sz="2500" dirty="0"/>
-          </a:p>
-        </p:txBody>
-      </p:sp>
-      <p:sp>
-        <p:nvSpPr>
-          <p:cNvPr id="15" name="Text 13"/>
-          <p:cNvSpPr/>
-          <p:nvPr/>
-        </p:nvSpPr>
-        <p:spPr>
-          <a:xfrm>
-            <a:off x="9166631" y="3840480"/>
-            <a:ext cx="2247824" cy="1005840"/>
-          </a:xfrm>
-          <a:prstGeom prst="rect">
-            <a:avLst/>
-          </a:prstGeom>
-          <a:noFill/>
-          <a:ln/>
-        </p:spPr>
-        <p:txBody>
-          <a:bodyPr wrap="square" lIns="0" tIns="0" rIns="0" bIns="0" rtlCol="0" anchor="t"/>
-          <a:lstStyle/>
-          <a:p>
-            <a:pPr indent="0" marL="0">
-              <a:lnSpc>
-                <a:spcPct val="130000"/>
-              </a:lnSpc>
-              <a:buNone/>
-            </a:pPr>
-            <a:r>
-              <a:rPr lang="en-US" sz="1800" dirty="0">
-                <a:solidFill>
-                  <a:srgbClr val="5A6166"/>
-                </a:solidFill>
-                <a:latin typeface="Inter" pitchFamily="34" charset="0"/>
-                <a:ea typeface="Inter" pitchFamily="34" charset="-122"/>
-                <a:cs typeface="Inter" pitchFamily="34" charset="-120"/>
-              </a:rPr>
-              <a:t>Det som virker, settes i drift.</a:t>
-            </a:r>
-            <a:endParaRPr lang="en-US" sz="1800" dirty="0"/>
-          </a:p>
-        </p:txBody>
-      </p:sp>
-      <p:pic>
-        <p:nvPicPr>
-          <p:cNvPr id="16" name="Image 0" descr="C:\Code\Work\startuplab-partner-presentation\pptx-templates\media\logo-red.png">    </p:cNvPr>
-          <p:cNvPicPr>
-            <a:picLocks noChangeAspect="1"/>
-          </p:cNvPicPr>
-          <p:nvPr/>
-        </p:nvPicPr>
-        <p:blipFill>
-          <a:blip r:embed="rId1"/>
           <a:stretch>
             <a:fillRect/>
           </a:stretch>
@@ -4048,7 +3828,7 @@
                 <a:ea typeface="Inter" pitchFamily="34" charset="-122"/>
                 <a:cs typeface="Inter" pitchFamily="34" charset="-120"/>
               </a:rPr>
-              <a:t>TEAMET</a:t>
+              <a:t>SLIK GÅR VI FREM</a:t>
             </a:r>
             <a:endParaRPr lang="en-US" sz="1600" dirty="0"/>
           </a:p>
@@ -4090,32 +3870,495 @@
                 <a:ea typeface="Replica LL TT" pitchFamily="34" charset="-122"/>
                 <a:cs typeface="Replica LL TT" pitchFamily="34" charset="-120"/>
               </a:rPr>
-              <a:t>Folkene du kommer til å </a:t>
-            </a:r>
-            <a:pPr indent="0" marL="0">
-              <a:lnSpc>
-                <a:spcPct val="100000"/>
-              </a:lnSpc>
-              <a:buNone/>
-            </a:pPr>
-            <a:r>
-              <a:rPr lang="en-US" sz="4000" b="1" dirty="0">
+              <a:t>Fire steg fra idé til pilot</a:t>
+            </a:r>
+            <a:endParaRPr lang="en-US" sz="4000" dirty="0"/>
+          </a:p>
+        </p:txBody>
+      </p:sp>
+      <p:sp>
+        <p:nvSpPr>
+          <p:cNvPr id="4" name="Text 2"/>
+          <p:cNvSpPr/>
+          <p:nvPr/>
+        </p:nvSpPr>
+        <p:spPr>
+          <a:xfrm>
+            <a:off x="777240" y="2423160"/>
+            <a:ext cx="2247824" cy="914400"/>
+          </a:xfrm>
+          <a:prstGeom prst="rect">
+            <a:avLst/>
+          </a:prstGeom>
+          <a:noFill/>
+          <a:ln/>
+        </p:spPr>
+        <p:txBody>
+          <a:bodyPr wrap="square" lIns="0" tIns="0" rIns="0" bIns="0" rtlCol="0" anchor="t"/>
+          <a:lstStyle/>
+          <a:p>
+            <a:pPr indent="0" marL="0">
+              <a:buNone/>
+            </a:pPr>
+            <a:r>
+              <a:rPr lang="en-US" sz="5600" dirty="0">
                 <a:solidFill>
                   <a:srgbClr val="FF3333"/>
+                </a:solidFill>
+                <a:latin typeface="Replica LL TT Heavy" pitchFamily="34" charset="0"/>
+                <a:ea typeface="Replica LL TT Heavy" pitchFamily="34" charset="-122"/>
+                <a:cs typeface="Replica LL TT Heavy" pitchFamily="34" charset="-120"/>
+              </a:rPr>
+              <a:t>01</a:t>
+            </a:r>
+            <a:endParaRPr lang="en-US" sz="5600" dirty="0"/>
+          </a:p>
+        </p:txBody>
+      </p:sp>
+      <p:sp>
+        <p:nvSpPr>
+          <p:cNvPr id="5" name="Text 3"/>
+          <p:cNvSpPr/>
+          <p:nvPr/>
+        </p:nvSpPr>
+        <p:spPr>
+          <a:xfrm>
+            <a:off x="777240" y="3355848"/>
+            <a:ext cx="2247824" cy="457200"/>
+          </a:xfrm>
+          <a:prstGeom prst="rect">
+            <a:avLst/>
+          </a:prstGeom>
+          <a:noFill/>
+          <a:ln/>
+        </p:spPr>
+        <p:txBody>
+          <a:bodyPr wrap="square" lIns="0" tIns="0" rIns="0" bIns="0" rtlCol="0" anchor="ctr"/>
+          <a:lstStyle/>
+          <a:p>
+            <a:pPr indent="0" marL="0">
+              <a:buNone/>
+            </a:pPr>
+            <a:r>
+              <a:rPr lang="en-US" sz="2500" b="1" dirty="0">
+                <a:solidFill>
+                  <a:srgbClr val="131415"/>
                 </a:solidFill>
                 <a:latin typeface="Replica LL TT" pitchFamily="34" charset="0"/>
                 <a:ea typeface="Replica LL TT" pitchFamily="34" charset="-122"/>
                 <a:cs typeface="Replica LL TT" pitchFamily="34" charset="-120"/>
               </a:rPr>
-              <a:t>jobbe med</a:t>
-            </a:r>
-            <a:endParaRPr lang="en-US" sz="4000" dirty="0"/>
+              <a:t>Kartlegg</a:t>
+            </a:r>
+            <a:endParaRPr lang="en-US" sz="2500" dirty="0"/>
+          </a:p>
+        </p:txBody>
+      </p:sp>
+      <p:sp>
+        <p:nvSpPr>
+          <p:cNvPr id="6" name="Text 4"/>
+          <p:cNvSpPr/>
+          <p:nvPr/>
+        </p:nvSpPr>
+        <p:spPr>
+          <a:xfrm>
+            <a:off x="777240" y="3840480"/>
+            <a:ext cx="2247824" cy="1005840"/>
+          </a:xfrm>
+          <a:prstGeom prst="rect">
+            <a:avLst/>
+          </a:prstGeom>
+          <a:noFill/>
+          <a:ln/>
+        </p:spPr>
+        <p:txBody>
+          <a:bodyPr wrap="square" lIns="0" tIns="0" rIns="0" bIns="0" rtlCol="0" anchor="t"/>
+          <a:lstStyle/>
+          <a:p>
+            <a:pPr indent="0" marL="0">
+              <a:lnSpc>
+                <a:spcPct val="130000"/>
+              </a:lnSpc>
+              <a:buNone/>
+            </a:pPr>
+            <a:r>
+              <a:rPr lang="en-US" sz="1800" dirty="0">
+                <a:solidFill>
+                  <a:srgbClr val="5A6166"/>
+                </a:solidFill>
+                <a:latin typeface="Inter" pitchFamily="34" charset="0"/>
+                <a:ea typeface="Inter" pitchFamily="34" charset="-122"/>
+                <a:cs typeface="Inter" pitchFamily="34" charset="-120"/>
+              </a:rPr>
+              <a:t>Vi finner utfordringen som er verdt å løse.</a:t>
+            </a:r>
+            <a:endParaRPr lang="en-US" sz="1800" dirty="0"/>
+          </a:p>
+        </p:txBody>
+      </p:sp>
+      <p:sp>
+        <p:nvSpPr>
+          <p:cNvPr id="7" name="Text 5"/>
+          <p:cNvSpPr/>
+          <p:nvPr/>
+        </p:nvSpPr>
+        <p:spPr>
+          <a:xfrm>
+            <a:off x="3573704" y="2423160"/>
+            <a:ext cx="2247824" cy="914400"/>
+          </a:xfrm>
+          <a:prstGeom prst="rect">
+            <a:avLst/>
+          </a:prstGeom>
+          <a:noFill/>
+          <a:ln/>
+        </p:spPr>
+        <p:txBody>
+          <a:bodyPr wrap="square" lIns="0" tIns="0" rIns="0" bIns="0" rtlCol="0" anchor="t"/>
+          <a:lstStyle/>
+          <a:p>
+            <a:pPr indent="0" marL="0">
+              <a:buNone/>
+            </a:pPr>
+            <a:r>
+              <a:rPr lang="en-US" sz="5600" dirty="0">
+                <a:solidFill>
+                  <a:srgbClr val="5A6166"/>
+                </a:solidFill>
+                <a:latin typeface="Replica LL TT Heavy" pitchFamily="34" charset="0"/>
+                <a:ea typeface="Replica LL TT Heavy" pitchFamily="34" charset="-122"/>
+                <a:cs typeface="Replica LL TT Heavy" pitchFamily="34" charset="-120"/>
+              </a:rPr>
+              <a:t>02</a:t>
+            </a:r>
+            <a:endParaRPr lang="en-US" sz="5600" dirty="0"/>
+          </a:p>
+        </p:txBody>
+      </p:sp>
+      <p:sp>
+        <p:nvSpPr>
+          <p:cNvPr id="8" name="Text 6"/>
+          <p:cNvSpPr/>
+          <p:nvPr/>
+        </p:nvSpPr>
+        <p:spPr>
+          <a:xfrm>
+            <a:off x="3573704" y="3355848"/>
+            <a:ext cx="2247824" cy="457200"/>
+          </a:xfrm>
+          <a:prstGeom prst="rect">
+            <a:avLst/>
+          </a:prstGeom>
+          <a:noFill/>
+          <a:ln/>
+        </p:spPr>
+        <p:txBody>
+          <a:bodyPr wrap="square" lIns="0" tIns="0" rIns="0" bIns="0" rtlCol="0" anchor="ctr"/>
+          <a:lstStyle/>
+          <a:p>
+            <a:pPr indent="0" marL="0">
+              <a:buNone/>
+            </a:pPr>
+            <a:r>
+              <a:rPr lang="en-US" sz="2500" b="1" dirty="0">
+                <a:solidFill>
+                  <a:srgbClr val="131415"/>
+                </a:solidFill>
+                <a:latin typeface="Replica LL TT" pitchFamily="34" charset="0"/>
+                <a:ea typeface="Replica LL TT" pitchFamily="34" charset="-122"/>
+                <a:cs typeface="Replica LL TT" pitchFamily="34" charset="-120"/>
+              </a:rPr>
+              <a:t>Match</a:t>
+            </a:r>
+            <a:endParaRPr lang="en-US" sz="2500" dirty="0"/>
+          </a:p>
+        </p:txBody>
+      </p:sp>
+      <p:sp>
+        <p:nvSpPr>
+          <p:cNvPr id="9" name="Text 7"/>
+          <p:cNvSpPr/>
+          <p:nvPr/>
+        </p:nvSpPr>
+        <p:spPr>
+          <a:xfrm>
+            <a:off x="3573704" y="3840480"/>
+            <a:ext cx="2247824" cy="1005840"/>
+          </a:xfrm>
+          <a:prstGeom prst="rect">
+            <a:avLst/>
+          </a:prstGeom>
+          <a:noFill/>
+          <a:ln/>
+        </p:spPr>
+        <p:txBody>
+          <a:bodyPr wrap="square" lIns="0" tIns="0" rIns="0" bIns="0" rtlCol="0" anchor="t"/>
+          <a:lstStyle/>
+          <a:p>
+            <a:pPr indent="0" marL="0">
+              <a:lnSpc>
+                <a:spcPct val="130000"/>
+              </a:lnSpc>
+              <a:buNone/>
+            </a:pPr>
+            <a:r>
+              <a:rPr lang="en-US" sz="1800" dirty="0">
+                <a:solidFill>
+                  <a:srgbClr val="5A6166"/>
+                </a:solidFill>
+                <a:latin typeface="Inter" pitchFamily="34" charset="0"/>
+                <a:ea typeface="Inter" pitchFamily="34" charset="-122"/>
+                <a:cs typeface="Inter" pitchFamily="34" charset="-120"/>
+              </a:rPr>
+              <a:t>Vi henter inn selskapene som treffer den.</a:t>
+            </a:r>
+            <a:endParaRPr lang="en-US" sz="1800" dirty="0"/>
+          </a:p>
+        </p:txBody>
+      </p:sp>
+      <p:sp>
+        <p:nvSpPr>
+          <p:cNvPr id="10" name="Text 8"/>
+          <p:cNvSpPr/>
+          <p:nvPr/>
+        </p:nvSpPr>
+        <p:spPr>
+          <a:xfrm>
+            <a:off x="6370168" y="2423160"/>
+            <a:ext cx="2247824" cy="914400"/>
+          </a:xfrm>
+          <a:prstGeom prst="rect">
+            <a:avLst/>
+          </a:prstGeom>
+          <a:noFill/>
+          <a:ln/>
+        </p:spPr>
+        <p:txBody>
+          <a:bodyPr wrap="square" lIns="0" tIns="0" rIns="0" bIns="0" rtlCol="0" anchor="t"/>
+          <a:lstStyle/>
+          <a:p>
+            <a:pPr indent="0" marL="0">
+              <a:buNone/>
+            </a:pPr>
+            <a:r>
+              <a:rPr lang="en-US" sz="5600" dirty="0">
+                <a:solidFill>
+                  <a:srgbClr val="5A6166"/>
+                </a:solidFill>
+                <a:latin typeface="Replica LL TT Heavy" pitchFamily="34" charset="0"/>
+                <a:ea typeface="Replica LL TT Heavy" pitchFamily="34" charset="-122"/>
+                <a:cs typeface="Replica LL TT Heavy" pitchFamily="34" charset="-120"/>
+              </a:rPr>
+              <a:t>03</a:t>
+            </a:r>
+            <a:endParaRPr lang="en-US" sz="5600" dirty="0"/>
+          </a:p>
+        </p:txBody>
+      </p:sp>
+      <p:sp>
+        <p:nvSpPr>
+          <p:cNvPr id="11" name="Text 9"/>
+          <p:cNvSpPr/>
+          <p:nvPr/>
+        </p:nvSpPr>
+        <p:spPr>
+          <a:xfrm>
+            <a:off x="6370168" y="3355848"/>
+            <a:ext cx="2247824" cy="457200"/>
+          </a:xfrm>
+          <a:prstGeom prst="rect">
+            <a:avLst/>
+          </a:prstGeom>
+          <a:noFill/>
+          <a:ln/>
+        </p:spPr>
+        <p:txBody>
+          <a:bodyPr wrap="square" lIns="0" tIns="0" rIns="0" bIns="0" rtlCol="0" anchor="ctr"/>
+          <a:lstStyle/>
+          <a:p>
+            <a:pPr indent="0" marL="0">
+              <a:buNone/>
+            </a:pPr>
+            <a:r>
+              <a:rPr lang="en-US" sz="2500" b="1" dirty="0">
+                <a:solidFill>
+                  <a:srgbClr val="131415"/>
+                </a:solidFill>
+                <a:latin typeface="Replica LL TT" pitchFamily="34" charset="0"/>
+                <a:ea typeface="Replica LL TT" pitchFamily="34" charset="-122"/>
+                <a:cs typeface="Replica LL TT" pitchFamily="34" charset="-120"/>
+              </a:rPr>
+              <a:t>Pilot</a:t>
+            </a:r>
+            <a:endParaRPr lang="en-US" sz="2500" dirty="0"/>
+          </a:p>
+        </p:txBody>
+      </p:sp>
+      <p:sp>
+        <p:nvSpPr>
+          <p:cNvPr id="12" name="Text 10"/>
+          <p:cNvSpPr/>
+          <p:nvPr/>
+        </p:nvSpPr>
+        <p:spPr>
+          <a:xfrm>
+            <a:off x="6370168" y="3840480"/>
+            <a:ext cx="2247824" cy="1005840"/>
+          </a:xfrm>
+          <a:prstGeom prst="rect">
+            <a:avLst/>
+          </a:prstGeom>
+          <a:noFill/>
+          <a:ln/>
+        </p:spPr>
+        <p:txBody>
+          <a:bodyPr wrap="square" lIns="0" tIns="0" rIns="0" bIns="0" rtlCol="0" anchor="t"/>
+          <a:lstStyle/>
+          <a:p>
+            <a:pPr indent="0" marL="0">
+              <a:lnSpc>
+                <a:spcPct val="130000"/>
+              </a:lnSpc>
+              <a:buNone/>
+            </a:pPr>
+            <a:r>
+              <a:rPr lang="en-US" sz="1800" dirty="0">
+                <a:solidFill>
+                  <a:srgbClr val="5A6166"/>
+                </a:solidFill>
+                <a:latin typeface="Inter" pitchFamily="34" charset="0"/>
+                <a:ea typeface="Inter" pitchFamily="34" charset="-122"/>
+                <a:cs typeface="Inter" pitchFamily="34" charset="-120"/>
+              </a:rPr>
+              <a:t>Vi rigger et forsøk med tydelige kriterier.</a:t>
+            </a:r>
+            <a:endParaRPr lang="en-US" sz="1800" dirty="0"/>
+          </a:p>
+        </p:txBody>
+      </p:sp>
+      <p:sp>
+        <p:nvSpPr>
+          <p:cNvPr id="13" name="Text 11"/>
+          <p:cNvSpPr/>
+          <p:nvPr/>
+        </p:nvSpPr>
+        <p:spPr>
+          <a:xfrm>
+            <a:off x="9166631" y="2423160"/>
+            <a:ext cx="2247824" cy="914400"/>
+          </a:xfrm>
+          <a:prstGeom prst="rect">
+            <a:avLst/>
+          </a:prstGeom>
+          <a:noFill/>
+          <a:ln/>
+        </p:spPr>
+        <p:txBody>
+          <a:bodyPr wrap="square" lIns="0" tIns="0" rIns="0" bIns="0" rtlCol="0" anchor="t"/>
+          <a:lstStyle/>
+          <a:p>
+            <a:pPr indent="0" marL="0">
+              <a:buNone/>
+            </a:pPr>
+            <a:r>
+              <a:rPr lang="en-US" sz="5600" dirty="0">
+                <a:solidFill>
+                  <a:srgbClr val="5A6166"/>
+                </a:solidFill>
+                <a:latin typeface="Replica LL TT Heavy" pitchFamily="34" charset="0"/>
+                <a:ea typeface="Replica LL TT Heavy" pitchFamily="34" charset="-122"/>
+                <a:cs typeface="Replica LL TT Heavy" pitchFamily="34" charset="-120"/>
+              </a:rPr>
+              <a:t>04</a:t>
+            </a:r>
+            <a:endParaRPr lang="en-US" sz="5600" dirty="0"/>
+          </a:p>
+        </p:txBody>
+      </p:sp>
+      <p:sp>
+        <p:nvSpPr>
+          <p:cNvPr id="14" name="Text 12"/>
+          <p:cNvSpPr/>
+          <p:nvPr/>
+        </p:nvSpPr>
+        <p:spPr>
+          <a:xfrm>
+            <a:off x="9166631" y="3355848"/>
+            <a:ext cx="2247824" cy="457200"/>
+          </a:xfrm>
+          <a:prstGeom prst="rect">
+            <a:avLst/>
+          </a:prstGeom>
+          <a:noFill/>
+          <a:ln/>
+        </p:spPr>
+        <p:txBody>
+          <a:bodyPr wrap="square" lIns="0" tIns="0" rIns="0" bIns="0" rtlCol="0" anchor="ctr"/>
+          <a:lstStyle/>
+          <a:p>
+            <a:pPr indent="0" marL="0">
+              <a:buNone/>
+            </a:pPr>
+            <a:r>
+              <a:rPr lang="en-US" sz="2500" b="1" dirty="0">
+                <a:solidFill>
+                  <a:srgbClr val="131415"/>
+                </a:solidFill>
+                <a:latin typeface="Replica LL TT" pitchFamily="34" charset="0"/>
+                <a:ea typeface="Replica LL TT" pitchFamily="34" charset="-122"/>
+                <a:cs typeface="Replica LL TT" pitchFamily="34" charset="-120"/>
+              </a:rPr>
+              <a:t>Skaler</a:t>
+            </a:r>
+            <a:endParaRPr lang="en-US" sz="2500" dirty="0"/>
+          </a:p>
+        </p:txBody>
+      </p:sp>
+      <p:sp>
+        <p:nvSpPr>
+          <p:cNvPr id="15" name="Text 13"/>
+          <p:cNvSpPr/>
+          <p:nvPr/>
+        </p:nvSpPr>
+        <p:spPr>
+          <a:xfrm>
+            <a:off x="9166631" y="3840480"/>
+            <a:ext cx="2247824" cy="1005840"/>
+          </a:xfrm>
+          <a:prstGeom prst="rect">
+            <a:avLst/>
+          </a:prstGeom>
+          <a:noFill/>
+          <a:ln/>
+        </p:spPr>
+        <p:txBody>
+          <a:bodyPr wrap="square" lIns="0" tIns="0" rIns="0" bIns="0" rtlCol="0" anchor="t"/>
+          <a:lstStyle/>
+          <a:p>
+            <a:pPr indent="0" marL="0">
+              <a:lnSpc>
+                <a:spcPct val="130000"/>
+              </a:lnSpc>
+              <a:buNone/>
+            </a:pPr>
+            <a:r>
+              <a:rPr lang="en-US" sz="1800" dirty="0">
+                <a:solidFill>
+                  <a:srgbClr val="5A6166"/>
+                </a:solidFill>
+                <a:latin typeface="Inter" pitchFamily="34" charset="0"/>
+                <a:ea typeface="Inter" pitchFamily="34" charset="-122"/>
+                <a:cs typeface="Inter" pitchFamily="34" charset="-120"/>
+              </a:rPr>
+              <a:t>Det som virker, settes i drift.</a:t>
+            </a:r>
+            <a:endParaRPr lang="en-US" sz="1800" dirty="0"/>
           </a:p>
         </p:txBody>
       </p:sp>
       <p:pic>
         <p:nvPicPr>
-          <p:cNvPr id="4" name="Image 0" descr="C:\Code\Work\startuplab-partner-presentation\pptx-templates\media\portrait-1.jpg">    </p:cNvPr>
+          <p:cNvPr id="16" name="Image 0" descr="C:\Code\Work\startuplab-partner-presentation\pptx-templates\media\logo-red.png">    </p:cNvPr>
           <p:cNvPicPr>
             <a:picLocks noChangeAspect="1"/>
           </p:cNvPicPr>
@@ -4123,486 +4366,6 @@
         </p:nvPicPr>
         <p:blipFill>
           <a:blip r:embed="rId1"/>
-          <a:srcRect l="0" r="0" t="0" b="0"/>
-          <a:stretch/>
-        </p:blipFill>
-        <p:spPr>
-          <a:xfrm>
-            <a:off x="777240" y="2286000"/>
-            <a:ext cx="2240280" cy="2240280"/>
-          </a:xfrm>
-          <a:prstGeom prst="ellipse">
-            <a:avLst/>
-          </a:prstGeom>
-        </p:spPr>
-      </p:pic>
-      <p:sp>
-        <p:nvSpPr>
-          <p:cNvPr id="5" name="Text 2"/>
-          <p:cNvSpPr/>
-          <p:nvPr/>
-        </p:nvSpPr>
-        <p:spPr>
-          <a:xfrm>
-            <a:off x="777240" y="4727448"/>
-            <a:ext cx="2240280" cy="365760"/>
-          </a:xfrm>
-          <a:prstGeom prst="rect">
-            <a:avLst/>
-          </a:prstGeom>
-          <a:noFill/>
-          <a:ln/>
-        </p:spPr>
-        <p:txBody>
-          <a:bodyPr wrap="square" lIns="0" tIns="0" rIns="0" bIns="0" rtlCol="0" anchor="ctr"/>
-          <a:lstStyle/>
-          <a:p>
-            <a:pPr algn="ctr" indent="0" marL="0">
-              <a:buNone/>
-            </a:pPr>
-            <a:r>
-              <a:rPr lang="en-US" sz="2100" b="1" dirty="0">
-                <a:solidFill>
-                  <a:srgbClr val="131415"/>
-                </a:solidFill>
-                <a:latin typeface="Replica LL TT" pitchFamily="34" charset="0"/>
-                <a:ea typeface="Replica LL TT" pitchFamily="34" charset="-122"/>
-                <a:cs typeface="Replica LL TT" pitchFamily="34" charset="-120"/>
-              </a:rPr>
-              <a:t>Christina Wiig</a:t>
-            </a:r>
-            <a:endParaRPr lang="en-US" sz="2100" dirty="0"/>
-          </a:p>
-        </p:txBody>
-      </p:sp>
-      <p:sp>
-        <p:nvSpPr>
-          <p:cNvPr id="6" name="Text 3"/>
-          <p:cNvSpPr/>
-          <p:nvPr/>
-        </p:nvSpPr>
-        <p:spPr>
-          <a:xfrm>
-            <a:off x="777240" y="5093208"/>
-            <a:ext cx="2240280" cy="694944"/>
-          </a:xfrm>
-          <a:prstGeom prst="rect">
-            <a:avLst/>
-          </a:prstGeom>
-          <a:noFill/>
-          <a:ln/>
-        </p:spPr>
-        <p:txBody>
-          <a:bodyPr wrap="square" lIns="0" tIns="0" rIns="0" bIns="0" rtlCol="0" anchor="t"/>
-          <a:lstStyle/>
-          <a:p>
-            <a:pPr algn="ctr" indent="0" marL="0">
-              <a:lnSpc>
-                <a:spcPct val="115000"/>
-              </a:lnSpc>
-              <a:buNone/>
-            </a:pPr>
-            <a:r>
-              <a:rPr lang="en-US" sz="1800" dirty="0">
-                <a:solidFill>
-                  <a:srgbClr val="5A6166"/>
-                </a:solidFill>
-                <a:latin typeface="Inter" pitchFamily="34" charset="0"/>
-                <a:ea typeface="Inter" pitchFamily="34" charset="-122"/>
-                <a:cs typeface="Inter" pitchFamily="34" charset="-120"/>
-              </a:rPr>
-              <a:t>Head of Corporate Partnerships</a:t>
-            </a:r>
-            <a:endParaRPr lang="en-US" sz="1800" dirty="0"/>
-          </a:p>
-        </p:txBody>
-      </p:sp>
-      <p:pic>
-        <p:nvPicPr>
-          <p:cNvPr id="7" name="Image 1" descr="C:\Code\Work\startuplab-partner-presentation\pptx-templates\media\portrait-2.jpg">    </p:cNvPr>
-          <p:cNvPicPr>
-            <a:picLocks noChangeAspect="1"/>
-          </p:cNvPicPr>
-          <p:nvPr/>
-        </p:nvPicPr>
-        <p:blipFill>
-          <a:blip r:embed="rId2"/>
-          <a:srcRect l="0" r="0" t="0" b="0"/>
-          <a:stretch/>
-        </p:blipFill>
-        <p:spPr>
-          <a:xfrm>
-            <a:off x="3576218" y="2286000"/>
-            <a:ext cx="2240280" cy="2240280"/>
-          </a:xfrm>
-          <a:prstGeom prst="ellipse">
-            <a:avLst/>
-          </a:prstGeom>
-        </p:spPr>
-      </p:pic>
-      <p:sp>
-        <p:nvSpPr>
-          <p:cNvPr id="8" name="Text 4"/>
-          <p:cNvSpPr/>
-          <p:nvPr/>
-        </p:nvSpPr>
-        <p:spPr>
-          <a:xfrm>
-            <a:off x="3576218" y="4727448"/>
-            <a:ext cx="2240280" cy="365760"/>
-          </a:xfrm>
-          <a:prstGeom prst="rect">
-            <a:avLst/>
-          </a:prstGeom>
-          <a:noFill/>
-          <a:ln/>
-        </p:spPr>
-        <p:txBody>
-          <a:bodyPr wrap="square" lIns="0" tIns="0" rIns="0" bIns="0" rtlCol="0" anchor="ctr"/>
-          <a:lstStyle/>
-          <a:p>
-            <a:pPr algn="ctr" indent="0" marL="0">
-              <a:buNone/>
-            </a:pPr>
-            <a:r>
-              <a:rPr lang="en-US" sz="2100" b="1" dirty="0">
-                <a:solidFill>
-                  <a:srgbClr val="131415"/>
-                </a:solidFill>
-                <a:latin typeface="Replica LL TT" pitchFamily="34" charset="0"/>
-                <a:ea typeface="Replica LL TT" pitchFamily="34" charset="-122"/>
-                <a:cs typeface="Replica LL TT" pitchFamily="34" charset="-120"/>
-              </a:rPr>
-              <a:t>Anniken Holst</a:t>
-            </a:r>
-            <a:endParaRPr lang="en-US" sz="2100" dirty="0"/>
-          </a:p>
-        </p:txBody>
-      </p:sp>
-      <p:sp>
-        <p:nvSpPr>
-          <p:cNvPr id="9" name="Text 5"/>
-          <p:cNvSpPr/>
-          <p:nvPr/>
-        </p:nvSpPr>
-        <p:spPr>
-          <a:xfrm>
-            <a:off x="3576218" y="5093208"/>
-            <a:ext cx="2240280" cy="694944"/>
-          </a:xfrm>
-          <a:prstGeom prst="rect">
-            <a:avLst/>
-          </a:prstGeom>
-          <a:noFill/>
-          <a:ln/>
-        </p:spPr>
-        <p:txBody>
-          <a:bodyPr wrap="square" lIns="0" tIns="0" rIns="0" bIns="0" rtlCol="0" anchor="t"/>
-          <a:lstStyle/>
-          <a:p>
-            <a:pPr algn="ctr" indent="0" marL="0">
-              <a:lnSpc>
-                <a:spcPct val="115000"/>
-              </a:lnSpc>
-              <a:buNone/>
-            </a:pPr>
-            <a:r>
-              <a:rPr lang="en-US" sz="1800" dirty="0">
-                <a:solidFill>
-                  <a:srgbClr val="5A6166"/>
-                </a:solidFill>
-                <a:latin typeface="Inter" pitchFamily="34" charset="0"/>
-                <a:ea typeface="Inter" pitchFamily="34" charset="-122"/>
-                <a:cs typeface="Inter" pitchFamily="34" charset="-120"/>
-              </a:rPr>
-              <a:t>Partner Manager</a:t>
-            </a:r>
-            <a:endParaRPr lang="en-US" sz="1800" dirty="0"/>
-          </a:p>
-        </p:txBody>
-      </p:sp>
-      <p:pic>
-        <p:nvPicPr>
-          <p:cNvPr id="10" name="Image 2" descr="C:\Code\Work\startuplab-partner-presentation\pptx-templates\media\portrait-3.jpg">    </p:cNvPr>
-          <p:cNvPicPr>
-            <a:picLocks noChangeAspect="1"/>
-          </p:cNvPicPr>
-          <p:nvPr/>
-        </p:nvPicPr>
-        <p:blipFill>
-          <a:blip r:embed="rId3"/>
-          <a:srcRect l="0" r="0" t="0" b="0"/>
-          <a:stretch/>
-        </p:blipFill>
-        <p:spPr>
-          <a:xfrm>
-            <a:off x="6375197" y="2286000"/>
-            <a:ext cx="2240280" cy="2240280"/>
-          </a:xfrm>
-          <a:prstGeom prst="ellipse">
-            <a:avLst/>
-          </a:prstGeom>
-        </p:spPr>
-      </p:pic>
-      <p:sp>
-        <p:nvSpPr>
-          <p:cNvPr id="11" name="Text 6"/>
-          <p:cNvSpPr/>
-          <p:nvPr/>
-        </p:nvSpPr>
-        <p:spPr>
-          <a:xfrm>
-            <a:off x="6375197" y="4727448"/>
-            <a:ext cx="2240280" cy="365760"/>
-          </a:xfrm>
-          <a:prstGeom prst="rect">
-            <a:avLst/>
-          </a:prstGeom>
-          <a:noFill/>
-          <a:ln/>
-        </p:spPr>
-        <p:txBody>
-          <a:bodyPr wrap="square" lIns="0" tIns="0" rIns="0" bIns="0" rtlCol="0" anchor="ctr"/>
-          <a:lstStyle/>
-          <a:p>
-            <a:pPr algn="ctr" indent="0" marL="0">
-              <a:buNone/>
-            </a:pPr>
-            <a:r>
-              <a:rPr lang="en-US" sz="2100" b="1" dirty="0">
-                <a:solidFill>
-                  <a:srgbClr val="131415"/>
-                </a:solidFill>
-                <a:latin typeface="Replica LL TT" pitchFamily="34" charset="0"/>
-                <a:ea typeface="Replica LL TT" pitchFamily="34" charset="-122"/>
-                <a:cs typeface="Replica LL TT" pitchFamily="34" charset="-120"/>
-              </a:rPr>
-              <a:t>Ola Jacobsen</a:t>
-            </a:r>
-            <a:endParaRPr lang="en-US" sz="2100" dirty="0"/>
-          </a:p>
-        </p:txBody>
-      </p:sp>
-      <p:sp>
-        <p:nvSpPr>
-          <p:cNvPr id="12" name="Text 7"/>
-          <p:cNvSpPr/>
-          <p:nvPr/>
-        </p:nvSpPr>
-        <p:spPr>
-          <a:xfrm>
-            <a:off x="6375197" y="5093208"/>
-            <a:ext cx="2240280" cy="694944"/>
-          </a:xfrm>
-          <a:prstGeom prst="rect">
-            <a:avLst/>
-          </a:prstGeom>
-          <a:noFill/>
-          <a:ln/>
-        </p:spPr>
-        <p:txBody>
-          <a:bodyPr wrap="square" lIns="0" tIns="0" rIns="0" bIns="0" rtlCol="0" anchor="t"/>
-          <a:lstStyle/>
-          <a:p>
-            <a:pPr algn="ctr" indent="0" marL="0">
-              <a:lnSpc>
-                <a:spcPct val="115000"/>
-              </a:lnSpc>
-              <a:buNone/>
-            </a:pPr>
-            <a:r>
-              <a:rPr lang="en-US" sz="1800" dirty="0">
-                <a:solidFill>
-                  <a:srgbClr val="5A6166"/>
-                </a:solidFill>
-                <a:latin typeface="Inter" pitchFamily="34" charset="0"/>
-                <a:ea typeface="Inter" pitchFamily="34" charset="-122"/>
-                <a:cs typeface="Inter" pitchFamily="34" charset="-120"/>
-              </a:rPr>
-              <a:t>Partner Manager</a:t>
-            </a:r>
-            <a:endParaRPr lang="en-US" sz="1800" dirty="0"/>
-          </a:p>
-        </p:txBody>
-      </p:sp>
-      <p:sp>
-        <p:nvSpPr>
-          <p:cNvPr id="13" name="Shape 8"/>
-          <p:cNvSpPr/>
-          <p:nvPr/>
-        </p:nvSpPr>
-        <p:spPr>
-          <a:xfrm>
-            <a:off x="9174175" y="2286000"/>
-            <a:ext cx="2240280" cy="2240280"/>
-          </a:xfrm>
-          <a:prstGeom prst="ellipse">
-            <a:avLst/>
-          </a:prstGeom>
-          <a:solidFill>
-            <a:srgbClr val="F0F0F0"/>
-          </a:solidFill>
-          <a:ln w="12700">
-            <a:solidFill>
-              <a:srgbClr val="D8DCDF"/>
-            </a:solidFill>
-            <a:prstDash val="solid"/>
-          </a:ln>
-        </p:spPr>
-      </p:sp>
-      <p:sp>
-        <p:nvSpPr>
-          <p:cNvPr id="14" name="Text 9"/>
-          <p:cNvSpPr/>
-          <p:nvPr/>
-        </p:nvSpPr>
-        <p:spPr>
-          <a:xfrm>
-            <a:off x="9174175" y="2994660"/>
-            <a:ext cx="2240280" cy="822960"/>
-          </a:xfrm>
-          <a:prstGeom prst="rect">
-            <a:avLst/>
-          </a:prstGeom>
-          <a:noFill/>
-          <a:ln/>
-        </p:spPr>
-        <p:txBody>
-          <a:bodyPr wrap="square" lIns="0" tIns="0" rIns="0" bIns="0" rtlCol="0" anchor="ctr"/>
-          <a:lstStyle/>
-          <a:p>
-            <a:pPr algn="ctr" indent="0" marL="0">
-              <a:lnSpc>
-                <a:spcPct val="120000"/>
-              </a:lnSpc>
-              <a:buNone/>
-            </a:pPr>
-            <a:r>
-              <a:rPr lang="en-US" sz="1800" dirty="0">
-                <a:solidFill>
-                  <a:srgbClr val="5A6166"/>
-                </a:solidFill>
-                <a:latin typeface="Inter" pitchFamily="34" charset="0"/>
-                <a:ea typeface="Inter" pitchFamily="34" charset="-122"/>
-                <a:cs typeface="Inter" pitchFamily="34" charset="-120"/>
-              </a:rPr>
-              <a:t>Sett inn</a:t>
-            </a:r>
-            <a:endParaRPr lang="en-US" sz="1800" dirty="0"/>
-          </a:p>
-          <a:p>
-            <a:pPr algn="ctr" indent="0" marL="0">
-              <a:lnSpc>
-                <a:spcPct val="120000"/>
-              </a:lnSpc>
-              <a:buNone/>
-            </a:pPr>
-            <a:r>
-              <a:rPr lang="en-US" sz="1800" dirty="0">
-                <a:solidFill>
-                  <a:srgbClr val="5A6166"/>
-                </a:solidFill>
-                <a:latin typeface="Inter" pitchFamily="34" charset="0"/>
-                <a:ea typeface="Inter" pitchFamily="34" charset="-122"/>
-                <a:cs typeface="Inter" pitchFamily="34" charset="-120"/>
-              </a:rPr>
-              <a:t>portrett</a:t>
-            </a:r>
-            <a:endParaRPr lang="en-US" sz="1800" dirty="0"/>
-          </a:p>
-        </p:txBody>
-      </p:sp>
-      <p:sp>
-        <p:nvSpPr>
-          <p:cNvPr id="15" name="Text 10"/>
-          <p:cNvSpPr/>
-          <p:nvPr/>
-        </p:nvSpPr>
-        <p:spPr>
-          <a:xfrm>
-            <a:off x="9174175" y="4727448"/>
-            <a:ext cx="2240280" cy="365760"/>
-          </a:xfrm>
-          <a:prstGeom prst="rect">
-            <a:avLst/>
-          </a:prstGeom>
-          <a:noFill/>
-          <a:ln/>
-        </p:spPr>
-        <p:txBody>
-          <a:bodyPr wrap="square" lIns="0" tIns="0" rIns="0" bIns="0" rtlCol="0" anchor="ctr"/>
-          <a:lstStyle/>
-          <a:p>
-            <a:pPr algn="ctr" indent="0" marL="0">
-              <a:buNone/>
-            </a:pPr>
-            <a:r>
-              <a:rPr lang="en-US" sz="2100" b="1" dirty="0">
-                <a:solidFill>
-                  <a:srgbClr val="131415"/>
-                </a:solidFill>
-                <a:latin typeface="Replica LL TT" pitchFamily="34" charset="0"/>
-                <a:ea typeface="Replica LL TT" pitchFamily="34" charset="-122"/>
-                <a:cs typeface="Replica LL TT" pitchFamily="34" charset="-120"/>
-              </a:rPr>
-              <a:t>Navn Navnesen</a:t>
-            </a:r>
-            <a:endParaRPr lang="en-US" sz="2100" dirty="0"/>
-          </a:p>
-        </p:txBody>
-      </p:sp>
-      <p:sp>
-        <p:nvSpPr>
-          <p:cNvPr id="16" name="Text 11"/>
-          <p:cNvSpPr/>
-          <p:nvPr/>
-        </p:nvSpPr>
-        <p:spPr>
-          <a:xfrm>
-            <a:off x="9174175" y="5093208"/>
-            <a:ext cx="2240280" cy="694944"/>
-          </a:xfrm>
-          <a:prstGeom prst="rect">
-            <a:avLst/>
-          </a:prstGeom>
-          <a:noFill/>
-          <a:ln/>
-        </p:spPr>
-        <p:txBody>
-          <a:bodyPr wrap="square" lIns="0" tIns="0" rIns="0" bIns="0" rtlCol="0" anchor="t"/>
-          <a:lstStyle/>
-          <a:p>
-            <a:pPr algn="ctr" indent="0" marL="0">
-              <a:lnSpc>
-                <a:spcPct val="115000"/>
-              </a:lnSpc>
-              <a:buNone/>
-            </a:pPr>
-            <a:r>
-              <a:rPr lang="en-US" sz="1800" dirty="0">
-                <a:solidFill>
-                  <a:srgbClr val="5A6166"/>
-                </a:solidFill>
-                <a:latin typeface="Inter" pitchFamily="34" charset="0"/>
-                <a:ea typeface="Inter" pitchFamily="34" charset="-122"/>
-                <a:cs typeface="Inter" pitchFamily="34" charset="-120"/>
-              </a:rPr>
-              <a:t>Rolle her</a:t>
-            </a:r>
-            <a:endParaRPr lang="en-US" sz="1800" dirty="0"/>
-          </a:p>
-        </p:txBody>
-      </p:sp>
-      <p:pic>
-        <p:nvPicPr>
-          <p:cNvPr id="17" name="Image 3" descr="C:\Code\Work\startuplab-partner-presentation\pptx-templates\media\logo-red.png">    </p:cNvPr>
-          <p:cNvPicPr>
-            <a:picLocks noChangeAspect="1"/>
-          </p:cNvPicPr>
-          <p:nvPr/>
-        </p:nvPicPr>
-        <p:blipFill>
-          <a:blip r:embed="rId4"/>
           <a:stretch>
             <a:fillRect/>
           </a:stretch>
@@ -4628,6 +4391,640 @@
 <file path=ppt/slides/slide15.xml><?xml version="1.0" encoding="utf-8"?>
 <p:sld xmlns:a="http://schemas.openxmlformats.org/drawingml/2006/main" xmlns:r="http://schemas.openxmlformats.org/officeDocument/2006/relationships" xmlns:p="http://schemas.openxmlformats.org/presentationml/2006/main">
   <p:cSld name="Slide 15">
+    <p:bg>
+      <p:bgPr>
+        <a:solidFill>
+          <a:srgbClr val="FFFFFF"/>
+        </a:solidFill>
+      </p:bgPr>
+    </p:bg>
+    <p:spTree>
+      <p:nvGrpSpPr>
+        <p:cNvPr id="1" name=""/>
+        <p:cNvGrpSpPr/>
+        <p:nvPr/>
+      </p:nvGrpSpPr>
+      <p:grpSpPr>
+        <a:xfrm>
+          <a:off x="0" y="0"/>
+          <a:ext cx="0" cy="0"/>
+          <a:chOff x="0" y="0"/>
+          <a:chExt cx="0" cy="0"/>
+        </a:xfrm>
+      </p:grpSpPr>
+      <p:sp>
+        <p:nvSpPr>
+          <p:cNvPr id="2" name="Text 0"/>
+          <p:cNvSpPr/>
+          <p:nvPr/>
+        </p:nvSpPr>
+        <p:spPr>
+          <a:xfrm>
+            <a:off x="777240" y="713232"/>
+            <a:ext cx="8229600" cy="292608"/>
+          </a:xfrm>
+          <a:prstGeom prst="rect">
+            <a:avLst/>
+          </a:prstGeom>
+          <a:noFill/>
+          <a:ln/>
+        </p:spPr>
+        <p:txBody>
+          <a:bodyPr wrap="square" lIns="0" tIns="0" rIns="0" bIns="0" rtlCol="0" anchor="ctr"/>
+          <a:lstStyle/>
+          <a:p>
+            <a:pPr indent="0" marL="0">
+              <a:buNone/>
+            </a:pPr>
+            <a:r>
+              <a:rPr lang="en-US" sz="1600" b="1" spc="250" kern="0" dirty="0">
+                <a:solidFill>
+                  <a:srgbClr val="FF3333"/>
+                </a:solidFill>
+                <a:latin typeface="Inter" pitchFamily="34" charset="0"/>
+                <a:ea typeface="Inter" pitchFamily="34" charset="-122"/>
+                <a:cs typeface="Inter" pitchFamily="34" charset="-120"/>
+              </a:rPr>
+              <a:t>TEAMET</a:t>
+            </a:r>
+            <a:endParaRPr lang="en-US" sz="1600" dirty="0"/>
+          </a:p>
+        </p:txBody>
+      </p:sp>
+      <p:sp>
+        <p:nvSpPr>
+          <p:cNvPr id="3" name="Text 1"/>
+          <p:cNvSpPr/>
+          <p:nvPr/>
+        </p:nvSpPr>
+        <p:spPr>
+          <a:xfrm>
+            <a:off x="777240" y="1051560"/>
+            <a:ext cx="10424160" cy="777240"/>
+          </a:xfrm>
+          <a:prstGeom prst="rect">
+            <a:avLst/>
+          </a:prstGeom>
+          <a:noFill/>
+          <a:ln/>
+        </p:spPr>
+        <p:txBody>
+          <a:bodyPr wrap="square" lIns="0" tIns="0" rIns="0" bIns="0" rtlCol="0" anchor="t"/>
+          <a:lstStyle/>
+          <a:p>
+            <a:pPr indent="0" marL="0">
+              <a:lnSpc>
+                <a:spcPct val="100000"/>
+              </a:lnSpc>
+              <a:buNone/>
+            </a:pPr>
+            <a:r>
+              <a:rPr lang="en-US" sz="4000" b="1" dirty="0">
+                <a:solidFill>
+                  <a:srgbClr val="131415"/>
+                </a:solidFill>
+                <a:latin typeface="Replica LL TT" pitchFamily="34" charset="0"/>
+                <a:ea typeface="Replica LL TT" pitchFamily="34" charset="-122"/>
+                <a:cs typeface="Replica LL TT" pitchFamily="34" charset="-120"/>
+              </a:rPr>
+              <a:t>Folkene du kommer til å </a:t>
+            </a:r>
+            <a:pPr indent="0" marL="0">
+              <a:lnSpc>
+                <a:spcPct val="100000"/>
+              </a:lnSpc>
+              <a:buNone/>
+            </a:pPr>
+            <a:r>
+              <a:rPr lang="en-US" sz="4000" b="1" dirty="0">
+                <a:solidFill>
+                  <a:srgbClr val="FF3333"/>
+                </a:solidFill>
+                <a:latin typeface="Replica LL TT" pitchFamily="34" charset="0"/>
+                <a:ea typeface="Replica LL TT" pitchFamily="34" charset="-122"/>
+                <a:cs typeface="Replica LL TT" pitchFamily="34" charset="-120"/>
+              </a:rPr>
+              <a:t>jobbe med</a:t>
+            </a:r>
+            <a:endParaRPr lang="en-US" sz="4000" dirty="0"/>
+          </a:p>
+        </p:txBody>
+      </p:sp>
+      <p:pic>
+        <p:nvPicPr>
+          <p:cNvPr id="4" name="Image 0" descr="C:\Code\Work\startuplab-partner-presentation\pptx-templates\media\portrait-1.jpg">    </p:cNvPr>
+          <p:cNvPicPr>
+            <a:picLocks noChangeAspect="1"/>
+          </p:cNvPicPr>
+          <p:nvPr/>
+        </p:nvPicPr>
+        <p:blipFill>
+          <a:blip r:embed="rId1"/>
+          <a:srcRect l="0" r="0" t="0" b="0"/>
+          <a:stretch/>
+        </p:blipFill>
+        <p:spPr>
+          <a:xfrm>
+            <a:off x="777240" y="2286000"/>
+            <a:ext cx="2240280" cy="2240280"/>
+          </a:xfrm>
+          <a:prstGeom prst="ellipse">
+            <a:avLst/>
+          </a:prstGeom>
+        </p:spPr>
+      </p:pic>
+      <p:sp>
+        <p:nvSpPr>
+          <p:cNvPr id="5" name="Text 2"/>
+          <p:cNvSpPr/>
+          <p:nvPr/>
+        </p:nvSpPr>
+        <p:spPr>
+          <a:xfrm>
+            <a:off x="777240" y="4727448"/>
+            <a:ext cx="2240280" cy="365760"/>
+          </a:xfrm>
+          <a:prstGeom prst="rect">
+            <a:avLst/>
+          </a:prstGeom>
+          <a:noFill/>
+          <a:ln/>
+        </p:spPr>
+        <p:txBody>
+          <a:bodyPr wrap="square" lIns="0" tIns="0" rIns="0" bIns="0" rtlCol="0" anchor="ctr"/>
+          <a:lstStyle/>
+          <a:p>
+            <a:pPr algn="ctr" indent="0" marL="0">
+              <a:buNone/>
+            </a:pPr>
+            <a:r>
+              <a:rPr lang="en-US" sz="2100" b="1" dirty="0">
+                <a:solidFill>
+                  <a:srgbClr val="131415"/>
+                </a:solidFill>
+                <a:latin typeface="Replica LL TT" pitchFamily="34" charset="0"/>
+                <a:ea typeface="Replica LL TT" pitchFamily="34" charset="-122"/>
+                <a:cs typeface="Replica LL TT" pitchFamily="34" charset="-120"/>
+              </a:rPr>
+              <a:t>Christina Wiig</a:t>
+            </a:r>
+            <a:endParaRPr lang="en-US" sz="2100" dirty="0"/>
+          </a:p>
+        </p:txBody>
+      </p:sp>
+      <p:sp>
+        <p:nvSpPr>
+          <p:cNvPr id="6" name="Text 3"/>
+          <p:cNvSpPr/>
+          <p:nvPr/>
+        </p:nvSpPr>
+        <p:spPr>
+          <a:xfrm>
+            <a:off x="777240" y="5093208"/>
+            <a:ext cx="2240280" cy="694944"/>
+          </a:xfrm>
+          <a:prstGeom prst="rect">
+            <a:avLst/>
+          </a:prstGeom>
+          <a:noFill/>
+          <a:ln/>
+        </p:spPr>
+        <p:txBody>
+          <a:bodyPr wrap="square" lIns="0" tIns="0" rIns="0" bIns="0" rtlCol="0" anchor="t"/>
+          <a:lstStyle/>
+          <a:p>
+            <a:pPr algn="ctr" indent="0" marL="0">
+              <a:lnSpc>
+                <a:spcPct val="115000"/>
+              </a:lnSpc>
+              <a:buNone/>
+            </a:pPr>
+            <a:r>
+              <a:rPr lang="en-US" sz="1800" dirty="0">
+                <a:solidFill>
+                  <a:srgbClr val="5A6166"/>
+                </a:solidFill>
+                <a:latin typeface="Inter" pitchFamily="34" charset="0"/>
+                <a:ea typeface="Inter" pitchFamily="34" charset="-122"/>
+                <a:cs typeface="Inter" pitchFamily="34" charset="-120"/>
+              </a:rPr>
+              <a:t>Head of Corporate Partnerships</a:t>
+            </a:r>
+            <a:endParaRPr lang="en-US" sz="1800" dirty="0"/>
+          </a:p>
+        </p:txBody>
+      </p:sp>
+      <p:pic>
+        <p:nvPicPr>
+          <p:cNvPr id="7" name="Image 1" descr="C:\Code\Work\startuplab-partner-presentation\pptx-templates\media\portrait-2.jpg">    </p:cNvPr>
+          <p:cNvPicPr>
+            <a:picLocks noChangeAspect="1"/>
+          </p:cNvPicPr>
+          <p:nvPr/>
+        </p:nvPicPr>
+        <p:blipFill>
+          <a:blip r:embed="rId2"/>
+          <a:srcRect l="0" r="0" t="0" b="0"/>
+          <a:stretch/>
+        </p:blipFill>
+        <p:spPr>
+          <a:xfrm>
+            <a:off x="3576218" y="2286000"/>
+            <a:ext cx="2240280" cy="2240280"/>
+          </a:xfrm>
+          <a:prstGeom prst="ellipse">
+            <a:avLst/>
+          </a:prstGeom>
+        </p:spPr>
+      </p:pic>
+      <p:sp>
+        <p:nvSpPr>
+          <p:cNvPr id="8" name="Text 4"/>
+          <p:cNvSpPr/>
+          <p:nvPr/>
+        </p:nvSpPr>
+        <p:spPr>
+          <a:xfrm>
+            <a:off x="3576218" y="4727448"/>
+            <a:ext cx="2240280" cy="365760"/>
+          </a:xfrm>
+          <a:prstGeom prst="rect">
+            <a:avLst/>
+          </a:prstGeom>
+          <a:noFill/>
+          <a:ln/>
+        </p:spPr>
+        <p:txBody>
+          <a:bodyPr wrap="square" lIns="0" tIns="0" rIns="0" bIns="0" rtlCol="0" anchor="ctr"/>
+          <a:lstStyle/>
+          <a:p>
+            <a:pPr algn="ctr" indent="0" marL="0">
+              <a:buNone/>
+            </a:pPr>
+            <a:r>
+              <a:rPr lang="en-US" sz="2100" b="1" dirty="0">
+                <a:solidFill>
+                  <a:srgbClr val="131415"/>
+                </a:solidFill>
+                <a:latin typeface="Replica LL TT" pitchFamily="34" charset="0"/>
+                <a:ea typeface="Replica LL TT" pitchFamily="34" charset="-122"/>
+                <a:cs typeface="Replica LL TT" pitchFamily="34" charset="-120"/>
+              </a:rPr>
+              <a:t>Anniken Holst</a:t>
+            </a:r>
+            <a:endParaRPr lang="en-US" sz="2100" dirty="0"/>
+          </a:p>
+        </p:txBody>
+      </p:sp>
+      <p:sp>
+        <p:nvSpPr>
+          <p:cNvPr id="9" name="Text 5"/>
+          <p:cNvSpPr/>
+          <p:nvPr/>
+        </p:nvSpPr>
+        <p:spPr>
+          <a:xfrm>
+            <a:off x="3576218" y="5093208"/>
+            <a:ext cx="2240280" cy="694944"/>
+          </a:xfrm>
+          <a:prstGeom prst="rect">
+            <a:avLst/>
+          </a:prstGeom>
+          <a:noFill/>
+          <a:ln/>
+        </p:spPr>
+        <p:txBody>
+          <a:bodyPr wrap="square" lIns="0" tIns="0" rIns="0" bIns="0" rtlCol="0" anchor="t"/>
+          <a:lstStyle/>
+          <a:p>
+            <a:pPr algn="ctr" indent="0" marL="0">
+              <a:lnSpc>
+                <a:spcPct val="115000"/>
+              </a:lnSpc>
+              <a:buNone/>
+            </a:pPr>
+            <a:r>
+              <a:rPr lang="en-US" sz="1800" dirty="0">
+                <a:solidFill>
+                  <a:srgbClr val="5A6166"/>
+                </a:solidFill>
+                <a:latin typeface="Inter" pitchFamily="34" charset="0"/>
+                <a:ea typeface="Inter" pitchFamily="34" charset="-122"/>
+                <a:cs typeface="Inter" pitchFamily="34" charset="-120"/>
+              </a:rPr>
+              <a:t>Partner Manager</a:t>
+            </a:r>
+            <a:endParaRPr lang="en-US" sz="1800" dirty="0"/>
+          </a:p>
+        </p:txBody>
+      </p:sp>
+      <p:pic>
+        <p:nvPicPr>
+          <p:cNvPr id="10" name="Image 2" descr="C:\Code\Work\startuplab-partner-presentation\pptx-templates\media\portrait-3.jpg">    </p:cNvPr>
+          <p:cNvPicPr>
+            <a:picLocks noChangeAspect="1"/>
+          </p:cNvPicPr>
+          <p:nvPr/>
+        </p:nvPicPr>
+        <p:blipFill>
+          <a:blip r:embed="rId3"/>
+          <a:srcRect l="0" r="0" t="0" b="0"/>
+          <a:stretch/>
+        </p:blipFill>
+        <p:spPr>
+          <a:xfrm>
+            <a:off x="6375197" y="2286000"/>
+            <a:ext cx="2240280" cy="2240280"/>
+          </a:xfrm>
+          <a:prstGeom prst="ellipse">
+            <a:avLst/>
+          </a:prstGeom>
+        </p:spPr>
+      </p:pic>
+      <p:sp>
+        <p:nvSpPr>
+          <p:cNvPr id="11" name="Text 6"/>
+          <p:cNvSpPr/>
+          <p:nvPr/>
+        </p:nvSpPr>
+        <p:spPr>
+          <a:xfrm>
+            <a:off x="6375197" y="4727448"/>
+            <a:ext cx="2240280" cy="365760"/>
+          </a:xfrm>
+          <a:prstGeom prst="rect">
+            <a:avLst/>
+          </a:prstGeom>
+          <a:noFill/>
+          <a:ln/>
+        </p:spPr>
+        <p:txBody>
+          <a:bodyPr wrap="square" lIns="0" tIns="0" rIns="0" bIns="0" rtlCol="0" anchor="ctr"/>
+          <a:lstStyle/>
+          <a:p>
+            <a:pPr algn="ctr" indent="0" marL="0">
+              <a:buNone/>
+            </a:pPr>
+            <a:r>
+              <a:rPr lang="en-US" sz="2100" b="1" dirty="0">
+                <a:solidFill>
+                  <a:srgbClr val="131415"/>
+                </a:solidFill>
+                <a:latin typeface="Replica LL TT" pitchFamily="34" charset="0"/>
+                <a:ea typeface="Replica LL TT" pitchFamily="34" charset="-122"/>
+                <a:cs typeface="Replica LL TT" pitchFamily="34" charset="-120"/>
+              </a:rPr>
+              <a:t>Ola Jacobsen</a:t>
+            </a:r>
+            <a:endParaRPr lang="en-US" sz="2100" dirty="0"/>
+          </a:p>
+        </p:txBody>
+      </p:sp>
+      <p:sp>
+        <p:nvSpPr>
+          <p:cNvPr id="12" name="Text 7"/>
+          <p:cNvSpPr/>
+          <p:nvPr/>
+        </p:nvSpPr>
+        <p:spPr>
+          <a:xfrm>
+            <a:off x="6375197" y="5093208"/>
+            <a:ext cx="2240280" cy="694944"/>
+          </a:xfrm>
+          <a:prstGeom prst="rect">
+            <a:avLst/>
+          </a:prstGeom>
+          <a:noFill/>
+          <a:ln/>
+        </p:spPr>
+        <p:txBody>
+          <a:bodyPr wrap="square" lIns="0" tIns="0" rIns="0" bIns="0" rtlCol="0" anchor="t"/>
+          <a:lstStyle/>
+          <a:p>
+            <a:pPr algn="ctr" indent="0" marL="0">
+              <a:lnSpc>
+                <a:spcPct val="115000"/>
+              </a:lnSpc>
+              <a:buNone/>
+            </a:pPr>
+            <a:r>
+              <a:rPr lang="en-US" sz="1800" dirty="0">
+                <a:solidFill>
+                  <a:srgbClr val="5A6166"/>
+                </a:solidFill>
+                <a:latin typeface="Inter" pitchFamily="34" charset="0"/>
+                <a:ea typeface="Inter" pitchFamily="34" charset="-122"/>
+                <a:cs typeface="Inter" pitchFamily="34" charset="-120"/>
+              </a:rPr>
+              <a:t>Partner Manager</a:t>
+            </a:r>
+            <a:endParaRPr lang="en-US" sz="1800" dirty="0"/>
+          </a:p>
+        </p:txBody>
+      </p:sp>
+      <p:sp>
+        <p:nvSpPr>
+          <p:cNvPr id="13" name="Shape 8"/>
+          <p:cNvSpPr/>
+          <p:nvPr/>
+        </p:nvSpPr>
+        <p:spPr>
+          <a:xfrm>
+            <a:off x="9174175" y="2286000"/>
+            <a:ext cx="2240280" cy="2240280"/>
+          </a:xfrm>
+          <a:prstGeom prst="ellipse">
+            <a:avLst/>
+          </a:prstGeom>
+          <a:solidFill>
+            <a:srgbClr val="F0F0F0"/>
+          </a:solidFill>
+          <a:ln w="12700">
+            <a:solidFill>
+              <a:srgbClr val="D8DCDF"/>
+            </a:solidFill>
+            <a:prstDash val="solid"/>
+          </a:ln>
+        </p:spPr>
+      </p:sp>
+      <p:sp>
+        <p:nvSpPr>
+          <p:cNvPr id="14" name="Text 9"/>
+          <p:cNvSpPr/>
+          <p:nvPr/>
+        </p:nvSpPr>
+        <p:spPr>
+          <a:xfrm>
+            <a:off x="9174175" y="2994660"/>
+            <a:ext cx="2240280" cy="822960"/>
+          </a:xfrm>
+          <a:prstGeom prst="rect">
+            <a:avLst/>
+          </a:prstGeom>
+          <a:noFill/>
+          <a:ln/>
+        </p:spPr>
+        <p:txBody>
+          <a:bodyPr wrap="square" lIns="0" tIns="0" rIns="0" bIns="0" rtlCol="0" anchor="ctr"/>
+          <a:lstStyle/>
+          <a:p>
+            <a:pPr algn="ctr" indent="0" marL="0">
+              <a:lnSpc>
+                <a:spcPct val="120000"/>
+              </a:lnSpc>
+              <a:buNone/>
+            </a:pPr>
+            <a:r>
+              <a:rPr lang="en-US" sz="1800" dirty="0">
+                <a:solidFill>
+                  <a:srgbClr val="5A6166"/>
+                </a:solidFill>
+                <a:latin typeface="Inter" pitchFamily="34" charset="0"/>
+                <a:ea typeface="Inter" pitchFamily="34" charset="-122"/>
+                <a:cs typeface="Inter" pitchFamily="34" charset="-120"/>
+              </a:rPr>
+              <a:t>Sett inn</a:t>
+            </a:r>
+            <a:endParaRPr lang="en-US" sz="1800" dirty="0"/>
+          </a:p>
+          <a:p>
+            <a:pPr algn="ctr" indent="0" marL="0">
+              <a:lnSpc>
+                <a:spcPct val="120000"/>
+              </a:lnSpc>
+              <a:buNone/>
+            </a:pPr>
+            <a:r>
+              <a:rPr lang="en-US" sz="1800" dirty="0">
+                <a:solidFill>
+                  <a:srgbClr val="5A6166"/>
+                </a:solidFill>
+                <a:latin typeface="Inter" pitchFamily="34" charset="0"/>
+                <a:ea typeface="Inter" pitchFamily="34" charset="-122"/>
+                <a:cs typeface="Inter" pitchFamily="34" charset="-120"/>
+              </a:rPr>
+              <a:t>portrett</a:t>
+            </a:r>
+            <a:endParaRPr lang="en-US" sz="1800" dirty="0"/>
+          </a:p>
+        </p:txBody>
+      </p:sp>
+      <p:sp>
+        <p:nvSpPr>
+          <p:cNvPr id="15" name="Text 10"/>
+          <p:cNvSpPr/>
+          <p:nvPr/>
+        </p:nvSpPr>
+        <p:spPr>
+          <a:xfrm>
+            <a:off x="9174175" y="4727448"/>
+            <a:ext cx="2240280" cy="365760"/>
+          </a:xfrm>
+          <a:prstGeom prst="rect">
+            <a:avLst/>
+          </a:prstGeom>
+          <a:noFill/>
+          <a:ln/>
+        </p:spPr>
+        <p:txBody>
+          <a:bodyPr wrap="square" lIns="0" tIns="0" rIns="0" bIns="0" rtlCol="0" anchor="ctr"/>
+          <a:lstStyle/>
+          <a:p>
+            <a:pPr algn="ctr" indent="0" marL="0">
+              <a:buNone/>
+            </a:pPr>
+            <a:r>
+              <a:rPr lang="en-US" sz="2100" b="1" dirty="0">
+                <a:solidFill>
+                  <a:srgbClr val="131415"/>
+                </a:solidFill>
+                <a:latin typeface="Replica LL TT" pitchFamily="34" charset="0"/>
+                <a:ea typeface="Replica LL TT" pitchFamily="34" charset="-122"/>
+                <a:cs typeface="Replica LL TT" pitchFamily="34" charset="-120"/>
+              </a:rPr>
+              <a:t>Navn Navnesen</a:t>
+            </a:r>
+            <a:endParaRPr lang="en-US" sz="2100" dirty="0"/>
+          </a:p>
+        </p:txBody>
+      </p:sp>
+      <p:sp>
+        <p:nvSpPr>
+          <p:cNvPr id="16" name="Text 11"/>
+          <p:cNvSpPr/>
+          <p:nvPr/>
+        </p:nvSpPr>
+        <p:spPr>
+          <a:xfrm>
+            <a:off x="9174175" y="5093208"/>
+            <a:ext cx="2240280" cy="694944"/>
+          </a:xfrm>
+          <a:prstGeom prst="rect">
+            <a:avLst/>
+          </a:prstGeom>
+          <a:noFill/>
+          <a:ln/>
+        </p:spPr>
+        <p:txBody>
+          <a:bodyPr wrap="square" lIns="0" tIns="0" rIns="0" bIns="0" rtlCol="0" anchor="t"/>
+          <a:lstStyle/>
+          <a:p>
+            <a:pPr algn="ctr" indent="0" marL="0">
+              <a:lnSpc>
+                <a:spcPct val="115000"/>
+              </a:lnSpc>
+              <a:buNone/>
+            </a:pPr>
+            <a:r>
+              <a:rPr lang="en-US" sz="1800" dirty="0">
+                <a:solidFill>
+                  <a:srgbClr val="5A6166"/>
+                </a:solidFill>
+                <a:latin typeface="Inter" pitchFamily="34" charset="0"/>
+                <a:ea typeface="Inter" pitchFamily="34" charset="-122"/>
+                <a:cs typeface="Inter" pitchFamily="34" charset="-120"/>
+              </a:rPr>
+              <a:t>Rolle her</a:t>
+            </a:r>
+            <a:endParaRPr lang="en-US" sz="1800" dirty="0"/>
+          </a:p>
+        </p:txBody>
+      </p:sp>
+      <p:pic>
+        <p:nvPicPr>
+          <p:cNvPr id="17" name="Image 3" descr="C:\Code\Work\startuplab-partner-presentation\pptx-templates\media\logo-red.png">    </p:cNvPr>
+          <p:cNvPicPr>
+            <a:picLocks noChangeAspect="1"/>
+          </p:cNvPicPr>
+          <p:nvPr/>
+        </p:nvPicPr>
+        <p:blipFill>
+          <a:blip r:embed="rId4"/>
+          <a:stretch>
+            <a:fillRect/>
+          </a:stretch>
+        </p:blipFill>
+        <p:spPr>
+          <a:xfrm>
+            <a:off x="777240" y="6035040"/>
+            <a:ext cx="843006" cy="310896"/>
+          </a:xfrm>
+          <a:prstGeom prst="rect">
+            <a:avLst/>
+          </a:prstGeom>
+        </p:spPr>
+      </p:pic>
+    </p:spTree>
+  </p:cSld>
+  <p:clrMapOvr>
+    <a:masterClrMapping/>
+  </p:clrMapOvr>
+</p:sld>
+</file>
+
+<file path=ppt/slides/slide16.xml><?xml version="1.0" encoding="utf-8"?>
+<p:sld xmlns:a="http://schemas.openxmlformats.org/drawingml/2006/main" xmlns:r="http://schemas.openxmlformats.org/officeDocument/2006/relationships" xmlns:p="http://schemas.openxmlformats.org/presentationml/2006/main">
+  <p:cSld name="Slide 16">
     <p:bg>
       <p:bgPr>
         <a:solidFill>
@@ -4833,9 +5230,9 @@
 </p:sld>
 </file>
 
-<file path=ppt/slides/slide16.xml><?xml version="1.0" encoding="utf-8"?>
+<file path=ppt/slides/slide17.xml><?xml version="1.0" encoding="utf-8"?>
 <p:sld xmlns:a="http://schemas.openxmlformats.org/drawingml/2006/main" xmlns:r="http://schemas.openxmlformats.org/officeDocument/2006/relationships" xmlns:p="http://schemas.openxmlformats.org/presentationml/2006/main">
-  <p:cSld name="Slide 16">
+  <p:cSld name="Slide 17">
     <p:bg>
       <p:bgPr>
         <a:solidFill>

</xml_diff>

<commit_message>
Legg til kapittelskille-mal med konturtall og indeksrekke
Kapittelnummeret er et stort grafisk tall med svak kropp og rosa kontur, og
en indeksrekke under tittelen viser hvor i løpet salen er.

Valgt blant fem varianter. Rosa kontur, ikke rød, slik at rødt fortsatt er
den eneste aksentfargen på sliden. Et helt hult tall ble forkastet: streken
alene forsvinner nesten på projektor over en så stor flate.

Indeksrekken ligger i én tekstboks. Ett tall per boks krever at bredden
regnes ut, og et anslag som er noen hundredeler for trangt får tallet til å
brekke i to linjer, noe et første forsøk gjorde.

Malen skiller seg fra de to andre dramatiske: seksjonsskillet er en rød
plakat, utsagnet er ren typografi. Rolig nok til å tåle fem gjentakelser i
samme deck, som var grunnen til å velge den framfor en rød blokkvariant.
</commit_message>
<xml_diff>
--- a/pptx-templates/Startuplab-slidemaler.pptx
+++ b/pptx-templates/Startuplab-slidemaler.pptx
@@ -22,9 +22,10 @@
     <p:sldId id="270" r:id="rId16"/>
     <p:sldId id="271" r:id="rId17"/>
     <p:sldId id="272" r:id="rId18"/>
+    <p:sldId id="273" r:id="rId19"/>
   </p:sldIdLst>
   <p:notesMasterIdLst>
-    <p:notesMasterId r:id="rId19"/>
+    <p:notesMasterId r:id="rId20"/>
   </p:notesMasterIdLst>
   <p:sldSz cx="12192000" cy="6858000"/>
   <p:notesSz cx="6858000" cy="12192000"/>
@@ -606,7 +607,7 @@
           <a:p>
             <a:r>
               <a:rPr lang="en-US" dirty="0"/>
-              <a:t>TEKST OG BILDERUTENETT. Fire liggende bilder i 2x2 med forklaringen samlet på venstre side, i stedet for bildetekst under hvert bilde. Bytt bilde: høyreklikk &gt; Endre bilde, utsnittet beholdes. Vil du ha bildene til venstre og teksten til høyre: marker alle fire bildene og dra dem over, og flytt tekstblokken motsatt vei. Kjør prepare-media.py på nye bilder, så får de samme lysstyrke som de andre.</a:t>
+              <a:t>KAPITTELSKILLE. To ting å endre per kapittel: det store tallet til høyre, og hvilket tall i rekken som er rødt (marker det og sett rød FF3333, og sett det forrige tilbake til grå 9BA1A5). Kickeren står bare «Kapittel», så du slipper å endre den også. Vil du heller ha temaet for delen der, skriv det inn. Har du flere eller færre enn fem kapitler, legg til eller slett tall i rekken.</a:t>
             </a:r>
             <a:endParaRPr lang="en-US" dirty="0"/>
           </a:p>
@@ -694,7 +695,7 @@
           <a:p>
             <a:r>
               <a:rPr lang="en-US" dirty="0"/>
-              <a:t>UTSAGN. Én setning, maks tre linjer. Dette er sliden du lar henge i stillhet et par sekunder før du snakker videre.</a:t>
+              <a:t>TEKST OG BILDERUTENETT. Fire liggende bilder i 2x2 med forklaringen samlet på venstre side, i stedet for bildetekst under hvert bilde. Bytt bilde: høyreklikk &gt; Endre bilde, utsnittet beholdes. Vil du ha bildene til venstre og teksten til høyre: marker alle fire bildene og dra dem over, og flytt tekstblokken motsatt vei. Kjør prepare-media.py på nye bilder, så får de samme lysstyrke som de andre.</a:t>
             </a:r>
             <a:endParaRPr lang="en-US" dirty="0"/>
           </a:p>
@@ -782,7 +783,7 @@
           <a:p>
             <a:r>
               <a:rPr lang="en-US" dirty="0"/>
-              <a:t>SITAT. Hold sitatet under 25 ord, ellers slutter salen å lese før du er ferdig å snakke. Både sitatet og navnet er plassholdere: bytt dem før du presenterer. Sirkelen er rundt maskert, så et innsatt portrett beholder formen.</a:t>
+              <a:t>UTSAGN. Én setning, maks tre linjer. Dette er sliden du lar henge i stillhet et par sekunder før du snakker videre.</a:t>
             </a:r>
             <a:endParaRPr lang="en-US" dirty="0"/>
           </a:p>
@@ -870,7 +871,7 @@
           <a:p>
             <a:r>
               <a:rPr lang="en-US" dirty="0"/>
-              <a:t>BILDERAD. Bildeteksten ligger under bildet, ikke oppå det, nettopp for å være lesbar fra bakerste rad. Overskriften i hvitt er 20 pt, forklaringen 18 pt. Bytt bilde: høyreklikk &gt; Endre bilde, utsnittet beholdes. Vil du ha fire bilder i stedet for tre: marker et bilde med tekstene under, kopier settet, og sett bildebredden til 2,6 tommer på alle fire. Hold forklaringen til to linjer, ellers treffer den logoen. Kjør prepare-media.py på nye bilder, så legges de i samme lysstyrke som de andre.</a:t>
+              <a:t>SITAT. Hold sitatet under 25 ord, ellers slutter salen å lese før du er ferdig å snakke. Både sitatet og navnet er plassholdere: bytt dem før du presenterer. Sirkelen er rundt maskert, så et innsatt portrett beholder formen.</a:t>
             </a:r>
             <a:endParaRPr lang="en-US" dirty="0"/>
           </a:p>
@@ -958,7 +959,7 @@
           <a:p>
             <a:r>
               <a:rPr lang="en-US" dirty="0"/>
-              <a:t>PROSESS. Det røde tallet viser hvor i løpet du er. Flytt den røde fargen til neste steg hvis du gjenbruker sliden lenger ut i presentasjonen.</a:t>
+              <a:t>BILDERAD. Bildeteksten ligger under bildet, ikke oppå det, nettopp for å være lesbar fra bakerste rad. Overskriften i hvitt er 20 pt, forklaringen 18 pt. Bytt bilde: høyreklikk &gt; Endre bilde, utsnittet beholdes. Vil du ha fire bilder i stedet for tre: marker et bilde med tekstene under, kopier settet, og sett bildebredden til 2,6 tommer på alle fire. Hold forklaringen til to linjer, ellers treffer den logoen. Kjør prepare-media.py på nye bilder, så legges de i samme lysstyrke som de andre.</a:t>
             </a:r>
             <a:endParaRPr lang="en-US" dirty="0"/>
           </a:p>
@@ -1046,7 +1047,7 @@
           <a:p>
             <a:r>
               <a:rPr lang="en-US" dirty="0"/>
-              <a:t>FOLK. Fire portretter spenner fra marg til marg. Bytt portrett: høyreklikk &gt; Endre bilde, den runde masken følger med. Den grå sirkelen er en ledig plass. Sjekk at rollene stemmer før du presenterer.</a:t>
+              <a:t>PROSESS. Det røde tallet viser hvor i løpet du er. Flytt den røde fargen til neste steg hvis du gjenbruker sliden lenger ut i presentasjonen.</a:t>
             </a:r>
             <a:endParaRPr lang="en-US" dirty="0"/>
           </a:p>
@@ -1134,7 +1135,7 @@
           <a:p>
             <a:r>
               <a:rPr lang="en-US" dirty="0"/>
-              <a:t>FILM. Slik legger du inn filmen: Sett inn &gt; Video &gt; Denne enheten. Dra filmen så den dekker hele flaten, høyreklikk &gt; Send bakover slik at tittelen og avspillingsmerket blir liggende oppå. Under Avspilling velger du Start automatisk hvis den skal gå av seg selv. Slett den røde sirkelen og trekanten når den ekte filmen er på plass.</a:t>
+              <a:t>FOLK. Fire portretter spenner fra marg til marg. Bytt portrett: høyreklikk &gt; Endre bilde, den runde masken følger med. Den grå sirkelen er en ledig plass. Sjekk at rollene stemmer før du presenterer.</a:t>
             </a:r>
             <a:endParaRPr lang="en-US" dirty="0"/>
           </a:p>
@@ -1222,7 +1223,7 @@
           <a:p>
             <a:r>
               <a:rPr lang="en-US" dirty="0"/>
-              <a:t>AVSLUTNING. La den stå på skjermen mens du tar spørsmål. Legg til e-post eller kontaktperson på linjen under nettadressen hvis salen skal kunne følge opp.</a:t>
+              <a:t>FILM. Slik legger du inn filmen: Sett inn &gt; Video &gt; Denne enheten. Dra filmen så den dekker hele flaten, høyreklikk &gt; Send bakover slik at tittelen og avspillingsmerket blir liggende oppå. Under Avspilling velger du Start automatisk hvis den skal gå av seg selv. Slett den røde sirkelen og trekanten når den ekte filmen er på plass.</a:t>
             </a:r>
             <a:endParaRPr lang="en-US" dirty="0"/>
           </a:p>
@@ -1246,6 +1247,94 @@
             <a:fld id="{F7021451-1387-4CA6-816F-3879F97B5CBC}" type="slidenum">
               <a:rPr lang="en-US"/>
               <a:t>17</a:t>
+            </a:fld>
+            <a:endParaRPr lang="en-US"/>
+          </a:p>
+        </p:txBody>
+      </p:sp>
+    </p:spTree>
+    <p:extLst>
+      <p:ext uri="{BB962C8B-B14F-4D97-AF65-F5344CB8AC3E}">
+        <p14:creationId xmlns:p14="http://schemas.microsoft.com/office/powerpoint/2010/main" val="1024086991"/>
+      </p:ext>
+    </p:extLst>
+  </p:cSld>
+  <p:clrMapOvr>
+    <a:masterClrMapping/>
+  </p:clrMapOvr>
+</p:notes>
+</file>
+
+<file path=ppt/notesSlides/notesSlide18.xml><?xml version="1.0" encoding="utf-8"?>
+<p:notes xmlns:a="http://schemas.openxmlformats.org/drawingml/2006/main" xmlns:r="http://schemas.openxmlformats.org/officeDocument/2006/relationships" xmlns:p="http://schemas.openxmlformats.org/presentationml/2006/main">
+  <p:cSld>
+    <p:spTree>
+      <p:nvGrpSpPr>
+        <p:cNvPr id="1" name=""/>
+        <p:cNvGrpSpPr/>
+        <p:nvPr/>
+      </p:nvGrpSpPr>
+      <p:grpSpPr>
+        <a:xfrm>
+          <a:off x="0" y="0"/>
+          <a:ext cx="0" cy="0"/>
+          <a:chOff x="0" y="0"/>
+          <a:chExt cx="0" cy="0"/>
+        </a:xfrm>
+      </p:grpSpPr>
+      <p:sp>
+        <p:nvSpPr>
+          <p:cNvPr id="2" name="Slide Image Placeholder 1"/>
+          <p:cNvSpPr>
+            <a:spLocks noGrp="1" noRot="1" noChangeAspect="1"/>
+          </p:cNvSpPr>
+          <p:nvPr>
+            <p:ph type="sldImg"/>
+          </p:nvPr>
+        </p:nvSpPr>
+        <p:spPr/>
+      </p:sp>
+      <p:sp>
+        <p:nvSpPr>
+          <p:cNvPr id="3" name="Notes Placeholder 2"/>
+          <p:cNvSpPr>
+            <a:spLocks noGrp="1"/>
+          </p:cNvSpPr>
+          <p:nvPr>
+            <p:ph type="body" idx="1"/>
+          </p:nvPr>
+        </p:nvSpPr>
+        <p:spPr/>
+        <p:txBody>
+          <a:bodyPr/>
+          <a:lstStyle/>
+          <a:p>
+            <a:r>
+              <a:rPr lang="en-US" dirty="0"/>
+              <a:t>AVSLUTNING. La den stå på skjermen mens du tar spørsmål. Legg til e-post eller kontaktperson på linjen under nettadressen hvis salen skal kunne følge opp.</a:t>
+            </a:r>
+            <a:endParaRPr lang="en-US" dirty="0"/>
+          </a:p>
+        </p:txBody>
+      </p:sp>
+      <p:sp>
+        <p:nvSpPr>
+          <p:cNvPr id="4" name="Slide Number Placeholder 3"/>
+          <p:cNvSpPr>
+            <a:spLocks noGrp="1"/>
+          </p:cNvSpPr>
+          <p:nvPr>
+            <p:ph type="sldNum" sz="quarter" idx="10"/>
+          </p:nvPr>
+        </p:nvSpPr>
+        <p:spPr/>
+        <p:txBody>
+          <a:bodyPr/>
+          <a:lstStyle/>
+          <a:p>
+            <a:fld id="{F7021451-1387-4CA6-816F-3879F97B5CBC}" type="slidenum">
+              <a:rPr lang="en-US"/>
+              <a:t>18</a:t>
             </a:fld>
             <a:endParaRPr lang="en-US"/>
           </a:p>
@@ -2529,6 +2618,335 @@
     <p:bg>
       <p:bgPr>
         <a:solidFill>
+          <a:srgbClr val="131415"/>
+        </a:solidFill>
+      </p:bgPr>
+    </p:bg>
+    <p:spTree>
+      <p:nvGrpSpPr>
+        <p:cNvPr id="1" name=""/>
+        <p:cNvGrpSpPr/>
+        <p:nvPr/>
+      </p:nvGrpSpPr>
+      <p:grpSpPr>
+        <a:xfrm>
+          <a:off x="0" y="0"/>
+          <a:ext cx="0" cy="0"/>
+          <a:chOff x="0" y="0"/>
+          <a:chExt cx="0" cy="0"/>
+        </a:xfrm>
+      </p:grpSpPr>
+      <p:sp>
+        <p:nvSpPr>
+          <p:cNvPr id="2" name="Text 0"/>
+          <p:cNvSpPr/>
+          <p:nvPr/>
+        </p:nvSpPr>
+        <p:spPr>
+          <a:xfrm>
+            <a:off x="6309360" y="137160"/>
+            <a:ext cx="6766560" cy="5852160"/>
+          </a:xfrm>
+          <a:prstGeom prst="rect">
+            <a:avLst/>
+          </a:prstGeom>
+          <a:noFill/>
+          <a:ln/>
+        </p:spPr>
+        <p:txBody>
+          <a:bodyPr wrap="square" lIns="0" tIns="0" rIns="0" bIns="0" rtlCol="0" anchor="ctr"/>
+          <a:lstStyle/>
+          <a:p>
+            <a:pPr indent="0" marL="0">
+              <a:buNone/>
+            </a:pPr>
+            <a:r>
+              <a:rPr lang="en-US" sz="40000" dirty="0">
+                <a:ln w="19050">
+                  <a:solidFill>
+                    <a:srgbClr val="FFE5EA"/>
+                  </a:solidFill>
+                </a:ln>
+                <a:solidFill>
+                  <a:srgbClr val="24272A"/>
+                </a:solidFill>
+                <a:latin typeface="Replica LL TT Heavy" pitchFamily="34" charset="0"/>
+                <a:ea typeface="Replica LL TT Heavy" pitchFamily="34" charset="-122"/>
+                <a:cs typeface="Replica LL TT Heavy" pitchFamily="34" charset="-120"/>
+              </a:rPr>
+              <a:t>02</a:t>
+            </a:r>
+            <a:endParaRPr lang="en-US" sz="40000" dirty="0"/>
+          </a:p>
+        </p:txBody>
+      </p:sp>
+      <p:sp>
+        <p:nvSpPr>
+          <p:cNvPr id="3" name="Text 1"/>
+          <p:cNvSpPr/>
+          <p:nvPr/>
+        </p:nvSpPr>
+        <p:spPr>
+          <a:xfrm>
+            <a:off x="777240" y="2468880"/>
+            <a:ext cx="8229600" cy="292608"/>
+          </a:xfrm>
+          <a:prstGeom prst="rect">
+            <a:avLst/>
+          </a:prstGeom>
+          <a:noFill/>
+          <a:ln/>
+        </p:spPr>
+        <p:txBody>
+          <a:bodyPr wrap="square" lIns="0" tIns="0" rIns="0" bIns="0" rtlCol="0" anchor="ctr"/>
+          <a:lstStyle/>
+          <a:p>
+            <a:pPr indent="0" marL="0">
+              <a:buNone/>
+            </a:pPr>
+            <a:r>
+              <a:rPr lang="en-US" sz="1600" b="1" spc="250" kern="0" dirty="0">
+                <a:solidFill>
+                  <a:srgbClr val="FF3333"/>
+                </a:solidFill>
+                <a:latin typeface="Inter" pitchFamily="34" charset="0"/>
+                <a:ea typeface="Inter" pitchFamily="34" charset="-122"/>
+                <a:cs typeface="Inter" pitchFamily="34" charset="-120"/>
+              </a:rPr>
+              <a:t>KAPITTEL</a:t>
+            </a:r>
+            <a:endParaRPr lang="en-US" sz="1600" dirty="0"/>
+          </a:p>
+        </p:txBody>
+      </p:sp>
+      <p:sp>
+        <p:nvSpPr>
+          <p:cNvPr id="4" name="Text 2"/>
+          <p:cNvSpPr/>
+          <p:nvPr/>
+        </p:nvSpPr>
+        <p:spPr>
+          <a:xfrm>
+            <a:off x="777240" y="2834640"/>
+            <a:ext cx="6035040" cy="1097280"/>
+          </a:xfrm>
+          <a:prstGeom prst="rect">
+            <a:avLst/>
+          </a:prstGeom>
+          <a:noFill/>
+          <a:ln/>
+        </p:spPr>
+        <p:txBody>
+          <a:bodyPr wrap="square" lIns="0" tIns="0" rIns="0" bIns="0" rtlCol="0" anchor="t"/>
+          <a:lstStyle/>
+          <a:p>
+            <a:pPr indent="0" marL="0">
+              <a:buNone/>
+            </a:pPr>
+            <a:r>
+              <a:rPr lang="en-US" sz="6000" dirty="0">
+                <a:solidFill>
+                  <a:srgbClr val="FFFFFF"/>
+                </a:solidFill>
+                <a:latin typeface="Replica LL TT Heavy" pitchFamily="34" charset="0"/>
+                <a:ea typeface="Replica LL TT Heavy" pitchFamily="34" charset="-122"/>
+                <a:cs typeface="Replica LL TT Heavy" pitchFamily="34" charset="-120"/>
+              </a:rPr>
+              <a:t>Velkommen</a:t>
+            </a:r>
+            <a:endParaRPr lang="en-US" sz="6000" dirty="0"/>
+          </a:p>
+        </p:txBody>
+      </p:sp>
+      <p:sp>
+        <p:nvSpPr>
+          <p:cNvPr id="5" name="Text 3"/>
+          <p:cNvSpPr/>
+          <p:nvPr/>
+        </p:nvSpPr>
+        <p:spPr>
+          <a:xfrm>
+            <a:off x="777240" y="4251960"/>
+            <a:ext cx="6400800" cy="502920"/>
+          </a:xfrm>
+          <a:prstGeom prst="rect">
+            <a:avLst/>
+          </a:prstGeom>
+          <a:noFill/>
+          <a:ln/>
+        </p:spPr>
+        <p:txBody>
+          <a:bodyPr wrap="square" lIns="0" tIns="0" rIns="0" bIns="0" rtlCol="0" anchor="ctr"/>
+          <a:lstStyle/>
+          <a:p>
+            <a:pPr indent="0" marL="0">
+              <a:buNone/>
+            </a:pPr>
+            <a:r>
+              <a:rPr lang="en-US" sz="2600" dirty="0">
+                <a:solidFill>
+                  <a:srgbClr val="9BA1A5"/>
+                </a:solidFill>
+                <a:latin typeface="Replica LL TT Heavy" pitchFamily="34" charset="0"/>
+                <a:ea typeface="Replica LL TT Heavy" pitchFamily="34" charset="-122"/>
+                <a:cs typeface="Replica LL TT Heavy" pitchFamily="34" charset="-120"/>
+              </a:rPr>
+              <a:t>01</a:t>
+            </a:r>
+            <a:pPr indent="0" marL="0">
+              <a:buNone/>
+            </a:pPr>
+            <a:r>
+              <a:rPr lang="en-US" sz="2600" dirty="0">
+                <a:solidFill>
+                  <a:srgbClr val="000000"/>
+                </a:solidFill>
+                <a:latin typeface="Replica LL TT Heavy" pitchFamily="34" charset="0"/>
+                <a:ea typeface="Replica LL TT Heavy" pitchFamily="34" charset="-122"/>
+                <a:cs typeface="Replica LL TT Heavy" pitchFamily="34" charset="-120"/>
+              </a:rPr>
+              <a:t>   </a:t>
+            </a:r>
+            <a:pPr indent="0" marL="0">
+              <a:buNone/>
+            </a:pPr>
+            <a:r>
+              <a:rPr lang="en-US" sz="2600" dirty="0">
+                <a:solidFill>
+                  <a:srgbClr val="FF3333"/>
+                </a:solidFill>
+                <a:latin typeface="Replica LL TT Heavy" pitchFamily="34" charset="0"/>
+                <a:ea typeface="Replica LL TT Heavy" pitchFamily="34" charset="-122"/>
+                <a:cs typeface="Replica LL TT Heavy" pitchFamily="34" charset="-120"/>
+              </a:rPr>
+              <a:t>02</a:t>
+            </a:r>
+            <a:pPr indent="0" marL="0">
+              <a:buNone/>
+            </a:pPr>
+            <a:r>
+              <a:rPr lang="en-US" sz="2600" dirty="0">
+                <a:solidFill>
+                  <a:srgbClr val="000000"/>
+                </a:solidFill>
+                <a:latin typeface="Replica LL TT Heavy" pitchFamily="34" charset="0"/>
+                <a:ea typeface="Replica LL TT Heavy" pitchFamily="34" charset="-122"/>
+                <a:cs typeface="Replica LL TT Heavy" pitchFamily="34" charset="-120"/>
+              </a:rPr>
+              <a:t>   </a:t>
+            </a:r>
+            <a:pPr indent="0" marL="0">
+              <a:buNone/>
+            </a:pPr>
+            <a:r>
+              <a:rPr lang="en-US" sz="2600" dirty="0">
+                <a:solidFill>
+                  <a:srgbClr val="9BA1A5"/>
+                </a:solidFill>
+                <a:latin typeface="Replica LL TT Heavy" pitchFamily="34" charset="0"/>
+                <a:ea typeface="Replica LL TT Heavy" pitchFamily="34" charset="-122"/>
+                <a:cs typeface="Replica LL TT Heavy" pitchFamily="34" charset="-120"/>
+              </a:rPr>
+              <a:t>03</a:t>
+            </a:r>
+            <a:pPr indent="0" marL="0">
+              <a:buNone/>
+            </a:pPr>
+            <a:r>
+              <a:rPr lang="en-US" sz="2600" dirty="0">
+                <a:solidFill>
+                  <a:srgbClr val="000000"/>
+                </a:solidFill>
+                <a:latin typeface="Replica LL TT Heavy" pitchFamily="34" charset="0"/>
+                <a:ea typeface="Replica LL TT Heavy" pitchFamily="34" charset="-122"/>
+                <a:cs typeface="Replica LL TT Heavy" pitchFamily="34" charset="-120"/>
+              </a:rPr>
+              <a:t>   </a:t>
+            </a:r>
+            <a:pPr indent="0" marL="0">
+              <a:buNone/>
+            </a:pPr>
+            <a:r>
+              <a:rPr lang="en-US" sz="2600" dirty="0">
+                <a:solidFill>
+                  <a:srgbClr val="9BA1A5"/>
+                </a:solidFill>
+                <a:latin typeface="Replica LL TT Heavy" pitchFamily="34" charset="0"/>
+                <a:ea typeface="Replica LL TT Heavy" pitchFamily="34" charset="-122"/>
+                <a:cs typeface="Replica LL TT Heavy" pitchFamily="34" charset="-120"/>
+              </a:rPr>
+              <a:t>04</a:t>
+            </a:r>
+            <a:pPr indent="0" marL="0">
+              <a:buNone/>
+            </a:pPr>
+            <a:r>
+              <a:rPr lang="en-US" sz="2600" dirty="0">
+                <a:solidFill>
+                  <a:srgbClr val="000000"/>
+                </a:solidFill>
+                <a:latin typeface="Replica LL TT Heavy" pitchFamily="34" charset="0"/>
+                <a:ea typeface="Replica LL TT Heavy" pitchFamily="34" charset="-122"/>
+                <a:cs typeface="Replica LL TT Heavy" pitchFamily="34" charset="-120"/>
+              </a:rPr>
+              <a:t>   </a:t>
+            </a:r>
+            <a:pPr indent="0" marL="0">
+              <a:buNone/>
+            </a:pPr>
+            <a:r>
+              <a:rPr lang="en-US" sz="2600" dirty="0">
+                <a:solidFill>
+                  <a:srgbClr val="9BA1A5"/>
+                </a:solidFill>
+                <a:latin typeface="Replica LL TT Heavy" pitchFamily="34" charset="0"/>
+                <a:ea typeface="Replica LL TT Heavy" pitchFamily="34" charset="-122"/>
+                <a:cs typeface="Replica LL TT Heavy" pitchFamily="34" charset="-120"/>
+              </a:rPr>
+              <a:t>05</a:t>
+            </a:r>
+            <a:endParaRPr lang="en-US" sz="2600" dirty="0"/>
+          </a:p>
+        </p:txBody>
+      </p:sp>
+      <p:pic>
+        <p:nvPicPr>
+          <p:cNvPr id="6" name="Image 0" descr="C:\Code\Work\startuplab-partner-presentation\pptx-templates\media\logo-white.png">    </p:cNvPr>
+          <p:cNvPicPr>
+            <a:picLocks noChangeAspect="1"/>
+          </p:cNvPicPr>
+          <p:nvPr/>
+        </p:nvPicPr>
+        <p:blipFill>
+          <a:blip r:embed="rId1"/>
+          <a:stretch>
+            <a:fillRect/>
+          </a:stretch>
+        </p:blipFill>
+        <p:spPr>
+          <a:xfrm>
+            <a:off x="777240" y="6035040"/>
+            <a:ext cx="843006" cy="310896"/>
+          </a:xfrm>
+          <a:prstGeom prst="rect">
+            <a:avLst/>
+          </a:prstGeom>
+        </p:spPr>
+      </p:pic>
+    </p:spTree>
+  </p:cSld>
+  <p:clrMapOvr>
+    <a:masterClrMapping/>
+  </p:clrMapOvr>
+</p:sld>
+</file>
+
+<file path=ppt/slides/slide11.xml><?xml version="1.0" encoding="utf-8"?>
+<p:sld xmlns:a="http://schemas.openxmlformats.org/drawingml/2006/main" xmlns:r="http://schemas.openxmlformats.org/officeDocument/2006/relationships" xmlns:p="http://schemas.openxmlformats.org/presentationml/2006/main">
+  <p:cSld name="Slide 11">
+    <p:bg>
+      <p:bgPr>
+        <a:solidFill>
           <a:srgbClr val="FFFFFF"/>
         </a:solidFill>
       </p:bgPr>
@@ -2831,9 +3249,9 @@
 </p:sld>
 </file>
 
-<file path=ppt/slides/slide11.xml><?xml version="1.0" encoding="utf-8"?>
+<file path=ppt/slides/slide12.xml><?xml version="1.0" encoding="utf-8"?>
 <p:sld xmlns:a="http://schemas.openxmlformats.org/drawingml/2006/main" xmlns:r="http://schemas.openxmlformats.org/officeDocument/2006/relationships" xmlns:p="http://schemas.openxmlformats.org/presentationml/2006/main">
-  <p:cSld name="Slide 11">
+  <p:cSld name="Slide 12">
     <p:bg>
       <p:bgPr>
         <a:solidFill>
@@ -3042,9 +3460,9 @@
 </p:sld>
 </file>
 
-<file path=ppt/slides/slide12.xml><?xml version="1.0" encoding="utf-8"?>
+<file path=ppt/slides/slide13.xml><?xml version="1.0" encoding="utf-8"?>
 <p:sld xmlns:a="http://schemas.openxmlformats.org/drawingml/2006/main" xmlns:r="http://schemas.openxmlformats.org/officeDocument/2006/relationships" xmlns:p="http://schemas.openxmlformats.org/presentationml/2006/main">
-  <p:cSld name="Slide 12">
+  <p:cSld name="Slide 13">
     <p:bg>
       <p:bgPr>
         <a:solidFill>
@@ -3305,9 +3723,9 @@
 </p:sld>
 </file>
 
-<file path=ppt/slides/slide13.xml><?xml version="1.0" encoding="utf-8"?>
+<file path=ppt/slides/slide14.xml><?xml version="1.0" encoding="utf-8"?>
 <p:sld xmlns:a="http://schemas.openxmlformats.org/drawingml/2006/main" xmlns:r="http://schemas.openxmlformats.org/officeDocument/2006/relationships" xmlns:p="http://schemas.openxmlformats.org/presentationml/2006/main">
-  <p:cSld name="Slide 13">
+  <p:cSld name="Slide 14">
     <p:bg>
       <p:bgPr>
         <a:solidFill>
@@ -3749,623 +4167,6 @@
         </p:nvPicPr>
         <p:blipFill>
           <a:blip r:embed="rId4"/>
-          <a:stretch>
-            <a:fillRect/>
-          </a:stretch>
-        </p:blipFill>
-        <p:spPr>
-          <a:xfrm>
-            <a:off x="777240" y="6035040"/>
-            <a:ext cx="843006" cy="310896"/>
-          </a:xfrm>
-          <a:prstGeom prst="rect">
-            <a:avLst/>
-          </a:prstGeom>
-        </p:spPr>
-      </p:pic>
-    </p:spTree>
-  </p:cSld>
-  <p:clrMapOvr>
-    <a:masterClrMapping/>
-  </p:clrMapOvr>
-</p:sld>
-</file>
-
-<file path=ppt/slides/slide14.xml><?xml version="1.0" encoding="utf-8"?>
-<p:sld xmlns:a="http://schemas.openxmlformats.org/drawingml/2006/main" xmlns:r="http://schemas.openxmlformats.org/officeDocument/2006/relationships" xmlns:p="http://schemas.openxmlformats.org/presentationml/2006/main">
-  <p:cSld name="Slide 14">
-    <p:bg>
-      <p:bgPr>
-        <a:solidFill>
-          <a:srgbClr val="FFFFFF"/>
-        </a:solidFill>
-      </p:bgPr>
-    </p:bg>
-    <p:spTree>
-      <p:nvGrpSpPr>
-        <p:cNvPr id="1" name=""/>
-        <p:cNvGrpSpPr/>
-        <p:nvPr/>
-      </p:nvGrpSpPr>
-      <p:grpSpPr>
-        <a:xfrm>
-          <a:off x="0" y="0"/>
-          <a:ext cx="0" cy="0"/>
-          <a:chOff x="0" y="0"/>
-          <a:chExt cx="0" cy="0"/>
-        </a:xfrm>
-      </p:grpSpPr>
-      <p:sp>
-        <p:nvSpPr>
-          <p:cNvPr id="2" name="Text 0"/>
-          <p:cNvSpPr/>
-          <p:nvPr/>
-        </p:nvSpPr>
-        <p:spPr>
-          <a:xfrm>
-            <a:off x="777240" y="713232"/>
-            <a:ext cx="8229600" cy="292608"/>
-          </a:xfrm>
-          <a:prstGeom prst="rect">
-            <a:avLst/>
-          </a:prstGeom>
-          <a:noFill/>
-          <a:ln/>
-        </p:spPr>
-        <p:txBody>
-          <a:bodyPr wrap="square" lIns="0" tIns="0" rIns="0" bIns="0" rtlCol="0" anchor="ctr"/>
-          <a:lstStyle/>
-          <a:p>
-            <a:pPr indent="0" marL="0">
-              <a:buNone/>
-            </a:pPr>
-            <a:r>
-              <a:rPr lang="en-US" sz="1600" b="1" spc="250" kern="0" dirty="0">
-                <a:solidFill>
-                  <a:srgbClr val="FF3333"/>
-                </a:solidFill>
-                <a:latin typeface="Inter" pitchFamily="34" charset="0"/>
-                <a:ea typeface="Inter" pitchFamily="34" charset="-122"/>
-                <a:cs typeface="Inter" pitchFamily="34" charset="-120"/>
-              </a:rPr>
-              <a:t>SLIK GÅR VI FREM</a:t>
-            </a:r>
-            <a:endParaRPr lang="en-US" sz="1600" dirty="0"/>
-          </a:p>
-        </p:txBody>
-      </p:sp>
-      <p:sp>
-        <p:nvSpPr>
-          <p:cNvPr id="3" name="Text 1"/>
-          <p:cNvSpPr/>
-          <p:nvPr/>
-        </p:nvSpPr>
-        <p:spPr>
-          <a:xfrm>
-            <a:off x="777240" y="1051560"/>
-            <a:ext cx="10424160" cy="777240"/>
-          </a:xfrm>
-          <a:prstGeom prst="rect">
-            <a:avLst/>
-          </a:prstGeom>
-          <a:noFill/>
-          <a:ln/>
-        </p:spPr>
-        <p:txBody>
-          <a:bodyPr wrap="square" lIns="0" tIns="0" rIns="0" bIns="0" rtlCol="0" anchor="t"/>
-          <a:lstStyle/>
-          <a:p>
-            <a:pPr indent="0" marL="0">
-              <a:lnSpc>
-                <a:spcPct val="100000"/>
-              </a:lnSpc>
-              <a:buNone/>
-            </a:pPr>
-            <a:r>
-              <a:rPr lang="en-US" sz="4000" b="1" dirty="0">
-                <a:solidFill>
-                  <a:srgbClr val="131415"/>
-                </a:solidFill>
-                <a:latin typeface="Replica LL TT" pitchFamily="34" charset="0"/>
-                <a:ea typeface="Replica LL TT" pitchFamily="34" charset="-122"/>
-                <a:cs typeface="Replica LL TT" pitchFamily="34" charset="-120"/>
-              </a:rPr>
-              <a:t>Fire steg fra idé til pilot</a:t>
-            </a:r>
-            <a:endParaRPr lang="en-US" sz="4000" dirty="0"/>
-          </a:p>
-        </p:txBody>
-      </p:sp>
-      <p:sp>
-        <p:nvSpPr>
-          <p:cNvPr id="4" name="Text 2"/>
-          <p:cNvSpPr/>
-          <p:nvPr/>
-        </p:nvSpPr>
-        <p:spPr>
-          <a:xfrm>
-            <a:off x="777240" y="2423160"/>
-            <a:ext cx="2247824" cy="914400"/>
-          </a:xfrm>
-          <a:prstGeom prst="rect">
-            <a:avLst/>
-          </a:prstGeom>
-          <a:noFill/>
-          <a:ln/>
-        </p:spPr>
-        <p:txBody>
-          <a:bodyPr wrap="square" lIns="0" tIns="0" rIns="0" bIns="0" rtlCol="0" anchor="t"/>
-          <a:lstStyle/>
-          <a:p>
-            <a:pPr indent="0" marL="0">
-              <a:buNone/>
-            </a:pPr>
-            <a:r>
-              <a:rPr lang="en-US" sz="5600" dirty="0">
-                <a:solidFill>
-                  <a:srgbClr val="FF3333"/>
-                </a:solidFill>
-                <a:latin typeface="Replica LL TT Heavy" pitchFamily="34" charset="0"/>
-                <a:ea typeface="Replica LL TT Heavy" pitchFamily="34" charset="-122"/>
-                <a:cs typeface="Replica LL TT Heavy" pitchFamily="34" charset="-120"/>
-              </a:rPr>
-              <a:t>01</a:t>
-            </a:r>
-            <a:endParaRPr lang="en-US" sz="5600" dirty="0"/>
-          </a:p>
-        </p:txBody>
-      </p:sp>
-      <p:sp>
-        <p:nvSpPr>
-          <p:cNvPr id="5" name="Text 3"/>
-          <p:cNvSpPr/>
-          <p:nvPr/>
-        </p:nvSpPr>
-        <p:spPr>
-          <a:xfrm>
-            <a:off x="777240" y="3355848"/>
-            <a:ext cx="2247824" cy="457200"/>
-          </a:xfrm>
-          <a:prstGeom prst="rect">
-            <a:avLst/>
-          </a:prstGeom>
-          <a:noFill/>
-          <a:ln/>
-        </p:spPr>
-        <p:txBody>
-          <a:bodyPr wrap="square" lIns="0" tIns="0" rIns="0" bIns="0" rtlCol="0" anchor="ctr"/>
-          <a:lstStyle/>
-          <a:p>
-            <a:pPr indent="0" marL="0">
-              <a:buNone/>
-            </a:pPr>
-            <a:r>
-              <a:rPr lang="en-US" sz="2500" b="1" dirty="0">
-                <a:solidFill>
-                  <a:srgbClr val="131415"/>
-                </a:solidFill>
-                <a:latin typeface="Replica LL TT" pitchFamily="34" charset="0"/>
-                <a:ea typeface="Replica LL TT" pitchFamily="34" charset="-122"/>
-                <a:cs typeface="Replica LL TT" pitchFamily="34" charset="-120"/>
-              </a:rPr>
-              <a:t>Kartlegg</a:t>
-            </a:r>
-            <a:endParaRPr lang="en-US" sz="2500" dirty="0"/>
-          </a:p>
-        </p:txBody>
-      </p:sp>
-      <p:sp>
-        <p:nvSpPr>
-          <p:cNvPr id="6" name="Text 4"/>
-          <p:cNvSpPr/>
-          <p:nvPr/>
-        </p:nvSpPr>
-        <p:spPr>
-          <a:xfrm>
-            <a:off x="777240" y="3840480"/>
-            <a:ext cx="2247824" cy="1005840"/>
-          </a:xfrm>
-          <a:prstGeom prst="rect">
-            <a:avLst/>
-          </a:prstGeom>
-          <a:noFill/>
-          <a:ln/>
-        </p:spPr>
-        <p:txBody>
-          <a:bodyPr wrap="square" lIns="0" tIns="0" rIns="0" bIns="0" rtlCol="0" anchor="t"/>
-          <a:lstStyle/>
-          <a:p>
-            <a:pPr indent="0" marL="0">
-              <a:lnSpc>
-                <a:spcPct val="130000"/>
-              </a:lnSpc>
-              <a:buNone/>
-            </a:pPr>
-            <a:r>
-              <a:rPr lang="en-US" sz="1800" dirty="0">
-                <a:solidFill>
-                  <a:srgbClr val="5A6166"/>
-                </a:solidFill>
-                <a:latin typeface="Inter" pitchFamily="34" charset="0"/>
-                <a:ea typeface="Inter" pitchFamily="34" charset="-122"/>
-                <a:cs typeface="Inter" pitchFamily="34" charset="-120"/>
-              </a:rPr>
-              <a:t>Vi finner utfordringen som er verdt å løse.</a:t>
-            </a:r>
-            <a:endParaRPr lang="en-US" sz="1800" dirty="0"/>
-          </a:p>
-        </p:txBody>
-      </p:sp>
-      <p:sp>
-        <p:nvSpPr>
-          <p:cNvPr id="7" name="Text 5"/>
-          <p:cNvSpPr/>
-          <p:nvPr/>
-        </p:nvSpPr>
-        <p:spPr>
-          <a:xfrm>
-            <a:off x="3573704" y="2423160"/>
-            <a:ext cx="2247824" cy="914400"/>
-          </a:xfrm>
-          <a:prstGeom prst="rect">
-            <a:avLst/>
-          </a:prstGeom>
-          <a:noFill/>
-          <a:ln/>
-        </p:spPr>
-        <p:txBody>
-          <a:bodyPr wrap="square" lIns="0" tIns="0" rIns="0" bIns="0" rtlCol="0" anchor="t"/>
-          <a:lstStyle/>
-          <a:p>
-            <a:pPr indent="0" marL="0">
-              <a:buNone/>
-            </a:pPr>
-            <a:r>
-              <a:rPr lang="en-US" sz="5600" dirty="0">
-                <a:solidFill>
-                  <a:srgbClr val="5A6166"/>
-                </a:solidFill>
-                <a:latin typeface="Replica LL TT Heavy" pitchFamily="34" charset="0"/>
-                <a:ea typeface="Replica LL TT Heavy" pitchFamily="34" charset="-122"/>
-                <a:cs typeface="Replica LL TT Heavy" pitchFamily="34" charset="-120"/>
-              </a:rPr>
-              <a:t>02</a:t>
-            </a:r>
-            <a:endParaRPr lang="en-US" sz="5600" dirty="0"/>
-          </a:p>
-        </p:txBody>
-      </p:sp>
-      <p:sp>
-        <p:nvSpPr>
-          <p:cNvPr id="8" name="Text 6"/>
-          <p:cNvSpPr/>
-          <p:nvPr/>
-        </p:nvSpPr>
-        <p:spPr>
-          <a:xfrm>
-            <a:off x="3573704" y="3355848"/>
-            <a:ext cx="2247824" cy="457200"/>
-          </a:xfrm>
-          <a:prstGeom prst="rect">
-            <a:avLst/>
-          </a:prstGeom>
-          <a:noFill/>
-          <a:ln/>
-        </p:spPr>
-        <p:txBody>
-          <a:bodyPr wrap="square" lIns="0" tIns="0" rIns="0" bIns="0" rtlCol="0" anchor="ctr"/>
-          <a:lstStyle/>
-          <a:p>
-            <a:pPr indent="0" marL="0">
-              <a:buNone/>
-            </a:pPr>
-            <a:r>
-              <a:rPr lang="en-US" sz="2500" b="1" dirty="0">
-                <a:solidFill>
-                  <a:srgbClr val="131415"/>
-                </a:solidFill>
-                <a:latin typeface="Replica LL TT" pitchFamily="34" charset="0"/>
-                <a:ea typeface="Replica LL TT" pitchFamily="34" charset="-122"/>
-                <a:cs typeface="Replica LL TT" pitchFamily="34" charset="-120"/>
-              </a:rPr>
-              <a:t>Match</a:t>
-            </a:r>
-            <a:endParaRPr lang="en-US" sz="2500" dirty="0"/>
-          </a:p>
-        </p:txBody>
-      </p:sp>
-      <p:sp>
-        <p:nvSpPr>
-          <p:cNvPr id="9" name="Text 7"/>
-          <p:cNvSpPr/>
-          <p:nvPr/>
-        </p:nvSpPr>
-        <p:spPr>
-          <a:xfrm>
-            <a:off x="3573704" y="3840480"/>
-            <a:ext cx="2247824" cy="1005840"/>
-          </a:xfrm>
-          <a:prstGeom prst="rect">
-            <a:avLst/>
-          </a:prstGeom>
-          <a:noFill/>
-          <a:ln/>
-        </p:spPr>
-        <p:txBody>
-          <a:bodyPr wrap="square" lIns="0" tIns="0" rIns="0" bIns="0" rtlCol="0" anchor="t"/>
-          <a:lstStyle/>
-          <a:p>
-            <a:pPr indent="0" marL="0">
-              <a:lnSpc>
-                <a:spcPct val="130000"/>
-              </a:lnSpc>
-              <a:buNone/>
-            </a:pPr>
-            <a:r>
-              <a:rPr lang="en-US" sz="1800" dirty="0">
-                <a:solidFill>
-                  <a:srgbClr val="5A6166"/>
-                </a:solidFill>
-                <a:latin typeface="Inter" pitchFamily="34" charset="0"/>
-                <a:ea typeface="Inter" pitchFamily="34" charset="-122"/>
-                <a:cs typeface="Inter" pitchFamily="34" charset="-120"/>
-              </a:rPr>
-              <a:t>Vi henter inn selskapene som treffer den.</a:t>
-            </a:r>
-            <a:endParaRPr lang="en-US" sz="1800" dirty="0"/>
-          </a:p>
-        </p:txBody>
-      </p:sp>
-      <p:sp>
-        <p:nvSpPr>
-          <p:cNvPr id="10" name="Text 8"/>
-          <p:cNvSpPr/>
-          <p:nvPr/>
-        </p:nvSpPr>
-        <p:spPr>
-          <a:xfrm>
-            <a:off x="6370168" y="2423160"/>
-            <a:ext cx="2247824" cy="914400"/>
-          </a:xfrm>
-          <a:prstGeom prst="rect">
-            <a:avLst/>
-          </a:prstGeom>
-          <a:noFill/>
-          <a:ln/>
-        </p:spPr>
-        <p:txBody>
-          <a:bodyPr wrap="square" lIns="0" tIns="0" rIns="0" bIns="0" rtlCol="0" anchor="t"/>
-          <a:lstStyle/>
-          <a:p>
-            <a:pPr indent="0" marL="0">
-              <a:buNone/>
-            </a:pPr>
-            <a:r>
-              <a:rPr lang="en-US" sz="5600" dirty="0">
-                <a:solidFill>
-                  <a:srgbClr val="5A6166"/>
-                </a:solidFill>
-                <a:latin typeface="Replica LL TT Heavy" pitchFamily="34" charset="0"/>
-                <a:ea typeface="Replica LL TT Heavy" pitchFamily="34" charset="-122"/>
-                <a:cs typeface="Replica LL TT Heavy" pitchFamily="34" charset="-120"/>
-              </a:rPr>
-              <a:t>03</a:t>
-            </a:r>
-            <a:endParaRPr lang="en-US" sz="5600" dirty="0"/>
-          </a:p>
-        </p:txBody>
-      </p:sp>
-      <p:sp>
-        <p:nvSpPr>
-          <p:cNvPr id="11" name="Text 9"/>
-          <p:cNvSpPr/>
-          <p:nvPr/>
-        </p:nvSpPr>
-        <p:spPr>
-          <a:xfrm>
-            <a:off x="6370168" y="3355848"/>
-            <a:ext cx="2247824" cy="457200"/>
-          </a:xfrm>
-          <a:prstGeom prst="rect">
-            <a:avLst/>
-          </a:prstGeom>
-          <a:noFill/>
-          <a:ln/>
-        </p:spPr>
-        <p:txBody>
-          <a:bodyPr wrap="square" lIns="0" tIns="0" rIns="0" bIns="0" rtlCol="0" anchor="ctr"/>
-          <a:lstStyle/>
-          <a:p>
-            <a:pPr indent="0" marL="0">
-              <a:buNone/>
-            </a:pPr>
-            <a:r>
-              <a:rPr lang="en-US" sz="2500" b="1" dirty="0">
-                <a:solidFill>
-                  <a:srgbClr val="131415"/>
-                </a:solidFill>
-                <a:latin typeface="Replica LL TT" pitchFamily="34" charset="0"/>
-                <a:ea typeface="Replica LL TT" pitchFamily="34" charset="-122"/>
-                <a:cs typeface="Replica LL TT" pitchFamily="34" charset="-120"/>
-              </a:rPr>
-              <a:t>Pilot</a:t>
-            </a:r>
-            <a:endParaRPr lang="en-US" sz="2500" dirty="0"/>
-          </a:p>
-        </p:txBody>
-      </p:sp>
-      <p:sp>
-        <p:nvSpPr>
-          <p:cNvPr id="12" name="Text 10"/>
-          <p:cNvSpPr/>
-          <p:nvPr/>
-        </p:nvSpPr>
-        <p:spPr>
-          <a:xfrm>
-            <a:off x="6370168" y="3840480"/>
-            <a:ext cx="2247824" cy="1005840"/>
-          </a:xfrm>
-          <a:prstGeom prst="rect">
-            <a:avLst/>
-          </a:prstGeom>
-          <a:noFill/>
-          <a:ln/>
-        </p:spPr>
-        <p:txBody>
-          <a:bodyPr wrap="square" lIns="0" tIns="0" rIns="0" bIns="0" rtlCol="0" anchor="t"/>
-          <a:lstStyle/>
-          <a:p>
-            <a:pPr indent="0" marL="0">
-              <a:lnSpc>
-                <a:spcPct val="130000"/>
-              </a:lnSpc>
-              <a:buNone/>
-            </a:pPr>
-            <a:r>
-              <a:rPr lang="en-US" sz="1800" dirty="0">
-                <a:solidFill>
-                  <a:srgbClr val="5A6166"/>
-                </a:solidFill>
-                <a:latin typeface="Inter" pitchFamily="34" charset="0"/>
-                <a:ea typeface="Inter" pitchFamily="34" charset="-122"/>
-                <a:cs typeface="Inter" pitchFamily="34" charset="-120"/>
-              </a:rPr>
-              <a:t>Vi rigger et forsøk med tydelige kriterier.</a:t>
-            </a:r>
-            <a:endParaRPr lang="en-US" sz="1800" dirty="0"/>
-          </a:p>
-        </p:txBody>
-      </p:sp>
-      <p:sp>
-        <p:nvSpPr>
-          <p:cNvPr id="13" name="Text 11"/>
-          <p:cNvSpPr/>
-          <p:nvPr/>
-        </p:nvSpPr>
-        <p:spPr>
-          <a:xfrm>
-            <a:off x="9166631" y="2423160"/>
-            <a:ext cx="2247824" cy="914400"/>
-          </a:xfrm>
-          <a:prstGeom prst="rect">
-            <a:avLst/>
-          </a:prstGeom>
-          <a:noFill/>
-          <a:ln/>
-        </p:spPr>
-        <p:txBody>
-          <a:bodyPr wrap="square" lIns="0" tIns="0" rIns="0" bIns="0" rtlCol="0" anchor="t"/>
-          <a:lstStyle/>
-          <a:p>
-            <a:pPr indent="0" marL="0">
-              <a:buNone/>
-            </a:pPr>
-            <a:r>
-              <a:rPr lang="en-US" sz="5600" dirty="0">
-                <a:solidFill>
-                  <a:srgbClr val="5A6166"/>
-                </a:solidFill>
-                <a:latin typeface="Replica LL TT Heavy" pitchFamily="34" charset="0"/>
-                <a:ea typeface="Replica LL TT Heavy" pitchFamily="34" charset="-122"/>
-                <a:cs typeface="Replica LL TT Heavy" pitchFamily="34" charset="-120"/>
-              </a:rPr>
-              <a:t>04</a:t>
-            </a:r>
-            <a:endParaRPr lang="en-US" sz="5600" dirty="0"/>
-          </a:p>
-        </p:txBody>
-      </p:sp>
-      <p:sp>
-        <p:nvSpPr>
-          <p:cNvPr id="14" name="Text 12"/>
-          <p:cNvSpPr/>
-          <p:nvPr/>
-        </p:nvSpPr>
-        <p:spPr>
-          <a:xfrm>
-            <a:off x="9166631" y="3355848"/>
-            <a:ext cx="2247824" cy="457200"/>
-          </a:xfrm>
-          <a:prstGeom prst="rect">
-            <a:avLst/>
-          </a:prstGeom>
-          <a:noFill/>
-          <a:ln/>
-        </p:spPr>
-        <p:txBody>
-          <a:bodyPr wrap="square" lIns="0" tIns="0" rIns="0" bIns="0" rtlCol="0" anchor="ctr"/>
-          <a:lstStyle/>
-          <a:p>
-            <a:pPr indent="0" marL="0">
-              <a:buNone/>
-            </a:pPr>
-            <a:r>
-              <a:rPr lang="en-US" sz="2500" b="1" dirty="0">
-                <a:solidFill>
-                  <a:srgbClr val="131415"/>
-                </a:solidFill>
-                <a:latin typeface="Replica LL TT" pitchFamily="34" charset="0"/>
-                <a:ea typeface="Replica LL TT" pitchFamily="34" charset="-122"/>
-                <a:cs typeface="Replica LL TT" pitchFamily="34" charset="-120"/>
-              </a:rPr>
-              <a:t>Skaler</a:t>
-            </a:r>
-            <a:endParaRPr lang="en-US" sz="2500" dirty="0"/>
-          </a:p>
-        </p:txBody>
-      </p:sp>
-      <p:sp>
-        <p:nvSpPr>
-          <p:cNvPr id="15" name="Text 13"/>
-          <p:cNvSpPr/>
-          <p:nvPr/>
-        </p:nvSpPr>
-        <p:spPr>
-          <a:xfrm>
-            <a:off x="9166631" y="3840480"/>
-            <a:ext cx="2247824" cy="1005840"/>
-          </a:xfrm>
-          <a:prstGeom prst="rect">
-            <a:avLst/>
-          </a:prstGeom>
-          <a:noFill/>
-          <a:ln/>
-        </p:spPr>
-        <p:txBody>
-          <a:bodyPr wrap="square" lIns="0" tIns="0" rIns="0" bIns="0" rtlCol="0" anchor="t"/>
-          <a:lstStyle/>
-          <a:p>
-            <a:pPr indent="0" marL="0">
-              <a:lnSpc>
-                <a:spcPct val="130000"/>
-              </a:lnSpc>
-              <a:buNone/>
-            </a:pPr>
-            <a:r>
-              <a:rPr lang="en-US" sz="1800" dirty="0">
-                <a:solidFill>
-                  <a:srgbClr val="5A6166"/>
-                </a:solidFill>
-                <a:latin typeface="Inter" pitchFamily="34" charset="0"/>
-                <a:ea typeface="Inter" pitchFamily="34" charset="-122"/>
-                <a:cs typeface="Inter" pitchFamily="34" charset="-120"/>
-              </a:rPr>
-              <a:t>Det som virker, settes i drift.</a:t>
-            </a:r>
-            <a:endParaRPr lang="en-US" sz="1800" dirty="0"/>
-          </a:p>
-        </p:txBody>
-      </p:sp>
-      <p:pic>
-        <p:nvPicPr>
-          <p:cNvPr id="16" name="Image 0" descr="C:\Code\Work\startuplab-partner-presentation\pptx-templates\media\logo-red.png">    </p:cNvPr>
-          <p:cNvPicPr>
-            <a:picLocks noChangeAspect="1"/>
-          </p:cNvPicPr>
-          <p:nvPr/>
-        </p:nvPicPr>
-        <p:blipFill>
-          <a:blip r:embed="rId1"/>
           <a:stretch>
             <a:fillRect/>
           </a:stretch>
@@ -4445,7 +4246,7 @@
                 <a:ea typeface="Inter" pitchFamily="34" charset="-122"/>
                 <a:cs typeface="Inter" pitchFamily="34" charset="-120"/>
               </a:rPr>
-              <a:t>TEAMET</a:t>
+              <a:t>SLIK GÅR VI FREM</a:t>
             </a:r>
             <a:endParaRPr lang="en-US" sz="1600" dirty="0"/>
           </a:p>
@@ -4487,32 +4288,495 @@
                 <a:ea typeface="Replica LL TT" pitchFamily="34" charset="-122"/>
                 <a:cs typeface="Replica LL TT" pitchFamily="34" charset="-120"/>
               </a:rPr>
-              <a:t>Folkene du kommer til å </a:t>
-            </a:r>
-            <a:pPr indent="0" marL="0">
-              <a:lnSpc>
-                <a:spcPct val="100000"/>
-              </a:lnSpc>
-              <a:buNone/>
-            </a:pPr>
-            <a:r>
-              <a:rPr lang="en-US" sz="4000" b="1" dirty="0">
+              <a:t>Fire steg fra idé til pilot</a:t>
+            </a:r>
+            <a:endParaRPr lang="en-US" sz="4000" dirty="0"/>
+          </a:p>
+        </p:txBody>
+      </p:sp>
+      <p:sp>
+        <p:nvSpPr>
+          <p:cNvPr id="4" name="Text 2"/>
+          <p:cNvSpPr/>
+          <p:nvPr/>
+        </p:nvSpPr>
+        <p:spPr>
+          <a:xfrm>
+            <a:off x="777240" y="2423160"/>
+            <a:ext cx="2247824" cy="914400"/>
+          </a:xfrm>
+          <a:prstGeom prst="rect">
+            <a:avLst/>
+          </a:prstGeom>
+          <a:noFill/>
+          <a:ln/>
+        </p:spPr>
+        <p:txBody>
+          <a:bodyPr wrap="square" lIns="0" tIns="0" rIns="0" bIns="0" rtlCol="0" anchor="t"/>
+          <a:lstStyle/>
+          <a:p>
+            <a:pPr indent="0" marL="0">
+              <a:buNone/>
+            </a:pPr>
+            <a:r>
+              <a:rPr lang="en-US" sz="5600" dirty="0">
                 <a:solidFill>
                   <a:srgbClr val="FF3333"/>
+                </a:solidFill>
+                <a:latin typeface="Replica LL TT Heavy" pitchFamily="34" charset="0"/>
+                <a:ea typeface="Replica LL TT Heavy" pitchFamily="34" charset="-122"/>
+                <a:cs typeface="Replica LL TT Heavy" pitchFamily="34" charset="-120"/>
+              </a:rPr>
+              <a:t>01</a:t>
+            </a:r>
+            <a:endParaRPr lang="en-US" sz="5600" dirty="0"/>
+          </a:p>
+        </p:txBody>
+      </p:sp>
+      <p:sp>
+        <p:nvSpPr>
+          <p:cNvPr id="5" name="Text 3"/>
+          <p:cNvSpPr/>
+          <p:nvPr/>
+        </p:nvSpPr>
+        <p:spPr>
+          <a:xfrm>
+            <a:off x="777240" y="3355848"/>
+            <a:ext cx="2247824" cy="457200"/>
+          </a:xfrm>
+          <a:prstGeom prst="rect">
+            <a:avLst/>
+          </a:prstGeom>
+          <a:noFill/>
+          <a:ln/>
+        </p:spPr>
+        <p:txBody>
+          <a:bodyPr wrap="square" lIns="0" tIns="0" rIns="0" bIns="0" rtlCol="0" anchor="ctr"/>
+          <a:lstStyle/>
+          <a:p>
+            <a:pPr indent="0" marL="0">
+              <a:buNone/>
+            </a:pPr>
+            <a:r>
+              <a:rPr lang="en-US" sz="2500" b="1" dirty="0">
+                <a:solidFill>
+                  <a:srgbClr val="131415"/>
                 </a:solidFill>
                 <a:latin typeface="Replica LL TT" pitchFamily="34" charset="0"/>
                 <a:ea typeface="Replica LL TT" pitchFamily="34" charset="-122"/>
                 <a:cs typeface="Replica LL TT" pitchFamily="34" charset="-120"/>
               </a:rPr>
-              <a:t>jobbe med</a:t>
-            </a:r>
-            <a:endParaRPr lang="en-US" sz="4000" dirty="0"/>
+              <a:t>Kartlegg</a:t>
+            </a:r>
+            <a:endParaRPr lang="en-US" sz="2500" dirty="0"/>
+          </a:p>
+        </p:txBody>
+      </p:sp>
+      <p:sp>
+        <p:nvSpPr>
+          <p:cNvPr id="6" name="Text 4"/>
+          <p:cNvSpPr/>
+          <p:nvPr/>
+        </p:nvSpPr>
+        <p:spPr>
+          <a:xfrm>
+            <a:off x="777240" y="3840480"/>
+            <a:ext cx="2247824" cy="1005840"/>
+          </a:xfrm>
+          <a:prstGeom prst="rect">
+            <a:avLst/>
+          </a:prstGeom>
+          <a:noFill/>
+          <a:ln/>
+        </p:spPr>
+        <p:txBody>
+          <a:bodyPr wrap="square" lIns="0" tIns="0" rIns="0" bIns="0" rtlCol="0" anchor="t"/>
+          <a:lstStyle/>
+          <a:p>
+            <a:pPr indent="0" marL="0">
+              <a:lnSpc>
+                <a:spcPct val="130000"/>
+              </a:lnSpc>
+              <a:buNone/>
+            </a:pPr>
+            <a:r>
+              <a:rPr lang="en-US" sz="1800" dirty="0">
+                <a:solidFill>
+                  <a:srgbClr val="5A6166"/>
+                </a:solidFill>
+                <a:latin typeface="Inter" pitchFamily="34" charset="0"/>
+                <a:ea typeface="Inter" pitchFamily="34" charset="-122"/>
+                <a:cs typeface="Inter" pitchFamily="34" charset="-120"/>
+              </a:rPr>
+              <a:t>Vi finner utfordringen som er verdt å løse.</a:t>
+            </a:r>
+            <a:endParaRPr lang="en-US" sz="1800" dirty="0"/>
+          </a:p>
+        </p:txBody>
+      </p:sp>
+      <p:sp>
+        <p:nvSpPr>
+          <p:cNvPr id="7" name="Text 5"/>
+          <p:cNvSpPr/>
+          <p:nvPr/>
+        </p:nvSpPr>
+        <p:spPr>
+          <a:xfrm>
+            <a:off x="3573704" y="2423160"/>
+            <a:ext cx="2247824" cy="914400"/>
+          </a:xfrm>
+          <a:prstGeom prst="rect">
+            <a:avLst/>
+          </a:prstGeom>
+          <a:noFill/>
+          <a:ln/>
+        </p:spPr>
+        <p:txBody>
+          <a:bodyPr wrap="square" lIns="0" tIns="0" rIns="0" bIns="0" rtlCol="0" anchor="t"/>
+          <a:lstStyle/>
+          <a:p>
+            <a:pPr indent="0" marL="0">
+              <a:buNone/>
+            </a:pPr>
+            <a:r>
+              <a:rPr lang="en-US" sz="5600" dirty="0">
+                <a:solidFill>
+                  <a:srgbClr val="5A6166"/>
+                </a:solidFill>
+                <a:latin typeface="Replica LL TT Heavy" pitchFamily="34" charset="0"/>
+                <a:ea typeface="Replica LL TT Heavy" pitchFamily="34" charset="-122"/>
+                <a:cs typeface="Replica LL TT Heavy" pitchFamily="34" charset="-120"/>
+              </a:rPr>
+              <a:t>02</a:t>
+            </a:r>
+            <a:endParaRPr lang="en-US" sz="5600" dirty="0"/>
+          </a:p>
+        </p:txBody>
+      </p:sp>
+      <p:sp>
+        <p:nvSpPr>
+          <p:cNvPr id="8" name="Text 6"/>
+          <p:cNvSpPr/>
+          <p:nvPr/>
+        </p:nvSpPr>
+        <p:spPr>
+          <a:xfrm>
+            <a:off x="3573704" y="3355848"/>
+            <a:ext cx="2247824" cy="457200"/>
+          </a:xfrm>
+          <a:prstGeom prst="rect">
+            <a:avLst/>
+          </a:prstGeom>
+          <a:noFill/>
+          <a:ln/>
+        </p:spPr>
+        <p:txBody>
+          <a:bodyPr wrap="square" lIns="0" tIns="0" rIns="0" bIns="0" rtlCol="0" anchor="ctr"/>
+          <a:lstStyle/>
+          <a:p>
+            <a:pPr indent="0" marL="0">
+              <a:buNone/>
+            </a:pPr>
+            <a:r>
+              <a:rPr lang="en-US" sz="2500" b="1" dirty="0">
+                <a:solidFill>
+                  <a:srgbClr val="131415"/>
+                </a:solidFill>
+                <a:latin typeface="Replica LL TT" pitchFamily="34" charset="0"/>
+                <a:ea typeface="Replica LL TT" pitchFamily="34" charset="-122"/>
+                <a:cs typeface="Replica LL TT" pitchFamily="34" charset="-120"/>
+              </a:rPr>
+              <a:t>Match</a:t>
+            </a:r>
+            <a:endParaRPr lang="en-US" sz="2500" dirty="0"/>
+          </a:p>
+        </p:txBody>
+      </p:sp>
+      <p:sp>
+        <p:nvSpPr>
+          <p:cNvPr id="9" name="Text 7"/>
+          <p:cNvSpPr/>
+          <p:nvPr/>
+        </p:nvSpPr>
+        <p:spPr>
+          <a:xfrm>
+            <a:off x="3573704" y="3840480"/>
+            <a:ext cx="2247824" cy="1005840"/>
+          </a:xfrm>
+          <a:prstGeom prst="rect">
+            <a:avLst/>
+          </a:prstGeom>
+          <a:noFill/>
+          <a:ln/>
+        </p:spPr>
+        <p:txBody>
+          <a:bodyPr wrap="square" lIns="0" tIns="0" rIns="0" bIns="0" rtlCol="0" anchor="t"/>
+          <a:lstStyle/>
+          <a:p>
+            <a:pPr indent="0" marL="0">
+              <a:lnSpc>
+                <a:spcPct val="130000"/>
+              </a:lnSpc>
+              <a:buNone/>
+            </a:pPr>
+            <a:r>
+              <a:rPr lang="en-US" sz="1800" dirty="0">
+                <a:solidFill>
+                  <a:srgbClr val="5A6166"/>
+                </a:solidFill>
+                <a:latin typeface="Inter" pitchFamily="34" charset="0"/>
+                <a:ea typeface="Inter" pitchFamily="34" charset="-122"/>
+                <a:cs typeface="Inter" pitchFamily="34" charset="-120"/>
+              </a:rPr>
+              <a:t>Vi henter inn selskapene som treffer den.</a:t>
+            </a:r>
+            <a:endParaRPr lang="en-US" sz="1800" dirty="0"/>
+          </a:p>
+        </p:txBody>
+      </p:sp>
+      <p:sp>
+        <p:nvSpPr>
+          <p:cNvPr id="10" name="Text 8"/>
+          <p:cNvSpPr/>
+          <p:nvPr/>
+        </p:nvSpPr>
+        <p:spPr>
+          <a:xfrm>
+            <a:off x="6370168" y="2423160"/>
+            <a:ext cx="2247824" cy="914400"/>
+          </a:xfrm>
+          <a:prstGeom prst="rect">
+            <a:avLst/>
+          </a:prstGeom>
+          <a:noFill/>
+          <a:ln/>
+        </p:spPr>
+        <p:txBody>
+          <a:bodyPr wrap="square" lIns="0" tIns="0" rIns="0" bIns="0" rtlCol="0" anchor="t"/>
+          <a:lstStyle/>
+          <a:p>
+            <a:pPr indent="0" marL="0">
+              <a:buNone/>
+            </a:pPr>
+            <a:r>
+              <a:rPr lang="en-US" sz="5600" dirty="0">
+                <a:solidFill>
+                  <a:srgbClr val="5A6166"/>
+                </a:solidFill>
+                <a:latin typeface="Replica LL TT Heavy" pitchFamily="34" charset="0"/>
+                <a:ea typeface="Replica LL TT Heavy" pitchFamily="34" charset="-122"/>
+                <a:cs typeface="Replica LL TT Heavy" pitchFamily="34" charset="-120"/>
+              </a:rPr>
+              <a:t>03</a:t>
+            </a:r>
+            <a:endParaRPr lang="en-US" sz="5600" dirty="0"/>
+          </a:p>
+        </p:txBody>
+      </p:sp>
+      <p:sp>
+        <p:nvSpPr>
+          <p:cNvPr id="11" name="Text 9"/>
+          <p:cNvSpPr/>
+          <p:nvPr/>
+        </p:nvSpPr>
+        <p:spPr>
+          <a:xfrm>
+            <a:off x="6370168" y="3355848"/>
+            <a:ext cx="2247824" cy="457200"/>
+          </a:xfrm>
+          <a:prstGeom prst="rect">
+            <a:avLst/>
+          </a:prstGeom>
+          <a:noFill/>
+          <a:ln/>
+        </p:spPr>
+        <p:txBody>
+          <a:bodyPr wrap="square" lIns="0" tIns="0" rIns="0" bIns="0" rtlCol="0" anchor="ctr"/>
+          <a:lstStyle/>
+          <a:p>
+            <a:pPr indent="0" marL="0">
+              <a:buNone/>
+            </a:pPr>
+            <a:r>
+              <a:rPr lang="en-US" sz="2500" b="1" dirty="0">
+                <a:solidFill>
+                  <a:srgbClr val="131415"/>
+                </a:solidFill>
+                <a:latin typeface="Replica LL TT" pitchFamily="34" charset="0"/>
+                <a:ea typeface="Replica LL TT" pitchFamily="34" charset="-122"/>
+                <a:cs typeface="Replica LL TT" pitchFamily="34" charset="-120"/>
+              </a:rPr>
+              <a:t>Pilot</a:t>
+            </a:r>
+            <a:endParaRPr lang="en-US" sz="2500" dirty="0"/>
+          </a:p>
+        </p:txBody>
+      </p:sp>
+      <p:sp>
+        <p:nvSpPr>
+          <p:cNvPr id="12" name="Text 10"/>
+          <p:cNvSpPr/>
+          <p:nvPr/>
+        </p:nvSpPr>
+        <p:spPr>
+          <a:xfrm>
+            <a:off x="6370168" y="3840480"/>
+            <a:ext cx="2247824" cy="1005840"/>
+          </a:xfrm>
+          <a:prstGeom prst="rect">
+            <a:avLst/>
+          </a:prstGeom>
+          <a:noFill/>
+          <a:ln/>
+        </p:spPr>
+        <p:txBody>
+          <a:bodyPr wrap="square" lIns="0" tIns="0" rIns="0" bIns="0" rtlCol="0" anchor="t"/>
+          <a:lstStyle/>
+          <a:p>
+            <a:pPr indent="0" marL="0">
+              <a:lnSpc>
+                <a:spcPct val="130000"/>
+              </a:lnSpc>
+              <a:buNone/>
+            </a:pPr>
+            <a:r>
+              <a:rPr lang="en-US" sz="1800" dirty="0">
+                <a:solidFill>
+                  <a:srgbClr val="5A6166"/>
+                </a:solidFill>
+                <a:latin typeface="Inter" pitchFamily="34" charset="0"/>
+                <a:ea typeface="Inter" pitchFamily="34" charset="-122"/>
+                <a:cs typeface="Inter" pitchFamily="34" charset="-120"/>
+              </a:rPr>
+              <a:t>Vi rigger et forsøk med tydelige kriterier.</a:t>
+            </a:r>
+            <a:endParaRPr lang="en-US" sz="1800" dirty="0"/>
+          </a:p>
+        </p:txBody>
+      </p:sp>
+      <p:sp>
+        <p:nvSpPr>
+          <p:cNvPr id="13" name="Text 11"/>
+          <p:cNvSpPr/>
+          <p:nvPr/>
+        </p:nvSpPr>
+        <p:spPr>
+          <a:xfrm>
+            <a:off x="9166631" y="2423160"/>
+            <a:ext cx="2247824" cy="914400"/>
+          </a:xfrm>
+          <a:prstGeom prst="rect">
+            <a:avLst/>
+          </a:prstGeom>
+          <a:noFill/>
+          <a:ln/>
+        </p:spPr>
+        <p:txBody>
+          <a:bodyPr wrap="square" lIns="0" tIns="0" rIns="0" bIns="0" rtlCol="0" anchor="t"/>
+          <a:lstStyle/>
+          <a:p>
+            <a:pPr indent="0" marL="0">
+              <a:buNone/>
+            </a:pPr>
+            <a:r>
+              <a:rPr lang="en-US" sz="5600" dirty="0">
+                <a:solidFill>
+                  <a:srgbClr val="5A6166"/>
+                </a:solidFill>
+                <a:latin typeface="Replica LL TT Heavy" pitchFamily="34" charset="0"/>
+                <a:ea typeface="Replica LL TT Heavy" pitchFamily="34" charset="-122"/>
+                <a:cs typeface="Replica LL TT Heavy" pitchFamily="34" charset="-120"/>
+              </a:rPr>
+              <a:t>04</a:t>
+            </a:r>
+            <a:endParaRPr lang="en-US" sz="5600" dirty="0"/>
+          </a:p>
+        </p:txBody>
+      </p:sp>
+      <p:sp>
+        <p:nvSpPr>
+          <p:cNvPr id="14" name="Text 12"/>
+          <p:cNvSpPr/>
+          <p:nvPr/>
+        </p:nvSpPr>
+        <p:spPr>
+          <a:xfrm>
+            <a:off x="9166631" y="3355848"/>
+            <a:ext cx="2247824" cy="457200"/>
+          </a:xfrm>
+          <a:prstGeom prst="rect">
+            <a:avLst/>
+          </a:prstGeom>
+          <a:noFill/>
+          <a:ln/>
+        </p:spPr>
+        <p:txBody>
+          <a:bodyPr wrap="square" lIns="0" tIns="0" rIns="0" bIns="0" rtlCol="0" anchor="ctr"/>
+          <a:lstStyle/>
+          <a:p>
+            <a:pPr indent="0" marL="0">
+              <a:buNone/>
+            </a:pPr>
+            <a:r>
+              <a:rPr lang="en-US" sz="2500" b="1" dirty="0">
+                <a:solidFill>
+                  <a:srgbClr val="131415"/>
+                </a:solidFill>
+                <a:latin typeface="Replica LL TT" pitchFamily="34" charset="0"/>
+                <a:ea typeface="Replica LL TT" pitchFamily="34" charset="-122"/>
+                <a:cs typeface="Replica LL TT" pitchFamily="34" charset="-120"/>
+              </a:rPr>
+              <a:t>Skaler</a:t>
+            </a:r>
+            <a:endParaRPr lang="en-US" sz="2500" dirty="0"/>
+          </a:p>
+        </p:txBody>
+      </p:sp>
+      <p:sp>
+        <p:nvSpPr>
+          <p:cNvPr id="15" name="Text 13"/>
+          <p:cNvSpPr/>
+          <p:nvPr/>
+        </p:nvSpPr>
+        <p:spPr>
+          <a:xfrm>
+            <a:off x="9166631" y="3840480"/>
+            <a:ext cx="2247824" cy="1005840"/>
+          </a:xfrm>
+          <a:prstGeom prst="rect">
+            <a:avLst/>
+          </a:prstGeom>
+          <a:noFill/>
+          <a:ln/>
+        </p:spPr>
+        <p:txBody>
+          <a:bodyPr wrap="square" lIns="0" tIns="0" rIns="0" bIns="0" rtlCol="0" anchor="t"/>
+          <a:lstStyle/>
+          <a:p>
+            <a:pPr indent="0" marL="0">
+              <a:lnSpc>
+                <a:spcPct val="130000"/>
+              </a:lnSpc>
+              <a:buNone/>
+            </a:pPr>
+            <a:r>
+              <a:rPr lang="en-US" sz="1800" dirty="0">
+                <a:solidFill>
+                  <a:srgbClr val="5A6166"/>
+                </a:solidFill>
+                <a:latin typeface="Inter" pitchFamily="34" charset="0"/>
+                <a:ea typeface="Inter" pitchFamily="34" charset="-122"/>
+                <a:cs typeface="Inter" pitchFamily="34" charset="-120"/>
+              </a:rPr>
+              <a:t>Det som virker, settes i drift.</a:t>
+            </a:r>
+            <a:endParaRPr lang="en-US" sz="1800" dirty="0"/>
           </a:p>
         </p:txBody>
       </p:sp>
       <p:pic>
         <p:nvPicPr>
-          <p:cNvPr id="4" name="Image 0" descr="C:\Code\Work\startuplab-partner-presentation\pptx-templates\media\portrait-1.jpg">    </p:cNvPr>
+          <p:cNvPr id="16" name="Image 0" descr="C:\Code\Work\startuplab-partner-presentation\pptx-templates\media\logo-red.png">    </p:cNvPr>
           <p:cNvPicPr>
             <a:picLocks noChangeAspect="1"/>
           </p:cNvPicPr>
@@ -4520,486 +4784,6 @@
         </p:nvPicPr>
         <p:blipFill>
           <a:blip r:embed="rId1"/>
-          <a:srcRect l="0" r="0" t="0" b="0"/>
-          <a:stretch/>
-        </p:blipFill>
-        <p:spPr>
-          <a:xfrm>
-            <a:off x="777240" y="2286000"/>
-            <a:ext cx="2240280" cy="2240280"/>
-          </a:xfrm>
-          <a:prstGeom prst="ellipse">
-            <a:avLst/>
-          </a:prstGeom>
-        </p:spPr>
-      </p:pic>
-      <p:sp>
-        <p:nvSpPr>
-          <p:cNvPr id="5" name="Text 2"/>
-          <p:cNvSpPr/>
-          <p:nvPr/>
-        </p:nvSpPr>
-        <p:spPr>
-          <a:xfrm>
-            <a:off x="777240" y="4727448"/>
-            <a:ext cx="2240280" cy="365760"/>
-          </a:xfrm>
-          <a:prstGeom prst="rect">
-            <a:avLst/>
-          </a:prstGeom>
-          <a:noFill/>
-          <a:ln/>
-        </p:spPr>
-        <p:txBody>
-          <a:bodyPr wrap="square" lIns="0" tIns="0" rIns="0" bIns="0" rtlCol="0" anchor="ctr"/>
-          <a:lstStyle/>
-          <a:p>
-            <a:pPr algn="ctr" indent="0" marL="0">
-              <a:buNone/>
-            </a:pPr>
-            <a:r>
-              <a:rPr lang="en-US" sz="2100" b="1" dirty="0">
-                <a:solidFill>
-                  <a:srgbClr val="131415"/>
-                </a:solidFill>
-                <a:latin typeface="Replica LL TT" pitchFamily="34" charset="0"/>
-                <a:ea typeface="Replica LL TT" pitchFamily="34" charset="-122"/>
-                <a:cs typeface="Replica LL TT" pitchFamily="34" charset="-120"/>
-              </a:rPr>
-              <a:t>Christina Wiig</a:t>
-            </a:r>
-            <a:endParaRPr lang="en-US" sz="2100" dirty="0"/>
-          </a:p>
-        </p:txBody>
-      </p:sp>
-      <p:sp>
-        <p:nvSpPr>
-          <p:cNvPr id="6" name="Text 3"/>
-          <p:cNvSpPr/>
-          <p:nvPr/>
-        </p:nvSpPr>
-        <p:spPr>
-          <a:xfrm>
-            <a:off x="777240" y="5093208"/>
-            <a:ext cx="2240280" cy="694944"/>
-          </a:xfrm>
-          <a:prstGeom prst="rect">
-            <a:avLst/>
-          </a:prstGeom>
-          <a:noFill/>
-          <a:ln/>
-        </p:spPr>
-        <p:txBody>
-          <a:bodyPr wrap="square" lIns="0" tIns="0" rIns="0" bIns="0" rtlCol="0" anchor="t"/>
-          <a:lstStyle/>
-          <a:p>
-            <a:pPr algn="ctr" indent="0" marL="0">
-              <a:lnSpc>
-                <a:spcPct val="115000"/>
-              </a:lnSpc>
-              <a:buNone/>
-            </a:pPr>
-            <a:r>
-              <a:rPr lang="en-US" sz="1800" dirty="0">
-                <a:solidFill>
-                  <a:srgbClr val="5A6166"/>
-                </a:solidFill>
-                <a:latin typeface="Inter" pitchFamily="34" charset="0"/>
-                <a:ea typeface="Inter" pitchFamily="34" charset="-122"/>
-                <a:cs typeface="Inter" pitchFamily="34" charset="-120"/>
-              </a:rPr>
-              <a:t>Head of Corporate Partnerships</a:t>
-            </a:r>
-            <a:endParaRPr lang="en-US" sz="1800" dirty="0"/>
-          </a:p>
-        </p:txBody>
-      </p:sp>
-      <p:pic>
-        <p:nvPicPr>
-          <p:cNvPr id="7" name="Image 1" descr="C:\Code\Work\startuplab-partner-presentation\pptx-templates\media\portrait-2.jpg">    </p:cNvPr>
-          <p:cNvPicPr>
-            <a:picLocks noChangeAspect="1"/>
-          </p:cNvPicPr>
-          <p:nvPr/>
-        </p:nvPicPr>
-        <p:blipFill>
-          <a:blip r:embed="rId2"/>
-          <a:srcRect l="0" r="0" t="0" b="0"/>
-          <a:stretch/>
-        </p:blipFill>
-        <p:spPr>
-          <a:xfrm>
-            <a:off x="3576218" y="2286000"/>
-            <a:ext cx="2240280" cy="2240280"/>
-          </a:xfrm>
-          <a:prstGeom prst="ellipse">
-            <a:avLst/>
-          </a:prstGeom>
-        </p:spPr>
-      </p:pic>
-      <p:sp>
-        <p:nvSpPr>
-          <p:cNvPr id="8" name="Text 4"/>
-          <p:cNvSpPr/>
-          <p:nvPr/>
-        </p:nvSpPr>
-        <p:spPr>
-          <a:xfrm>
-            <a:off x="3576218" y="4727448"/>
-            <a:ext cx="2240280" cy="365760"/>
-          </a:xfrm>
-          <a:prstGeom prst="rect">
-            <a:avLst/>
-          </a:prstGeom>
-          <a:noFill/>
-          <a:ln/>
-        </p:spPr>
-        <p:txBody>
-          <a:bodyPr wrap="square" lIns="0" tIns="0" rIns="0" bIns="0" rtlCol="0" anchor="ctr"/>
-          <a:lstStyle/>
-          <a:p>
-            <a:pPr algn="ctr" indent="0" marL="0">
-              <a:buNone/>
-            </a:pPr>
-            <a:r>
-              <a:rPr lang="en-US" sz="2100" b="1" dirty="0">
-                <a:solidFill>
-                  <a:srgbClr val="131415"/>
-                </a:solidFill>
-                <a:latin typeface="Replica LL TT" pitchFamily="34" charset="0"/>
-                <a:ea typeface="Replica LL TT" pitchFamily="34" charset="-122"/>
-                <a:cs typeface="Replica LL TT" pitchFamily="34" charset="-120"/>
-              </a:rPr>
-              <a:t>Anniken Holst</a:t>
-            </a:r>
-            <a:endParaRPr lang="en-US" sz="2100" dirty="0"/>
-          </a:p>
-        </p:txBody>
-      </p:sp>
-      <p:sp>
-        <p:nvSpPr>
-          <p:cNvPr id="9" name="Text 5"/>
-          <p:cNvSpPr/>
-          <p:nvPr/>
-        </p:nvSpPr>
-        <p:spPr>
-          <a:xfrm>
-            <a:off x="3576218" y="5093208"/>
-            <a:ext cx="2240280" cy="694944"/>
-          </a:xfrm>
-          <a:prstGeom prst="rect">
-            <a:avLst/>
-          </a:prstGeom>
-          <a:noFill/>
-          <a:ln/>
-        </p:spPr>
-        <p:txBody>
-          <a:bodyPr wrap="square" lIns="0" tIns="0" rIns="0" bIns="0" rtlCol="0" anchor="t"/>
-          <a:lstStyle/>
-          <a:p>
-            <a:pPr algn="ctr" indent="0" marL="0">
-              <a:lnSpc>
-                <a:spcPct val="115000"/>
-              </a:lnSpc>
-              <a:buNone/>
-            </a:pPr>
-            <a:r>
-              <a:rPr lang="en-US" sz="1800" dirty="0">
-                <a:solidFill>
-                  <a:srgbClr val="5A6166"/>
-                </a:solidFill>
-                <a:latin typeface="Inter" pitchFamily="34" charset="0"/>
-                <a:ea typeface="Inter" pitchFamily="34" charset="-122"/>
-                <a:cs typeface="Inter" pitchFamily="34" charset="-120"/>
-              </a:rPr>
-              <a:t>Partner Manager</a:t>
-            </a:r>
-            <a:endParaRPr lang="en-US" sz="1800" dirty="0"/>
-          </a:p>
-        </p:txBody>
-      </p:sp>
-      <p:pic>
-        <p:nvPicPr>
-          <p:cNvPr id="10" name="Image 2" descr="C:\Code\Work\startuplab-partner-presentation\pptx-templates\media\portrait-3.jpg">    </p:cNvPr>
-          <p:cNvPicPr>
-            <a:picLocks noChangeAspect="1"/>
-          </p:cNvPicPr>
-          <p:nvPr/>
-        </p:nvPicPr>
-        <p:blipFill>
-          <a:blip r:embed="rId3"/>
-          <a:srcRect l="0" r="0" t="0" b="0"/>
-          <a:stretch/>
-        </p:blipFill>
-        <p:spPr>
-          <a:xfrm>
-            <a:off x="6375197" y="2286000"/>
-            <a:ext cx="2240280" cy="2240280"/>
-          </a:xfrm>
-          <a:prstGeom prst="ellipse">
-            <a:avLst/>
-          </a:prstGeom>
-        </p:spPr>
-      </p:pic>
-      <p:sp>
-        <p:nvSpPr>
-          <p:cNvPr id="11" name="Text 6"/>
-          <p:cNvSpPr/>
-          <p:nvPr/>
-        </p:nvSpPr>
-        <p:spPr>
-          <a:xfrm>
-            <a:off x="6375197" y="4727448"/>
-            <a:ext cx="2240280" cy="365760"/>
-          </a:xfrm>
-          <a:prstGeom prst="rect">
-            <a:avLst/>
-          </a:prstGeom>
-          <a:noFill/>
-          <a:ln/>
-        </p:spPr>
-        <p:txBody>
-          <a:bodyPr wrap="square" lIns="0" tIns="0" rIns="0" bIns="0" rtlCol="0" anchor="ctr"/>
-          <a:lstStyle/>
-          <a:p>
-            <a:pPr algn="ctr" indent="0" marL="0">
-              <a:buNone/>
-            </a:pPr>
-            <a:r>
-              <a:rPr lang="en-US" sz="2100" b="1" dirty="0">
-                <a:solidFill>
-                  <a:srgbClr val="131415"/>
-                </a:solidFill>
-                <a:latin typeface="Replica LL TT" pitchFamily="34" charset="0"/>
-                <a:ea typeface="Replica LL TT" pitchFamily="34" charset="-122"/>
-                <a:cs typeface="Replica LL TT" pitchFamily="34" charset="-120"/>
-              </a:rPr>
-              <a:t>Ola Jacobsen</a:t>
-            </a:r>
-            <a:endParaRPr lang="en-US" sz="2100" dirty="0"/>
-          </a:p>
-        </p:txBody>
-      </p:sp>
-      <p:sp>
-        <p:nvSpPr>
-          <p:cNvPr id="12" name="Text 7"/>
-          <p:cNvSpPr/>
-          <p:nvPr/>
-        </p:nvSpPr>
-        <p:spPr>
-          <a:xfrm>
-            <a:off x="6375197" y="5093208"/>
-            <a:ext cx="2240280" cy="694944"/>
-          </a:xfrm>
-          <a:prstGeom prst="rect">
-            <a:avLst/>
-          </a:prstGeom>
-          <a:noFill/>
-          <a:ln/>
-        </p:spPr>
-        <p:txBody>
-          <a:bodyPr wrap="square" lIns="0" tIns="0" rIns="0" bIns="0" rtlCol="0" anchor="t"/>
-          <a:lstStyle/>
-          <a:p>
-            <a:pPr algn="ctr" indent="0" marL="0">
-              <a:lnSpc>
-                <a:spcPct val="115000"/>
-              </a:lnSpc>
-              <a:buNone/>
-            </a:pPr>
-            <a:r>
-              <a:rPr lang="en-US" sz="1800" dirty="0">
-                <a:solidFill>
-                  <a:srgbClr val="5A6166"/>
-                </a:solidFill>
-                <a:latin typeface="Inter" pitchFamily="34" charset="0"/>
-                <a:ea typeface="Inter" pitchFamily="34" charset="-122"/>
-                <a:cs typeface="Inter" pitchFamily="34" charset="-120"/>
-              </a:rPr>
-              <a:t>Partner Manager</a:t>
-            </a:r>
-            <a:endParaRPr lang="en-US" sz="1800" dirty="0"/>
-          </a:p>
-        </p:txBody>
-      </p:sp>
-      <p:sp>
-        <p:nvSpPr>
-          <p:cNvPr id="13" name="Shape 8"/>
-          <p:cNvSpPr/>
-          <p:nvPr/>
-        </p:nvSpPr>
-        <p:spPr>
-          <a:xfrm>
-            <a:off x="9174175" y="2286000"/>
-            <a:ext cx="2240280" cy="2240280"/>
-          </a:xfrm>
-          <a:prstGeom prst="ellipse">
-            <a:avLst/>
-          </a:prstGeom>
-          <a:solidFill>
-            <a:srgbClr val="F0F0F0"/>
-          </a:solidFill>
-          <a:ln w="12700">
-            <a:solidFill>
-              <a:srgbClr val="D8DCDF"/>
-            </a:solidFill>
-            <a:prstDash val="solid"/>
-          </a:ln>
-        </p:spPr>
-      </p:sp>
-      <p:sp>
-        <p:nvSpPr>
-          <p:cNvPr id="14" name="Text 9"/>
-          <p:cNvSpPr/>
-          <p:nvPr/>
-        </p:nvSpPr>
-        <p:spPr>
-          <a:xfrm>
-            <a:off x="9174175" y="2994660"/>
-            <a:ext cx="2240280" cy="822960"/>
-          </a:xfrm>
-          <a:prstGeom prst="rect">
-            <a:avLst/>
-          </a:prstGeom>
-          <a:noFill/>
-          <a:ln/>
-        </p:spPr>
-        <p:txBody>
-          <a:bodyPr wrap="square" lIns="0" tIns="0" rIns="0" bIns="0" rtlCol="0" anchor="ctr"/>
-          <a:lstStyle/>
-          <a:p>
-            <a:pPr algn="ctr" indent="0" marL="0">
-              <a:lnSpc>
-                <a:spcPct val="120000"/>
-              </a:lnSpc>
-              <a:buNone/>
-            </a:pPr>
-            <a:r>
-              <a:rPr lang="en-US" sz="1800" dirty="0">
-                <a:solidFill>
-                  <a:srgbClr val="5A6166"/>
-                </a:solidFill>
-                <a:latin typeface="Inter" pitchFamily="34" charset="0"/>
-                <a:ea typeface="Inter" pitchFamily="34" charset="-122"/>
-                <a:cs typeface="Inter" pitchFamily="34" charset="-120"/>
-              </a:rPr>
-              <a:t>Sett inn</a:t>
-            </a:r>
-            <a:endParaRPr lang="en-US" sz="1800" dirty="0"/>
-          </a:p>
-          <a:p>
-            <a:pPr algn="ctr" indent="0" marL="0">
-              <a:lnSpc>
-                <a:spcPct val="120000"/>
-              </a:lnSpc>
-              <a:buNone/>
-            </a:pPr>
-            <a:r>
-              <a:rPr lang="en-US" sz="1800" dirty="0">
-                <a:solidFill>
-                  <a:srgbClr val="5A6166"/>
-                </a:solidFill>
-                <a:latin typeface="Inter" pitchFamily="34" charset="0"/>
-                <a:ea typeface="Inter" pitchFamily="34" charset="-122"/>
-                <a:cs typeface="Inter" pitchFamily="34" charset="-120"/>
-              </a:rPr>
-              <a:t>portrett</a:t>
-            </a:r>
-            <a:endParaRPr lang="en-US" sz="1800" dirty="0"/>
-          </a:p>
-        </p:txBody>
-      </p:sp>
-      <p:sp>
-        <p:nvSpPr>
-          <p:cNvPr id="15" name="Text 10"/>
-          <p:cNvSpPr/>
-          <p:nvPr/>
-        </p:nvSpPr>
-        <p:spPr>
-          <a:xfrm>
-            <a:off x="9174175" y="4727448"/>
-            <a:ext cx="2240280" cy="365760"/>
-          </a:xfrm>
-          <a:prstGeom prst="rect">
-            <a:avLst/>
-          </a:prstGeom>
-          <a:noFill/>
-          <a:ln/>
-        </p:spPr>
-        <p:txBody>
-          <a:bodyPr wrap="square" lIns="0" tIns="0" rIns="0" bIns="0" rtlCol="0" anchor="ctr"/>
-          <a:lstStyle/>
-          <a:p>
-            <a:pPr algn="ctr" indent="0" marL="0">
-              <a:buNone/>
-            </a:pPr>
-            <a:r>
-              <a:rPr lang="en-US" sz="2100" b="1" dirty="0">
-                <a:solidFill>
-                  <a:srgbClr val="131415"/>
-                </a:solidFill>
-                <a:latin typeface="Replica LL TT" pitchFamily="34" charset="0"/>
-                <a:ea typeface="Replica LL TT" pitchFamily="34" charset="-122"/>
-                <a:cs typeface="Replica LL TT" pitchFamily="34" charset="-120"/>
-              </a:rPr>
-              <a:t>Navn Navnesen</a:t>
-            </a:r>
-            <a:endParaRPr lang="en-US" sz="2100" dirty="0"/>
-          </a:p>
-        </p:txBody>
-      </p:sp>
-      <p:sp>
-        <p:nvSpPr>
-          <p:cNvPr id="16" name="Text 11"/>
-          <p:cNvSpPr/>
-          <p:nvPr/>
-        </p:nvSpPr>
-        <p:spPr>
-          <a:xfrm>
-            <a:off x="9174175" y="5093208"/>
-            <a:ext cx="2240280" cy="694944"/>
-          </a:xfrm>
-          <a:prstGeom prst="rect">
-            <a:avLst/>
-          </a:prstGeom>
-          <a:noFill/>
-          <a:ln/>
-        </p:spPr>
-        <p:txBody>
-          <a:bodyPr wrap="square" lIns="0" tIns="0" rIns="0" bIns="0" rtlCol="0" anchor="t"/>
-          <a:lstStyle/>
-          <a:p>
-            <a:pPr algn="ctr" indent="0" marL="0">
-              <a:lnSpc>
-                <a:spcPct val="115000"/>
-              </a:lnSpc>
-              <a:buNone/>
-            </a:pPr>
-            <a:r>
-              <a:rPr lang="en-US" sz="1800" dirty="0">
-                <a:solidFill>
-                  <a:srgbClr val="5A6166"/>
-                </a:solidFill>
-                <a:latin typeface="Inter" pitchFamily="34" charset="0"/>
-                <a:ea typeface="Inter" pitchFamily="34" charset="-122"/>
-                <a:cs typeface="Inter" pitchFamily="34" charset="-120"/>
-              </a:rPr>
-              <a:t>Rolle her</a:t>
-            </a:r>
-            <a:endParaRPr lang="en-US" sz="1800" dirty="0"/>
-          </a:p>
-        </p:txBody>
-      </p:sp>
-      <p:pic>
-        <p:nvPicPr>
-          <p:cNvPr id="17" name="Image 3" descr="C:\Code\Work\startuplab-partner-presentation\pptx-templates\media\logo-red.png">    </p:cNvPr>
-          <p:cNvPicPr>
-            <a:picLocks noChangeAspect="1"/>
-          </p:cNvPicPr>
-          <p:nvPr/>
-        </p:nvPicPr>
-        <p:blipFill>
-          <a:blip r:embed="rId4"/>
           <a:stretch>
             <a:fillRect/>
           </a:stretch>
@@ -5025,6 +4809,640 @@
 <file path=ppt/slides/slide16.xml><?xml version="1.0" encoding="utf-8"?>
 <p:sld xmlns:a="http://schemas.openxmlformats.org/drawingml/2006/main" xmlns:r="http://schemas.openxmlformats.org/officeDocument/2006/relationships" xmlns:p="http://schemas.openxmlformats.org/presentationml/2006/main">
   <p:cSld name="Slide 16">
+    <p:bg>
+      <p:bgPr>
+        <a:solidFill>
+          <a:srgbClr val="FFFFFF"/>
+        </a:solidFill>
+      </p:bgPr>
+    </p:bg>
+    <p:spTree>
+      <p:nvGrpSpPr>
+        <p:cNvPr id="1" name=""/>
+        <p:cNvGrpSpPr/>
+        <p:nvPr/>
+      </p:nvGrpSpPr>
+      <p:grpSpPr>
+        <a:xfrm>
+          <a:off x="0" y="0"/>
+          <a:ext cx="0" cy="0"/>
+          <a:chOff x="0" y="0"/>
+          <a:chExt cx="0" cy="0"/>
+        </a:xfrm>
+      </p:grpSpPr>
+      <p:sp>
+        <p:nvSpPr>
+          <p:cNvPr id="2" name="Text 0"/>
+          <p:cNvSpPr/>
+          <p:nvPr/>
+        </p:nvSpPr>
+        <p:spPr>
+          <a:xfrm>
+            <a:off x="777240" y="713232"/>
+            <a:ext cx="8229600" cy="292608"/>
+          </a:xfrm>
+          <a:prstGeom prst="rect">
+            <a:avLst/>
+          </a:prstGeom>
+          <a:noFill/>
+          <a:ln/>
+        </p:spPr>
+        <p:txBody>
+          <a:bodyPr wrap="square" lIns="0" tIns="0" rIns="0" bIns="0" rtlCol="0" anchor="ctr"/>
+          <a:lstStyle/>
+          <a:p>
+            <a:pPr indent="0" marL="0">
+              <a:buNone/>
+            </a:pPr>
+            <a:r>
+              <a:rPr lang="en-US" sz="1600" b="1" spc="250" kern="0" dirty="0">
+                <a:solidFill>
+                  <a:srgbClr val="FF3333"/>
+                </a:solidFill>
+                <a:latin typeface="Inter" pitchFamily="34" charset="0"/>
+                <a:ea typeface="Inter" pitchFamily="34" charset="-122"/>
+                <a:cs typeface="Inter" pitchFamily="34" charset="-120"/>
+              </a:rPr>
+              <a:t>TEAMET</a:t>
+            </a:r>
+            <a:endParaRPr lang="en-US" sz="1600" dirty="0"/>
+          </a:p>
+        </p:txBody>
+      </p:sp>
+      <p:sp>
+        <p:nvSpPr>
+          <p:cNvPr id="3" name="Text 1"/>
+          <p:cNvSpPr/>
+          <p:nvPr/>
+        </p:nvSpPr>
+        <p:spPr>
+          <a:xfrm>
+            <a:off x="777240" y="1051560"/>
+            <a:ext cx="10424160" cy="777240"/>
+          </a:xfrm>
+          <a:prstGeom prst="rect">
+            <a:avLst/>
+          </a:prstGeom>
+          <a:noFill/>
+          <a:ln/>
+        </p:spPr>
+        <p:txBody>
+          <a:bodyPr wrap="square" lIns="0" tIns="0" rIns="0" bIns="0" rtlCol="0" anchor="t"/>
+          <a:lstStyle/>
+          <a:p>
+            <a:pPr indent="0" marL="0">
+              <a:lnSpc>
+                <a:spcPct val="100000"/>
+              </a:lnSpc>
+              <a:buNone/>
+            </a:pPr>
+            <a:r>
+              <a:rPr lang="en-US" sz="4000" b="1" dirty="0">
+                <a:solidFill>
+                  <a:srgbClr val="131415"/>
+                </a:solidFill>
+                <a:latin typeface="Replica LL TT" pitchFamily="34" charset="0"/>
+                <a:ea typeface="Replica LL TT" pitchFamily="34" charset="-122"/>
+                <a:cs typeface="Replica LL TT" pitchFamily="34" charset="-120"/>
+              </a:rPr>
+              <a:t>Folkene du kommer til å </a:t>
+            </a:r>
+            <a:pPr indent="0" marL="0">
+              <a:lnSpc>
+                <a:spcPct val="100000"/>
+              </a:lnSpc>
+              <a:buNone/>
+            </a:pPr>
+            <a:r>
+              <a:rPr lang="en-US" sz="4000" b="1" dirty="0">
+                <a:solidFill>
+                  <a:srgbClr val="FF3333"/>
+                </a:solidFill>
+                <a:latin typeface="Replica LL TT" pitchFamily="34" charset="0"/>
+                <a:ea typeface="Replica LL TT" pitchFamily="34" charset="-122"/>
+                <a:cs typeface="Replica LL TT" pitchFamily="34" charset="-120"/>
+              </a:rPr>
+              <a:t>jobbe med</a:t>
+            </a:r>
+            <a:endParaRPr lang="en-US" sz="4000" dirty="0"/>
+          </a:p>
+        </p:txBody>
+      </p:sp>
+      <p:pic>
+        <p:nvPicPr>
+          <p:cNvPr id="4" name="Image 0" descr="C:\Code\Work\startuplab-partner-presentation\pptx-templates\media\portrait-1.jpg">    </p:cNvPr>
+          <p:cNvPicPr>
+            <a:picLocks noChangeAspect="1"/>
+          </p:cNvPicPr>
+          <p:nvPr/>
+        </p:nvPicPr>
+        <p:blipFill>
+          <a:blip r:embed="rId1"/>
+          <a:srcRect l="0" r="0" t="0" b="0"/>
+          <a:stretch/>
+        </p:blipFill>
+        <p:spPr>
+          <a:xfrm>
+            <a:off x="777240" y="2286000"/>
+            <a:ext cx="2240280" cy="2240280"/>
+          </a:xfrm>
+          <a:prstGeom prst="ellipse">
+            <a:avLst/>
+          </a:prstGeom>
+        </p:spPr>
+      </p:pic>
+      <p:sp>
+        <p:nvSpPr>
+          <p:cNvPr id="5" name="Text 2"/>
+          <p:cNvSpPr/>
+          <p:nvPr/>
+        </p:nvSpPr>
+        <p:spPr>
+          <a:xfrm>
+            <a:off x="777240" y="4727448"/>
+            <a:ext cx="2240280" cy="365760"/>
+          </a:xfrm>
+          <a:prstGeom prst="rect">
+            <a:avLst/>
+          </a:prstGeom>
+          <a:noFill/>
+          <a:ln/>
+        </p:spPr>
+        <p:txBody>
+          <a:bodyPr wrap="square" lIns="0" tIns="0" rIns="0" bIns="0" rtlCol="0" anchor="ctr"/>
+          <a:lstStyle/>
+          <a:p>
+            <a:pPr algn="ctr" indent="0" marL="0">
+              <a:buNone/>
+            </a:pPr>
+            <a:r>
+              <a:rPr lang="en-US" sz="2100" b="1" dirty="0">
+                <a:solidFill>
+                  <a:srgbClr val="131415"/>
+                </a:solidFill>
+                <a:latin typeface="Replica LL TT" pitchFamily="34" charset="0"/>
+                <a:ea typeface="Replica LL TT" pitchFamily="34" charset="-122"/>
+                <a:cs typeface="Replica LL TT" pitchFamily="34" charset="-120"/>
+              </a:rPr>
+              <a:t>Christina Wiig</a:t>
+            </a:r>
+            <a:endParaRPr lang="en-US" sz="2100" dirty="0"/>
+          </a:p>
+        </p:txBody>
+      </p:sp>
+      <p:sp>
+        <p:nvSpPr>
+          <p:cNvPr id="6" name="Text 3"/>
+          <p:cNvSpPr/>
+          <p:nvPr/>
+        </p:nvSpPr>
+        <p:spPr>
+          <a:xfrm>
+            <a:off x="777240" y="5093208"/>
+            <a:ext cx="2240280" cy="694944"/>
+          </a:xfrm>
+          <a:prstGeom prst="rect">
+            <a:avLst/>
+          </a:prstGeom>
+          <a:noFill/>
+          <a:ln/>
+        </p:spPr>
+        <p:txBody>
+          <a:bodyPr wrap="square" lIns="0" tIns="0" rIns="0" bIns="0" rtlCol="0" anchor="t"/>
+          <a:lstStyle/>
+          <a:p>
+            <a:pPr algn="ctr" indent="0" marL="0">
+              <a:lnSpc>
+                <a:spcPct val="115000"/>
+              </a:lnSpc>
+              <a:buNone/>
+            </a:pPr>
+            <a:r>
+              <a:rPr lang="en-US" sz="1800" dirty="0">
+                <a:solidFill>
+                  <a:srgbClr val="5A6166"/>
+                </a:solidFill>
+                <a:latin typeface="Inter" pitchFamily="34" charset="0"/>
+                <a:ea typeface="Inter" pitchFamily="34" charset="-122"/>
+                <a:cs typeface="Inter" pitchFamily="34" charset="-120"/>
+              </a:rPr>
+              <a:t>Head of Corporate Partnerships</a:t>
+            </a:r>
+            <a:endParaRPr lang="en-US" sz="1800" dirty="0"/>
+          </a:p>
+        </p:txBody>
+      </p:sp>
+      <p:pic>
+        <p:nvPicPr>
+          <p:cNvPr id="7" name="Image 1" descr="C:\Code\Work\startuplab-partner-presentation\pptx-templates\media\portrait-2.jpg">    </p:cNvPr>
+          <p:cNvPicPr>
+            <a:picLocks noChangeAspect="1"/>
+          </p:cNvPicPr>
+          <p:nvPr/>
+        </p:nvPicPr>
+        <p:blipFill>
+          <a:blip r:embed="rId2"/>
+          <a:srcRect l="0" r="0" t="0" b="0"/>
+          <a:stretch/>
+        </p:blipFill>
+        <p:spPr>
+          <a:xfrm>
+            <a:off x="3576218" y="2286000"/>
+            <a:ext cx="2240280" cy="2240280"/>
+          </a:xfrm>
+          <a:prstGeom prst="ellipse">
+            <a:avLst/>
+          </a:prstGeom>
+        </p:spPr>
+      </p:pic>
+      <p:sp>
+        <p:nvSpPr>
+          <p:cNvPr id="8" name="Text 4"/>
+          <p:cNvSpPr/>
+          <p:nvPr/>
+        </p:nvSpPr>
+        <p:spPr>
+          <a:xfrm>
+            <a:off x="3576218" y="4727448"/>
+            <a:ext cx="2240280" cy="365760"/>
+          </a:xfrm>
+          <a:prstGeom prst="rect">
+            <a:avLst/>
+          </a:prstGeom>
+          <a:noFill/>
+          <a:ln/>
+        </p:spPr>
+        <p:txBody>
+          <a:bodyPr wrap="square" lIns="0" tIns="0" rIns="0" bIns="0" rtlCol="0" anchor="ctr"/>
+          <a:lstStyle/>
+          <a:p>
+            <a:pPr algn="ctr" indent="0" marL="0">
+              <a:buNone/>
+            </a:pPr>
+            <a:r>
+              <a:rPr lang="en-US" sz="2100" b="1" dirty="0">
+                <a:solidFill>
+                  <a:srgbClr val="131415"/>
+                </a:solidFill>
+                <a:latin typeface="Replica LL TT" pitchFamily="34" charset="0"/>
+                <a:ea typeface="Replica LL TT" pitchFamily="34" charset="-122"/>
+                <a:cs typeface="Replica LL TT" pitchFamily="34" charset="-120"/>
+              </a:rPr>
+              <a:t>Anniken Holst</a:t>
+            </a:r>
+            <a:endParaRPr lang="en-US" sz="2100" dirty="0"/>
+          </a:p>
+        </p:txBody>
+      </p:sp>
+      <p:sp>
+        <p:nvSpPr>
+          <p:cNvPr id="9" name="Text 5"/>
+          <p:cNvSpPr/>
+          <p:nvPr/>
+        </p:nvSpPr>
+        <p:spPr>
+          <a:xfrm>
+            <a:off x="3576218" y="5093208"/>
+            <a:ext cx="2240280" cy="694944"/>
+          </a:xfrm>
+          <a:prstGeom prst="rect">
+            <a:avLst/>
+          </a:prstGeom>
+          <a:noFill/>
+          <a:ln/>
+        </p:spPr>
+        <p:txBody>
+          <a:bodyPr wrap="square" lIns="0" tIns="0" rIns="0" bIns="0" rtlCol="0" anchor="t"/>
+          <a:lstStyle/>
+          <a:p>
+            <a:pPr algn="ctr" indent="0" marL="0">
+              <a:lnSpc>
+                <a:spcPct val="115000"/>
+              </a:lnSpc>
+              <a:buNone/>
+            </a:pPr>
+            <a:r>
+              <a:rPr lang="en-US" sz="1800" dirty="0">
+                <a:solidFill>
+                  <a:srgbClr val="5A6166"/>
+                </a:solidFill>
+                <a:latin typeface="Inter" pitchFamily="34" charset="0"/>
+                <a:ea typeface="Inter" pitchFamily="34" charset="-122"/>
+                <a:cs typeface="Inter" pitchFamily="34" charset="-120"/>
+              </a:rPr>
+              <a:t>Partner Manager</a:t>
+            </a:r>
+            <a:endParaRPr lang="en-US" sz="1800" dirty="0"/>
+          </a:p>
+        </p:txBody>
+      </p:sp>
+      <p:pic>
+        <p:nvPicPr>
+          <p:cNvPr id="10" name="Image 2" descr="C:\Code\Work\startuplab-partner-presentation\pptx-templates\media\portrait-3.jpg">    </p:cNvPr>
+          <p:cNvPicPr>
+            <a:picLocks noChangeAspect="1"/>
+          </p:cNvPicPr>
+          <p:nvPr/>
+        </p:nvPicPr>
+        <p:blipFill>
+          <a:blip r:embed="rId3"/>
+          <a:srcRect l="0" r="0" t="0" b="0"/>
+          <a:stretch/>
+        </p:blipFill>
+        <p:spPr>
+          <a:xfrm>
+            <a:off x="6375197" y="2286000"/>
+            <a:ext cx="2240280" cy="2240280"/>
+          </a:xfrm>
+          <a:prstGeom prst="ellipse">
+            <a:avLst/>
+          </a:prstGeom>
+        </p:spPr>
+      </p:pic>
+      <p:sp>
+        <p:nvSpPr>
+          <p:cNvPr id="11" name="Text 6"/>
+          <p:cNvSpPr/>
+          <p:nvPr/>
+        </p:nvSpPr>
+        <p:spPr>
+          <a:xfrm>
+            <a:off x="6375197" y="4727448"/>
+            <a:ext cx="2240280" cy="365760"/>
+          </a:xfrm>
+          <a:prstGeom prst="rect">
+            <a:avLst/>
+          </a:prstGeom>
+          <a:noFill/>
+          <a:ln/>
+        </p:spPr>
+        <p:txBody>
+          <a:bodyPr wrap="square" lIns="0" tIns="0" rIns="0" bIns="0" rtlCol="0" anchor="ctr"/>
+          <a:lstStyle/>
+          <a:p>
+            <a:pPr algn="ctr" indent="0" marL="0">
+              <a:buNone/>
+            </a:pPr>
+            <a:r>
+              <a:rPr lang="en-US" sz="2100" b="1" dirty="0">
+                <a:solidFill>
+                  <a:srgbClr val="131415"/>
+                </a:solidFill>
+                <a:latin typeface="Replica LL TT" pitchFamily="34" charset="0"/>
+                <a:ea typeface="Replica LL TT" pitchFamily="34" charset="-122"/>
+                <a:cs typeface="Replica LL TT" pitchFamily="34" charset="-120"/>
+              </a:rPr>
+              <a:t>Ola Jacobsen</a:t>
+            </a:r>
+            <a:endParaRPr lang="en-US" sz="2100" dirty="0"/>
+          </a:p>
+        </p:txBody>
+      </p:sp>
+      <p:sp>
+        <p:nvSpPr>
+          <p:cNvPr id="12" name="Text 7"/>
+          <p:cNvSpPr/>
+          <p:nvPr/>
+        </p:nvSpPr>
+        <p:spPr>
+          <a:xfrm>
+            <a:off x="6375197" y="5093208"/>
+            <a:ext cx="2240280" cy="694944"/>
+          </a:xfrm>
+          <a:prstGeom prst="rect">
+            <a:avLst/>
+          </a:prstGeom>
+          <a:noFill/>
+          <a:ln/>
+        </p:spPr>
+        <p:txBody>
+          <a:bodyPr wrap="square" lIns="0" tIns="0" rIns="0" bIns="0" rtlCol="0" anchor="t"/>
+          <a:lstStyle/>
+          <a:p>
+            <a:pPr algn="ctr" indent="0" marL="0">
+              <a:lnSpc>
+                <a:spcPct val="115000"/>
+              </a:lnSpc>
+              <a:buNone/>
+            </a:pPr>
+            <a:r>
+              <a:rPr lang="en-US" sz="1800" dirty="0">
+                <a:solidFill>
+                  <a:srgbClr val="5A6166"/>
+                </a:solidFill>
+                <a:latin typeface="Inter" pitchFamily="34" charset="0"/>
+                <a:ea typeface="Inter" pitchFamily="34" charset="-122"/>
+                <a:cs typeface="Inter" pitchFamily="34" charset="-120"/>
+              </a:rPr>
+              <a:t>Partner Manager</a:t>
+            </a:r>
+            <a:endParaRPr lang="en-US" sz="1800" dirty="0"/>
+          </a:p>
+        </p:txBody>
+      </p:sp>
+      <p:sp>
+        <p:nvSpPr>
+          <p:cNvPr id="13" name="Shape 8"/>
+          <p:cNvSpPr/>
+          <p:nvPr/>
+        </p:nvSpPr>
+        <p:spPr>
+          <a:xfrm>
+            <a:off x="9174175" y="2286000"/>
+            <a:ext cx="2240280" cy="2240280"/>
+          </a:xfrm>
+          <a:prstGeom prst="ellipse">
+            <a:avLst/>
+          </a:prstGeom>
+          <a:solidFill>
+            <a:srgbClr val="F0F0F0"/>
+          </a:solidFill>
+          <a:ln w="12700">
+            <a:solidFill>
+              <a:srgbClr val="D8DCDF"/>
+            </a:solidFill>
+            <a:prstDash val="solid"/>
+          </a:ln>
+        </p:spPr>
+      </p:sp>
+      <p:sp>
+        <p:nvSpPr>
+          <p:cNvPr id="14" name="Text 9"/>
+          <p:cNvSpPr/>
+          <p:nvPr/>
+        </p:nvSpPr>
+        <p:spPr>
+          <a:xfrm>
+            <a:off x="9174175" y="2994660"/>
+            <a:ext cx="2240280" cy="822960"/>
+          </a:xfrm>
+          <a:prstGeom prst="rect">
+            <a:avLst/>
+          </a:prstGeom>
+          <a:noFill/>
+          <a:ln/>
+        </p:spPr>
+        <p:txBody>
+          <a:bodyPr wrap="square" lIns="0" tIns="0" rIns="0" bIns="0" rtlCol="0" anchor="ctr"/>
+          <a:lstStyle/>
+          <a:p>
+            <a:pPr algn="ctr" indent="0" marL="0">
+              <a:lnSpc>
+                <a:spcPct val="120000"/>
+              </a:lnSpc>
+              <a:buNone/>
+            </a:pPr>
+            <a:r>
+              <a:rPr lang="en-US" sz="1800" dirty="0">
+                <a:solidFill>
+                  <a:srgbClr val="5A6166"/>
+                </a:solidFill>
+                <a:latin typeface="Inter" pitchFamily="34" charset="0"/>
+                <a:ea typeface="Inter" pitchFamily="34" charset="-122"/>
+                <a:cs typeface="Inter" pitchFamily="34" charset="-120"/>
+              </a:rPr>
+              <a:t>Sett inn</a:t>
+            </a:r>
+            <a:endParaRPr lang="en-US" sz="1800" dirty="0"/>
+          </a:p>
+          <a:p>
+            <a:pPr algn="ctr" indent="0" marL="0">
+              <a:lnSpc>
+                <a:spcPct val="120000"/>
+              </a:lnSpc>
+              <a:buNone/>
+            </a:pPr>
+            <a:r>
+              <a:rPr lang="en-US" sz="1800" dirty="0">
+                <a:solidFill>
+                  <a:srgbClr val="5A6166"/>
+                </a:solidFill>
+                <a:latin typeface="Inter" pitchFamily="34" charset="0"/>
+                <a:ea typeface="Inter" pitchFamily="34" charset="-122"/>
+                <a:cs typeface="Inter" pitchFamily="34" charset="-120"/>
+              </a:rPr>
+              <a:t>portrett</a:t>
+            </a:r>
+            <a:endParaRPr lang="en-US" sz="1800" dirty="0"/>
+          </a:p>
+        </p:txBody>
+      </p:sp>
+      <p:sp>
+        <p:nvSpPr>
+          <p:cNvPr id="15" name="Text 10"/>
+          <p:cNvSpPr/>
+          <p:nvPr/>
+        </p:nvSpPr>
+        <p:spPr>
+          <a:xfrm>
+            <a:off x="9174175" y="4727448"/>
+            <a:ext cx="2240280" cy="365760"/>
+          </a:xfrm>
+          <a:prstGeom prst="rect">
+            <a:avLst/>
+          </a:prstGeom>
+          <a:noFill/>
+          <a:ln/>
+        </p:spPr>
+        <p:txBody>
+          <a:bodyPr wrap="square" lIns="0" tIns="0" rIns="0" bIns="0" rtlCol="0" anchor="ctr"/>
+          <a:lstStyle/>
+          <a:p>
+            <a:pPr algn="ctr" indent="0" marL="0">
+              <a:buNone/>
+            </a:pPr>
+            <a:r>
+              <a:rPr lang="en-US" sz="2100" b="1" dirty="0">
+                <a:solidFill>
+                  <a:srgbClr val="131415"/>
+                </a:solidFill>
+                <a:latin typeface="Replica LL TT" pitchFamily="34" charset="0"/>
+                <a:ea typeface="Replica LL TT" pitchFamily="34" charset="-122"/>
+                <a:cs typeface="Replica LL TT" pitchFamily="34" charset="-120"/>
+              </a:rPr>
+              <a:t>Navn Navnesen</a:t>
+            </a:r>
+            <a:endParaRPr lang="en-US" sz="2100" dirty="0"/>
+          </a:p>
+        </p:txBody>
+      </p:sp>
+      <p:sp>
+        <p:nvSpPr>
+          <p:cNvPr id="16" name="Text 11"/>
+          <p:cNvSpPr/>
+          <p:nvPr/>
+        </p:nvSpPr>
+        <p:spPr>
+          <a:xfrm>
+            <a:off x="9174175" y="5093208"/>
+            <a:ext cx="2240280" cy="694944"/>
+          </a:xfrm>
+          <a:prstGeom prst="rect">
+            <a:avLst/>
+          </a:prstGeom>
+          <a:noFill/>
+          <a:ln/>
+        </p:spPr>
+        <p:txBody>
+          <a:bodyPr wrap="square" lIns="0" tIns="0" rIns="0" bIns="0" rtlCol="0" anchor="t"/>
+          <a:lstStyle/>
+          <a:p>
+            <a:pPr algn="ctr" indent="0" marL="0">
+              <a:lnSpc>
+                <a:spcPct val="115000"/>
+              </a:lnSpc>
+              <a:buNone/>
+            </a:pPr>
+            <a:r>
+              <a:rPr lang="en-US" sz="1800" dirty="0">
+                <a:solidFill>
+                  <a:srgbClr val="5A6166"/>
+                </a:solidFill>
+                <a:latin typeface="Inter" pitchFamily="34" charset="0"/>
+                <a:ea typeface="Inter" pitchFamily="34" charset="-122"/>
+                <a:cs typeface="Inter" pitchFamily="34" charset="-120"/>
+              </a:rPr>
+              <a:t>Rolle her</a:t>
+            </a:r>
+            <a:endParaRPr lang="en-US" sz="1800" dirty="0"/>
+          </a:p>
+        </p:txBody>
+      </p:sp>
+      <p:pic>
+        <p:nvPicPr>
+          <p:cNvPr id="17" name="Image 3" descr="C:\Code\Work\startuplab-partner-presentation\pptx-templates\media\logo-red.png">    </p:cNvPr>
+          <p:cNvPicPr>
+            <a:picLocks noChangeAspect="1"/>
+          </p:cNvPicPr>
+          <p:nvPr/>
+        </p:nvPicPr>
+        <p:blipFill>
+          <a:blip r:embed="rId4"/>
+          <a:stretch>
+            <a:fillRect/>
+          </a:stretch>
+        </p:blipFill>
+        <p:spPr>
+          <a:xfrm>
+            <a:off x="777240" y="6035040"/>
+            <a:ext cx="843006" cy="310896"/>
+          </a:xfrm>
+          <a:prstGeom prst="rect">
+            <a:avLst/>
+          </a:prstGeom>
+        </p:spPr>
+      </p:pic>
+    </p:spTree>
+  </p:cSld>
+  <p:clrMapOvr>
+    <a:masterClrMapping/>
+  </p:clrMapOvr>
+</p:sld>
+</file>
+
+<file path=ppt/slides/slide17.xml><?xml version="1.0" encoding="utf-8"?>
+<p:sld xmlns:a="http://schemas.openxmlformats.org/drawingml/2006/main" xmlns:r="http://schemas.openxmlformats.org/officeDocument/2006/relationships" xmlns:p="http://schemas.openxmlformats.org/presentationml/2006/main">
+  <p:cSld name="Slide 17">
     <p:bg>
       <p:bgPr>
         <a:solidFill>
@@ -5230,9 +5648,9 @@
 </p:sld>
 </file>
 
-<file path=ppt/slides/slide17.xml><?xml version="1.0" encoding="utf-8"?>
+<file path=ppt/slides/slide18.xml><?xml version="1.0" encoding="utf-8"?>
 <p:sld xmlns:a="http://schemas.openxmlformats.org/drawingml/2006/main" xmlns:r="http://schemas.openxmlformats.org/officeDocument/2006/relationships" xmlns:p="http://schemas.openxmlformats.org/presentationml/2006/main">
-  <p:cSld name="Slide 17">
+  <p:cSld name="Slide 18">
     <p:bg>
       <p:bgPr>
         <a:solidFill>

</xml_diff>

<commit_message>
Stram bokstavavstanden på kickeren, og ta med begge portrettformene
Kickeren gikk fra 2,5 til 1,8 i bokstavavstand. Valgt visuelt ved å se samme
tekst i fem trinn ved siden av hverandre, ikke ut fra en tabell: 2,5 spriket
tydelig, 1,8 leser fortsatt som en etikett. Overskriftene er urørt.

Teamsliden finnes nå i to utgaver i selve decket, slide 16 og 17: runde
portretter og avrundede firkanter. Formen styres av et argument til malen, ikke
av SL_RUNDE, slik at begge er tilgjengelige i begge utgavene av decket.

contact-sheet.py tar nå mappe og utdatafil som argumenter. Et forsøk på å
gjenbruke det uten argumenter byttet navn på render-mappene rundt kallet, og
da ett navnebytte feilet fordi målet fantes, lå mappene igjen ombyttet og
oversikten ble merket som den skarpe når den var den avrundede.
</commit_message>
<xml_diff>
--- a/pptx-templates/Startuplab-slidemaler.pptx
+++ b/pptx-templates/Startuplab-slidemaler.pptx
@@ -23,9 +23,10 @@
     <p:sldId id="271" r:id="rId17"/>
     <p:sldId id="272" r:id="rId18"/>
     <p:sldId id="273" r:id="rId19"/>
+    <p:sldId id="274" r:id="rId20"/>
   </p:sldIdLst>
   <p:notesMasterIdLst>
-    <p:notesMasterId r:id="rId20"/>
+    <p:notesMasterId r:id="rId21"/>
   </p:notesMasterIdLst>
   <p:sldSz cx="12192000" cy="6858000"/>
   <p:notesSz cx="6858000" cy="12192000"/>
@@ -1135,7 +1136,7 @@
           <a:p>
             <a:r>
               <a:rPr lang="en-US" dirty="0"/>
-              <a:t>FOLK. Fire portretter spenner fra marg til marg. Bytt portrett: høyreklikk &gt; Endre bilde, den runde masken følger med. Den grå sirkelen er en ledig plass. Sjekk at rollene stemmer før du presenterer.</a:t>
+              <a:t>FOLK, sirkler. Decket har begge formene, så bruk den som passer resten av presentasjonen din, og slett den andre. Fire portretter spenner fra marg til marg. Bytt portrett: høyreklikk &gt; Endre bilde, formen følger med. Den grå plassen er ledig. Sjekk at rollene stemmer før du presenterer.</a:t>
             </a:r>
             <a:endParaRPr lang="en-US" dirty="0"/>
           </a:p>
@@ -1223,7 +1224,7 @@
           <a:p>
             <a:r>
               <a:rPr lang="en-US" dirty="0"/>
-              <a:t>FILM. Slik legger du inn filmen: Sett inn &gt; Video &gt; Denne enheten. Dra filmen så den dekker hele flaten, høyreklikk &gt; Send bakover slik at tittelen og avspillingsmerket blir liggende oppå. Under Avspilling velger du Start automatisk hvis den skal gå av seg selv. Slett den røde sirkelen og trekanten når den ekte filmen er på plass.</a:t>
+              <a:t>FOLK, avrundede firkanter. Decket har begge formene, så bruk den som passer resten av presentasjonen din, og slett den andre. Fire portretter spenner fra marg til marg. Bytt portrett: høyreklikk &gt; Endre bilde, formen følger med. Den grå plassen er ledig. Sjekk at rollene stemmer før du presenterer.</a:t>
             </a:r>
             <a:endParaRPr lang="en-US" dirty="0"/>
           </a:p>
@@ -1311,7 +1312,7 @@
           <a:p>
             <a:r>
               <a:rPr lang="en-US" dirty="0"/>
-              <a:t>AVSLUTNING. La den stå på skjermen mens du tar spørsmål. Legg til e-post eller kontaktperson på linjen under nettadressen hvis salen skal kunne følge opp.</a:t>
+              <a:t>FILM. Slik legger du inn filmen: Sett inn &gt; Video &gt; Denne enheten. Dra filmen så den dekker hele flaten, høyreklikk &gt; Send bakover slik at tittelen og avspillingsmerket blir liggende oppå. Under Avspilling velger du Start automatisk hvis den skal gå av seg selv. Slett den røde sirkelen og trekanten når den ekte filmen er på plass.</a:t>
             </a:r>
             <a:endParaRPr lang="en-US" dirty="0"/>
           </a:p>
@@ -1335,6 +1336,94 @@
             <a:fld id="{F7021451-1387-4CA6-816F-3879F97B5CBC}" type="slidenum">
               <a:rPr lang="en-US"/>
               <a:t>18</a:t>
+            </a:fld>
+            <a:endParaRPr lang="en-US"/>
+          </a:p>
+        </p:txBody>
+      </p:sp>
+    </p:spTree>
+    <p:extLst>
+      <p:ext uri="{BB962C8B-B14F-4D97-AF65-F5344CB8AC3E}">
+        <p14:creationId xmlns:p14="http://schemas.microsoft.com/office/powerpoint/2010/main" val="1024086991"/>
+      </p:ext>
+    </p:extLst>
+  </p:cSld>
+  <p:clrMapOvr>
+    <a:masterClrMapping/>
+  </p:clrMapOvr>
+</p:notes>
+</file>
+
+<file path=ppt/notesSlides/notesSlide19.xml><?xml version="1.0" encoding="utf-8"?>
+<p:notes xmlns:a="http://schemas.openxmlformats.org/drawingml/2006/main" xmlns:r="http://schemas.openxmlformats.org/officeDocument/2006/relationships" xmlns:p="http://schemas.openxmlformats.org/presentationml/2006/main">
+  <p:cSld>
+    <p:spTree>
+      <p:nvGrpSpPr>
+        <p:cNvPr id="1" name=""/>
+        <p:cNvGrpSpPr/>
+        <p:nvPr/>
+      </p:nvGrpSpPr>
+      <p:grpSpPr>
+        <a:xfrm>
+          <a:off x="0" y="0"/>
+          <a:ext cx="0" cy="0"/>
+          <a:chOff x="0" y="0"/>
+          <a:chExt cx="0" cy="0"/>
+        </a:xfrm>
+      </p:grpSpPr>
+      <p:sp>
+        <p:nvSpPr>
+          <p:cNvPr id="2" name="Slide Image Placeholder 1"/>
+          <p:cNvSpPr>
+            <a:spLocks noGrp="1" noRot="1" noChangeAspect="1"/>
+          </p:cNvSpPr>
+          <p:nvPr>
+            <p:ph type="sldImg"/>
+          </p:nvPr>
+        </p:nvSpPr>
+        <p:spPr/>
+      </p:sp>
+      <p:sp>
+        <p:nvSpPr>
+          <p:cNvPr id="3" name="Notes Placeholder 2"/>
+          <p:cNvSpPr>
+            <a:spLocks noGrp="1"/>
+          </p:cNvSpPr>
+          <p:nvPr>
+            <p:ph type="body" idx="1"/>
+          </p:nvPr>
+        </p:nvSpPr>
+        <p:spPr/>
+        <p:txBody>
+          <a:bodyPr/>
+          <a:lstStyle/>
+          <a:p>
+            <a:r>
+              <a:rPr lang="en-US" dirty="0"/>
+              <a:t>AVSLUTNING. La den stå på skjermen mens du tar spørsmål. Legg til e-post eller kontaktperson på linjen under nettadressen hvis salen skal kunne følge opp.</a:t>
+            </a:r>
+            <a:endParaRPr lang="en-US" dirty="0"/>
+          </a:p>
+        </p:txBody>
+      </p:sp>
+      <p:sp>
+        <p:nvSpPr>
+          <p:cNvPr id="4" name="Slide Number Placeholder 3"/>
+          <p:cNvSpPr>
+            <a:spLocks noGrp="1"/>
+          </p:cNvSpPr>
+          <p:nvPr>
+            <p:ph type="sldNum" sz="quarter" idx="10"/>
+          </p:nvPr>
+        </p:nvSpPr>
+        <p:spPr/>
+        <p:txBody>
+          <a:bodyPr/>
+          <a:lstStyle/>
+          <a:p>
+            <a:fld id="{F7021451-1387-4CA6-816F-3879F97B5CBC}" type="slidenum">
+              <a:rPr lang="en-US"/>
+              <a:t>19</a:t>
             </a:fld>
             <a:endParaRPr lang="en-US"/>
           </a:p>
@@ -2451,7 +2540,7 @@
               <a:buNone/>
             </a:pPr>
             <a:r>
-              <a:rPr lang="en-US" sz="1600" b="1" spc="250" kern="0" dirty="0">
+              <a:rPr lang="en-US" sz="1600" b="1" spc="180" kern="0" dirty="0">
                 <a:solidFill>
                   <a:srgbClr val="FFFFFF"/>
                 </a:solidFill>
@@ -2705,7 +2794,7 @@
               <a:buNone/>
             </a:pPr>
             <a:r>
-              <a:rPr lang="en-US" sz="1600" b="1" spc="250" kern="0" dirty="0">
+              <a:rPr lang="en-US" sz="1600" b="1" spc="180" kern="0" dirty="0">
                 <a:solidFill>
                   <a:srgbClr val="FF3333"/>
                 </a:solidFill>
@@ -2990,7 +3079,7 @@
               <a:buNone/>
             </a:pPr>
             <a:r>
-              <a:rPr lang="en-US" sz="1600" b="1" spc="250" kern="0" dirty="0">
+              <a:rPr lang="en-US" sz="1600" b="1" spc="180" kern="0" dirty="0">
                 <a:solidFill>
                   <a:srgbClr val="FF3333"/>
                 </a:solidFill>
@@ -3298,7 +3387,7 @@
               <a:buNone/>
             </a:pPr>
             <a:r>
-              <a:rPr lang="en-US" sz="1600" b="1" spc="250" kern="0" dirty="0">
+              <a:rPr lang="en-US" sz="1600" b="1" spc="180" kern="0" dirty="0">
                 <a:solidFill>
                   <a:srgbClr val="FF3333"/>
                 </a:solidFill>
@@ -3772,7 +3861,7 @@
               <a:buNone/>
             </a:pPr>
             <a:r>
-              <a:rPr lang="en-US" sz="1600" b="1" spc="250" kern="0" dirty="0">
+              <a:rPr lang="en-US" sz="1600" b="1" spc="180" kern="0" dirty="0">
                 <a:solidFill>
                   <a:srgbClr val="FF3333"/>
                 </a:solidFill>
@@ -4238,7 +4327,7 @@
               <a:buNone/>
             </a:pPr>
             <a:r>
-              <a:rPr lang="en-US" sz="1600" b="1" spc="250" kern="0" dirty="0">
+              <a:rPr lang="en-US" sz="1600" b="1" spc="180" kern="0" dirty="0">
                 <a:solidFill>
                   <a:srgbClr val="FF3333"/>
                 </a:solidFill>
@@ -4855,7 +4944,7 @@
               <a:buNone/>
             </a:pPr>
             <a:r>
-              <a:rPr lang="en-US" sz="1600" b="1" spc="250" kern="0" dirty="0">
+              <a:rPr lang="en-US" sz="1600" b="1" spc="180" kern="0" dirty="0">
                 <a:solidFill>
                   <a:srgbClr val="FF3333"/>
                 </a:solidFill>
@@ -5443,6 +5532,645 @@
 <file path=ppt/slides/slide17.xml><?xml version="1.0" encoding="utf-8"?>
 <p:sld xmlns:a="http://schemas.openxmlformats.org/drawingml/2006/main" xmlns:r="http://schemas.openxmlformats.org/officeDocument/2006/relationships" xmlns:p="http://schemas.openxmlformats.org/presentationml/2006/main">
   <p:cSld name="Slide 17">
+    <p:bg>
+      <p:bgPr>
+        <a:solidFill>
+          <a:srgbClr val="FFFFFF"/>
+        </a:solidFill>
+      </p:bgPr>
+    </p:bg>
+    <p:spTree>
+      <p:nvGrpSpPr>
+        <p:cNvPr id="1" name=""/>
+        <p:cNvGrpSpPr/>
+        <p:nvPr/>
+      </p:nvGrpSpPr>
+      <p:grpSpPr>
+        <a:xfrm>
+          <a:off x="0" y="0"/>
+          <a:ext cx="0" cy="0"/>
+          <a:chOff x="0" y="0"/>
+          <a:chExt cx="0" cy="0"/>
+        </a:xfrm>
+      </p:grpSpPr>
+      <p:sp>
+        <p:nvSpPr>
+          <p:cNvPr id="2" name="Text 0"/>
+          <p:cNvSpPr/>
+          <p:nvPr/>
+        </p:nvSpPr>
+        <p:spPr>
+          <a:xfrm>
+            <a:off x="777240" y="713232"/>
+            <a:ext cx="8229600" cy="292608"/>
+          </a:xfrm>
+          <a:prstGeom prst="rect">
+            <a:avLst/>
+          </a:prstGeom>
+          <a:noFill/>
+          <a:ln/>
+        </p:spPr>
+        <p:txBody>
+          <a:bodyPr wrap="square" lIns="0" tIns="0" rIns="0" bIns="0" rtlCol="0" anchor="ctr"/>
+          <a:lstStyle/>
+          <a:p>
+            <a:pPr indent="0" marL="0">
+              <a:buNone/>
+            </a:pPr>
+            <a:r>
+              <a:rPr lang="en-US" sz="1600" b="1" spc="180" kern="0" dirty="0">
+                <a:solidFill>
+                  <a:srgbClr val="FF3333"/>
+                </a:solidFill>
+                <a:latin typeface="Inter" pitchFamily="34" charset="0"/>
+                <a:ea typeface="Inter" pitchFamily="34" charset="-122"/>
+                <a:cs typeface="Inter" pitchFamily="34" charset="-120"/>
+              </a:rPr>
+              <a:t>TEAMET</a:t>
+            </a:r>
+            <a:endParaRPr lang="en-US" sz="1600" dirty="0"/>
+          </a:p>
+        </p:txBody>
+      </p:sp>
+      <p:sp>
+        <p:nvSpPr>
+          <p:cNvPr id="3" name="Text 1"/>
+          <p:cNvSpPr/>
+          <p:nvPr/>
+        </p:nvSpPr>
+        <p:spPr>
+          <a:xfrm>
+            <a:off x="777240" y="1051560"/>
+            <a:ext cx="10424160" cy="777240"/>
+          </a:xfrm>
+          <a:prstGeom prst="rect">
+            <a:avLst/>
+          </a:prstGeom>
+          <a:noFill/>
+          <a:ln/>
+        </p:spPr>
+        <p:txBody>
+          <a:bodyPr wrap="square" lIns="0" tIns="0" rIns="0" bIns="0" rtlCol="0" anchor="t"/>
+          <a:lstStyle/>
+          <a:p>
+            <a:pPr indent="0" marL="0">
+              <a:lnSpc>
+                <a:spcPct val="100000"/>
+              </a:lnSpc>
+              <a:buNone/>
+            </a:pPr>
+            <a:r>
+              <a:rPr lang="en-US" sz="4000" b="1" dirty="0">
+                <a:solidFill>
+                  <a:srgbClr val="131415"/>
+                </a:solidFill>
+                <a:latin typeface="Replica LL TT" pitchFamily="34" charset="0"/>
+                <a:ea typeface="Replica LL TT" pitchFamily="34" charset="-122"/>
+                <a:cs typeface="Replica LL TT" pitchFamily="34" charset="-120"/>
+              </a:rPr>
+              <a:t>Folkene du kommer til å </a:t>
+            </a:r>
+            <a:pPr indent="0" marL="0">
+              <a:lnSpc>
+                <a:spcPct val="100000"/>
+              </a:lnSpc>
+              <a:buNone/>
+            </a:pPr>
+            <a:r>
+              <a:rPr lang="en-US" sz="4000" b="1" dirty="0">
+                <a:solidFill>
+                  <a:srgbClr val="FF3333"/>
+                </a:solidFill>
+                <a:latin typeface="Replica LL TT" pitchFamily="34" charset="0"/>
+                <a:ea typeface="Replica LL TT" pitchFamily="34" charset="-122"/>
+                <a:cs typeface="Replica LL TT" pitchFamily="34" charset="-120"/>
+              </a:rPr>
+              <a:t>jobbe med</a:t>
+            </a:r>
+            <a:endParaRPr lang="en-US" sz="4000" dirty="0"/>
+          </a:p>
+        </p:txBody>
+      </p:sp>
+      <p:pic>
+        <p:nvPicPr>
+          <p:cNvPr id="4" name="Image 0" descr="C:\Code\Work\startuplab-partner-presentation\pptx-templates\media\portrait-1-rund.png">    </p:cNvPr>
+          <p:cNvPicPr>
+            <a:picLocks noChangeAspect="1"/>
+          </p:cNvPicPr>
+          <p:nvPr/>
+        </p:nvPicPr>
+        <p:blipFill>
+          <a:blip r:embed="rId1"/>
+          <a:stretch>
+            <a:fillRect/>
+          </a:stretch>
+        </p:blipFill>
+        <p:spPr>
+          <a:xfrm>
+            <a:off x="777240" y="2286000"/>
+            <a:ext cx="2240280" cy="2240280"/>
+          </a:xfrm>
+          <a:prstGeom prst="rect">
+            <a:avLst/>
+          </a:prstGeom>
+        </p:spPr>
+      </p:pic>
+      <p:sp>
+        <p:nvSpPr>
+          <p:cNvPr id="5" name="Text 2"/>
+          <p:cNvSpPr/>
+          <p:nvPr/>
+        </p:nvSpPr>
+        <p:spPr>
+          <a:xfrm>
+            <a:off x="777240" y="4727448"/>
+            <a:ext cx="2240280" cy="365760"/>
+          </a:xfrm>
+          <a:prstGeom prst="rect">
+            <a:avLst/>
+          </a:prstGeom>
+          <a:noFill/>
+          <a:ln/>
+        </p:spPr>
+        <p:txBody>
+          <a:bodyPr wrap="square" lIns="0" tIns="0" rIns="0" bIns="0" rtlCol="0" anchor="ctr"/>
+          <a:lstStyle/>
+          <a:p>
+            <a:pPr algn="ctr" indent="0" marL="0">
+              <a:buNone/>
+            </a:pPr>
+            <a:r>
+              <a:rPr lang="en-US" sz="2100" b="1" dirty="0">
+                <a:solidFill>
+                  <a:srgbClr val="131415"/>
+                </a:solidFill>
+                <a:latin typeface="Replica LL TT" pitchFamily="34" charset="0"/>
+                <a:ea typeface="Replica LL TT" pitchFamily="34" charset="-122"/>
+                <a:cs typeface="Replica LL TT" pitchFamily="34" charset="-120"/>
+              </a:rPr>
+              <a:t>Christina Wiig</a:t>
+            </a:r>
+            <a:endParaRPr lang="en-US" sz="2100" dirty="0"/>
+          </a:p>
+        </p:txBody>
+      </p:sp>
+      <p:sp>
+        <p:nvSpPr>
+          <p:cNvPr id="6" name="Text 3"/>
+          <p:cNvSpPr/>
+          <p:nvPr/>
+        </p:nvSpPr>
+        <p:spPr>
+          <a:xfrm>
+            <a:off x="777240" y="5093208"/>
+            <a:ext cx="2240280" cy="694944"/>
+          </a:xfrm>
+          <a:prstGeom prst="rect">
+            <a:avLst/>
+          </a:prstGeom>
+          <a:noFill/>
+          <a:ln/>
+        </p:spPr>
+        <p:txBody>
+          <a:bodyPr wrap="square" lIns="0" tIns="0" rIns="0" bIns="0" rtlCol="0" anchor="t"/>
+          <a:lstStyle/>
+          <a:p>
+            <a:pPr algn="ctr" indent="0" marL="0">
+              <a:lnSpc>
+                <a:spcPct val="115000"/>
+              </a:lnSpc>
+              <a:buNone/>
+            </a:pPr>
+            <a:r>
+              <a:rPr lang="en-US" sz="1800" dirty="0">
+                <a:solidFill>
+                  <a:srgbClr val="5A6166"/>
+                </a:solidFill>
+                <a:latin typeface="Inter" pitchFamily="34" charset="0"/>
+                <a:ea typeface="Inter" pitchFamily="34" charset="-122"/>
+                <a:cs typeface="Inter" pitchFamily="34" charset="-120"/>
+              </a:rPr>
+              <a:t>Head of Corporate Partnerships</a:t>
+            </a:r>
+            <a:endParaRPr lang="en-US" sz="1800" dirty="0"/>
+          </a:p>
+        </p:txBody>
+      </p:sp>
+      <p:pic>
+        <p:nvPicPr>
+          <p:cNvPr id="7" name="Image 1" descr="C:\Code\Work\startuplab-partner-presentation\pptx-templates\media\portrait-2-rund.png">    </p:cNvPr>
+          <p:cNvPicPr>
+            <a:picLocks noChangeAspect="1"/>
+          </p:cNvPicPr>
+          <p:nvPr/>
+        </p:nvPicPr>
+        <p:blipFill>
+          <a:blip r:embed="rId2"/>
+          <a:stretch>
+            <a:fillRect/>
+          </a:stretch>
+        </p:blipFill>
+        <p:spPr>
+          <a:xfrm>
+            <a:off x="3576218" y="2286000"/>
+            <a:ext cx="2240280" cy="2240280"/>
+          </a:xfrm>
+          <a:prstGeom prst="rect">
+            <a:avLst/>
+          </a:prstGeom>
+        </p:spPr>
+      </p:pic>
+      <p:sp>
+        <p:nvSpPr>
+          <p:cNvPr id="8" name="Text 4"/>
+          <p:cNvSpPr/>
+          <p:nvPr/>
+        </p:nvSpPr>
+        <p:spPr>
+          <a:xfrm>
+            <a:off x="3576218" y="4727448"/>
+            <a:ext cx="2240280" cy="365760"/>
+          </a:xfrm>
+          <a:prstGeom prst="rect">
+            <a:avLst/>
+          </a:prstGeom>
+          <a:noFill/>
+          <a:ln/>
+        </p:spPr>
+        <p:txBody>
+          <a:bodyPr wrap="square" lIns="0" tIns="0" rIns="0" bIns="0" rtlCol="0" anchor="ctr"/>
+          <a:lstStyle/>
+          <a:p>
+            <a:pPr algn="ctr" indent="0" marL="0">
+              <a:buNone/>
+            </a:pPr>
+            <a:r>
+              <a:rPr lang="en-US" sz="2100" b="1" dirty="0">
+                <a:solidFill>
+                  <a:srgbClr val="131415"/>
+                </a:solidFill>
+                <a:latin typeface="Replica LL TT" pitchFamily="34" charset="0"/>
+                <a:ea typeface="Replica LL TT" pitchFamily="34" charset="-122"/>
+                <a:cs typeface="Replica LL TT" pitchFamily="34" charset="-120"/>
+              </a:rPr>
+              <a:t>Anniken Holst</a:t>
+            </a:r>
+            <a:endParaRPr lang="en-US" sz="2100" dirty="0"/>
+          </a:p>
+        </p:txBody>
+      </p:sp>
+      <p:sp>
+        <p:nvSpPr>
+          <p:cNvPr id="9" name="Text 5"/>
+          <p:cNvSpPr/>
+          <p:nvPr/>
+        </p:nvSpPr>
+        <p:spPr>
+          <a:xfrm>
+            <a:off x="3576218" y="5093208"/>
+            <a:ext cx="2240280" cy="694944"/>
+          </a:xfrm>
+          <a:prstGeom prst="rect">
+            <a:avLst/>
+          </a:prstGeom>
+          <a:noFill/>
+          <a:ln/>
+        </p:spPr>
+        <p:txBody>
+          <a:bodyPr wrap="square" lIns="0" tIns="0" rIns="0" bIns="0" rtlCol="0" anchor="t"/>
+          <a:lstStyle/>
+          <a:p>
+            <a:pPr algn="ctr" indent="0" marL="0">
+              <a:lnSpc>
+                <a:spcPct val="115000"/>
+              </a:lnSpc>
+              <a:buNone/>
+            </a:pPr>
+            <a:r>
+              <a:rPr lang="en-US" sz="1800" dirty="0">
+                <a:solidFill>
+                  <a:srgbClr val="5A6166"/>
+                </a:solidFill>
+                <a:latin typeface="Inter" pitchFamily="34" charset="0"/>
+                <a:ea typeface="Inter" pitchFamily="34" charset="-122"/>
+                <a:cs typeface="Inter" pitchFamily="34" charset="-120"/>
+              </a:rPr>
+              <a:t>Partner Manager</a:t>
+            </a:r>
+            <a:endParaRPr lang="en-US" sz="1800" dirty="0"/>
+          </a:p>
+        </p:txBody>
+      </p:sp>
+      <p:pic>
+        <p:nvPicPr>
+          <p:cNvPr id="10" name="Image 2" descr="C:\Code\Work\startuplab-partner-presentation\pptx-templates\media\portrait-3-rund.png">    </p:cNvPr>
+          <p:cNvPicPr>
+            <a:picLocks noChangeAspect="1"/>
+          </p:cNvPicPr>
+          <p:nvPr/>
+        </p:nvPicPr>
+        <p:blipFill>
+          <a:blip r:embed="rId3"/>
+          <a:stretch>
+            <a:fillRect/>
+          </a:stretch>
+        </p:blipFill>
+        <p:spPr>
+          <a:xfrm>
+            <a:off x="6375197" y="2286000"/>
+            <a:ext cx="2240280" cy="2240280"/>
+          </a:xfrm>
+          <a:prstGeom prst="rect">
+            <a:avLst/>
+          </a:prstGeom>
+        </p:spPr>
+      </p:pic>
+      <p:sp>
+        <p:nvSpPr>
+          <p:cNvPr id="11" name="Text 6"/>
+          <p:cNvSpPr/>
+          <p:nvPr/>
+        </p:nvSpPr>
+        <p:spPr>
+          <a:xfrm>
+            <a:off x="6375197" y="4727448"/>
+            <a:ext cx="2240280" cy="365760"/>
+          </a:xfrm>
+          <a:prstGeom prst="rect">
+            <a:avLst/>
+          </a:prstGeom>
+          <a:noFill/>
+          <a:ln/>
+        </p:spPr>
+        <p:txBody>
+          <a:bodyPr wrap="square" lIns="0" tIns="0" rIns="0" bIns="0" rtlCol="0" anchor="ctr"/>
+          <a:lstStyle/>
+          <a:p>
+            <a:pPr algn="ctr" indent="0" marL="0">
+              <a:buNone/>
+            </a:pPr>
+            <a:r>
+              <a:rPr lang="en-US" sz="2100" b="1" dirty="0">
+                <a:solidFill>
+                  <a:srgbClr val="131415"/>
+                </a:solidFill>
+                <a:latin typeface="Replica LL TT" pitchFamily="34" charset="0"/>
+                <a:ea typeface="Replica LL TT" pitchFamily="34" charset="-122"/>
+                <a:cs typeface="Replica LL TT" pitchFamily="34" charset="-120"/>
+              </a:rPr>
+              <a:t>Ola Jacobsen</a:t>
+            </a:r>
+            <a:endParaRPr lang="en-US" sz="2100" dirty="0"/>
+          </a:p>
+        </p:txBody>
+      </p:sp>
+      <p:sp>
+        <p:nvSpPr>
+          <p:cNvPr id="12" name="Text 7"/>
+          <p:cNvSpPr/>
+          <p:nvPr/>
+        </p:nvSpPr>
+        <p:spPr>
+          <a:xfrm>
+            <a:off x="6375197" y="5093208"/>
+            <a:ext cx="2240280" cy="694944"/>
+          </a:xfrm>
+          <a:prstGeom prst="rect">
+            <a:avLst/>
+          </a:prstGeom>
+          <a:noFill/>
+          <a:ln/>
+        </p:spPr>
+        <p:txBody>
+          <a:bodyPr wrap="square" lIns="0" tIns="0" rIns="0" bIns="0" rtlCol="0" anchor="t"/>
+          <a:lstStyle/>
+          <a:p>
+            <a:pPr algn="ctr" indent="0" marL="0">
+              <a:lnSpc>
+                <a:spcPct val="115000"/>
+              </a:lnSpc>
+              <a:buNone/>
+            </a:pPr>
+            <a:r>
+              <a:rPr lang="en-US" sz="1800" dirty="0">
+                <a:solidFill>
+                  <a:srgbClr val="5A6166"/>
+                </a:solidFill>
+                <a:latin typeface="Inter" pitchFamily="34" charset="0"/>
+                <a:ea typeface="Inter" pitchFamily="34" charset="-122"/>
+                <a:cs typeface="Inter" pitchFamily="34" charset="-120"/>
+              </a:rPr>
+              <a:t>Partner Manager</a:t>
+            </a:r>
+            <a:endParaRPr lang="en-US" sz="1800" dirty="0"/>
+          </a:p>
+        </p:txBody>
+      </p:sp>
+      <p:sp>
+        <p:nvSpPr>
+          <p:cNvPr id="13" name="Shape 8"/>
+          <p:cNvSpPr/>
+          <p:nvPr/>
+        </p:nvSpPr>
+        <p:spPr>
+          <a:xfrm>
+            <a:off x="9174175" y="2286000"/>
+            <a:ext cx="2240280" cy="2240280"/>
+          </a:xfrm>
+          <a:prstGeom prst="roundRect">
+            <a:avLst>
+              <a:gd name="adj" fmla="val 4332"/>
+            </a:avLst>
+          </a:prstGeom>
+          <a:solidFill>
+            <a:srgbClr val="F0F0F0"/>
+          </a:solidFill>
+          <a:ln w="12700">
+            <a:solidFill>
+              <a:srgbClr val="D8DCDF"/>
+            </a:solidFill>
+            <a:prstDash val="solid"/>
+          </a:ln>
+        </p:spPr>
+      </p:sp>
+      <p:sp>
+        <p:nvSpPr>
+          <p:cNvPr id="14" name="Text 9"/>
+          <p:cNvSpPr/>
+          <p:nvPr/>
+        </p:nvSpPr>
+        <p:spPr>
+          <a:xfrm>
+            <a:off x="9174175" y="2994660"/>
+            <a:ext cx="2240280" cy="822960"/>
+          </a:xfrm>
+          <a:prstGeom prst="rect">
+            <a:avLst/>
+          </a:prstGeom>
+          <a:noFill/>
+          <a:ln/>
+        </p:spPr>
+        <p:txBody>
+          <a:bodyPr wrap="square" lIns="0" tIns="0" rIns="0" bIns="0" rtlCol="0" anchor="ctr"/>
+          <a:lstStyle/>
+          <a:p>
+            <a:pPr algn="ctr" indent="0" marL="0">
+              <a:lnSpc>
+                <a:spcPct val="120000"/>
+              </a:lnSpc>
+              <a:buNone/>
+            </a:pPr>
+            <a:r>
+              <a:rPr lang="en-US" sz="1800" dirty="0">
+                <a:solidFill>
+                  <a:srgbClr val="5A6166"/>
+                </a:solidFill>
+                <a:latin typeface="Inter" pitchFamily="34" charset="0"/>
+                <a:ea typeface="Inter" pitchFamily="34" charset="-122"/>
+                <a:cs typeface="Inter" pitchFamily="34" charset="-120"/>
+              </a:rPr>
+              <a:t>Sett inn</a:t>
+            </a:r>
+            <a:endParaRPr lang="en-US" sz="1800" dirty="0"/>
+          </a:p>
+          <a:p>
+            <a:pPr algn="ctr" indent="0" marL="0">
+              <a:lnSpc>
+                <a:spcPct val="120000"/>
+              </a:lnSpc>
+              <a:buNone/>
+            </a:pPr>
+            <a:r>
+              <a:rPr lang="en-US" sz="1800" dirty="0">
+                <a:solidFill>
+                  <a:srgbClr val="5A6166"/>
+                </a:solidFill>
+                <a:latin typeface="Inter" pitchFamily="34" charset="0"/>
+                <a:ea typeface="Inter" pitchFamily="34" charset="-122"/>
+                <a:cs typeface="Inter" pitchFamily="34" charset="-120"/>
+              </a:rPr>
+              <a:t>portrett</a:t>
+            </a:r>
+            <a:endParaRPr lang="en-US" sz="1800" dirty="0"/>
+          </a:p>
+        </p:txBody>
+      </p:sp>
+      <p:sp>
+        <p:nvSpPr>
+          <p:cNvPr id="15" name="Text 10"/>
+          <p:cNvSpPr/>
+          <p:nvPr/>
+        </p:nvSpPr>
+        <p:spPr>
+          <a:xfrm>
+            <a:off x="9174175" y="4727448"/>
+            <a:ext cx="2240280" cy="365760"/>
+          </a:xfrm>
+          <a:prstGeom prst="rect">
+            <a:avLst/>
+          </a:prstGeom>
+          <a:noFill/>
+          <a:ln/>
+        </p:spPr>
+        <p:txBody>
+          <a:bodyPr wrap="square" lIns="0" tIns="0" rIns="0" bIns="0" rtlCol="0" anchor="ctr"/>
+          <a:lstStyle/>
+          <a:p>
+            <a:pPr algn="ctr" indent="0" marL="0">
+              <a:buNone/>
+            </a:pPr>
+            <a:r>
+              <a:rPr lang="en-US" sz="2100" b="1" dirty="0">
+                <a:solidFill>
+                  <a:srgbClr val="131415"/>
+                </a:solidFill>
+                <a:latin typeface="Replica LL TT" pitchFamily="34" charset="0"/>
+                <a:ea typeface="Replica LL TT" pitchFamily="34" charset="-122"/>
+                <a:cs typeface="Replica LL TT" pitchFamily="34" charset="-120"/>
+              </a:rPr>
+              <a:t>Navn Navnesen</a:t>
+            </a:r>
+            <a:endParaRPr lang="en-US" sz="2100" dirty="0"/>
+          </a:p>
+        </p:txBody>
+      </p:sp>
+      <p:sp>
+        <p:nvSpPr>
+          <p:cNvPr id="16" name="Text 11"/>
+          <p:cNvSpPr/>
+          <p:nvPr/>
+        </p:nvSpPr>
+        <p:spPr>
+          <a:xfrm>
+            <a:off x="9174175" y="5093208"/>
+            <a:ext cx="2240280" cy="694944"/>
+          </a:xfrm>
+          <a:prstGeom prst="rect">
+            <a:avLst/>
+          </a:prstGeom>
+          <a:noFill/>
+          <a:ln/>
+        </p:spPr>
+        <p:txBody>
+          <a:bodyPr wrap="square" lIns="0" tIns="0" rIns="0" bIns="0" rtlCol="0" anchor="t"/>
+          <a:lstStyle/>
+          <a:p>
+            <a:pPr algn="ctr" indent="0" marL="0">
+              <a:lnSpc>
+                <a:spcPct val="115000"/>
+              </a:lnSpc>
+              <a:buNone/>
+            </a:pPr>
+            <a:r>
+              <a:rPr lang="en-US" sz="1800" dirty="0">
+                <a:solidFill>
+                  <a:srgbClr val="5A6166"/>
+                </a:solidFill>
+                <a:latin typeface="Inter" pitchFamily="34" charset="0"/>
+                <a:ea typeface="Inter" pitchFamily="34" charset="-122"/>
+                <a:cs typeface="Inter" pitchFamily="34" charset="-120"/>
+              </a:rPr>
+              <a:t>Rolle her</a:t>
+            </a:r>
+            <a:endParaRPr lang="en-US" sz="1800" dirty="0"/>
+          </a:p>
+        </p:txBody>
+      </p:sp>
+      <p:pic>
+        <p:nvPicPr>
+          <p:cNvPr id="17" name="Image 3" descr="C:\Code\Work\startuplab-partner-presentation\pptx-templates\media\logo-red.png">    </p:cNvPr>
+          <p:cNvPicPr>
+            <a:picLocks noChangeAspect="1"/>
+          </p:cNvPicPr>
+          <p:nvPr/>
+        </p:nvPicPr>
+        <p:blipFill>
+          <a:blip r:embed="rId4"/>
+          <a:stretch>
+            <a:fillRect/>
+          </a:stretch>
+        </p:blipFill>
+        <p:spPr>
+          <a:xfrm>
+            <a:off x="777240" y="6035040"/>
+            <a:ext cx="843006" cy="310896"/>
+          </a:xfrm>
+          <a:prstGeom prst="rect">
+            <a:avLst/>
+          </a:prstGeom>
+        </p:spPr>
+      </p:pic>
+    </p:spTree>
+  </p:cSld>
+  <p:clrMapOvr>
+    <a:masterClrMapping/>
+  </p:clrMapOvr>
+</p:sld>
+</file>
+
+<file path=ppt/slides/slide18.xml><?xml version="1.0" encoding="utf-8"?>
+<p:sld xmlns:a="http://schemas.openxmlformats.org/drawingml/2006/main" xmlns:r="http://schemas.openxmlformats.org/officeDocument/2006/relationships" xmlns:p="http://schemas.openxmlformats.org/presentationml/2006/main">
+  <p:cSld name="Slide 18">
     <p:bg>
       <p:bgPr>
         <a:solidFill>
@@ -5549,7 +6277,7 @@
               <a:buNone/>
             </a:pPr>
             <a:r>
-              <a:rPr lang="en-US" sz="1600" b="1" spc="250" kern="0" dirty="0">
+              <a:rPr lang="en-US" sz="1600" b="1" spc="180" kern="0" dirty="0">
                 <a:solidFill>
                   <a:srgbClr val="FF3333"/>
                 </a:solidFill>
@@ -5648,9 +6376,9 @@
 </p:sld>
 </file>
 
-<file path=ppt/slides/slide18.xml><?xml version="1.0" encoding="utf-8"?>
+<file path=ppt/slides/slide19.xml><?xml version="1.0" encoding="utf-8"?>
 <p:sld xmlns:a="http://schemas.openxmlformats.org/drawingml/2006/main" xmlns:r="http://schemas.openxmlformats.org/officeDocument/2006/relationships" xmlns:p="http://schemas.openxmlformats.org/presentationml/2006/main">
-  <p:cSld name="Slide 18">
+  <p:cSld name="Slide 19">
     <p:bg>
       <p:bgPr>
         <a:solidFill>
@@ -5831,7 +6559,7 @@
               <a:buNone/>
             </a:pPr>
             <a:r>
-              <a:rPr lang="en-US" sz="1600" b="1" spc="250" kern="0" dirty="0">
+              <a:rPr lang="en-US" sz="1600" b="1" spc="180" kern="0" dirty="0">
                 <a:solidFill>
                   <a:srgbClr val="FF3333"/>
                 </a:solidFill>
@@ -6436,7 +7164,7 @@
               <a:buNone/>
             </a:pPr>
             <a:r>
-              <a:rPr lang="en-US" sz="1600" b="1" spc="250" kern="0" dirty="0">
+              <a:rPr lang="en-US" sz="1600" b="1" spc="180" kern="0" dirty="0">
                 <a:solidFill>
                   <a:srgbClr val="FFFFFF"/>
                 </a:solidFill>
@@ -6593,7 +7321,7 @@
               <a:buNone/>
             </a:pPr>
             <a:r>
-              <a:rPr lang="en-US" sz="1600" b="1" spc="250" kern="0" dirty="0">
+              <a:rPr lang="en-US" sz="1600" b="1" spc="180" kern="0" dirty="0">
                 <a:solidFill>
                   <a:srgbClr val="FF3333"/>
                 </a:solidFill>
@@ -6834,7 +7562,7 @@
               <a:buNone/>
             </a:pPr>
             <a:r>
-              <a:rPr lang="en-US" sz="1600" b="1" spc="250" kern="0" dirty="0">
+              <a:rPr lang="en-US" sz="1600" b="1" spc="180" kern="0" dirty="0">
                 <a:solidFill>
                   <a:srgbClr val="FF3333"/>
                 </a:solidFill>
@@ -7278,7 +8006,7 @@
               <a:buNone/>
             </a:pPr>
             <a:r>
-              <a:rPr lang="en-US" sz="1600" b="1" spc="250" kern="0" dirty="0">
+              <a:rPr lang="en-US" sz="1600" b="1" spc="180" kern="0" dirty="0">
                 <a:solidFill>
                   <a:srgbClr val="FFFFFF"/>
                 </a:solidFill>
@@ -7458,7 +8186,7 @@
               <a:buNone/>
             </a:pPr>
             <a:r>
-              <a:rPr lang="en-US" sz="1600" b="1" spc="250" kern="0" dirty="0">
+              <a:rPr lang="en-US" sz="1600" b="1" spc="180" kern="0" dirty="0">
                 <a:solidFill>
                   <a:srgbClr val="FF3333"/>
                 </a:solidFill>
@@ -7674,7 +8402,7 @@
               <a:buNone/>
             </a:pPr>
             <a:r>
-              <a:rPr lang="en-US" sz="1600" b="1" spc="250" kern="0" dirty="0">
+              <a:rPr lang="en-US" sz="1600" b="1" spc="180" kern="0" dirty="0">
                 <a:solidFill>
                   <a:srgbClr val="FF3333"/>
                 </a:solidFill>
@@ -8248,7 +8976,7 @@
               <a:buNone/>
             </a:pPr>
             <a:r>
-              <a:rPr lang="en-US" sz="1600" b="1" spc="250" kern="0" dirty="0">
+              <a:rPr lang="en-US" sz="1600" b="1" spc="180" kern="0" dirty="0">
                 <a:solidFill>
                   <a:srgbClr val="FF3333"/>
                 </a:solidFill>

</xml_diff>

<commit_message>
Legg til teamslide med fem portretter og avrundede hjørner
Egen mal, ikke en variant av fire-på-rad: med fem portretter må bildebredden,
mellomrommet og navnestørrelsen ned, ellers sprekker navnene ut av kolonnene.
Portrettene har egne bildefiler fordi hjørnradiusen regnes ut fra
visningsbredden, som er smalere her.

Rolleboksen er 0,32 tommer bredere enn portrettet og sentrert over det. Med
bare portrettbredden brakk «Head of Corporate Partnerships» til tre linjer
mens naboene hadde én, og raden ble skjev. Alternativet var å korte ned en
ekte tittel, som ikke er vår å endre.

build-en-mal.js bygger én mal til sin egen fil. Trengs når hovedfilene er
åpne i PowerPoint: da kan de ikke skrives til, og en full ombygging ville
uansett overskrevet innhold som er fylt inn manuelt.

Malen er lagt til i slides-light.js, men hovedfilene er IKKE bygget på nytt,
siden Christina fyller inn innhold i dem nå.
</commit_message>
<xml_diff>
--- a/pptx-templates/Startuplab-slidemaler.pptx
+++ b/pptx-templates/Startuplab-slidemaler.pptx
@@ -4,6 +4,9 @@
   <p:sldMasterIdLst>
     <p:sldMasterId id="2147483648" r:id="rId1"/>
   </p:sldMasterIdLst>
+  <p:notesMasterIdLst>
+    <p:notesMasterId r:id="rId21"/>
+  </p:notesMasterIdLst>
   <p:sldIdLst>
     <p:sldId id="256" r:id="rId2"/>
     <p:sldId id="257" r:id="rId3"/>
@@ -25,9 +28,6 @@
     <p:sldId id="273" r:id="rId19"/>
     <p:sldId id="274" r:id="rId20"/>
   </p:sldIdLst>
-  <p:notesMasterIdLst>
-    <p:notesMasterId r:id="rId21"/>
-  </p:notesMasterIdLst>
   <p:sldSz cx="12192000" cy="6858000"/>
   <p:notesSz cx="6858000" cy="12192000"/>
   <p:defaultTextStyle>
@@ -122,6 +122,11 @@
       </a:defRPr>
     </a:lvl9pPr>
   </p:defaultTextStyle>
+  <p:extLst>
+    <p:ext uri="{EFAFB233-063F-42B5-8137-9DF3F51BA10A}">
+      <p15:sldGuideLst xmlns:p15="http://schemas.microsoft.com/office/powerpoint/2012/main"/>
+    </p:ext>
+  </p:extLst>
 </p:presentation>
 </file>
 
@@ -147,234 +152,10 @@
           <a:chExt cx="0" cy="0"/>
         </a:xfrm>
       </p:grpSpPr>
-      <p:sp>
-        <p:nvSpPr>
-          <p:cNvPr id="2" name="Header Placeholder 1"/>
-          <p:cNvSpPr>
-            <a:spLocks noGrp="1"/>
-          </p:cNvSpPr>
-          <p:nvPr>
-            <p:ph type="hdr" sz="quarter"/>
-          </p:nvPr>
-        </p:nvSpPr>
-        <p:spPr>
-          <a:xfrm>
-            <a:off x="0" y="0"/>
-            <a:ext cx="2971800" cy="458788"/>
-          </a:xfrm>
-          <a:prstGeom prst="rect">
-            <a:avLst/>
-          </a:prstGeom>
-        </p:spPr>
-        <p:txBody>
-          <a:bodyPr vert="horz" lIns="91440" tIns="45720" rIns="91440" bIns="45720" rtlCol="0"/>
-          <a:lstStyle>
-            <a:lvl1pPr algn="l">
-              <a:defRPr sz="1200"/>
-            </a:lvl1pPr>
-          </a:lstStyle>
-          <a:p>
-            <a:endParaRPr lang="en-US"/>
-          </a:p>
-        </p:txBody>
-      </p:sp>
-      <p:sp>
-        <p:nvSpPr>
-          <p:cNvPr id="3" name="Date Placeholder 2"/>
-          <p:cNvSpPr>
-            <a:spLocks noGrp="1"/>
-          </p:cNvSpPr>
-          <p:nvPr>
-            <p:ph type="dt" idx="1"/>
-          </p:nvPr>
-        </p:nvSpPr>
-        <p:spPr>
-          <a:xfrm>
-            <a:off x="3884613" y="0"/>
-            <a:ext cx="2971800" cy="458788"/>
-          </a:xfrm>
-          <a:prstGeom prst="rect">
-            <a:avLst/>
-          </a:prstGeom>
-        </p:spPr>
-        <p:txBody>
-          <a:bodyPr vert="horz" lIns="91440" tIns="45720" rIns="91440" bIns="45720" rtlCol="0"/>
-          <a:lstStyle>
-            <a:lvl1pPr algn="r">
-              <a:defRPr sz="1200"/>
-            </a:lvl1pPr>
-          </a:lstStyle>
-          <a:p>
-            <a:fld id="{5282F153-3F37-0F45-9E97-73ACFA13230C}" type="datetimeFigureOut">
-              <a:rPr lang="en-US"/>
-              <a:t>7/23/19</a:t>
-            </a:fld>
-            <a:endParaRPr lang="en-US"/>
-          </a:p>
-        </p:txBody>
-      </p:sp>
-      <p:sp>
-        <p:nvSpPr>
-          <p:cNvPr id="4" name="Slide Image Placeholder 3"/>
-          <p:cNvSpPr>
-            <a:spLocks noGrp="1" noRot="1" noChangeAspect="1"/>
-          </p:cNvSpPr>
-          <p:nvPr>
-            <p:ph type="sldImg" idx="2"/>
-          </p:nvPr>
-        </p:nvSpPr>
-        <p:spPr>
-          <a:xfrm>
-            <a:off x="685800" y="1143000"/>
-            <a:ext cx="5486400" cy="3086100"/>
-          </a:xfrm>
-          <a:prstGeom prst="rect">
-            <a:avLst/>
-          </a:prstGeom>
-          <a:noFill/>
-          <a:ln w="12700">
-            <a:solidFill>
-              <a:prstClr val="black"/>
-            </a:solidFill>
-          </a:ln>
-        </p:spPr>
-        <p:txBody>
-          <a:bodyPr vert="horz" lIns="91440" tIns="45720" rIns="91440" bIns="45720" rtlCol="0" anchor="ctr"/>
-          <a:lstStyle/>
-          <a:p>
-            <a:endParaRPr lang="en-US"/>
-          </a:p>
-        </p:txBody>
-      </p:sp>
-      <p:sp>
-        <p:nvSpPr>
-          <p:cNvPr id="5" name="Notes Placeholder 4"/>
-          <p:cNvSpPr>
-            <a:spLocks noGrp="1"/>
-          </p:cNvSpPr>
-          <p:nvPr>
-            <p:ph type="body" sz="quarter" idx="3"/>
-          </p:nvPr>
-        </p:nvSpPr>
-        <p:spPr>
-          <a:xfrm>
-            <a:off x="685800" y="4400550"/>
-            <a:ext cx="5486400" cy="3600450"/>
-          </a:xfrm>
-          <a:prstGeom prst="rect">
-            <a:avLst/>
-          </a:prstGeom>
-        </p:spPr>
-        <p:txBody>
-          <a:bodyPr vert="horz" lIns="91440" tIns="45720" rIns="91440" bIns="45720" rtlCol="0"/>
-          <a:lstStyle/>
-          <a:p>
-            <a:pPr lvl="0"/>
-            <a:r>
-              <a:rPr lang="en-US"/>
-              <a:t>Click to edit Master text styles</a:t>
-            </a:r>
-          </a:p>
-          <a:p>
-            <a:pPr lvl="1"/>
-            <a:r>
-              <a:rPr lang="en-US"/>
-              <a:t>Second level</a:t>
-            </a:r>
-          </a:p>
-          <a:p>
-            <a:pPr lvl="2"/>
-            <a:r>
-              <a:rPr lang="en-US"/>
-              <a:t>Third level</a:t>
-            </a:r>
-          </a:p>
-          <a:p>
-            <a:pPr lvl="3"/>
-            <a:r>
-              <a:rPr lang="en-US"/>
-              <a:t>Fourth level</a:t>
-            </a:r>
-          </a:p>
-          <a:p>
-            <a:pPr lvl="4"/>
-            <a:r>
-              <a:rPr lang="en-US"/>
-              <a:t>Fifth level</a:t>
-            </a:r>
-          </a:p>
-        </p:txBody>
-      </p:sp>
-      <p:sp>
-        <p:nvSpPr>
-          <p:cNvPr id="6" name="Footer Placeholder 5"/>
-          <p:cNvSpPr>
-            <a:spLocks noGrp="1"/>
-          </p:cNvSpPr>
-          <p:nvPr>
-            <p:ph type="ftr" sz="quarter" idx="4"/>
-          </p:nvPr>
-        </p:nvSpPr>
-        <p:spPr>
-          <a:xfrm>
-            <a:off x="0" y="8685213"/>
-            <a:ext cx="2971800" cy="458787"/>
-          </a:xfrm>
-          <a:prstGeom prst="rect">
-            <a:avLst/>
-          </a:prstGeom>
-        </p:spPr>
-        <p:txBody>
-          <a:bodyPr vert="horz" lIns="91440" tIns="45720" rIns="91440" bIns="45720" rtlCol="0" anchor="b"/>
-          <a:lstStyle>
-            <a:lvl1pPr algn="l">
-              <a:defRPr sz="1200"/>
-            </a:lvl1pPr>
-          </a:lstStyle>
-          <a:p>
-            <a:endParaRPr lang="en-US"/>
-          </a:p>
-        </p:txBody>
-      </p:sp>
-      <p:sp>
-        <p:nvSpPr>
-          <p:cNvPr id="7" name="Slide Number Placeholder 6"/>
-          <p:cNvSpPr>
-            <a:spLocks noGrp="1"/>
-          </p:cNvSpPr>
-          <p:nvPr>
-            <p:ph type="sldNum" sz="quarter" idx="5"/>
-          </p:nvPr>
-        </p:nvSpPr>
-        <p:spPr>
-          <a:xfrm>
-            <a:off x="3884613" y="8685213"/>
-            <a:ext cx="2971800" cy="458787"/>
-          </a:xfrm>
-          <a:prstGeom prst="rect">
-            <a:avLst/>
-          </a:prstGeom>
-        </p:spPr>
-        <p:txBody>
-          <a:bodyPr vert="horz" lIns="91440" tIns="45720" rIns="91440" bIns="45720" rtlCol="0" anchor="b"/>
-          <a:lstStyle>
-            <a:lvl1pPr algn="r">
-              <a:defRPr sz="1200"/>
-            </a:lvl1pPr>
-          </a:lstStyle>
-          <a:p>
-            <a:fld id="{CE5E9CC1-C706-0F49-92D6-E571CC5EEA8F}" type="slidenum">
-              <a:rPr lang="en-US"/>
-              <a:t>‹#›</a:t>
-            </a:fld>
-            <a:endParaRPr lang="en-US"/>
-          </a:p>
-        </p:txBody>
-      </p:sp>
     </p:spTree>
     <p:extLst>
       <p:ext uri="{BB962C8B-B14F-4D97-AF65-F5344CB8AC3E}">
-        <p14:creationId xmlns:p14="http://schemas.microsoft.com/office/powerpoint/2010/main" val="1024086991"/>
+        <p14:creationId xmlns:p14="http://schemas.microsoft.com/office/powerpoint/2010/main" val="1360392604"/>
       </p:ext>
     </p:extLst>
   </p:cSld>
@@ -522,7 +303,6 @@
               <a:rPr lang="en-US" dirty="0"/>
               <a:t>FORSIDE. Bytt bilde: høyreklikk på bildet &gt; Endre bilde &gt; Fra en fil. Velg et bilde med et rolig parti nede til venstre, ellers konkurrerer motivet med tittelen. Vil du flytte det røde ordet: marker ordet og sett skriftfargen til rød (FF3333).</a:t>
             </a:r>
-            <a:endParaRPr lang="en-US" dirty="0"/>
           </a:p>
         </p:txBody>
       </p:sp>
@@ -610,7 +390,6 @@
               <a:rPr lang="en-US" dirty="0"/>
               <a:t>KAPITTELSKILLE. To ting å endre per kapittel: det store tallet til høyre, og hvilket tall i rekken som er rødt (marker det og sett rød FF3333, og sett det forrige tilbake til grå 9BA1A5). Kickeren står bare «Kapittel», så du slipper å endre den også. Vil du heller ha temaet for delen der, skriv det inn. Har du flere eller færre enn fem kapitler, legg til eller slett tall i rekken.</a:t>
             </a:r>
-            <a:endParaRPr lang="en-US" dirty="0"/>
           </a:p>
         </p:txBody>
       </p:sp>
@@ -698,7 +477,6 @@
               <a:rPr lang="en-US" dirty="0"/>
               <a:t>TEKST OG BILDERUTENETT. Fire liggende bilder i 2x2 med forklaringen samlet på venstre side, i stedet for bildetekst under hvert bilde. Bytt bilde: høyreklikk &gt; Endre bilde, utsnittet beholdes. Vil du ha bildene til venstre og teksten til høyre: marker alle fire bildene og dra dem over, og flytt tekstblokken motsatt vei. Kjør prepare-media.py på nye bilder, så får de samme lysstyrke som de andre.</a:t>
             </a:r>
-            <a:endParaRPr lang="en-US" dirty="0"/>
           </a:p>
         </p:txBody>
       </p:sp>
@@ -786,7 +564,6 @@
               <a:rPr lang="en-US" dirty="0"/>
               <a:t>UTSAGN. Én setning, maks tre linjer. Dette er sliden du lar henge i stillhet et par sekunder før du snakker videre.</a:t>
             </a:r>
-            <a:endParaRPr lang="en-US" dirty="0"/>
           </a:p>
         </p:txBody>
       </p:sp>
@@ -874,7 +651,6 @@
               <a:rPr lang="en-US" dirty="0"/>
               <a:t>SITAT. Hold sitatet under 25 ord, ellers slutter salen å lese før du er ferdig å snakke. Både sitatet og navnet er plassholdere: bytt dem før du presenterer. Sirkelen er rundt maskert, så et innsatt portrett beholder formen.</a:t>
             </a:r>
-            <a:endParaRPr lang="en-US" dirty="0"/>
           </a:p>
         </p:txBody>
       </p:sp>
@@ -962,7 +738,6 @@
               <a:rPr lang="en-US" dirty="0"/>
               <a:t>BILDERAD. Bildeteksten ligger under bildet, ikke oppå det, nettopp for å være lesbar fra bakerste rad. Overskriften i hvitt er 20 pt, forklaringen 18 pt. Bytt bilde: høyreklikk &gt; Endre bilde, utsnittet beholdes. Vil du ha fire bilder i stedet for tre: marker et bilde med tekstene under, kopier settet, og sett bildebredden til 2,6 tommer på alle fire. Hold forklaringen til to linjer, ellers treffer den logoen. Kjør prepare-media.py på nye bilder, så legges de i samme lysstyrke som de andre.</a:t>
             </a:r>
-            <a:endParaRPr lang="en-US" dirty="0"/>
           </a:p>
         </p:txBody>
       </p:sp>
@@ -1050,7 +825,6 @@
               <a:rPr lang="en-US" dirty="0"/>
               <a:t>PROSESS. Det røde tallet viser hvor i løpet du er. Flytt den røde fargen til neste steg hvis du gjenbruker sliden lenger ut i presentasjonen.</a:t>
             </a:r>
-            <a:endParaRPr lang="en-US" dirty="0"/>
           </a:p>
         </p:txBody>
       </p:sp>
@@ -1138,7 +912,6 @@
               <a:rPr lang="en-US" dirty="0"/>
               <a:t>FOLK, sirkler. Decket har begge formene, så bruk den som passer resten av presentasjonen din, og slett den andre. Fire portretter spenner fra marg til marg. Bytt portrett: høyreklikk &gt; Endre bilde, formen følger med. Den grå plassen er ledig. Sjekk at rollene stemmer før du presenterer.</a:t>
             </a:r>
-            <a:endParaRPr lang="en-US" dirty="0"/>
           </a:p>
         </p:txBody>
       </p:sp>
@@ -1226,7 +999,6 @@
               <a:rPr lang="en-US" dirty="0"/>
               <a:t>FOLK, avrundede firkanter. Decket har begge formene, så bruk den som passer resten av presentasjonen din, og slett den andre. Fire portretter spenner fra marg til marg. Bytt portrett: høyreklikk &gt; Endre bilde, formen følger med. Den grå plassen er ledig. Sjekk at rollene stemmer før du presenterer.</a:t>
             </a:r>
-            <a:endParaRPr lang="en-US" dirty="0"/>
           </a:p>
         </p:txBody>
       </p:sp>
@@ -1314,7 +1086,6 @@
               <a:rPr lang="en-US" dirty="0"/>
               <a:t>FILM. Slik legger du inn filmen: Sett inn &gt; Video &gt; Denne enheten. Dra filmen så den dekker hele flaten, høyreklikk &gt; Send bakover slik at tittelen og avspillingsmerket blir liggende oppå. Under Avspilling velger du Start automatisk hvis den skal gå av seg selv. Slett den røde sirkelen og trekanten når den ekte filmen er på plass.</a:t>
             </a:r>
-            <a:endParaRPr lang="en-US" dirty="0"/>
           </a:p>
         </p:txBody>
       </p:sp>
@@ -1402,7 +1173,6 @@
               <a:rPr lang="en-US" dirty="0"/>
               <a:t>AVSLUTNING. La den stå på skjermen mens du tar spørsmål. Legg til e-post eller kontaktperson på linjen under nettadressen hvis salen skal kunne følge opp.</a:t>
             </a:r>
-            <a:endParaRPr lang="en-US" dirty="0"/>
           </a:p>
         </p:txBody>
       </p:sp>
@@ -1490,7 +1260,6 @@
               <a:rPr lang="en-US" dirty="0"/>
               <a:t>AGENDA. Fire rader er dimensjonert for plassen. Trenger du fem, marker alle radene og minsk avstanden mellom dem til ca. 0,8 tommer først, ellers havner den nederste raden oppå logoen.</a:t>
             </a:r>
-            <a:endParaRPr lang="en-US" dirty="0"/>
           </a:p>
         </p:txBody>
       </p:sp>
@@ -1578,7 +1347,6 @@
               <a:rPr lang="en-US" dirty="0"/>
               <a:t>SEKSJONSSKILLE. Bruk mellom hoveddeler så publikum får en pause og vet hvor de er. Maks to korte linjer, ellers mister plakaten kraften.</a:t>
             </a:r>
-            <a:endParaRPr lang="en-US" dirty="0"/>
           </a:p>
         </p:txBody>
       </p:sp>
@@ -1666,7 +1434,6 @@
               <a:rPr lang="en-US" dirty="0"/>
               <a:t>STORT TALL. Ett tall per slide. Skal publikum huske to tall, bruk to slides. Teksten til høyre er der for å oppgi kilde og forbehold, ikke for et nytt poeng.</a:t>
             </a:r>
-            <a:endParaRPr lang="en-US" dirty="0"/>
           </a:p>
         </p:txBody>
       </p:sp>
@@ -1754,7 +1521,6 @@
               <a:rPr lang="en-US" dirty="0"/>
               <a:t>TALLREKKE. Tre tall er maks. Rund av: publikum husker 4 000, ikke 4 037. Hold hver verdi kort, lange verdier brekker over to linjer og dytter etiketten ned.</a:t>
             </a:r>
-            <a:endParaRPr lang="en-US" dirty="0"/>
           </a:p>
         </p:txBody>
       </p:sp>
@@ -1842,7 +1608,6 @@
               <a:rPr lang="en-US" dirty="0"/>
               <a:t>HELFLATE-BILDE. Sløret over bildet er en egen firkant: klikk den og juster gjennomsiktigheten hvis ditt bilde er lysere eller mørkere enn dette.</a:t>
             </a:r>
-            <a:endParaRPr lang="en-US" dirty="0"/>
           </a:p>
         </p:txBody>
       </p:sp>
@@ -1930,7 +1695,6 @@
               <a:rPr lang="en-US" dirty="0"/>
               <a:t>TEKST OG BILDE. Bildet går helt ut til kanten med vilje, ikke krymp det inn i en ramme. Vil du ha bildet på venstre side: flytt bildet til x = 0 og tekstblokken til høyre halvdel.</a:t>
             </a:r>
-            <a:endParaRPr lang="en-US" dirty="0"/>
           </a:p>
         </p:txBody>
       </p:sp>
@@ -2018,7 +1782,6 @@
               <a:rPr lang="en-US" dirty="0"/>
               <a:t>PROGRAMKORT. Fem kort er maks på bredden. Trenger du fire, slett ett kort og dra de andre utover så mellomrommene blir like. Bytter du ut et bilde, kjør prepare-media.py på det først: den legger alle kortbildene i samme lysstyrke og fargestyrke, ellers spriker raden.</a:t>
             </a:r>
-            <a:endParaRPr lang="en-US" dirty="0"/>
           </a:p>
         </p:txBody>
       </p:sp>
@@ -2106,7 +1869,6 @@
               <a:rPr lang="en-US" dirty="0"/>
               <a:t>PUNKTGRID. Seks er taket. Hold hver beskrivelse til to linjer, ellers kolliderer nederste rad med logoen.</a:t>
             </a:r>
-            <a:endParaRPr lang="en-US" dirty="0"/>
           </a:p>
         </p:txBody>
       </p:sp>
@@ -2179,6 +1941,11 @@
 <file path=ppt/slideMasters/slideMaster1.xml><?xml version="1.0" encoding="utf-8"?>
 <p:sldMaster xmlns:a="http://schemas.openxmlformats.org/drawingml/2006/main" xmlns:r="http://schemas.openxmlformats.org/officeDocument/2006/relationships" xmlns:p="http://schemas.openxmlformats.org/presentationml/2006/main">
   <p:cSld>
+    <p:bg>
+      <p:bgRef idx="1001">
+        <a:schemeClr val="bg1"/>
+      </p:bgRef>
+    </p:bg>
     <p:spTree>
       <p:nvGrpSpPr>
         <p:cNvPr id="1" name=""/>
@@ -2472,15 +2239,15 @@
       </p:grpSpPr>
       <p:pic>
         <p:nvPicPr>
-          <p:cNvPr id="2" name="Image 0" descr="C:\Code\Work\startuplab-partner-presentation\pptx-templates\media\cover.jpg">    </p:cNvPr>
+          <p:cNvPr id="2" name="Image 0" descr="C:\Code\Work\startuplab-partner-presentation\pptx-templates\media\cover.jpg"/>
           <p:cNvPicPr>
             <a:picLocks noChangeAspect="1"/>
           </p:cNvPicPr>
           <p:nvPr/>
         </p:nvPicPr>
         <p:blipFill>
-          <a:blip r:embed="rId1"/>
-          <a:srcRect l="0" r="0" t="0" b="0"/>
+          <a:blip r:embed="rId3"/>
+          <a:srcRect/>
           <a:stretch/>
         </p:blipFill>
         <p:spPr>
@@ -2514,6 +2281,13 @@
           </a:solidFill>
           <a:ln/>
         </p:spPr>
+        <p:txBody>
+          <a:bodyPr/>
+          <a:lstStyle/>
+          <a:p>
+            <a:endParaRPr lang="nb-NO"/>
+          </a:p>
+        </p:txBody>
       </p:sp>
       <p:sp>
         <p:nvSpPr>
@@ -2536,11 +2310,11 @@
           <a:bodyPr wrap="square" lIns="0" tIns="0" rIns="0" bIns="0" rtlCol="0" anchor="ctr"/>
           <a:lstStyle/>
           <a:p>
-            <a:pPr indent="0" marL="0">
-              <a:buNone/>
-            </a:pPr>
-            <a:r>
-              <a:rPr lang="en-US" sz="1600" b="1" spc="180" kern="0" dirty="0">
+            <a:pPr marL="0" indent="0">
+              <a:buNone/>
+            </a:pPr>
+            <a:r>
+              <a:rPr lang="en-US" sz="1600" b="1" kern="0" spc="180" dirty="0">
                 <a:solidFill>
                   <a:srgbClr val="FFFFFF"/>
                 </a:solidFill>
@@ -2575,7 +2349,7 @@
           <a:bodyPr wrap="square" lIns="0" tIns="0" rIns="0" bIns="0" rtlCol="0" anchor="t"/>
           <a:lstStyle/>
           <a:p>
-            <a:pPr indent="0" marL="0">
+            <a:pPr marL="0" indent="0">
               <a:lnSpc>
                 <a:spcPct val="92000"/>
               </a:lnSpc>
@@ -2592,12 +2366,6 @@
               </a:rPr>
               <a:t>Bygger det </a:t>
             </a:r>
-            <a:pPr indent="0" marL="0">
-              <a:lnSpc>
-                <a:spcPct val="92000"/>
-              </a:lnSpc>
-              <a:buNone/>
-            </a:pPr>
             <a:r>
               <a:rPr lang="en-US" sz="5400" dirty="0">
                 <a:solidFill>
@@ -2609,12 +2377,6 @@
               </a:rPr>
               <a:t>neste</a:t>
             </a:r>
-            <a:pPr indent="0" marL="0">
-              <a:lnSpc>
-                <a:spcPct val="92000"/>
-              </a:lnSpc>
-              <a:buNone/>
-            </a:pPr>
             <a:r>
               <a:rPr lang="en-US" sz="5400" dirty="0">
                 <a:solidFill>
@@ -2632,14 +2394,14 @@
       </p:sp>
       <p:pic>
         <p:nvPicPr>
-          <p:cNvPr id="6" name="Image 1" descr="C:\Code\Work\startuplab-partner-presentation\pptx-templates\media\logo-white.png">    </p:cNvPr>
+          <p:cNvPr id="6" name="Image 1" descr="C:\Code\Work\startuplab-partner-presentation\pptx-templates\media\logo-white.png"/>
           <p:cNvPicPr>
             <a:picLocks noChangeAspect="1"/>
           </p:cNvPicPr>
           <p:nvPr/>
         </p:nvPicPr>
         <p:blipFill>
-          <a:blip r:embed="rId2"/>
+          <a:blip r:embed="rId4"/>
           <a:stretch>
             <a:fillRect/>
           </a:stretch>
@@ -2675,7 +2437,7 @@
           <a:bodyPr wrap="square" lIns="0" tIns="0" rIns="0" bIns="0" rtlCol="0" anchor="ctr"/>
           <a:lstStyle/>
           <a:p>
-            <a:pPr algn="r" indent="0" marL="0">
+            <a:pPr marL="0" indent="0" algn="r">
               <a:buNone/>
             </a:pPr>
             <a:r>
@@ -2709,6 +2471,7 @@
         <a:solidFill>
           <a:srgbClr val="131415"/>
         </a:solidFill>
+        <a:effectLst/>
       </p:bgPr>
     </p:bg>
     <p:spTree>
@@ -2746,7 +2509,7 @@
           <a:bodyPr wrap="square" lIns="0" tIns="0" rIns="0" bIns="0" rtlCol="0" anchor="ctr"/>
           <a:lstStyle/>
           <a:p>
-            <a:pPr indent="0" marL="0">
+            <a:pPr marL="0" indent="0">
               <a:buNone/>
             </a:pPr>
             <a:r>
@@ -2790,11 +2553,11 @@
           <a:bodyPr wrap="square" lIns="0" tIns="0" rIns="0" bIns="0" rtlCol="0" anchor="ctr"/>
           <a:lstStyle/>
           <a:p>
-            <a:pPr indent="0" marL="0">
-              <a:buNone/>
-            </a:pPr>
-            <a:r>
-              <a:rPr lang="en-US" sz="1600" b="1" spc="180" kern="0" dirty="0">
+            <a:pPr marL="0" indent="0">
+              <a:buNone/>
+            </a:pPr>
+            <a:r>
+              <a:rPr lang="en-US" sz="1600" b="1" kern="0" spc="180" dirty="0">
                 <a:solidFill>
                   <a:srgbClr val="FF3333"/>
                 </a:solidFill>
@@ -2829,7 +2592,7 @@
           <a:bodyPr wrap="square" lIns="0" tIns="0" rIns="0" bIns="0" rtlCol="0" anchor="t"/>
           <a:lstStyle/>
           <a:p>
-            <a:pPr indent="0" marL="0">
+            <a:pPr marL="0" indent="0">
               <a:buNone/>
             </a:pPr>
             <a:r>
@@ -2868,7 +2631,7 @@
           <a:bodyPr wrap="square" lIns="0" tIns="0" rIns="0" bIns="0" rtlCol="0" anchor="ctr"/>
           <a:lstStyle/>
           <a:p>
-            <a:pPr indent="0" marL="0">
+            <a:pPr marL="0" indent="0">
               <a:buNone/>
             </a:pPr>
             <a:r>
@@ -2882,9 +2645,6 @@
               </a:rPr>
               <a:t>01</a:t>
             </a:r>
-            <a:pPr indent="0" marL="0">
-              <a:buNone/>
-            </a:pPr>
             <a:r>
               <a:rPr lang="en-US" sz="2600" dirty="0">
                 <a:solidFill>
@@ -2896,9 +2656,6 @@
               </a:rPr>
               <a:t>   </a:t>
             </a:r>
-            <a:pPr indent="0" marL="0">
-              <a:buNone/>
-            </a:pPr>
             <a:r>
               <a:rPr lang="en-US" sz="2600" dirty="0">
                 <a:solidFill>
@@ -2910,9 +2667,6 @@
               </a:rPr>
               <a:t>02</a:t>
             </a:r>
-            <a:pPr indent="0" marL="0">
-              <a:buNone/>
-            </a:pPr>
             <a:r>
               <a:rPr lang="en-US" sz="2600" dirty="0">
                 <a:solidFill>
@@ -2924,9 +2678,6 @@
               </a:rPr>
               <a:t>   </a:t>
             </a:r>
-            <a:pPr indent="0" marL="0">
-              <a:buNone/>
-            </a:pPr>
             <a:r>
               <a:rPr lang="en-US" sz="2600" dirty="0">
                 <a:solidFill>
@@ -2938,9 +2689,6 @@
               </a:rPr>
               <a:t>03</a:t>
             </a:r>
-            <a:pPr indent="0" marL="0">
-              <a:buNone/>
-            </a:pPr>
             <a:r>
               <a:rPr lang="en-US" sz="2600" dirty="0">
                 <a:solidFill>
@@ -2952,9 +2700,6 @@
               </a:rPr>
               <a:t>   </a:t>
             </a:r>
-            <a:pPr indent="0" marL="0">
-              <a:buNone/>
-            </a:pPr>
             <a:r>
               <a:rPr lang="en-US" sz="2600" dirty="0">
                 <a:solidFill>
@@ -2966,9 +2711,6 @@
               </a:rPr>
               <a:t>04</a:t>
             </a:r>
-            <a:pPr indent="0" marL="0">
-              <a:buNone/>
-            </a:pPr>
             <a:r>
               <a:rPr lang="en-US" sz="2600" dirty="0">
                 <a:solidFill>
@@ -2980,9 +2722,6 @@
               </a:rPr>
               <a:t>   </a:t>
             </a:r>
-            <a:pPr indent="0" marL="0">
-              <a:buNone/>
-            </a:pPr>
             <a:r>
               <a:rPr lang="en-US" sz="2600" dirty="0">
                 <a:solidFill>
@@ -3000,14 +2739,14 @@
       </p:sp>
       <p:pic>
         <p:nvPicPr>
-          <p:cNvPr id="6" name="Image 0" descr="C:\Code\Work\startuplab-partner-presentation\pptx-templates\media\logo-white.png">    </p:cNvPr>
+          <p:cNvPr id="6" name="Image 0" descr="C:\Code\Work\startuplab-partner-presentation\pptx-templates\media\logo-white.png"/>
           <p:cNvPicPr>
             <a:picLocks noChangeAspect="1"/>
           </p:cNvPicPr>
           <p:nvPr/>
         </p:nvPicPr>
         <p:blipFill>
-          <a:blip r:embed="rId1"/>
+          <a:blip r:embed="rId3"/>
           <a:stretch>
             <a:fillRect/>
           </a:stretch>
@@ -3038,6 +2777,7 @@
         <a:solidFill>
           <a:srgbClr val="FFFFFF"/>
         </a:solidFill>
+        <a:effectLst/>
       </p:bgPr>
     </p:bg>
     <p:spTree>
@@ -3075,11 +2815,11 @@
           <a:bodyPr wrap="square" lIns="0" tIns="0" rIns="0" bIns="0" rtlCol="0" anchor="ctr"/>
           <a:lstStyle/>
           <a:p>
-            <a:pPr indent="0" marL="0">
-              <a:buNone/>
-            </a:pPr>
-            <a:r>
-              <a:rPr lang="en-US" sz="1600" b="1" spc="180" kern="0" dirty="0">
+            <a:pPr marL="0" indent="0">
+              <a:buNone/>
+            </a:pPr>
+            <a:r>
+              <a:rPr lang="en-US" sz="1600" b="1" kern="0" spc="180" dirty="0">
                 <a:solidFill>
                   <a:srgbClr val="FF3333"/>
                 </a:solidFill>
@@ -3114,7 +2854,7 @@
           <a:bodyPr wrap="square" lIns="0" tIns="0" rIns="0" bIns="0" rtlCol="0" anchor="t"/>
           <a:lstStyle/>
           <a:p>
-            <a:pPr indent="0" marL="0">
+            <a:pPr marL="0" indent="0">
               <a:lnSpc>
                 <a:spcPct val="102000"/>
               </a:lnSpc>
@@ -3125,16 +2865,19 @@
                 <a:solidFill>
                   <a:srgbClr val="131415"/>
                 </a:solidFill>
-                <a:latin typeface="Replica LL TT" pitchFamily="34" charset="0"/>
+                <a:latin typeface="Replica LL TT Heavy" panose="020B0904010101010104" pitchFamily="34" charset="0"/>
                 <a:ea typeface="Replica LL TT" pitchFamily="34" charset="-122"/>
-                <a:cs typeface="Replica LL TT" pitchFamily="34" charset="-120"/>
+                <a:cs typeface="Replica LL TT Heavy" panose="020B0904010101010104" pitchFamily="34" charset="0"/>
               </a:rPr>
               <a:t>Fire ting vi gjorde</a:t>
             </a:r>
-            <a:endParaRPr lang="en-US" sz="3400" dirty="0"/>
-          </a:p>
-          <a:p>
-            <a:pPr indent="0" marL="0">
+            <a:endParaRPr lang="en-US" sz="3400" dirty="0">
+              <a:latin typeface="Replica LL TT Heavy" panose="020B0904010101010104" pitchFamily="34" charset="0"/>
+              <a:cs typeface="Replica LL TT Heavy" panose="020B0904010101010104" pitchFamily="34" charset="0"/>
+            </a:endParaRPr>
+          </a:p>
+          <a:p>
+            <a:pPr marL="0" indent="0">
               <a:lnSpc>
                 <a:spcPct val="102000"/>
               </a:lnSpc>
@@ -3145,30 +2888,27 @@
                 <a:solidFill>
                   <a:srgbClr val="FF3333"/>
                 </a:solidFill>
-                <a:latin typeface="Replica LL TT" pitchFamily="34" charset="0"/>
+                <a:latin typeface="Replica LL TT Heavy" panose="020B0904010101010104" pitchFamily="34" charset="0"/>
                 <a:ea typeface="Replica LL TT" pitchFamily="34" charset="-122"/>
-                <a:cs typeface="Replica LL TT" pitchFamily="34" charset="-120"/>
+                <a:cs typeface="Replica LL TT Heavy" panose="020B0904010101010104" pitchFamily="34" charset="0"/>
               </a:rPr>
               <a:t>mest</a:t>
             </a:r>
-            <a:pPr indent="0" marL="0">
-              <a:lnSpc>
-                <a:spcPct val="102000"/>
-              </a:lnSpc>
-              <a:buNone/>
-            </a:pPr>
             <a:r>
               <a:rPr lang="en-US" sz="3400" b="1" dirty="0">
                 <a:solidFill>
                   <a:srgbClr val="131415"/>
                 </a:solidFill>
-                <a:latin typeface="Replica LL TT" pitchFamily="34" charset="0"/>
+                <a:latin typeface="Replica LL TT Heavy" panose="020B0904010101010104" pitchFamily="34" charset="0"/>
                 <a:ea typeface="Replica LL TT" pitchFamily="34" charset="-122"/>
-                <a:cs typeface="Replica LL TT" pitchFamily="34" charset="-120"/>
+                <a:cs typeface="Replica LL TT Heavy" panose="020B0904010101010104" pitchFamily="34" charset="0"/>
               </a:rPr>
               <a:t> av</a:t>
             </a:r>
-            <a:endParaRPr lang="en-US" sz="3400" dirty="0"/>
+            <a:endParaRPr lang="en-US" sz="3400" dirty="0">
+              <a:latin typeface="Replica LL TT Heavy" panose="020B0904010101010104" pitchFamily="34" charset="0"/>
+              <a:cs typeface="Replica LL TT Heavy" panose="020B0904010101010104" pitchFamily="34" charset="0"/>
+            </a:endParaRPr>
           </a:p>
         </p:txBody>
       </p:sp>
@@ -3193,9 +2933,9 @@
           <a:bodyPr wrap="square" lIns="0" tIns="0" rIns="0" bIns="0" rtlCol="0" anchor="t"/>
           <a:lstStyle/>
           <a:p>
-            <a:pPr indent="0" marL="0">
+            <a:pPr marL="0" indent="0">
               <a:lnSpc>
-                <a:spcPct val="140000"/>
+                <a:spcPct val="150000"/>
               </a:lnSpc>
               <a:buNone/>
             </a:pPr>
@@ -3216,15 +2956,15 @@
       </p:sp>
       <p:pic>
         <p:nvPicPr>
-          <p:cNvPr id="5" name="Image 0" descr="C:\Code\Work\startuplab-partner-presentation\pptx-templates\media\grid-1.jpg">    </p:cNvPr>
+          <p:cNvPr id="5" name="Image 0" descr="C:\Code\Work\startuplab-partner-presentation\pptx-templates\media\grid-1.jpg"/>
           <p:cNvPicPr>
             <a:picLocks noChangeAspect="1"/>
           </p:cNvPicPr>
           <p:nvPr/>
         </p:nvPicPr>
         <p:blipFill>
-          <a:blip r:embed="rId1"/>
-          <a:srcRect l="0" r="0" t="0" b="0"/>
+          <a:blip r:embed="rId3"/>
+          <a:srcRect/>
           <a:stretch/>
         </p:blipFill>
         <p:spPr>
@@ -3239,15 +2979,15 @@
       </p:pic>
       <p:pic>
         <p:nvPicPr>
-          <p:cNvPr id="6" name="Image 1" descr="C:\Code\Work\startuplab-partner-presentation\pptx-templates\media\grid-2.jpg">    </p:cNvPr>
+          <p:cNvPr id="6" name="Image 1" descr="C:\Code\Work\startuplab-partner-presentation\pptx-templates\media\grid-2.jpg"/>
           <p:cNvPicPr>
             <a:picLocks noChangeAspect="1"/>
           </p:cNvPicPr>
           <p:nvPr/>
         </p:nvPicPr>
         <p:blipFill>
-          <a:blip r:embed="rId2"/>
-          <a:srcRect l="0" r="0" t="0" b="0"/>
+          <a:blip r:embed="rId4"/>
+          <a:srcRect/>
           <a:stretch/>
         </p:blipFill>
         <p:spPr>
@@ -3262,15 +3002,15 @@
       </p:pic>
       <p:pic>
         <p:nvPicPr>
-          <p:cNvPr id="7" name="Image 2" descr="C:\Code\Work\startuplab-partner-presentation\pptx-templates\media\grid-3.jpg">    </p:cNvPr>
+          <p:cNvPr id="7" name="Image 2" descr="C:\Code\Work\startuplab-partner-presentation\pptx-templates\media\grid-3.jpg"/>
           <p:cNvPicPr>
             <a:picLocks noChangeAspect="1"/>
           </p:cNvPicPr>
           <p:nvPr/>
         </p:nvPicPr>
         <p:blipFill>
-          <a:blip r:embed="rId3"/>
-          <a:srcRect l="0" r="0" t="0" b="0"/>
+          <a:blip r:embed="rId5"/>
+          <a:srcRect/>
           <a:stretch/>
         </p:blipFill>
         <p:spPr>
@@ -3285,15 +3025,15 @@
       </p:pic>
       <p:pic>
         <p:nvPicPr>
-          <p:cNvPr id="8" name="Image 3" descr="C:\Code\Work\startuplab-partner-presentation\pptx-templates\media\grid-4.jpg">    </p:cNvPr>
+          <p:cNvPr id="8" name="Image 3" descr="C:\Code\Work\startuplab-partner-presentation\pptx-templates\media\grid-4.jpg"/>
           <p:cNvPicPr>
             <a:picLocks noChangeAspect="1"/>
           </p:cNvPicPr>
           <p:nvPr/>
         </p:nvPicPr>
         <p:blipFill>
-          <a:blip r:embed="rId4"/>
-          <a:srcRect l="0" r="0" t="0" b="0"/>
+          <a:blip r:embed="rId6"/>
+          <a:srcRect/>
           <a:stretch/>
         </p:blipFill>
         <p:spPr>
@@ -3308,14 +3048,14 @@
       </p:pic>
       <p:pic>
         <p:nvPicPr>
-          <p:cNvPr id="9" name="Image 4" descr="C:\Code\Work\startuplab-partner-presentation\pptx-templates\media\logo-red.png">    </p:cNvPr>
+          <p:cNvPr id="9" name="Image 4" descr="C:\Code\Work\startuplab-partner-presentation\pptx-templates\media\logo-red.png"/>
           <p:cNvPicPr>
             <a:picLocks noChangeAspect="1"/>
           </p:cNvPicPr>
           <p:nvPr/>
         </p:nvPicPr>
         <p:blipFill>
-          <a:blip r:embed="rId5"/>
+          <a:blip r:embed="rId7"/>
           <a:stretch>
             <a:fillRect/>
           </a:stretch>
@@ -3346,6 +3086,7 @@
         <a:solidFill>
           <a:srgbClr val="131415"/>
         </a:solidFill>
+        <a:effectLst/>
       </p:bgPr>
     </p:bg>
     <p:spTree>
@@ -3383,11 +3124,11 @@
           <a:bodyPr wrap="square" lIns="0" tIns="0" rIns="0" bIns="0" rtlCol="0" anchor="ctr"/>
           <a:lstStyle/>
           <a:p>
-            <a:pPr indent="0" marL="0">
-              <a:buNone/>
-            </a:pPr>
-            <a:r>
-              <a:rPr lang="en-US" sz="1600" b="1" spc="180" kern="0" dirty="0">
+            <a:pPr marL="0" indent="0">
+              <a:buNone/>
+            </a:pPr>
+            <a:r>
+              <a:rPr lang="en-US" sz="1600" b="1" kern="0" spc="180" dirty="0">
                 <a:solidFill>
                   <a:srgbClr val="FF3333"/>
                 </a:solidFill>
@@ -3422,7 +3163,7 @@
           <a:bodyPr wrap="square" lIns="0" tIns="0" rIns="0" bIns="0" rtlCol="0" anchor="t"/>
           <a:lstStyle/>
           <a:p>
-            <a:pPr indent="0" marL="0">
+            <a:pPr marL="0" indent="0">
               <a:lnSpc>
                 <a:spcPct val="98000"/>
               </a:lnSpc>
@@ -3442,7 +3183,7 @@
             <a:endParaRPr lang="en-US" sz="5200" dirty="0"/>
           </a:p>
           <a:p>
-            <a:pPr indent="0" marL="0">
+            <a:pPr marL="0" indent="0">
               <a:lnSpc>
                 <a:spcPct val="98000"/>
               </a:lnSpc>
@@ -3462,7 +3203,7 @@
             <a:endParaRPr lang="en-US" sz="5200" dirty="0"/>
           </a:p>
           <a:p>
-            <a:pPr indent="0" marL="0">
+            <a:pPr marL="0" indent="0">
               <a:lnSpc>
                 <a:spcPct val="98000"/>
               </a:lnSpc>
@@ -3479,12 +3220,6 @@
               </a:rPr>
               <a:t>Vi bygger </a:t>
             </a:r>
-            <a:pPr indent="0" marL="0">
-              <a:lnSpc>
-                <a:spcPct val="98000"/>
-              </a:lnSpc>
-              <a:buNone/>
-            </a:pPr>
             <a:r>
               <a:rPr lang="en-US" sz="5200" dirty="0">
                 <a:solidFill>
@@ -3496,12 +3231,6 @@
               </a:rPr>
               <a:t>selskaper</a:t>
             </a:r>
-            <a:pPr indent="0" marL="0">
-              <a:lnSpc>
-                <a:spcPct val="98000"/>
-              </a:lnSpc>
-              <a:buNone/>
-            </a:pPr>
             <a:r>
               <a:rPr lang="en-US" sz="5200" dirty="0">
                 <a:solidFill>
@@ -3519,14 +3248,14 @@
       </p:sp>
       <p:pic>
         <p:nvPicPr>
-          <p:cNvPr id="4" name="Image 0" descr="C:\Code\Work\startuplab-partner-presentation\pptx-templates\media\logo-white.png">    </p:cNvPr>
+          <p:cNvPr id="4" name="Image 0" descr="C:\Code\Work\startuplab-partner-presentation\pptx-templates\media\logo-white.png"/>
           <p:cNvPicPr>
             <a:picLocks noChangeAspect="1"/>
           </p:cNvPicPr>
           <p:nvPr/>
         </p:nvPicPr>
         <p:blipFill>
-          <a:blip r:embed="rId1"/>
+          <a:blip r:embed="rId3"/>
           <a:stretch>
             <a:fillRect/>
           </a:stretch>
@@ -3557,6 +3286,7 @@
         <a:solidFill>
           <a:srgbClr val="F7F7F7"/>
         </a:solidFill>
+        <a:effectLst/>
       </p:bgPr>
     </p:bg>
     <p:spTree>
@@ -3594,7 +3324,7 @@
           <a:bodyPr wrap="square" lIns="0" tIns="0" rIns="0" bIns="0" rtlCol="0" anchor="t"/>
           <a:lstStyle/>
           <a:p>
-            <a:pPr indent="0" marL="0">
+            <a:pPr marL="0" indent="0">
               <a:lnSpc>
                 <a:spcPct val="115000"/>
               </a:lnSpc>
@@ -3636,7 +3366,7 @@
           <a:bodyPr wrap="square" lIns="0" tIns="0" rIns="0" bIns="0" rtlCol="0" anchor="ctr"/>
           <a:lstStyle/>
           <a:p>
-            <a:pPr indent="0" marL="0">
+            <a:pPr marL="0" indent="0">
               <a:buNone/>
             </a:pPr>
             <a:r>
@@ -3675,7 +3405,7 @@
           <a:bodyPr wrap="square" lIns="0" tIns="0" rIns="0" bIns="0" rtlCol="0" anchor="ctr"/>
           <a:lstStyle/>
           <a:p>
-            <a:pPr indent="0" marL="0">
+            <a:pPr marL="0" indent="0">
               <a:buNone/>
             </a:pPr>
             <a:r>
@@ -3717,6 +3447,13 @@
             <a:prstDash val="solid"/>
           </a:ln>
         </p:spPr>
+        <p:txBody>
+          <a:bodyPr/>
+          <a:lstStyle/>
+          <a:p>
+            <a:endParaRPr lang="nb-NO"/>
+          </a:p>
+        </p:txBody>
       </p:sp>
       <p:sp>
         <p:nvSpPr>
@@ -3739,7 +3476,7 @@
           <a:bodyPr wrap="square" lIns="0" tIns="0" rIns="0" bIns="0" rtlCol="0" anchor="ctr"/>
           <a:lstStyle/>
           <a:p>
-            <a:pPr algn="ctr" indent="0" marL="0">
+            <a:pPr marL="0" indent="0" algn="ctr">
               <a:lnSpc>
                 <a:spcPct val="120000"/>
               </a:lnSpc>
@@ -3759,7 +3496,7 @@
             <a:endParaRPr lang="en-US" sz="1800" dirty="0"/>
           </a:p>
           <a:p>
-            <a:pPr algn="ctr" indent="0" marL="0">
+            <a:pPr marL="0" indent="0" algn="ctr">
               <a:lnSpc>
                 <a:spcPct val="120000"/>
               </a:lnSpc>
@@ -3782,14 +3519,14 @@
       </p:sp>
       <p:pic>
         <p:nvPicPr>
-          <p:cNvPr id="7" name="Image 0" descr="C:\Code\Work\startuplab-partner-presentation\pptx-templates\media\logo-red.png">    </p:cNvPr>
+          <p:cNvPr id="7" name="Image 0" descr="C:\Code\Work\startuplab-partner-presentation\pptx-templates\media\logo-red.png"/>
           <p:cNvPicPr>
             <a:picLocks noChangeAspect="1"/>
           </p:cNvPicPr>
           <p:nvPr/>
         </p:nvPicPr>
         <p:blipFill>
-          <a:blip r:embed="rId1"/>
+          <a:blip r:embed="rId3"/>
           <a:stretch>
             <a:fillRect/>
           </a:stretch>
@@ -3820,6 +3557,7 @@
         <a:solidFill>
           <a:srgbClr val="131415"/>
         </a:solidFill>
+        <a:effectLst/>
       </p:bgPr>
     </p:bg>
     <p:spTree>
@@ -3857,11 +3595,11 @@
           <a:bodyPr wrap="square" lIns="0" tIns="0" rIns="0" bIns="0" rtlCol="0" anchor="ctr"/>
           <a:lstStyle/>
           <a:p>
-            <a:pPr indent="0" marL="0">
-              <a:buNone/>
-            </a:pPr>
-            <a:r>
-              <a:rPr lang="en-US" sz="1600" b="1" spc="180" kern="0" dirty="0">
+            <a:pPr marL="0" indent="0">
+              <a:buNone/>
+            </a:pPr>
+            <a:r>
+              <a:rPr lang="en-US" sz="1600" b="1" kern="0" spc="180" dirty="0">
                 <a:solidFill>
                   <a:srgbClr val="FF3333"/>
                 </a:solidFill>
@@ -3896,7 +3634,7 @@
           <a:bodyPr wrap="square" lIns="0" tIns="0" rIns="0" bIns="0" rtlCol="0" anchor="t"/>
           <a:lstStyle/>
           <a:p>
-            <a:pPr indent="0" marL="0">
+            <a:pPr marL="0" indent="0">
               <a:lnSpc>
                 <a:spcPct val="100000"/>
               </a:lnSpc>
@@ -3907,49 +3645,248 @@
                 <a:solidFill>
                   <a:srgbClr val="FFFFFF"/>
                 </a:solidFill>
+                <a:latin typeface="Replica LL TT Heavy" panose="020B0904010101010104" pitchFamily="34" charset="0"/>
+                <a:ea typeface="Replica LL TT" pitchFamily="34" charset="-122"/>
+                <a:cs typeface="Replica LL TT Heavy" panose="020B0904010101010104" pitchFamily="34" charset="0"/>
+              </a:rPr>
+              <a:t>Tre øyeblikk fra </a:t>
+            </a:r>
+            <a:r>
+              <a:rPr lang="en-US" sz="4000" b="1" dirty="0">
+                <a:solidFill>
+                  <a:srgbClr val="FF3333"/>
+                </a:solidFill>
+                <a:latin typeface="Replica LL TT Heavy" panose="020B0904010101010104" pitchFamily="34" charset="0"/>
+                <a:ea typeface="Replica LL TT" pitchFamily="34" charset="-122"/>
+                <a:cs typeface="Replica LL TT Heavy" panose="020B0904010101010104" pitchFamily="34" charset="0"/>
+              </a:rPr>
+              <a:t>2025</a:t>
+            </a:r>
+            <a:endParaRPr lang="en-US" sz="4000" dirty="0">
+              <a:latin typeface="Replica LL TT Heavy" panose="020B0904010101010104" pitchFamily="34" charset="0"/>
+              <a:cs typeface="Replica LL TT Heavy" panose="020B0904010101010104" pitchFamily="34" charset="0"/>
+            </a:endParaRPr>
+          </a:p>
+        </p:txBody>
+      </p:sp>
+      <p:pic>
+        <p:nvPicPr>
+          <p:cNvPr id="4" name="Image 0" descr="C:\Code\Work\startuplab-partner-presentation\pptx-templates\media\row-1.jpg"/>
+          <p:cNvPicPr>
+            <a:picLocks noChangeAspect="1"/>
+          </p:cNvPicPr>
+          <p:nvPr/>
+        </p:nvPicPr>
+        <p:blipFill>
+          <a:blip r:embed="rId3"/>
+          <a:srcRect/>
+          <a:stretch/>
+        </p:blipFill>
+        <p:spPr>
+          <a:xfrm>
+            <a:off x="777240" y="2240280"/>
+            <a:ext cx="3301898" cy="2201266"/>
+          </a:xfrm>
+          <a:prstGeom prst="rect">
+            <a:avLst/>
+          </a:prstGeom>
+        </p:spPr>
+      </p:pic>
+      <p:sp>
+        <p:nvSpPr>
+          <p:cNvPr id="5" name="Text 2"/>
+          <p:cNvSpPr/>
+          <p:nvPr/>
+        </p:nvSpPr>
+        <p:spPr>
+          <a:xfrm>
+            <a:off x="777240" y="4624426"/>
+            <a:ext cx="3301898" cy="420624"/>
+          </a:xfrm>
+          <a:prstGeom prst="rect">
+            <a:avLst/>
+          </a:prstGeom>
+          <a:noFill/>
+          <a:ln/>
+        </p:spPr>
+        <p:txBody>
+          <a:bodyPr wrap="square" lIns="0" tIns="0" rIns="0" bIns="0" rtlCol="0" anchor="ctr"/>
+          <a:lstStyle/>
+          <a:p>
+            <a:pPr marL="0" indent="0">
+              <a:buNone/>
+            </a:pPr>
+            <a:r>
+              <a:rPr lang="en-US" sz="2000" b="1" dirty="0">
+                <a:solidFill>
+                  <a:srgbClr val="FFFFFF"/>
+                </a:solidFill>
                 <a:latin typeface="Replica LL TT" pitchFamily="34" charset="0"/>
                 <a:ea typeface="Replica LL TT" pitchFamily="34" charset="-122"/>
                 <a:cs typeface="Replica LL TT" pitchFamily="34" charset="-120"/>
               </a:rPr>
-              <a:t>Tre øyeblikk fra </a:t>
-            </a:r>
-            <a:pPr indent="0" marL="0">
-              <a:lnSpc>
-                <a:spcPct val="100000"/>
-              </a:lnSpc>
-              <a:buNone/>
-            </a:pPr>
-            <a:r>
-              <a:rPr lang="en-US" sz="4000" b="1" dirty="0">
-                <a:solidFill>
-                  <a:srgbClr val="FF3333"/>
+              <a:t>Fullt hus</a:t>
+            </a:r>
+            <a:endParaRPr lang="en-US" sz="2000" dirty="0"/>
+          </a:p>
+        </p:txBody>
+      </p:sp>
+      <p:sp>
+        <p:nvSpPr>
+          <p:cNvPr id="6" name="Text 3"/>
+          <p:cNvSpPr/>
+          <p:nvPr/>
+        </p:nvSpPr>
+        <p:spPr>
+          <a:xfrm>
+            <a:off x="777240" y="5063338"/>
+            <a:ext cx="3301898" cy="658368"/>
+          </a:xfrm>
+          <a:prstGeom prst="rect">
+            <a:avLst/>
+          </a:prstGeom>
+          <a:noFill/>
+          <a:ln/>
+        </p:spPr>
+        <p:txBody>
+          <a:bodyPr wrap="square" lIns="0" tIns="0" rIns="0" bIns="0" rtlCol="0" anchor="t"/>
+          <a:lstStyle/>
+          <a:p>
+            <a:pPr marL="0" indent="0">
+              <a:buNone/>
+            </a:pPr>
+            <a:r>
+              <a:rPr lang="en-US" sz="1800" dirty="0">
+                <a:solidFill>
+                  <a:srgbClr val="9BA1A5"/>
+                </a:solidFill>
+                <a:latin typeface="Inter" pitchFamily="34" charset="0"/>
+                <a:ea typeface="Inter" pitchFamily="34" charset="-122"/>
+                <a:cs typeface="Inter" pitchFamily="34" charset="-120"/>
+              </a:rPr>
+              <a:t>Over 400 deltakere på Demo Day i Forskningsparken.</a:t>
+            </a:r>
+            <a:endParaRPr lang="en-US" sz="1800" dirty="0"/>
+          </a:p>
+        </p:txBody>
+      </p:sp>
+      <p:pic>
+        <p:nvPicPr>
+          <p:cNvPr id="7" name="Image 1" descr="C:\Code\Work\startuplab-partner-presentation\pptx-templates\media\row-2.jpg"/>
+          <p:cNvPicPr>
+            <a:picLocks noChangeAspect="1"/>
+          </p:cNvPicPr>
+          <p:nvPr/>
+        </p:nvPicPr>
+        <p:blipFill>
+          <a:blip r:embed="rId4"/>
+          <a:srcRect/>
+          <a:stretch/>
+        </p:blipFill>
+        <p:spPr>
+          <a:xfrm>
+            <a:off x="4444898" y="2240280"/>
+            <a:ext cx="3301898" cy="2201266"/>
+          </a:xfrm>
+          <a:prstGeom prst="rect">
+            <a:avLst/>
+          </a:prstGeom>
+        </p:spPr>
+      </p:pic>
+      <p:sp>
+        <p:nvSpPr>
+          <p:cNvPr id="8" name="Text 4"/>
+          <p:cNvSpPr/>
+          <p:nvPr/>
+        </p:nvSpPr>
+        <p:spPr>
+          <a:xfrm>
+            <a:off x="4444898" y="4624426"/>
+            <a:ext cx="3301898" cy="420624"/>
+          </a:xfrm>
+          <a:prstGeom prst="rect">
+            <a:avLst/>
+          </a:prstGeom>
+          <a:noFill/>
+          <a:ln/>
+        </p:spPr>
+        <p:txBody>
+          <a:bodyPr wrap="square" lIns="0" tIns="0" rIns="0" bIns="0" rtlCol="0" anchor="ctr"/>
+          <a:lstStyle/>
+          <a:p>
+            <a:pPr marL="0" indent="0">
+              <a:buNone/>
+            </a:pPr>
+            <a:r>
+              <a:rPr lang="en-US" sz="2000" b="1" dirty="0">
+                <a:solidFill>
+                  <a:srgbClr val="FFFFFF"/>
                 </a:solidFill>
                 <a:latin typeface="Replica LL TT" pitchFamily="34" charset="0"/>
                 <a:ea typeface="Replica LL TT" pitchFamily="34" charset="-122"/>
                 <a:cs typeface="Replica LL TT" pitchFamily="34" charset="-120"/>
               </a:rPr>
-              <a:t>2025</a:t>
-            </a:r>
-            <a:endParaRPr lang="en-US" sz="4000" dirty="0"/>
+              <a:t>Nye koblinger</a:t>
+            </a:r>
+            <a:endParaRPr lang="en-US" sz="2000" dirty="0"/>
+          </a:p>
+        </p:txBody>
+      </p:sp>
+      <p:sp>
+        <p:nvSpPr>
+          <p:cNvPr id="9" name="Text 5"/>
+          <p:cNvSpPr/>
+          <p:nvPr/>
+        </p:nvSpPr>
+        <p:spPr>
+          <a:xfrm>
+            <a:off x="4444898" y="5063338"/>
+            <a:ext cx="3301898" cy="658368"/>
+          </a:xfrm>
+          <a:prstGeom prst="rect">
+            <a:avLst/>
+          </a:prstGeom>
+          <a:noFill/>
+          <a:ln/>
+        </p:spPr>
+        <p:txBody>
+          <a:bodyPr wrap="square" lIns="0" tIns="0" rIns="0" bIns="0" rtlCol="0" anchor="t"/>
+          <a:lstStyle/>
+          <a:p>
+            <a:pPr marL="0" indent="0">
+              <a:buNone/>
+            </a:pPr>
+            <a:r>
+              <a:rPr lang="en-US" sz="1800" dirty="0">
+                <a:solidFill>
+                  <a:srgbClr val="9BA1A5"/>
+                </a:solidFill>
+                <a:latin typeface="Inter" pitchFamily="34" charset="0"/>
+                <a:ea typeface="Inter" pitchFamily="34" charset="-122"/>
+                <a:cs typeface="Inter" pitchFamily="34" charset="-120"/>
+              </a:rPr>
+              <a:t>Partnere og gründere møttes på tolv matchmaking-runder.</a:t>
+            </a:r>
+            <a:endParaRPr lang="en-US" sz="1800" dirty="0"/>
           </a:p>
         </p:txBody>
       </p:sp>
       <p:pic>
         <p:nvPicPr>
-          <p:cNvPr id="4" name="Image 0" descr="C:\Code\Work\startuplab-partner-presentation\pptx-templates\media\row-1.jpg">    </p:cNvPr>
+          <p:cNvPr id="10" name="Image 2" descr="C:\Code\Work\startuplab-partner-presentation\pptx-templates\media\row-3.jpg"/>
           <p:cNvPicPr>
             <a:picLocks noChangeAspect="1"/>
           </p:cNvPicPr>
           <p:nvPr/>
         </p:nvPicPr>
         <p:blipFill>
-          <a:blip r:embed="rId1"/>
-          <a:srcRect l="0" r="0" t="0" b="0"/>
+          <a:blip r:embed="rId5"/>
+          <a:srcRect/>
           <a:stretch/>
         </p:blipFill>
         <p:spPr>
           <a:xfrm>
-            <a:off x="777240" y="2240280"/>
+            <a:off x="8112557" y="2240280"/>
             <a:ext cx="3301898" cy="2201266"/>
           </a:xfrm>
           <a:prstGeom prst="rect">
@@ -3959,13 +3896,13 @@
       </p:pic>
       <p:sp>
         <p:nvSpPr>
-          <p:cNvPr id="5" name="Text 2"/>
-          <p:cNvSpPr/>
-          <p:nvPr/>
-        </p:nvSpPr>
-        <p:spPr>
-          <a:xfrm>
-            <a:off x="777240" y="4624426"/>
+          <p:cNvPr id="11" name="Text 6"/>
+          <p:cNvSpPr/>
+          <p:nvPr/>
+        </p:nvSpPr>
+        <p:spPr>
+          <a:xfrm>
+            <a:off x="8112557" y="4624426"/>
             <a:ext cx="3301898" cy="420624"/>
           </a:xfrm>
           <a:prstGeom prst="rect">
@@ -3978,7 +3915,7 @@
           <a:bodyPr wrap="square" lIns="0" tIns="0" rIns="0" bIns="0" rtlCol="0" anchor="ctr"/>
           <a:lstStyle/>
           <a:p>
-            <a:pPr indent="0" marL="0">
+            <a:pPr marL="0" indent="0">
               <a:buNone/>
             </a:pPr>
             <a:r>
@@ -3990,7 +3927,7 @@
                 <a:ea typeface="Replica LL TT" pitchFamily="34" charset="-122"/>
                 <a:cs typeface="Replica LL TT" pitchFamily="34" charset="-120"/>
               </a:rPr>
-              <a:t>Fullt hus</a:t>
+              <a:t>Ut i felt</a:t>
             </a:r>
             <a:endParaRPr lang="en-US" sz="2000" dirty="0"/>
           </a:p>
@@ -3998,13 +3935,13 @@
       </p:sp>
       <p:sp>
         <p:nvSpPr>
-          <p:cNvPr id="6" name="Text 3"/>
-          <p:cNvSpPr/>
-          <p:nvPr/>
-        </p:nvSpPr>
-        <p:spPr>
-          <a:xfrm>
-            <a:off x="777240" y="5063338"/>
+          <p:cNvPr id="12" name="Text 7"/>
+          <p:cNvSpPr/>
+          <p:nvPr/>
+        </p:nvSpPr>
+        <p:spPr>
+          <a:xfrm>
+            <a:off x="8112557" y="5063338"/>
             <a:ext cx="3301898" cy="658368"/>
           </a:xfrm>
           <a:prstGeom prst="rect">
@@ -4017,10 +3954,7 @@
           <a:bodyPr wrap="square" lIns="0" tIns="0" rIns="0" bIns="0" rtlCol="0" anchor="t"/>
           <a:lstStyle/>
           <a:p>
-            <a:pPr indent="0" marL="0">
-              <a:lnSpc>
-                <a:spcPct val="130000"/>
-              </a:lnSpc>
+            <a:pPr marL="0" indent="0">
               <a:buNone/>
             </a:pPr>
             <a:r>
@@ -4032,7 +3966,7 @@
                 <a:ea typeface="Inter" pitchFamily="34" charset="-122"/>
                 <a:cs typeface="Inter" pitchFamily="34" charset="-120"/>
               </a:rPr>
-              <a:t>Over 400 deltakere på Demo Day i Forskningsparken.</a:t>
+              <a:t>Befaring med partnerne i Energy-programmet.</a:t>
             </a:r>
             <a:endParaRPr lang="en-US" sz="1800" dirty="0"/>
           </a:p>
@@ -4040,222 +3974,14 @@
       </p:sp>
       <p:pic>
         <p:nvPicPr>
-          <p:cNvPr id="7" name="Image 1" descr="C:\Code\Work\startuplab-partner-presentation\pptx-templates\media\row-2.jpg">    </p:cNvPr>
+          <p:cNvPr id="13" name="Image 3" descr="C:\Code\Work\startuplab-partner-presentation\pptx-templates\media\logo-white.png"/>
           <p:cNvPicPr>
             <a:picLocks noChangeAspect="1"/>
           </p:cNvPicPr>
           <p:nvPr/>
         </p:nvPicPr>
         <p:blipFill>
-          <a:blip r:embed="rId2"/>
-          <a:srcRect l="0" r="0" t="0" b="0"/>
-          <a:stretch/>
-        </p:blipFill>
-        <p:spPr>
-          <a:xfrm>
-            <a:off x="4444898" y="2240280"/>
-            <a:ext cx="3301898" cy="2201266"/>
-          </a:xfrm>
-          <a:prstGeom prst="rect">
-            <a:avLst/>
-          </a:prstGeom>
-        </p:spPr>
-      </p:pic>
-      <p:sp>
-        <p:nvSpPr>
-          <p:cNvPr id="8" name="Text 4"/>
-          <p:cNvSpPr/>
-          <p:nvPr/>
-        </p:nvSpPr>
-        <p:spPr>
-          <a:xfrm>
-            <a:off x="4444898" y="4624426"/>
-            <a:ext cx="3301898" cy="420624"/>
-          </a:xfrm>
-          <a:prstGeom prst="rect">
-            <a:avLst/>
-          </a:prstGeom>
-          <a:noFill/>
-          <a:ln/>
-        </p:spPr>
-        <p:txBody>
-          <a:bodyPr wrap="square" lIns="0" tIns="0" rIns="0" bIns="0" rtlCol="0" anchor="ctr"/>
-          <a:lstStyle/>
-          <a:p>
-            <a:pPr indent="0" marL="0">
-              <a:buNone/>
-            </a:pPr>
-            <a:r>
-              <a:rPr lang="en-US" sz="2000" b="1" dirty="0">
-                <a:solidFill>
-                  <a:srgbClr val="FFFFFF"/>
-                </a:solidFill>
-                <a:latin typeface="Replica LL TT" pitchFamily="34" charset="0"/>
-                <a:ea typeface="Replica LL TT" pitchFamily="34" charset="-122"/>
-                <a:cs typeface="Replica LL TT" pitchFamily="34" charset="-120"/>
-              </a:rPr>
-              <a:t>Nye koblinger</a:t>
-            </a:r>
-            <a:endParaRPr lang="en-US" sz="2000" dirty="0"/>
-          </a:p>
-        </p:txBody>
-      </p:sp>
-      <p:sp>
-        <p:nvSpPr>
-          <p:cNvPr id="9" name="Text 5"/>
-          <p:cNvSpPr/>
-          <p:nvPr/>
-        </p:nvSpPr>
-        <p:spPr>
-          <a:xfrm>
-            <a:off x="4444898" y="5063338"/>
-            <a:ext cx="3301898" cy="658368"/>
-          </a:xfrm>
-          <a:prstGeom prst="rect">
-            <a:avLst/>
-          </a:prstGeom>
-          <a:noFill/>
-          <a:ln/>
-        </p:spPr>
-        <p:txBody>
-          <a:bodyPr wrap="square" lIns="0" tIns="0" rIns="0" bIns="0" rtlCol="0" anchor="t"/>
-          <a:lstStyle/>
-          <a:p>
-            <a:pPr indent="0" marL="0">
-              <a:lnSpc>
-                <a:spcPct val="130000"/>
-              </a:lnSpc>
-              <a:buNone/>
-            </a:pPr>
-            <a:r>
-              <a:rPr lang="en-US" sz="1800" dirty="0">
-                <a:solidFill>
-                  <a:srgbClr val="9BA1A5"/>
-                </a:solidFill>
-                <a:latin typeface="Inter" pitchFamily="34" charset="0"/>
-                <a:ea typeface="Inter" pitchFamily="34" charset="-122"/>
-                <a:cs typeface="Inter" pitchFamily="34" charset="-120"/>
-              </a:rPr>
-              <a:t>Partnere og gründere møttes på tolv matchmaking-runder.</a:t>
-            </a:r>
-            <a:endParaRPr lang="en-US" sz="1800" dirty="0"/>
-          </a:p>
-        </p:txBody>
-      </p:sp>
-      <p:pic>
-        <p:nvPicPr>
-          <p:cNvPr id="10" name="Image 2" descr="C:\Code\Work\startuplab-partner-presentation\pptx-templates\media\row-3.jpg">    </p:cNvPr>
-          <p:cNvPicPr>
-            <a:picLocks noChangeAspect="1"/>
-          </p:cNvPicPr>
-          <p:nvPr/>
-        </p:nvPicPr>
-        <p:blipFill>
-          <a:blip r:embed="rId3"/>
-          <a:srcRect l="0" r="0" t="0" b="0"/>
-          <a:stretch/>
-        </p:blipFill>
-        <p:spPr>
-          <a:xfrm>
-            <a:off x="8112557" y="2240280"/>
-            <a:ext cx="3301898" cy="2201266"/>
-          </a:xfrm>
-          <a:prstGeom prst="rect">
-            <a:avLst/>
-          </a:prstGeom>
-        </p:spPr>
-      </p:pic>
-      <p:sp>
-        <p:nvSpPr>
-          <p:cNvPr id="11" name="Text 6"/>
-          <p:cNvSpPr/>
-          <p:nvPr/>
-        </p:nvSpPr>
-        <p:spPr>
-          <a:xfrm>
-            <a:off x="8112557" y="4624426"/>
-            <a:ext cx="3301898" cy="420624"/>
-          </a:xfrm>
-          <a:prstGeom prst="rect">
-            <a:avLst/>
-          </a:prstGeom>
-          <a:noFill/>
-          <a:ln/>
-        </p:spPr>
-        <p:txBody>
-          <a:bodyPr wrap="square" lIns="0" tIns="0" rIns="0" bIns="0" rtlCol="0" anchor="ctr"/>
-          <a:lstStyle/>
-          <a:p>
-            <a:pPr indent="0" marL="0">
-              <a:buNone/>
-            </a:pPr>
-            <a:r>
-              <a:rPr lang="en-US" sz="2000" b="1" dirty="0">
-                <a:solidFill>
-                  <a:srgbClr val="FFFFFF"/>
-                </a:solidFill>
-                <a:latin typeface="Replica LL TT" pitchFamily="34" charset="0"/>
-                <a:ea typeface="Replica LL TT" pitchFamily="34" charset="-122"/>
-                <a:cs typeface="Replica LL TT" pitchFamily="34" charset="-120"/>
-              </a:rPr>
-              <a:t>Ut i felt</a:t>
-            </a:r>
-            <a:endParaRPr lang="en-US" sz="2000" dirty="0"/>
-          </a:p>
-        </p:txBody>
-      </p:sp>
-      <p:sp>
-        <p:nvSpPr>
-          <p:cNvPr id="12" name="Text 7"/>
-          <p:cNvSpPr/>
-          <p:nvPr/>
-        </p:nvSpPr>
-        <p:spPr>
-          <a:xfrm>
-            <a:off x="8112557" y="5063338"/>
-            <a:ext cx="3301898" cy="658368"/>
-          </a:xfrm>
-          <a:prstGeom prst="rect">
-            <a:avLst/>
-          </a:prstGeom>
-          <a:noFill/>
-          <a:ln/>
-        </p:spPr>
-        <p:txBody>
-          <a:bodyPr wrap="square" lIns="0" tIns="0" rIns="0" bIns="0" rtlCol="0" anchor="t"/>
-          <a:lstStyle/>
-          <a:p>
-            <a:pPr indent="0" marL="0">
-              <a:lnSpc>
-                <a:spcPct val="130000"/>
-              </a:lnSpc>
-              <a:buNone/>
-            </a:pPr>
-            <a:r>
-              <a:rPr lang="en-US" sz="1800" dirty="0">
-                <a:solidFill>
-                  <a:srgbClr val="9BA1A5"/>
-                </a:solidFill>
-                <a:latin typeface="Inter" pitchFamily="34" charset="0"/>
-                <a:ea typeface="Inter" pitchFamily="34" charset="-122"/>
-                <a:cs typeface="Inter" pitchFamily="34" charset="-120"/>
-              </a:rPr>
-              <a:t>Befaring med partnerne i Energy-programmet.</a:t>
-            </a:r>
-            <a:endParaRPr lang="en-US" sz="1800" dirty="0"/>
-          </a:p>
-        </p:txBody>
-      </p:sp>
-      <p:pic>
-        <p:nvPicPr>
-          <p:cNvPr id="13" name="Image 3" descr="C:\Code\Work\startuplab-partner-presentation\pptx-templates\media\logo-white.png">    </p:cNvPr>
-          <p:cNvPicPr>
-            <a:picLocks noChangeAspect="1"/>
-          </p:cNvPicPr>
-          <p:nvPr/>
-        </p:nvPicPr>
-        <p:blipFill>
-          <a:blip r:embed="rId4"/>
+          <a:blip r:embed="rId6"/>
           <a:stretch>
             <a:fillRect/>
           </a:stretch>
@@ -4286,6 +4012,7 @@
         <a:solidFill>
           <a:srgbClr val="FFFFFF"/>
         </a:solidFill>
+        <a:effectLst/>
       </p:bgPr>
     </p:bg>
     <p:spTree>
@@ -4323,11 +4050,11 @@
           <a:bodyPr wrap="square" lIns="0" tIns="0" rIns="0" bIns="0" rtlCol="0" anchor="ctr"/>
           <a:lstStyle/>
           <a:p>
-            <a:pPr indent="0" marL="0">
-              <a:buNone/>
-            </a:pPr>
-            <a:r>
-              <a:rPr lang="en-US" sz="1600" b="1" spc="180" kern="0" dirty="0">
+            <a:pPr marL="0" indent="0">
+              <a:buNone/>
+            </a:pPr>
+            <a:r>
+              <a:rPr lang="en-US" sz="1600" b="1" kern="0" spc="180" dirty="0">
                 <a:solidFill>
                   <a:srgbClr val="FF3333"/>
                 </a:solidFill>
@@ -4362,7 +4089,7 @@
           <a:bodyPr wrap="square" lIns="0" tIns="0" rIns="0" bIns="0" rtlCol="0" anchor="t"/>
           <a:lstStyle/>
           <a:p>
-            <a:pPr indent="0" marL="0">
+            <a:pPr marL="0" indent="0">
               <a:lnSpc>
                 <a:spcPct val="100000"/>
               </a:lnSpc>
@@ -4404,7 +4131,7 @@
           <a:bodyPr wrap="square" lIns="0" tIns="0" rIns="0" bIns="0" rtlCol="0" anchor="t"/>
           <a:lstStyle/>
           <a:p>
-            <a:pPr indent="0" marL="0">
+            <a:pPr marL="0" indent="0">
               <a:buNone/>
             </a:pPr>
             <a:r>
@@ -4443,7 +4170,7 @@
           <a:bodyPr wrap="square" lIns="0" tIns="0" rIns="0" bIns="0" rtlCol="0" anchor="ctr"/>
           <a:lstStyle/>
           <a:p>
-            <a:pPr indent="0" marL="0">
+            <a:pPr marL="0" indent="0">
               <a:buNone/>
             </a:pPr>
             <a:r>
@@ -4482,7 +4209,7 @@
           <a:bodyPr wrap="square" lIns="0" tIns="0" rIns="0" bIns="0" rtlCol="0" anchor="t"/>
           <a:lstStyle/>
           <a:p>
-            <a:pPr indent="0" marL="0">
+            <a:pPr marL="0" indent="0">
               <a:lnSpc>
                 <a:spcPct val="130000"/>
               </a:lnSpc>
@@ -4524,7 +4251,7 @@
           <a:bodyPr wrap="square" lIns="0" tIns="0" rIns="0" bIns="0" rtlCol="0" anchor="t"/>
           <a:lstStyle/>
           <a:p>
-            <a:pPr indent="0" marL="0">
+            <a:pPr marL="0" indent="0">
               <a:buNone/>
             </a:pPr>
             <a:r>
@@ -4563,7 +4290,7 @@
           <a:bodyPr wrap="square" lIns="0" tIns="0" rIns="0" bIns="0" rtlCol="0" anchor="ctr"/>
           <a:lstStyle/>
           <a:p>
-            <a:pPr indent="0" marL="0">
+            <a:pPr marL="0" indent="0">
               <a:buNone/>
             </a:pPr>
             <a:r>
@@ -4602,7 +4329,7 @@
           <a:bodyPr wrap="square" lIns="0" tIns="0" rIns="0" bIns="0" rtlCol="0" anchor="t"/>
           <a:lstStyle/>
           <a:p>
-            <a:pPr indent="0" marL="0">
+            <a:pPr marL="0" indent="0">
               <a:lnSpc>
                 <a:spcPct val="130000"/>
               </a:lnSpc>
@@ -4644,7 +4371,7 @@
           <a:bodyPr wrap="square" lIns="0" tIns="0" rIns="0" bIns="0" rtlCol="0" anchor="t"/>
           <a:lstStyle/>
           <a:p>
-            <a:pPr indent="0" marL="0">
+            <a:pPr marL="0" indent="0">
               <a:buNone/>
             </a:pPr>
             <a:r>
@@ -4683,7 +4410,7 @@
           <a:bodyPr wrap="square" lIns="0" tIns="0" rIns="0" bIns="0" rtlCol="0" anchor="ctr"/>
           <a:lstStyle/>
           <a:p>
-            <a:pPr indent="0" marL="0">
+            <a:pPr marL="0" indent="0">
               <a:buNone/>
             </a:pPr>
             <a:r>
@@ -4722,7 +4449,7 @@
           <a:bodyPr wrap="square" lIns="0" tIns="0" rIns="0" bIns="0" rtlCol="0" anchor="t"/>
           <a:lstStyle/>
           <a:p>
-            <a:pPr indent="0" marL="0">
+            <a:pPr marL="0" indent="0">
               <a:lnSpc>
                 <a:spcPct val="130000"/>
               </a:lnSpc>
@@ -4764,7 +4491,7 @@
           <a:bodyPr wrap="square" lIns="0" tIns="0" rIns="0" bIns="0" rtlCol="0" anchor="t"/>
           <a:lstStyle/>
           <a:p>
-            <a:pPr indent="0" marL="0">
+            <a:pPr marL="0" indent="0">
               <a:buNone/>
             </a:pPr>
             <a:r>
@@ -4803,7 +4530,7 @@
           <a:bodyPr wrap="square" lIns="0" tIns="0" rIns="0" bIns="0" rtlCol="0" anchor="ctr"/>
           <a:lstStyle/>
           <a:p>
-            <a:pPr indent="0" marL="0">
+            <a:pPr marL="0" indent="0">
               <a:buNone/>
             </a:pPr>
             <a:r>
@@ -4842,7 +4569,7 @@
           <a:bodyPr wrap="square" lIns="0" tIns="0" rIns="0" bIns="0" rtlCol="0" anchor="t"/>
           <a:lstStyle/>
           <a:p>
-            <a:pPr indent="0" marL="0">
+            <a:pPr marL="0" indent="0">
               <a:lnSpc>
                 <a:spcPct val="130000"/>
               </a:lnSpc>
@@ -4865,14 +4592,14 @@
       </p:sp>
       <p:pic>
         <p:nvPicPr>
-          <p:cNvPr id="16" name="Image 0" descr="C:\Code\Work\startuplab-partner-presentation\pptx-templates\media\logo-red.png">    </p:cNvPr>
+          <p:cNvPr id="16" name="Image 0" descr="C:\Code\Work\startuplab-partner-presentation\pptx-templates\media\logo-red.png"/>
           <p:cNvPicPr>
             <a:picLocks noChangeAspect="1"/>
           </p:cNvPicPr>
           <p:nvPr/>
         </p:nvPicPr>
         <p:blipFill>
-          <a:blip r:embed="rId1"/>
+          <a:blip r:embed="rId3"/>
           <a:stretch>
             <a:fillRect/>
           </a:stretch>
@@ -4903,6 +4630,7 @@
         <a:solidFill>
           <a:srgbClr val="FFFFFF"/>
         </a:solidFill>
+        <a:effectLst/>
       </p:bgPr>
     </p:bg>
     <p:spTree>
@@ -4940,11 +4668,11 @@
           <a:bodyPr wrap="square" lIns="0" tIns="0" rIns="0" bIns="0" rtlCol="0" anchor="ctr"/>
           <a:lstStyle/>
           <a:p>
-            <a:pPr indent="0" marL="0">
-              <a:buNone/>
-            </a:pPr>
-            <a:r>
-              <a:rPr lang="en-US" sz="1600" b="1" spc="180" kern="0" dirty="0">
+            <a:pPr marL="0" indent="0">
+              <a:buNone/>
+            </a:pPr>
+            <a:r>
+              <a:rPr lang="en-US" sz="1600" b="1" kern="0" spc="180" dirty="0">
                 <a:solidFill>
                   <a:srgbClr val="FF3333"/>
                 </a:solidFill>
@@ -4979,7 +4707,7 @@
           <a:bodyPr wrap="square" lIns="0" tIns="0" rIns="0" bIns="0" rtlCol="0" anchor="t"/>
           <a:lstStyle/>
           <a:p>
-            <a:pPr indent="0" marL="0">
+            <a:pPr marL="0" indent="0">
               <a:lnSpc>
                 <a:spcPct val="100000"/>
               </a:lnSpc>
@@ -4996,12 +4724,6 @@
               </a:rPr>
               <a:t>Folkene du kommer til å </a:t>
             </a:r>
-            <a:pPr indent="0" marL="0">
-              <a:lnSpc>
-                <a:spcPct val="100000"/>
-              </a:lnSpc>
-              <a:buNone/>
-            </a:pPr>
             <a:r>
               <a:rPr lang="en-US" sz="4000" b="1" dirty="0">
                 <a:solidFill>
@@ -5019,15 +4741,15 @@
       </p:sp>
       <p:pic>
         <p:nvPicPr>
-          <p:cNvPr id="4" name="Image 0" descr="C:\Code\Work\startuplab-partner-presentation\pptx-templates\media\portrait-1.jpg">    </p:cNvPr>
+          <p:cNvPr id="4" name="Image 0" descr="C:\Code\Work\startuplab-partner-presentation\pptx-templates\media\portrait-1.jpg"/>
           <p:cNvPicPr>
             <a:picLocks noChangeAspect="1"/>
           </p:cNvPicPr>
           <p:nvPr/>
         </p:nvPicPr>
         <p:blipFill>
-          <a:blip r:embed="rId1"/>
-          <a:srcRect l="0" r="0" t="0" b="0"/>
+          <a:blip r:embed="rId3"/>
+          <a:srcRect/>
           <a:stretch/>
         </p:blipFill>
         <p:spPr>
@@ -5061,7 +4783,7 @@
           <a:bodyPr wrap="square" lIns="0" tIns="0" rIns="0" bIns="0" rtlCol="0" anchor="ctr"/>
           <a:lstStyle/>
           <a:p>
-            <a:pPr algn="ctr" indent="0" marL="0">
+            <a:pPr marL="0" indent="0" algn="ctr">
               <a:buNone/>
             </a:pPr>
             <a:r>
@@ -5100,7 +4822,7 @@
           <a:bodyPr wrap="square" lIns="0" tIns="0" rIns="0" bIns="0" rtlCol="0" anchor="t"/>
           <a:lstStyle/>
           <a:p>
-            <a:pPr algn="ctr" indent="0" marL="0">
+            <a:pPr marL="0" indent="0" algn="ctr">
               <a:lnSpc>
                 <a:spcPct val="115000"/>
               </a:lnSpc>
@@ -5123,15 +4845,15 @@
       </p:sp>
       <p:pic>
         <p:nvPicPr>
-          <p:cNvPr id="7" name="Image 1" descr="C:\Code\Work\startuplab-partner-presentation\pptx-templates\media\portrait-2.jpg">    </p:cNvPr>
+          <p:cNvPr id="7" name="Image 1" descr="C:\Code\Work\startuplab-partner-presentation\pptx-templates\media\portrait-2.jpg"/>
           <p:cNvPicPr>
             <a:picLocks noChangeAspect="1"/>
           </p:cNvPicPr>
           <p:nvPr/>
         </p:nvPicPr>
         <p:blipFill>
-          <a:blip r:embed="rId2"/>
-          <a:srcRect l="0" r="0" t="0" b="0"/>
+          <a:blip r:embed="rId4"/>
+          <a:srcRect/>
           <a:stretch/>
         </p:blipFill>
         <p:spPr>
@@ -5165,7 +4887,7 @@
           <a:bodyPr wrap="square" lIns="0" tIns="0" rIns="0" bIns="0" rtlCol="0" anchor="ctr"/>
           <a:lstStyle/>
           <a:p>
-            <a:pPr algn="ctr" indent="0" marL="0">
+            <a:pPr marL="0" indent="0" algn="ctr">
               <a:buNone/>
             </a:pPr>
             <a:r>
@@ -5204,7 +4926,7 @@
           <a:bodyPr wrap="square" lIns="0" tIns="0" rIns="0" bIns="0" rtlCol="0" anchor="t"/>
           <a:lstStyle/>
           <a:p>
-            <a:pPr algn="ctr" indent="0" marL="0">
+            <a:pPr marL="0" indent="0" algn="ctr">
               <a:lnSpc>
                 <a:spcPct val="115000"/>
               </a:lnSpc>
@@ -5227,15 +4949,15 @@
       </p:sp>
       <p:pic>
         <p:nvPicPr>
-          <p:cNvPr id="10" name="Image 2" descr="C:\Code\Work\startuplab-partner-presentation\pptx-templates\media\portrait-3.jpg">    </p:cNvPr>
+          <p:cNvPr id="10" name="Image 2" descr="C:\Code\Work\startuplab-partner-presentation\pptx-templates\media\portrait-3.jpg"/>
           <p:cNvPicPr>
             <a:picLocks noChangeAspect="1"/>
           </p:cNvPicPr>
           <p:nvPr/>
         </p:nvPicPr>
         <p:blipFill>
-          <a:blip r:embed="rId3"/>
-          <a:srcRect l="0" r="0" t="0" b="0"/>
+          <a:blip r:embed="rId5"/>
+          <a:srcRect/>
           <a:stretch/>
         </p:blipFill>
         <p:spPr>
@@ -5269,7 +4991,7 @@
           <a:bodyPr wrap="square" lIns="0" tIns="0" rIns="0" bIns="0" rtlCol="0" anchor="ctr"/>
           <a:lstStyle/>
           <a:p>
-            <a:pPr algn="ctr" indent="0" marL="0">
+            <a:pPr marL="0" indent="0" algn="ctr">
               <a:buNone/>
             </a:pPr>
             <a:r>
@@ -5308,7 +5030,7 @@
           <a:bodyPr wrap="square" lIns="0" tIns="0" rIns="0" bIns="0" rtlCol="0" anchor="t"/>
           <a:lstStyle/>
           <a:p>
-            <a:pPr algn="ctr" indent="0" marL="0">
+            <a:pPr marL="0" indent="0" algn="ctr">
               <a:lnSpc>
                 <a:spcPct val="115000"/>
               </a:lnSpc>
@@ -5353,6 +5075,13 @@
             <a:prstDash val="solid"/>
           </a:ln>
         </p:spPr>
+        <p:txBody>
+          <a:bodyPr/>
+          <a:lstStyle/>
+          <a:p>
+            <a:endParaRPr lang="nb-NO"/>
+          </a:p>
+        </p:txBody>
       </p:sp>
       <p:sp>
         <p:nvSpPr>
@@ -5375,7 +5104,7 @@
           <a:bodyPr wrap="square" lIns="0" tIns="0" rIns="0" bIns="0" rtlCol="0" anchor="ctr"/>
           <a:lstStyle/>
           <a:p>
-            <a:pPr algn="ctr" indent="0" marL="0">
+            <a:pPr marL="0" indent="0" algn="ctr">
               <a:lnSpc>
                 <a:spcPct val="120000"/>
               </a:lnSpc>
@@ -5395,7 +5124,7 @@
             <a:endParaRPr lang="en-US" sz="1800" dirty="0"/>
           </a:p>
           <a:p>
-            <a:pPr algn="ctr" indent="0" marL="0">
+            <a:pPr marL="0" indent="0" algn="ctr">
               <a:lnSpc>
                 <a:spcPct val="120000"/>
               </a:lnSpc>
@@ -5437,7 +5166,7 @@
           <a:bodyPr wrap="square" lIns="0" tIns="0" rIns="0" bIns="0" rtlCol="0" anchor="ctr"/>
           <a:lstStyle/>
           <a:p>
-            <a:pPr algn="ctr" indent="0" marL="0">
+            <a:pPr marL="0" indent="0" algn="ctr">
               <a:buNone/>
             </a:pPr>
             <a:r>
@@ -5476,7 +5205,7 @@
           <a:bodyPr wrap="square" lIns="0" tIns="0" rIns="0" bIns="0" rtlCol="0" anchor="t"/>
           <a:lstStyle/>
           <a:p>
-            <a:pPr algn="ctr" indent="0" marL="0">
+            <a:pPr marL="0" indent="0" algn="ctr">
               <a:lnSpc>
                 <a:spcPct val="115000"/>
               </a:lnSpc>
@@ -5499,14 +5228,14 @@
       </p:sp>
       <p:pic>
         <p:nvPicPr>
-          <p:cNvPr id="17" name="Image 3" descr="C:\Code\Work\startuplab-partner-presentation\pptx-templates\media\logo-red.png">    </p:cNvPr>
+          <p:cNvPr id="17" name="Image 3" descr="C:\Code\Work\startuplab-partner-presentation\pptx-templates\media\logo-red.png"/>
           <p:cNvPicPr>
             <a:picLocks noChangeAspect="1"/>
           </p:cNvPicPr>
           <p:nvPr/>
         </p:nvPicPr>
         <p:blipFill>
-          <a:blip r:embed="rId4"/>
+          <a:blip r:embed="rId6"/>
           <a:stretch>
             <a:fillRect/>
           </a:stretch>
@@ -5537,6 +5266,7 @@
         <a:solidFill>
           <a:srgbClr val="FFFFFF"/>
         </a:solidFill>
+        <a:effectLst/>
       </p:bgPr>
     </p:bg>
     <p:spTree>
@@ -5574,11 +5304,11 @@
           <a:bodyPr wrap="square" lIns="0" tIns="0" rIns="0" bIns="0" rtlCol="0" anchor="ctr"/>
           <a:lstStyle/>
           <a:p>
-            <a:pPr indent="0" marL="0">
-              <a:buNone/>
-            </a:pPr>
-            <a:r>
-              <a:rPr lang="en-US" sz="1600" b="1" spc="180" kern="0" dirty="0">
+            <a:pPr marL="0" indent="0">
+              <a:buNone/>
+            </a:pPr>
+            <a:r>
+              <a:rPr lang="en-US" sz="1600" b="1" kern="0" spc="180" dirty="0">
                 <a:solidFill>
                   <a:srgbClr val="FF3333"/>
                 </a:solidFill>
@@ -5613,7 +5343,7 @@
           <a:bodyPr wrap="square" lIns="0" tIns="0" rIns="0" bIns="0" rtlCol="0" anchor="t"/>
           <a:lstStyle/>
           <a:p>
-            <a:pPr indent="0" marL="0">
+            <a:pPr marL="0" indent="0">
               <a:lnSpc>
                 <a:spcPct val="100000"/>
               </a:lnSpc>
@@ -5630,12 +5360,6 @@
               </a:rPr>
               <a:t>Folkene du kommer til å </a:t>
             </a:r>
-            <a:pPr indent="0" marL="0">
-              <a:lnSpc>
-                <a:spcPct val="100000"/>
-              </a:lnSpc>
-              <a:buNone/>
-            </a:pPr>
             <a:r>
               <a:rPr lang="en-US" sz="4000" b="1" dirty="0">
                 <a:solidFill>
@@ -5653,217 +5377,7 @@
       </p:sp>
       <p:pic>
         <p:nvPicPr>
-          <p:cNvPr id="4" name="Image 0" descr="C:\Code\Work\startuplab-partner-presentation\pptx-templates\media\portrait-1-rund.png">    </p:cNvPr>
-          <p:cNvPicPr>
-            <a:picLocks noChangeAspect="1"/>
-          </p:cNvPicPr>
-          <p:nvPr/>
-        </p:nvPicPr>
-        <p:blipFill>
-          <a:blip r:embed="rId1"/>
-          <a:stretch>
-            <a:fillRect/>
-          </a:stretch>
-        </p:blipFill>
-        <p:spPr>
-          <a:xfrm>
-            <a:off x="777240" y="2286000"/>
-            <a:ext cx="2240280" cy="2240280"/>
-          </a:xfrm>
-          <a:prstGeom prst="rect">
-            <a:avLst/>
-          </a:prstGeom>
-        </p:spPr>
-      </p:pic>
-      <p:sp>
-        <p:nvSpPr>
-          <p:cNvPr id="5" name="Text 2"/>
-          <p:cNvSpPr/>
-          <p:nvPr/>
-        </p:nvSpPr>
-        <p:spPr>
-          <a:xfrm>
-            <a:off x="777240" y="4727448"/>
-            <a:ext cx="2240280" cy="365760"/>
-          </a:xfrm>
-          <a:prstGeom prst="rect">
-            <a:avLst/>
-          </a:prstGeom>
-          <a:noFill/>
-          <a:ln/>
-        </p:spPr>
-        <p:txBody>
-          <a:bodyPr wrap="square" lIns="0" tIns="0" rIns="0" bIns="0" rtlCol="0" anchor="ctr"/>
-          <a:lstStyle/>
-          <a:p>
-            <a:pPr algn="ctr" indent="0" marL="0">
-              <a:buNone/>
-            </a:pPr>
-            <a:r>
-              <a:rPr lang="en-US" sz="2100" b="1" dirty="0">
-                <a:solidFill>
-                  <a:srgbClr val="131415"/>
-                </a:solidFill>
-                <a:latin typeface="Replica LL TT" pitchFamily="34" charset="0"/>
-                <a:ea typeface="Replica LL TT" pitchFamily="34" charset="-122"/>
-                <a:cs typeface="Replica LL TT" pitchFamily="34" charset="-120"/>
-              </a:rPr>
-              <a:t>Christina Wiig</a:t>
-            </a:r>
-            <a:endParaRPr lang="en-US" sz="2100" dirty="0"/>
-          </a:p>
-        </p:txBody>
-      </p:sp>
-      <p:sp>
-        <p:nvSpPr>
-          <p:cNvPr id="6" name="Text 3"/>
-          <p:cNvSpPr/>
-          <p:nvPr/>
-        </p:nvSpPr>
-        <p:spPr>
-          <a:xfrm>
-            <a:off x="777240" y="5093208"/>
-            <a:ext cx="2240280" cy="694944"/>
-          </a:xfrm>
-          <a:prstGeom prst="rect">
-            <a:avLst/>
-          </a:prstGeom>
-          <a:noFill/>
-          <a:ln/>
-        </p:spPr>
-        <p:txBody>
-          <a:bodyPr wrap="square" lIns="0" tIns="0" rIns="0" bIns="0" rtlCol="0" anchor="t"/>
-          <a:lstStyle/>
-          <a:p>
-            <a:pPr algn="ctr" indent="0" marL="0">
-              <a:lnSpc>
-                <a:spcPct val="115000"/>
-              </a:lnSpc>
-              <a:buNone/>
-            </a:pPr>
-            <a:r>
-              <a:rPr lang="en-US" sz="1800" dirty="0">
-                <a:solidFill>
-                  <a:srgbClr val="5A6166"/>
-                </a:solidFill>
-                <a:latin typeface="Inter" pitchFamily="34" charset="0"/>
-                <a:ea typeface="Inter" pitchFamily="34" charset="-122"/>
-                <a:cs typeface="Inter" pitchFamily="34" charset="-120"/>
-              </a:rPr>
-              <a:t>Head of Corporate Partnerships</a:t>
-            </a:r>
-            <a:endParaRPr lang="en-US" sz="1800" dirty="0"/>
-          </a:p>
-        </p:txBody>
-      </p:sp>
-      <p:pic>
-        <p:nvPicPr>
-          <p:cNvPr id="7" name="Image 1" descr="C:\Code\Work\startuplab-partner-presentation\pptx-templates\media\portrait-2-rund.png">    </p:cNvPr>
-          <p:cNvPicPr>
-            <a:picLocks noChangeAspect="1"/>
-          </p:cNvPicPr>
-          <p:nvPr/>
-        </p:nvPicPr>
-        <p:blipFill>
-          <a:blip r:embed="rId2"/>
-          <a:stretch>
-            <a:fillRect/>
-          </a:stretch>
-        </p:blipFill>
-        <p:spPr>
-          <a:xfrm>
-            <a:off x="3576218" y="2286000"/>
-            <a:ext cx="2240280" cy="2240280"/>
-          </a:xfrm>
-          <a:prstGeom prst="rect">
-            <a:avLst/>
-          </a:prstGeom>
-        </p:spPr>
-      </p:pic>
-      <p:sp>
-        <p:nvSpPr>
-          <p:cNvPr id="8" name="Text 4"/>
-          <p:cNvSpPr/>
-          <p:nvPr/>
-        </p:nvSpPr>
-        <p:spPr>
-          <a:xfrm>
-            <a:off x="3576218" y="4727448"/>
-            <a:ext cx="2240280" cy="365760"/>
-          </a:xfrm>
-          <a:prstGeom prst="rect">
-            <a:avLst/>
-          </a:prstGeom>
-          <a:noFill/>
-          <a:ln/>
-        </p:spPr>
-        <p:txBody>
-          <a:bodyPr wrap="square" lIns="0" tIns="0" rIns="0" bIns="0" rtlCol="0" anchor="ctr"/>
-          <a:lstStyle/>
-          <a:p>
-            <a:pPr algn="ctr" indent="0" marL="0">
-              <a:buNone/>
-            </a:pPr>
-            <a:r>
-              <a:rPr lang="en-US" sz="2100" b="1" dirty="0">
-                <a:solidFill>
-                  <a:srgbClr val="131415"/>
-                </a:solidFill>
-                <a:latin typeface="Replica LL TT" pitchFamily="34" charset="0"/>
-                <a:ea typeface="Replica LL TT" pitchFamily="34" charset="-122"/>
-                <a:cs typeface="Replica LL TT" pitchFamily="34" charset="-120"/>
-              </a:rPr>
-              <a:t>Anniken Holst</a:t>
-            </a:r>
-            <a:endParaRPr lang="en-US" sz="2100" dirty="0"/>
-          </a:p>
-        </p:txBody>
-      </p:sp>
-      <p:sp>
-        <p:nvSpPr>
-          <p:cNvPr id="9" name="Text 5"/>
-          <p:cNvSpPr/>
-          <p:nvPr/>
-        </p:nvSpPr>
-        <p:spPr>
-          <a:xfrm>
-            <a:off x="3576218" y="5093208"/>
-            <a:ext cx="2240280" cy="694944"/>
-          </a:xfrm>
-          <a:prstGeom prst="rect">
-            <a:avLst/>
-          </a:prstGeom>
-          <a:noFill/>
-          <a:ln/>
-        </p:spPr>
-        <p:txBody>
-          <a:bodyPr wrap="square" lIns="0" tIns="0" rIns="0" bIns="0" rtlCol="0" anchor="t"/>
-          <a:lstStyle/>
-          <a:p>
-            <a:pPr algn="ctr" indent="0" marL="0">
-              <a:lnSpc>
-                <a:spcPct val="115000"/>
-              </a:lnSpc>
-              <a:buNone/>
-            </a:pPr>
-            <a:r>
-              <a:rPr lang="en-US" sz="1800" dirty="0">
-                <a:solidFill>
-                  <a:srgbClr val="5A6166"/>
-                </a:solidFill>
-                <a:latin typeface="Inter" pitchFamily="34" charset="0"/>
-                <a:ea typeface="Inter" pitchFamily="34" charset="-122"/>
-                <a:cs typeface="Inter" pitchFamily="34" charset="-120"/>
-              </a:rPr>
-              <a:t>Partner Manager</a:t>
-            </a:r>
-            <a:endParaRPr lang="en-US" sz="1800" dirty="0"/>
-          </a:p>
-        </p:txBody>
-      </p:sp>
-      <p:pic>
-        <p:nvPicPr>
-          <p:cNvPr id="10" name="Image 2" descr="C:\Code\Work\startuplab-partner-presentation\pptx-templates\media\portrait-3-rund.png">    </p:cNvPr>
+          <p:cNvPr id="4" name="Image 0" descr="C:\Code\Work\startuplab-partner-presentation\pptx-templates\media\portrait-1-rund.png"/>
           <p:cNvPicPr>
             <a:picLocks noChangeAspect="1"/>
           </p:cNvPicPr>
@@ -5877,7 +5391,7 @@
         </p:blipFill>
         <p:spPr>
           <a:xfrm>
-            <a:off x="6375197" y="2286000"/>
+            <a:off x="777240" y="2286000"/>
             <a:ext cx="2240280" cy="2240280"/>
           </a:xfrm>
           <a:prstGeom prst="rect">
@@ -5887,13 +5401,13 @@
       </p:pic>
       <p:sp>
         <p:nvSpPr>
-          <p:cNvPr id="11" name="Text 6"/>
-          <p:cNvSpPr/>
-          <p:nvPr/>
-        </p:nvSpPr>
-        <p:spPr>
-          <a:xfrm>
-            <a:off x="6375197" y="4727448"/>
+          <p:cNvPr id="5" name="Text 2"/>
+          <p:cNvSpPr/>
+          <p:nvPr/>
+        </p:nvSpPr>
+        <p:spPr>
+          <a:xfrm>
+            <a:off x="777240" y="4727448"/>
             <a:ext cx="2240280" cy="365760"/>
           </a:xfrm>
           <a:prstGeom prst="rect">
@@ -5906,7 +5420,7 @@
           <a:bodyPr wrap="square" lIns="0" tIns="0" rIns="0" bIns="0" rtlCol="0" anchor="ctr"/>
           <a:lstStyle/>
           <a:p>
-            <a:pPr algn="ctr" indent="0" marL="0">
+            <a:pPr marL="0" indent="0" algn="ctr">
               <a:buNone/>
             </a:pPr>
             <a:r>
@@ -5918,6 +5432,216 @@
                 <a:ea typeface="Replica LL TT" pitchFamily="34" charset="-122"/>
                 <a:cs typeface="Replica LL TT" pitchFamily="34" charset="-120"/>
               </a:rPr>
+              <a:t>Christina Wiig</a:t>
+            </a:r>
+            <a:endParaRPr lang="en-US" sz="2100" dirty="0"/>
+          </a:p>
+        </p:txBody>
+      </p:sp>
+      <p:sp>
+        <p:nvSpPr>
+          <p:cNvPr id="6" name="Text 3"/>
+          <p:cNvSpPr/>
+          <p:nvPr/>
+        </p:nvSpPr>
+        <p:spPr>
+          <a:xfrm>
+            <a:off x="777240" y="5093208"/>
+            <a:ext cx="2240280" cy="694944"/>
+          </a:xfrm>
+          <a:prstGeom prst="rect">
+            <a:avLst/>
+          </a:prstGeom>
+          <a:noFill/>
+          <a:ln/>
+        </p:spPr>
+        <p:txBody>
+          <a:bodyPr wrap="square" lIns="0" tIns="0" rIns="0" bIns="0" rtlCol="0" anchor="t"/>
+          <a:lstStyle/>
+          <a:p>
+            <a:pPr marL="0" indent="0" algn="ctr">
+              <a:lnSpc>
+                <a:spcPct val="115000"/>
+              </a:lnSpc>
+              <a:buNone/>
+            </a:pPr>
+            <a:r>
+              <a:rPr lang="en-US" sz="1800" dirty="0">
+                <a:solidFill>
+                  <a:srgbClr val="5A6166"/>
+                </a:solidFill>
+                <a:latin typeface="Inter" pitchFamily="34" charset="0"/>
+                <a:ea typeface="Inter" pitchFamily="34" charset="-122"/>
+                <a:cs typeface="Inter" pitchFamily="34" charset="-120"/>
+              </a:rPr>
+              <a:t>Head of Corporate Partnerships</a:t>
+            </a:r>
+            <a:endParaRPr lang="en-US" sz="1800" dirty="0"/>
+          </a:p>
+        </p:txBody>
+      </p:sp>
+      <p:pic>
+        <p:nvPicPr>
+          <p:cNvPr id="7" name="Image 1" descr="C:\Code\Work\startuplab-partner-presentation\pptx-templates\media\portrait-2-rund.png"/>
+          <p:cNvPicPr>
+            <a:picLocks noChangeAspect="1"/>
+          </p:cNvPicPr>
+          <p:nvPr/>
+        </p:nvPicPr>
+        <p:blipFill>
+          <a:blip r:embed="rId4"/>
+          <a:stretch>
+            <a:fillRect/>
+          </a:stretch>
+        </p:blipFill>
+        <p:spPr>
+          <a:xfrm>
+            <a:off x="3576218" y="2286000"/>
+            <a:ext cx="2240280" cy="2240280"/>
+          </a:xfrm>
+          <a:prstGeom prst="rect">
+            <a:avLst/>
+          </a:prstGeom>
+        </p:spPr>
+      </p:pic>
+      <p:sp>
+        <p:nvSpPr>
+          <p:cNvPr id="8" name="Text 4"/>
+          <p:cNvSpPr/>
+          <p:nvPr/>
+        </p:nvSpPr>
+        <p:spPr>
+          <a:xfrm>
+            <a:off x="3576218" y="4727448"/>
+            <a:ext cx="2240280" cy="365760"/>
+          </a:xfrm>
+          <a:prstGeom prst="rect">
+            <a:avLst/>
+          </a:prstGeom>
+          <a:noFill/>
+          <a:ln/>
+        </p:spPr>
+        <p:txBody>
+          <a:bodyPr wrap="square" lIns="0" tIns="0" rIns="0" bIns="0" rtlCol="0" anchor="ctr"/>
+          <a:lstStyle/>
+          <a:p>
+            <a:pPr marL="0" indent="0" algn="ctr">
+              <a:buNone/>
+            </a:pPr>
+            <a:r>
+              <a:rPr lang="en-US" sz="2100" b="1" dirty="0">
+                <a:solidFill>
+                  <a:srgbClr val="131415"/>
+                </a:solidFill>
+                <a:latin typeface="Replica LL TT" pitchFamily="34" charset="0"/>
+                <a:ea typeface="Replica LL TT" pitchFamily="34" charset="-122"/>
+                <a:cs typeface="Replica LL TT" pitchFamily="34" charset="-120"/>
+              </a:rPr>
+              <a:t>Anniken Holst</a:t>
+            </a:r>
+            <a:endParaRPr lang="en-US" sz="2100" dirty="0"/>
+          </a:p>
+        </p:txBody>
+      </p:sp>
+      <p:sp>
+        <p:nvSpPr>
+          <p:cNvPr id="9" name="Text 5"/>
+          <p:cNvSpPr/>
+          <p:nvPr/>
+        </p:nvSpPr>
+        <p:spPr>
+          <a:xfrm>
+            <a:off x="3576218" y="5093208"/>
+            <a:ext cx="2240280" cy="694944"/>
+          </a:xfrm>
+          <a:prstGeom prst="rect">
+            <a:avLst/>
+          </a:prstGeom>
+          <a:noFill/>
+          <a:ln/>
+        </p:spPr>
+        <p:txBody>
+          <a:bodyPr wrap="square" lIns="0" tIns="0" rIns="0" bIns="0" rtlCol="0" anchor="t"/>
+          <a:lstStyle/>
+          <a:p>
+            <a:pPr marL="0" indent="0" algn="ctr">
+              <a:lnSpc>
+                <a:spcPct val="115000"/>
+              </a:lnSpc>
+              <a:buNone/>
+            </a:pPr>
+            <a:r>
+              <a:rPr lang="en-US" sz="1800" dirty="0">
+                <a:solidFill>
+                  <a:srgbClr val="5A6166"/>
+                </a:solidFill>
+                <a:latin typeface="Inter" pitchFamily="34" charset="0"/>
+                <a:ea typeface="Inter" pitchFamily="34" charset="-122"/>
+                <a:cs typeface="Inter" pitchFamily="34" charset="-120"/>
+              </a:rPr>
+              <a:t>Partner Manager</a:t>
+            </a:r>
+            <a:endParaRPr lang="en-US" sz="1800" dirty="0"/>
+          </a:p>
+        </p:txBody>
+      </p:sp>
+      <p:pic>
+        <p:nvPicPr>
+          <p:cNvPr id="10" name="Image 2" descr="C:\Code\Work\startuplab-partner-presentation\pptx-templates\media\portrait-3-rund.png"/>
+          <p:cNvPicPr>
+            <a:picLocks noChangeAspect="1"/>
+          </p:cNvPicPr>
+          <p:nvPr/>
+        </p:nvPicPr>
+        <p:blipFill>
+          <a:blip r:embed="rId5"/>
+          <a:stretch>
+            <a:fillRect/>
+          </a:stretch>
+        </p:blipFill>
+        <p:spPr>
+          <a:xfrm>
+            <a:off x="6375197" y="2286000"/>
+            <a:ext cx="2240280" cy="2240280"/>
+          </a:xfrm>
+          <a:prstGeom prst="rect">
+            <a:avLst/>
+          </a:prstGeom>
+        </p:spPr>
+      </p:pic>
+      <p:sp>
+        <p:nvSpPr>
+          <p:cNvPr id="11" name="Text 6"/>
+          <p:cNvSpPr/>
+          <p:nvPr/>
+        </p:nvSpPr>
+        <p:spPr>
+          <a:xfrm>
+            <a:off x="6375197" y="4727448"/>
+            <a:ext cx="2240280" cy="365760"/>
+          </a:xfrm>
+          <a:prstGeom prst="rect">
+            <a:avLst/>
+          </a:prstGeom>
+          <a:noFill/>
+          <a:ln/>
+        </p:spPr>
+        <p:txBody>
+          <a:bodyPr wrap="square" lIns="0" tIns="0" rIns="0" bIns="0" rtlCol="0" anchor="ctr"/>
+          <a:lstStyle/>
+          <a:p>
+            <a:pPr marL="0" indent="0" algn="ctr">
+              <a:buNone/>
+            </a:pPr>
+            <a:r>
+              <a:rPr lang="en-US" sz="2100" b="1" dirty="0">
+                <a:solidFill>
+                  <a:srgbClr val="131415"/>
+                </a:solidFill>
+                <a:latin typeface="Replica LL TT" pitchFamily="34" charset="0"/>
+                <a:ea typeface="Replica LL TT" pitchFamily="34" charset="-122"/>
+                <a:cs typeface="Replica LL TT" pitchFamily="34" charset="-120"/>
+              </a:rPr>
               <a:t>Ola Jacobsen</a:t>
             </a:r>
             <a:endParaRPr lang="en-US" sz="2100" dirty="0"/>
@@ -5945,7 +5669,7 @@
           <a:bodyPr wrap="square" lIns="0" tIns="0" rIns="0" bIns="0" rtlCol="0" anchor="t"/>
           <a:lstStyle/>
           <a:p>
-            <a:pPr algn="ctr" indent="0" marL="0">
+            <a:pPr marL="0" indent="0" algn="ctr">
               <a:lnSpc>
                 <a:spcPct val="115000"/>
               </a:lnSpc>
@@ -5992,6 +5716,13 @@
             <a:prstDash val="solid"/>
           </a:ln>
         </p:spPr>
+        <p:txBody>
+          <a:bodyPr/>
+          <a:lstStyle/>
+          <a:p>
+            <a:endParaRPr lang="nb-NO"/>
+          </a:p>
+        </p:txBody>
       </p:sp>
       <p:sp>
         <p:nvSpPr>
@@ -6014,7 +5745,7 @@
           <a:bodyPr wrap="square" lIns="0" tIns="0" rIns="0" bIns="0" rtlCol="0" anchor="ctr"/>
           <a:lstStyle/>
           <a:p>
-            <a:pPr algn="ctr" indent="0" marL="0">
+            <a:pPr marL="0" indent="0" algn="ctr">
               <a:lnSpc>
                 <a:spcPct val="120000"/>
               </a:lnSpc>
@@ -6034,7 +5765,7 @@
             <a:endParaRPr lang="en-US" sz="1800" dirty="0"/>
           </a:p>
           <a:p>
-            <a:pPr algn="ctr" indent="0" marL="0">
+            <a:pPr marL="0" indent="0" algn="ctr">
               <a:lnSpc>
                 <a:spcPct val="120000"/>
               </a:lnSpc>
@@ -6076,7 +5807,7 @@
           <a:bodyPr wrap="square" lIns="0" tIns="0" rIns="0" bIns="0" rtlCol="0" anchor="ctr"/>
           <a:lstStyle/>
           <a:p>
-            <a:pPr algn="ctr" indent="0" marL="0">
+            <a:pPr marL="0" indent="0" algn="ctr">
               <a:buNone/>
             </a:pPr>
             <a:r>
@@ -6115,7 +5846,7 @@
           <a:bodyPr wrap="square" lIns="0" tIns="0" rIns="0" bIns="0" rtlCol="0" anchor="t"/>
           <a:lstStyle/>
           <a:p>
-            <a:pPr algn="ctr" indent="0" marL="0">
+            <a:pPr marL="0" indent="0" algn="ctr">
               <a:lnSpc>
                 <a:spcPct val="115000"/>
               </a:lnSpc>
@@ -6138,14 +5869,14 @@
       </p:sp>
       <p:pic>
         <p:nvPicPr>
-          <p:cNvPr id="17" name="Image 3" descr="C:\Code\Work\startuplab-partner-presentation\pptx-templates\media\logo-red.png">    </p:cNvPr>
+          <p:cNvPr id="17" name="Image 3" descr="C:\Code\Work\startuplab-partner-presentation\pptx-templates\media\logo-red.png"/>
           <p:cNvPicPr>
             <a:picLocks noChangeAspect="1"/>
           </p:cNvPicPr>
           <p:nvPr/>
         </p:nvPicPr>
         <p:blipFill>
-          <a:blip r:embed="rId4"/>
+          <a:blip r:embed="rId6"/>
           <a:stretch>
             <a:fillRect/>
           </a:stretch>
@@ -6176,6 +5907,7 @@
         <a:solidFill>
           <a:srgbClr val="131415"/>
         </a:solidFill>
+        <a:effectLst/>
       </p:bgPr>
     </p:bg>
     <p:spTree>
@@ -6211,6 +5943,13 @@
           </a:solidFill>
           <a:ln/>
         </p:spPr>
+        <p:txBody>
+          <a:bodyPr/>
+          <a:lstStyle/>
+          <a:p>
+            <a:endParaRPr lang="nb-NO"/>
+          </a:p>
+        </p:txBody>
       </p:sp>
       <p:sp>
         <p:nvSpPr>
@@ -6231,6 +5970,13 @@
           </a:solidFill>
           <a:ln/>
         </p:spPr>
+        <p:txBody>
+          <a:bodyPr/>
+          <a:lstStyle/>
+          <a:p>
+            <a:endParaRPr lang="nb-NO"/>
+          </a:p>
+        </p:txBody>
       </p:sp>
       <p:sp>
         <p:nvSpPr>
@@ -6251,6 +5997,13 @@
           </a:solidFill>
           <a:ln/>
         </p:spPr>
+        <p:txBody>
+          <a:bodyPr/>
+          <a:lstStyle/>
+          <a:p>
+            <a:endParaRPr lang="nb-NO"/>
+          </a:p>
+        </p:txBody>
       </p:sp>
       <p:sp>
         <p:nvSpPr>
@@ -6273,11 +6026,11 @@
           <a:bodyPr wrap="square" lIns="0" tIns="0" rIns="0" bIns="0" rtlCol="0" anchor="ctr"/>
           <a:lstStyle/>
           <a:p>
-            <a:pPr indent="0" marL="0">
-              <a:buNone/>
-            </a:pPr>
-            <a:r>
-              <a:rPr lang="en-US" sz="1600" b="1" spc="180" kern="0" dirty="0">
+            <a:pPr marL="0" indent="0">
+              <a:buNone/>
+            </a:pPr>
+            <a:r>
+              <a:rPr lang="en-US" sz="1600" b="1" kern="0" spc="180" dirty="0">
                 <a:solidFill>
                   <a:srgbClr val="FF3333"/>
                 </a:solidFill>
@@ -6312,7 +6065,7 @@
           <a:bodyPr wrap="square" lIns="0" tIns="0" rIns="0" bIns="0" rtlCol="0" anchor="t"/>
           <a:lstStyle/>
           <a:p>
-            <a:pPr indent="0" marL="0">
+            <a:pPr marL="0" indent="0">
               <a:buNone/>
             </a:pPr>
             <a:r>
@@ -6326,9 +6079,6 @@
               </a:rPr>
               <a:t>Året i </a:t>
             </a:r>
-            <a:pPr indent="0" marL="0">
-              <a:buNone/>
-            </a:pPr>
             <a:r>
               <a:rPr lang="en-US" sz="4000" b="1" dirty="0">
                 <a:solidFill>
@@ -6346,14 +6096,14 @@
       </p:sp>
       <p:pic>
         <p:nvPicPr>
-          <p:cNvPr id="7" name="Image 0" descr="C:\Code\Work\startuplab-partner-presentation\pptx-templates\media\logo-white.png">    </p:cNvPr>
+          <p:cNvPr id="7" name="Image 0" descr="C:\Code\Work\startuplab-partner-presentation\pptx-templates\media\logo-white.png"/>
           <p:cNvPicPr>
             <a:picLocks noChangeAspect="1"/>
           </p:cNvPicPr>
           <p:nvPr/>
         </p:nvPicPr>
         <p:blipFill>
-          <a:blip r:embed="rId1"/>
+          <a:blip r:embed="rId3"/>
           <a:stretch>
             <a:fillRect/>
           </a:stretch>
@@ -6384,6 +6134,7 @@
         <a:solidFill>
           <a:srgbClr val="FF3333"/>
         </a:solidFill>
+        <a:effectLst/>
       </p:bgPr>
     </p:bg>
     <p:spTree>
@@ -6402,14 +6153,14 @@
       </p:grpSpPr>
       <p:pic>
         <p:nvPicPr>
-          <p:cNvPr id="2" name="Image 0" descr="C:\Code\Work\startuplab-partner-presentation\pptx-templates\media\logo-white.png">    </p:cNvPr>
+          <p:cNvPr id="2" name="Image 0" descr="C:\Code\Work\startuplab-partner-presentation\pptx-templates\media\logo-white.png"/>
           <p:cNvPicPr>
             <a:picLocks noChangeAspect="1"/>
           </p:cNvPicPr>
           <p:nvPr/>
         </p:nvPicPr>
         <p:blipFill>
-          <a:blip r:embed="rId1"/>
+          <a:blip r:embed="rId3"/>
           <a:stretch>
             <a:fillRect/>
           </a:stretch>
@@ -6445,7 +6196,7 @@
           <a:bodyPr wrap="square" lIns="0" tIns="0" rIns="0" bIns="0" rtlCol="0" anchor="ctr"/>
           <a:lstStyle/>
           <a:p>
-            <a:pPr indent="0" marL="0">
+            <a:pPr marL="0" indent="0">
               <a:buNone/>
             </a:pPr>
             <a:r>
@@ -6484,7 +6235,7 @@
           <a:bodyPr wrap="square" lIns="0" tIns="0" rIns="0" bIns="0" rtlCol="0" anchor="ctr"/>
           <a:lstStyle/>
           <a:p>
-            <a:pPr indent="0" marL="0">
+            <a:pPr marL="0" indent="0">
               <a:buNone/>
             </a:pPr>
             <a:r>
@@ -6518,6 +6269,7 @@
         <a:solidFill>
           <a:srgbClr val="FFFFFF"/>
         </a:solidFill>
+        <a:effectLst/>
       </p:bgPr>
     </p:bg>
     <p:spTree>
@@ -6555,11 +6307,11 @@
           <a:bodyPr wrap="square" lIns="0" tIns="0" rIns="0" bIns="0" rtlCol="0" anchor="ctr"/>
           <a:lstStyle/>
           <a:p>
-            <a:pPr indent="0" marL="0">
-              <a:buNone/>
-            </a:pPr>
-            <a:r>
-              <a:rPr lang="en-US" sz="1600" b="1" spc="180" kern="0" dirty="0">
+            <a:pPr marL="0" indent="0">
+              <a:buNone/>
+            </a:pPr>
+            <a:r>
+              <a:rPr lang="en-US" sz="1600" b="1" kern="0" spc="180" dirty="0">
                 <a:solidFill>
                   <a:srgbClr val="FF3333"/>
                 </a:solidFill>
@@ -6594,7 +6346,7 @@
           <a:bodyPr wrap="square" lIns="0" tIns="0" rIns="0" bIns="0" rtlCol="0" anchor="t"/>
           <a:lstStyle/>
           <a:p>
-            <a:pPr indent="0" marL="0">
+            <a:pPr marL="0" indent="0">
               <a:lnSpc>
                 <a:spcPct val="100000"/>
               </a:lnSpc>
@@ -6636,7 +6388,7 @@
           <a:bodyPr wrap="square" lIns="0" tIns="0" rIns="0" bIns="0" rtlCol="0" anchor="ctr"/>
           <a:lstStyle/>
           <a:p>
-            <a:pPr indent="0" marL="0">
+            <a:pPr marL="0" indent="0">
               <a:buNone/>
             </a:pPr>
             <a:r>
@@ -6675,7 +6427,7 @@
           <a:bodyPr wrap="square" lIns="0" tIns="0" rIns="0" bIns="0" rtlCol="0" anchor="ctr"/>
           <a:lstStyle/>
           <a:p>
-            <a:pPr indent="0" marL="0">
+            <a:pPr marL="0" indent="0">
               <a:buNone/>
             </a:pPr>
             <a:r>
@@ -6714,7 +6466,7 @@
           <a:bodyPr wrap="square" lIns="0" tIns="0" rIns="0" bIns="0" rtlCol="0" anchor="ctr"/>
           <a:lstStyle/>
           <a:p>
-            <a:pPr indent="0" marL="0">
+            <a:pPr marL="0" indent="0">
               <a:buNone/>
             </a:pPr>
             <a:r>
@@ -6753,7 +6505,7 @@
           <a:bodyPr wrap="square" lIns="0" tIns="0" rIns="0" bIns="0" rtlCol="0" anchor="ctr"/>
           <a:lstStyle/>
           <a:p>
-            <a:pPr indent="0" marL="0">
+            <a:pPr marL="0" indent="0">
               <a:buNone/>
             </a:pPr>
             <a:r>
@@ -6792,7 +6544,7 @@
           <a:bodyPr wrap="square" lIns="0" tIns="0" rIns="0" bIns="0" rtlCol="0" anchor="ctr"/>
           <a:lstStyle/>
           <a:p>
-            <a:pPr indent="0" marL="0">
+            <a:pPr marL="0" indent="0">
               <a:buNone/>
             </a:pPr>
             <a:r>
@@ -6831,7 +6583,7 @@
           <a:bodyPr wrap="square" lIns="0" tIns="0" rIns="0" bIns="0" rtlCol="0" anchor="ctr"/>
           <a:lstStyle/>
           <a:p>
-            <a:pPr indent="0" marL="0">
+            <a:pPr marL="0" indent="0">
               <a:buNone/>
             </a:pPr>
             <a:r>
@@ -6870,7 +6622,7 @@
           <a:bodyPr wrap="square" lIns="0" tIns="0" rIns="0" bIns="0" rtlCol="0" anchor="ctr"/>
           <a:lstStyle/>
           <a:p>
-            <a:pPr indent="0" marL="0">
+            <a:pPr marL="0" indent="0">
               <a:buNone/>
             </a:pPr>
             <a:r>
@@ -6909,7 +6661,7 @@
           <a:bodyPr wrap="square" lIns="0" tIns="0" rIns="0" bIns="0" rtlCol="0" anchor="ctr"/>
           <a:lstStyle/>
           <a:p>
-            <a:pPr indent="0" marL="0">
+            <a:pPr marL="0" indent="0">
               <a:buNone/>
             </a:pPr>
             <a:r>
@@ -6948,7 +6700,7 @@
           <a:bodyPr wrap="square" lIns="0" tIns="0" rIns="0" bIns="0" rtlCol="0" anchor="ctr"/>
           <a:lstStyle/>
           <a:p>
-            <a:pPr indent="0" marL="0">
+            <a:pPr marL="0" indent="0">
               <a:buNone/>
             </a:pPr>
             <a:r>
@@ -6987,7 +6739,7 @@
           <a:bodyPr wrap="square" lIns="0" tIns="0" rIns="0" bIns="0" rtlCol="0" anchor="ctr"/>
           <a:lstStyle/>
           <a:p>
-            <a:pPr indent="0" marL="0">
+            <a:pPr marL="0" indent="0">
               <a:buNone/>
             </a:pPr>
             <a:r>
@@ -7026,7 +6778,7 @@
           <a:bodyPr wrap="square" lIns="0" tIns="0" rIns="0" bIns="0" rtlCol="0" anchor="ctr"/>
           <a:lstStyle/>
           <a:p>
-            <a:pPr indent="0" marL="0">
+            <a:pPr marL="0" indent="0">
               <a:buNone/>
             </a:pPr>
             <a:r>
@@ -7065,7 +6817,7 @@
           <a:bodyPr wrap="square" lIns="0" tIns="0" rIns="0" bIns="0" rtlCol="0" anchor="ctr"/>
           <a:lstStyle/>
           <a:p>
-            <a:pPr indent="0" marL="0">
+            <a:pPr marL="0" indent="0">
               <a:buNone/>
             </a:pPr>
             <a:r>
@@ -7085,14 +6837,14 @@
       </p:sp>
       <p:pic>
         <p:nvPicPr>
-          <p:cNvPr id="16" name="Image 0" descr="C:\Code\Work\startuplab-partner-presentation\pptx-templates\media\logo-red.png">    </p:cNvPr>
+          <p:cNvPr id="16" name="Image 0" descr="C:\Code\Work\startuplab-partner-presentation\pptx-templates\media\logo-red.png"/>
           <p:cNvPicPr>
             <a:picLocks noChangeAspect="1"/>
           </p:cNvPicPr>
           <p:nvPr/>
         </p:nvPicPr>
         <p:blipFill>
-          <a:blip r:embed="rId1"/>
+          <a:blip r:embed="rId3"/>
           <a:stretch>
             <a:fillRect/>
           </a:stretch>
@@ -7123,6 +6875,7 @@
         <a:solidFill>
           <a:srgbClr val="FF3333"/>
         </a:solidFill>
+        <a:effectLst/>
       </p:bgPr>
     </p:bg>
     <p:spTree>
@@ -7160,11 +6913,11 @@
           <a:bodyPr wrap="square" lIns="0" tIns="0" rIns="0" bIns="0" rtlCol="0" anchor="ctr"/>
           <a:lstStyle/>
           <a:p>
-            <a:pPr indent="0" marL="0">
-              <a:buNone/>
-            </a:pPr>
-            <a:r>
-              <a:rPr lang="en-US" sz="1600" b="1" spc="180" kern="0" dirty="0">
+            <a:pPr marL="0" indent="0">
+              <a:buNone/>
+            </a:pPr>
+            <a:r>
+              <a:rPr lang="en-US" sz="1600" b="1" kern="0" spc="180" dirty="0">
                 <a:solidFill>
                   <a:srgbClr val="FFFFFF"/>
                 </a:solidFill>
@@ -7199,7 +6952,7 @@
           <a:bodyPr wrap="square" lIns="0" tIns="0" rIns="0" bIns="0" rtlCol="0" anchor="t"/>
           <a:lstStyle/>
           <a:p>
-            <a:pPr indent="0" marL="0">
+            <a:pPr marL="0" indent="0">
               <a:lnSpc>
                 <a:spcPct val="85000"/>
               </a:lnSpc>
@@ -7219,7 +6972,7 @@
             <a:endParaRPr lang="en-US" sz="9200" dirty="0"/>
           </a:p>
           <a:p>
-            <a:pPr indent="0" marL="0">
+            <a:pPr marL="0" indent="0">
               <a:lnSpc>
                 <a:spcPct val="85000"/>
               </a:lnSpc>
@@ -7242,14 +6995,14 @@
       </p:sp>
       <p:pic>
         <p:nvPicPr>
-          <p:cNvPr id="4" name="Image 0" descr="C:\Code\Work\startuplab-partner-presentation\pptx-templates\media\logo-white.png">    </p:cNvPr>
+          <p:cNvPr id="4" name="Image 0" descr="C:\Code\Work\startuplab-partner-presentation\pptx-templates\media\logo-white.png"/>
           <p:cNvPicPr>
             <a:picLocks noChangeAspect="1"/>
           </p:cNvPicPr>
           <p:nvPr/>
         </p:nvPicPr>
         <p:blipFill>
-          <a:blip r:embed="rId1"/>
+          <a:blip r:embed="rId3"/>
           <a:stretch>
             <a:fillRect/>
           </a:stretch>
@@ -7280,6 +7033,7 @@
         <a:solidFill>
           <a:srgbClr val="131415"/>
         </a:solidFill>
+        <a:effectLst/>
       </p:bgPr>
     </p:bg>
     <p:spTree>
@@ -7317,11 +7071,11 @@
           <a:bodyPr wrap="square" lIns="0" tIns="0" rIns="0" bIns="0" rtlCol="0" anchor="ctr"/>
           <a:lstStyle/>
           <a:p>
-            <a:pPr indent="0" marL="0">
-              <a:buNone/>
-            </a:pPr>
-            <a:r>
-              <a:rPr lang="en-US" sz="1600" b="1" spc="180" kern="0" dirty="0">
+            <a:pPr marL="0" indent="0">
+              <a:buNone/>
+            </a:pPr>
+            <a:r>
+              <a:rPr lang="en-US" sz="1600" b="1" kern="0" spc="180" dirty="0">
                 <a:solidFill>
                   <a:srgbClr val="FF3333"/>
                 </a:solidFill>
@@ -7356,7 +7110,7 @@
           <a:bodyPr wrap="square" lIns="0" tIns="0" rIns="0" bIns="0" rtlCol="0" anchor="t"/>
           <a:lstStyle/>
           <a:p>
-            <a:pPr indent="0" marL="0">
+            <a:pPr marL="0" indent="0">
               <a:lnSpc>
                 <a:spcPct val="80000"/>
               </a:lnSpc>
@@ -7398,7 +7152,7 @@
           <a:bodyPr wrap="square" lIns="0" tIns="0" rIns="0" bIns="0" rtlCol="0" anchor="t"/>
           <a:lstStyle/>
           <a:p>
-            <a:pPr indent="0" marL="0">
+            <a:pPr marL="0" indent="0">
               <a:lnSpc>
                 <a:spcPct val="105000"/>
               </a:lnSpc>
@@ -7418,7 +7172,7 @@
             <a:endParaRPr lang="en-US" sz="2700" dirty="0"/>
           </a:p>
           <a:p>
-            <a:pPr indent="0" marL="0">
+            <a:pPr marL="0" indent="0">
               <a:lnSpc>
                 <a:spcPct val="105000"/>
               </a:lnSpc>
@@ -7460,7 +7214,7 @@
           <a:bodyPr wrap="square" lIns="0" tIns="0" rIns="0" bIns="0" rtlCol="0" anchor="t"/>
           <a:lstStyle/>
           <a:p>
-            <a:pPr indent="0" marL="0">
+            <a:pPr marL="0" indent="0">
               <a:lnSpc>
                 <a:spcPct val="135000"/>
               </a:lnSpc>
@@ -7483,14 +7237,14 @@
       </p:sp>
       <p:pic>
         <p:nvPicPr>
-          <p:cNvPr id="6" name="Image 0" descr="C:\Code\Work\startuplab-partner-presentation\pptx-templates\media\logo-white.png">    </p:cNvPr>
+          <p:cNvPr id="6" name="Image 0" descr="C:\Code\Work\startuplab-partner-presentation\pptx-templates\media\logo-white.png"/>
           <p:cNvPicPr>
             <a:picLocks noChangeAspect="1"/>
           </p:cNvPicPr>
           <p:nvPr/>
         </p:nvPicPr>
         <p:blipFill>
-          <a:blip r:embed="rId1"/>
+          <a:blip r:embed="rId3"/>
           <a:stretch>
             <a:fillRect/>
           </a:stretch>
@@ -7521,6 +7275,7 @@
         <a:solidFill>
           <a:srgbClr val="F7F7F7"/>
         </a:solidFill>
+        <a:effectLst/>
       </p:bgPr>
     </p:bg>
     <p:spTree>
@@ -7558,11 +7313,11 @@
           <a:bodyPr wrap="square" lIns="0" tIns="0" rIns="0" bIns="0" rtlCol="0" anchor="ctr"/>
           <a:lstStyle/>
           <a:p>
-            <a:pPr indent="0" marL="0">
-              <a:buNone/>
-            </a:pPr>
-            <a:r>
-              <a:rPr lang="en-US" sz="1600" b="1" spc="180" kern="0" dirty="0">
+            <a:pPr marL="0" indent="0">
+              <a:buNone/>
+            </a:pPr>
+            <a:r>
+              <a:rPr lang="en-US" sz="1600" b="1" kern="0" spc="180" dirty="0">
                 <a:solidFill>
                   <a:srgbClr val="FF3333"/>
                 </a:solidFill>
@@ -7597,7 +7352,7 @@
           <a:bodyPr wrap="square" lIns="0" tIns="0" rIns="0" bIns="0" rtlCol="0" anchor="t"/>
           <a:lstStyle/>
           <a:p>
-            <a:pPr indent="0" marL="0">
+            <a:pPr marL="0" indent="0">
               <a:lnSpc>
                 <a:spcPct val="100000"/>
               </a:lnSpc>
@@ -7614,12 +7369,6 @@
               </a:rPr>
               <a:t>Tretten år, oppsummert i </a:t>
             </a:r>
-            <a:pPr indent="0" marL="0">
-              <a:lnSpc>
-                <a:spcPct val="100000"/>
-              </a:lnSpc>
-              <a:buNone/>
-            </a:pPr>
             <a:r>
               <a:rPr lang="en-US" sz="4000" b="1" dirty="0">
                 <a:solidFill>
@@ -7656,7 +7405,7 @@
           <a:bodyPr wrap="square" lIns="0" tIns="0" rIns="0" bIns="0" rtlCol="0" anchor="t"/>
           <a:lstStyle/>
           <a:p>
-            <a:pPr indent="0" marL="0">
+            <a:pPr marL="0" indent="0">
               <a:lnSpc>
                 <a:spcPct val="90000"/>
               </a:lnSpc>
@@ -7698,7 +7447,7 @@
           <a:bodyPr wrap="square" lIns="0" tIns="0" rIns="0" bIns="0" rtlCol="0" anchor="t"/>
           <a:lstStyle/>
           <a:p>
-            <a:pPr indent="0" marL="0">
+            <a:pPr marL="0" indent="0">
               <a:lnSpc>
                 <a:spcPct val="115000"/>
               </a:lnSpc>
@@ -7740,7 +7489,7 @@
           <a:bodyPr wrap="square" lIns="0" tIns="0" rIns="0" bIns="0" rtlCol="0" anchor="t"/>
           <a:lstStyle/>
           <a:p>
-            <a:pPr indent="0" marL="0">
+            <a:pPr marL="0" indent="0">
               <a:lnSpc>
                 <a:spcPct val="90000"/>
               </a:lnSpc>
@@ -7782,7 +7531,7 @@
           <a:bodyPr wrap="square" lIns="0" tIns="0" rIns="0" bIns="0" rtlCol="0" anchor="t"/>
           <a:lstStyle/>
           <a:p>
-            <a:pPr indent="0" marL="0">
+            <a:pPr marL="0" indent="0">
               <a:lnSpc>
                 <a:spcPct val="115000"/>
               </a:lnSpc>
@@ -7824,7 +7573,7 @@
           <a:bodyPr wrap="square" lIns="0" tIns="0" rIns="0" bIns="0" rtlCol="0" anchor="t"/>
           <a:lstStyle/>
           <a:p>
-            <a:pPr indent="0" marL="0">
+            <a:pPr marL="0" indent="0">
               <a:lnSpc>
                 <a:spcPct val="90000"/>
               </a:lnSpc>
@@ -7866,7 +7615,7 @@
           <a:bodyPr wrap="square" lIns="0" tIns="0" rIns="0" bIns="0" rtlCol="0" anchor="t"/>
           <a:lstStyle/>
           <a:p>
-            <a:pPr indent="0" marL="0">
+            <a:pPr marL="0" indent="0">
               <a:lnSpc>
                 <a:spcPct val="115000"/>
               </a:lnSpc>
@@ -7889,14 +7638,14 @@
       </p:sp>
       <p:pic>
         <p:nvPicPr>
-          <p:cNvPr id="10" name="Image 0" descr="C:\Code\Work\startuplab-partner-presentation\pptx-templates\media\logo-red.png">    </p:cNvPr>
+          <p:cNvPr id="10" name="Image 0" descr="C:\Code\Work\startuplab-partner-presentation\pptx-templates\media\logo-red.png"/>
           <p:cNvPicPr>
             <a:picLocks noChangeAspect="1"/>
           </p:cNvPicPr>
           <p:nvPr/>
         </p:nvPicPr>
         <p:blipFill>
-          <a:blip r:embed="rId1"/>
+          <a:blip r:embed="rId3"/>
           <a:stretch>
             <a:fillRect/>
           </a:stretch>
@@ -7938,15 +7687,15 @@
       </p:grpSpPr>
       <p:pic>
         <p:nvPicPr>
-          <p:cNvPr id="2" name="Image 0" descr="C:\Code\Work\startuplab-partner-presentation\pptx-templates\media\fullbleed.jpg">    </p:cNvPr>
+          <p:cNvPr id="2" name="Image 0" descr="C:\Code\Work\startuplab-partner-presentation\pptx-templates\media\fullbleed.jpg"/>
           <p:cNvPicPr>
             <a:picLocks noChangeAspect="1"/>
           </p:cNvPicPr>
           <p:nvPr/>
         </p:nvPicPr>
         <p:blipFill>
-          <a:blip r:embed="rId1"/>
-          <a:srcRect l="0" r="0" t="0" b="0"/>
+          <a:blip r:embed="rId3"/>
+          <a:srcRect/>
           <a:stretch/>
         </p:blipFill>
         <p:spPr>
@@ -7980,6 +7729,13 @@
           </a:solidFill>
           <a:ln/>
         </p:spPr>
+        <p:txBody>
+          <a:bodyPr/>
+          <a:lstStyle/>
+          <a:p>
+            <a:endParaRPr lang="nb-NO"/>
+          </a:p>
+        </p:txBody>
       </p:sp>
       <p:sp>
         <p:nvSpPr>
@@ -8002,11 +7758,11 @@
           <a:bodyPr wrap="square" lIns="0" tIns="0" rIns="0" bIns="0" rtlCol="0" anchor="ctr"/>
           <a:lstStyle/>
           <a:p>
-            <a:pPr indent="0" marL="0">
-              <a:buNone/>
-            </a:pPr>
-            <a:r>
-              <a:rPr lang="en-US" sz="1600" b="1" spc="180" kern="0" dirty="0">
+            <a:pPr marL="0" indent="0">
+              <a:buNone/>
+            </a:pPr>
+            <a:r>
+              <a:rPr lang="en-US" sz="1600" b="1" kern="0" spc="180" dirty="0">
                 <a:solidFill>
                   <a:srgbClr val="FFFFFF"/>
                 </a:solidFill>
@@ -8041,7 +7797,7 @@
           <a:bodyPr wrap="square" lIns="0" tIns="0" rIns="0" bIns="0" rtlCol="0" anchor="t"/>
           <a:lstStyle/>
           <a:p>
-            <a:pPr indent="0" marL="0">
+            <a:pPr marL="0" indent="0">
               <a:lnSpc>
                 <a:spcPct val="100000"/>
               </a:lnSpc>
@@ -8061,7 +7817,7 @@
             <a:endParaRPr lang="en-US" sz="4000" dirty="0"/>
           </a:p>
           <a:p>
-            <a:pPr indent="0" marL="0">
+            <a:pPr marL="0" indent="0">
               <a:lnSpc>
                 <a:spcPct val="100000"/>
               </a:lnSpc>
@@ -8084,14 +7840,14 @@
       </p:sp>
       <p:pic>
         <p:nvPicPr>
-          <p:cNvPr id="6" name="Image 1" descr="C:\Code\Work\startuplab-partner-presentation\pptx-templates\media\logo-white.png">    </p:cNvPr>
+          <p:cNvPr id="6" name="Image 1" descr="C:\Code\Work\startuplab-partner-presentation\pptx-templates\media\logo-white.png"/>
           <p:cNvPicPr>
             <a:picLocks noChangeAspect="1"/>
           </p:cNvPicPr>
           <p:nvPr/>
         </p:nvPicPr>
         <p:blipFill>
-          <a:blip r:embed="rId2"/>
+          <a:blip r:embed="rId4"/>
           <a:stretch>
             <a:fillRect/>
           </a:stretch>
@@ -8122,6 +7878,7 @@
         <a:solidFill>
           <a:srgbClr val="FFFFFF"/>
         </a:solidFill>
+        <a:effectLst/>
       </p:bgPr>
     </p:bg>
     <p:spTree>
@@ -8140,15 +7897,15 @@
       </p:grpSpPr>
       <p:pic>
         <p:nvPicPr>
-          <p:cNvPr id="2" name="Image 0" descr="C:\Code\Work\startuplab-partner-presentation\pptx-templates\media\split.jpg">    </p:cNvPr>
+          <p:cNvPr id="2" name="Image 0" descr="C:\Code\Work\startuplab-partner-presentation\pptx-templates\media\split.jpg"/>
           <p:cNvPicPr>
             <a:picLocks noChangeAspect="1"/>
           </p:cNvPicPr>
           <p:nvPr/>
         </p:nvPicPr>
         <p:blipFill>
-          <a:blip r:embed="rId1"/>
-          <a:srcRect l="0" r="0" t="0" b="0"/>
+          <a:blip r:embed="rId3"/>
+          <a:srcRect/>
           <a:stretch/>
         </p:blipFill>
         <p:spPr>
@@ -8182,11 +7939,11 @@
           <a:bodyPr wrap="square" lIns="0" tIns="0" rIns="0" bIns="0" rtlCol="0" anchor="ctr"/>
           <a:lstStyle/>
           <a:p>
-            <a:pPr indent="0" marL="0">
-              <a:buNone/>
-            </a:pPr>
-            <a:r>
-              <a:rPr lang="en-US" sz="1600" b="1" spc="180" kern="0" dirty="0">
+            <a:pPr marL="0" indent="0">
+              <a:buNone/>
+            </a:pPr>
+            <a:r>
+              <a:rPr lang="en-US" sz="1600" b="1" kern="0" spc="180" dirty="0">
                 <a:solidFill>
                   <a:srgbClr val="FF3333"/>
                 </a:solidFill>
@@ -8221,7 +7978,7 @@
           <a:bodyPr wrap="square" lIns="0" tIns="0" rIns="0" bIns="0" rtlCol="0" anchor="t"/>
           <a:lstStyle/>
           <a:p>
-            <a:pPr indent="0" marL="0">
+            <a:pPr marL="0" indent="0">
               <a:lnSpc>
                 <a:spcPct val="102000"/>
               </a:lnSpc>
@@ -8232,16 +7989,19 @@
                 <a:solidFill>
                   <a:srgbClr val="131415"/>
                 </a:solidFill>
-                <a:latin typeface="Replica LL TT" pitchFamily="34" charset="0"/>
+                <a:latin typeface="Replica LL TT Heavy" panose="020B0904010101010104" pitchFamily="34" charset="0"/>
                 <a:ea typeface="Replica LL TT" pitchFamily="34" charset="-122"/>
-                <a:cs typeface="Replica LL TT" pitchFamily="34" charset="-120"/>
+                <a:cs typeface="Replica LL TT Heavy" panose="020B0904010101010104" pitchFamily="34" charset="0"/>
               </a:rPr>
               <a:t>Fra første møte</a:t>
             </a:r>
-            <a:endParaRPr lang="en-US" sz="3400" dirty="0"/>
-          </a:p>
-          <a:p>
-            <a:pPr indent="0" marL="0">
+            <a:endParaRPr lang="en-US" sz="3400" dirty="0">
+              <a:latin typeface="Replica LL TT Heavy" panose="020B0904010101010104" pitchFamily="34" charset="0"/>
+              <a:cs typeface="Replica LL TT Heavy" panose="020B0904010101010104" pitchFamily="34" charset="0"/>
+            </a:endParaRPr>
+          </a:p>
+          <a:p>
+            <a:pPr marL="0" indent="0">
               <a:lnSpc>
                 <a:spcPct val="102000"/>
               </a:lnSpc>
@@ -8252,30 +8012,27 @@
                 <a:solidFill>
                   <a:srgbClr val="131415"/>
                 </a:solidFill>
-                <a:latin typeface="Replica LL TT" pitchFamily="34" charset="0"/>
+                <a:latin typeface="Replica LL TT Heavy" panose="020B0904010101010104" pitchFamily="34" charset="0"/>
                 <a:ea typeface="Replica LL TT" pitchFamily="34" charset="-122"/>
-                <a:cs typeface="Replica LL TT" pitchFamily="34" charset="-120"/>
+                <a:cs typeface="Replica LL TT Heavy" panose="020B0904010101010104" pitchFamily="34" charset="0"/>
               </a:rPr>
               <a:t>til signert </a:t>
             </a:r>
-            <a:pPr indent="0" marL="0">
-              <a:lnSpc>
-                <a:spcPct val="102000"/>
-              </a:lnSpc>
-              <a:buNone/>
-            </a:pPr>
             <a:r>
               <a:rPr lang="en-US" sz="3400" b="1" dirty="0">
                 <a:solidFill>
                   <a:srgbClr val="FF3333"/>
                 </a:solidFill>
-                <a:latin typeface="Replica LL TT" pitchFamily="34" charset="0"/>
+                <a:latin typeface="Replica LL TT Heavy" panose="020B0904010101010104" pitchFamily="34" charset="0"/>
                 <a:ea typeface="Replica LL TT" pitchFamily="34" charset="-122"/>
-                <a:cs typeface="Replica LL TT" pitchFamily="34" charset="-120"/>
+                <a:cs typeface="Replica LL TT Heavy" panose="020B0904010101010104" pitchFamily="34" charset="0"/>
               </a:rPr>
               <a:t>pilot</a:t>
             </a:r>
-            <a:endParaRPr lang="en-US" sz="3400" dirty="0"/>
+            <a:endParaRPr lang="en-US" sz="3400" dirty="0">
+              <a:latin typeface="Replica LL TT Heavy" panose="020B0904010101010104" pitchFamily="34" charset="0"/>
+              <a:cs typeface="Replica LL TT Heavy" panose="020B0904010101010104" pitchFamily="34" charset="0"/>
+            </a:endParaRPr>
           </a:p>
         </p:txBody>
       </p:sp>
@@ -8300,10 +8057,7 @@
           <a:bodyPr wrap="square" lIns="0" tIns="0" rIns="0" bIns="0" rtlCol="0" anchor="t"/>
           <a:lstStyle/>
           <a:p>
-            <a:pPr indent="0" marL="0">
-              <a:lnSpc>
-                <a:spcPct val="140000"/>
-              </a:lnSpc>
+            <a:pPr marL="0" indent="0">
               <a:buNone/>
             </a:pPr>
             <a:r>
@@ -8323,14 +8077,14 @@
       </p:sp>
       <p:pic>
         <p:nvPicPr>
-          <p:cNvPr id="6" name="Image 1" descr="C:\Code\Work\startuplab-partner-presentation\pptx-templates\media\logo-red.png">    </p:cNvPr>
+          <p:cNvPr id="6" name="Image 1" descr="C:\Code\Work\startuplab-partner-presentation\pptx-templates\media\logo-red.png"/>
           <p:cNvPicPr>
             <a:picLocks noChangeAspect="1"/>
           </p:cNvPicPr>
           <p:nvPr/>
         </p:nvPicPr>
         <p:blipFill>
-          <a:blip r:embed="rId2"/>
+          <a:blip r:embed="rId4"/>
           <a:stretch>
             <a:fillRect/>
           </a:stretch>
@@ -8361,6 +8115,7 @@
         <a:solidFill>
           <a:srgbClr val="131415"/>
         </a:solidFill>
+        <a:effectLst/>
       </p:bgPr>
     </p:bg>
     <p:spTree>
@@ -8398,11 +8153,11 @@
           <a:bodyPr wrap="square" lIns="0" tIns="0" rIns="0" bIns="0" rtlCol="0" anchor="ctr"/>
           <a:lstStyle/>
           <a:p>
-            <a:pPr indent="0" marL="0">
-              <a:buNone/>
-            </a:pPr>
-            <a:r>
-              <a:rPr lang="en-US" sz="1600" b="1" spc="180" kern="0" dirty="0">
+            <a:pPr marL="0" indent="0">
+              <a:buNone/>
+            </a:pPr>
+            <a:r>
+              <a:rPr lang="en-US" sz="1600" b="1" kern="0" spc="180" dirty="0">
                 <a:solidFill>
                   <a:srgbClr val="FF3333"/>
                 </a:solidFill>
@@ -8437,7 +8192,7 @@
           <a:bodyPr wrap="square" lIns="0" tIns="0" rIns="0" bIns="0" rtlCol="0" anchor="t"/>
           <a:lstStyle/>
           <a:p>
-            <a:pPr indent="0" marL="0">
+            <a:pPr marL="0" indent="0">
               <a:lnSpc>
                 <a:spcPct val="100000"/>
               </a:lnSpc>
@@ -8454,12 +8209,6 @@
               </a:rPr>
               <a:t>Fem sektorer, ett </a:t>
             </a:r>
-            <a:pPr indent="0" marL="0">
-              <a:lnSpc>
-                <a:spcPct val="100000"/>
-              </a:lnSpc>
-              <a:buNone/>
-            </a:pPr>
             <a:r>
               <a:rPr lang="en-US" sz="4000" b="1" dirty="0">
                 <a:solidFill>
@@ -8477,15 +8226,15 @@
       </p:sp>
       <p:pic>
         <p:nvPicPr>
-          <p:cNvPr id="4" name="Image 0" descr="C:\Code\Work\startuplab-partner-presentation\pptx-templates\media\card-energy.jpg">    </p:cNvPr>
+          <p:cNvPr id="4" name="Image 0" descr="C:\Code\Work\startuplab-partner-presentation\pptx-templates\media\card-energy.jpg"/>
           <p:cNvPicPr>
             <a:picLocks noChangeAspect="1"/>
           </p:cNvPicPr>
           <p:nvPr/>
         </p:nvPicPr>
         <p:blipFill>
-          <a:blip r:embed="rId1"/>
-          <a:srcRect l="0" r="0" t="0" b="0"/>
+          <a:blip r:embed="rId3"/>
+          <a:srcRect/>
           <a:stretch/>
         </p:blipFill>
         <p:spPr>
@@ -8519,6 +8268,13 @@
           </a:solidFill>
           <a:ln/>
         </p:spPr>
+        <p:txBody>
+          <a:bodyPr/>
+          <a:lstStyle/>
+          <a:p>
+            <a:endParaRPr lang="nb-NO"/>
+          </a:p>
+        </p:txBody>
       </p:sp>
       <p:sp>
         <p:nvSpPr>
@@ -8541,7 +8297,7 @@
           <a:bodyPr wrap="square" lIns="0" tIns="0" rIns="0" bIns="0" rtlCol="0" anchor="ctr"/>
           <a:lstStyle/>
           <a:p>
-            <a:pPr algn="ctr" indent="0" marL="0">
+            <a:pPr marL="0" indent="0" algn="ctr">
               <a:buNone/>
             </a:pPr>
             <a:r>
@@ -8561,15 +8317,15 @@
       </p:sp>
       <p:pic>
         <p:nvPicPr>
-          <p:cNvPr id="7" name="Image 1" descr="C:\Code\Work\startuplab-partner-presentation\pptx-templates\media\card-ocean.jpg">    </p:cNvPr>
+          <p:cNvPr id="7" name="Image 1" descr="C:\Code\Work\startuplab-partner-presentation\pptx-templates\media\card-ocean.jpg"/>
           <p:cNvPicPr>
             <a:picLocks noChangeAspect="1"/>
           </p:cNvPicPr>
           <p:nvPr/>
         </p:nvPicPr>
         <p:blipFill>
-          <a:blip r:embed="rId2"/>
-          <a:srcRect l="0" r="0" t="0" b="0"/>
+          <a:blip r:embed="rId4"/>
+          <a:srcRect/>
           <a:stretch/>
         </p:blipFill>
         <p:spPr>
@@ -8603,6 +8359,13 @@
           </a:solidFill>
           <a:ln/>
         </p:spPr>
+        <p:txBody>
+          <a:bodyPr/>
+          <a:lstStyle/>
+          <a:p>
+            <a:endParaRPr lang="nb-NO"/>
+          </a:p>
+        </p:txBody>
       </p:sp>
       <p:sp>
         <p:nvSpPr>
@@ -8625,7 +8388,7 @@
           <a:bodyPr wrap="square" lIns="0" tIns="0" rIns="0" bIns="0" rtlCol="0" anchor="ctr"/>
           <a:lstStyle/>
           <a:p>
-            <a:pPr algn="ctr" indent="0" marL="0">
+            <a:pPr marL="0" indent="0" algn="ctr">
               <a:buNone/>
             </a:pPr>
             <a:r>
@@ -8645,15 +8408,15 @@
       </p:sp>
       <p:pic>
         <p:nvPicPr>
-          <p:cNvPr id="10" name="Image 2" descr="C:\Code\Work\startuplab-partner-presentation\pptx-templates\media\card-hardware.jpg">    </p:cNvPr>
+          <p:cNvPr id="10" name="Image 2" descr="C:\Code\Work\startuplab-partner-presentation\pptx-templates\media\card-hardware.jpg"/>
           <p:cNvPicPr>
             <a:picLocks noChangeAspect="1"/>
           </p:cNvPicPr>
           <p:nvPr/>
         </p:nvPicPr>
         <p:blipFill>
-          <a:blip r:embed="rId3"/>
-          <a:srcRect l="0" r="0" t="0" b="0"/>
+          <a:blip r:embed="rId5"/>
+          <a:srcRect/>
           <a:stretch/>
         </p:blipFill>
         <p:spPr>
@@ -8687,6 +8450,13 @@
           </a:solidFill>
           <a:ln/>
         </p:spPr>
+        <p:txBody>
+          <a:bodyPr/>
+          <a:lstStyle/>
+          <a:p>
+            <a:endParaRPr lang="nb-NO"/>
+          </a:p>
+        </p:txBody>
       </p:sp>
       <p:sp>
         <p:nvSpPr>
@@ -8709,7 +8479,7 @@
           <a:bodyPr wrap="square" lIns="0" tIns="0" rIns="0" bIns="0" rtlCol="0" anchor="ctr"/>
           <a:lstStyle/>
           <a:p>
-            <a:pPr algn="ctr" indent="0" marL="0">
+            <a:pPr marL="0" indent="0" algn="ctr">
               <a:buNone/>
             </a:pPr>
             <a:r>
@@ -8729,15 +8499,15 @@
       </p:sp>
       <p:pic>
         <p:nvPicPr>
-          <p:cNvPr id="13" name="Image 3" descr="C:\Code\Work\startuplab-partner-presentation\pptx-templates\media\card-construction.jpg">    </p:cNvPr>
+          <p:cNvPr id="13" name="Image 3" descr="C:\Code\Work\startuplab-partner-presentation\pptx-templates\media\card-construction.jpg"/>
           <p:cNvPicPr>
             <a:picLocks noChangeAspect="1"/>
           </p:cNvPicPr>
           <p:nvPr/>
         </p:nvPicPr>
         <p:blipFill>
-          <a:blip r:embed="rId4"/>
-          <a:srcRect l="0" r="0" t="0" b="0"/>
+          <a:blip r:embed="rId6"/>
+          <a:srcRect/>
           <a:stretch/>
         </p:blipFill>
         <p:spPr>
@@ -8771,6 +8541,13 @@
           </a:solidFill>
           <a:ln/>
         </p:spPr>
+        <p:txBody>
+          <a:bodyPr/>
+          <a:lstStyle/>
+          <a:p>
+            <a:endParaRPr lang="nb-NO"/>
+          </a:p>
+        </p:txBody>
       </p:sp>
       <p:sp>
         <p:nvSpPr>
@@ -8793,7 +8570,7 @@
           <a:bodyPr wrap="square" lIns="0" tIns="0" rIns="0" bIns="0" rtlCol="0" anchor="ctr"/>
           <a:lstStyle/>
           <a:p>
-            <a:pPr algn="ctr" indent="0" marL="0">
+            <a:pPr marL="0" indent="0" algn="ctr">
               <a:buNone/>
             </a:pPr>
             <a:r>
@@ -8813,15 +8590,15 @@
       </p:sp>
       <p:pic>
         <p:nvPicPr>
-          <p:cNvPr id="16" name="Image 4" descr="C:\Code\Work\startuplab-partner-presentation\pptx-templates\media\card-defence.jpg">    </p:cNvPr>
+          <p:cNvPr id="16" name="Image 4" descr="C:\Code\Work\startuplab-partner-presentation\pptx-templates\media\card-defence.jpg"/>
           <p:cNvPicPr>
             <a:picLocks noChangeAspect="1"/>
           </p:cNvPicPr>
           <p:nvPr/>
         </p:nvPicPr>
         <p:blipFill>
-          <a:blip r:embed="rId5"/>
-          <a:srcRect l="0" r="0" t="0" b="0"/>
+          <a:blip r:embed="rId7"/>
+          <a:srcRect/>
           <a:stretch/>
         </p:blipFill>
         <p:spPr>
@@ -8855,6 +8632,13 @@
           </a:solidFill>
           <a:ln/>
         </p:spPr>
+        <p:txBody>
+          <a:bodyPr/>
+          <a:lstStyle/>
+          <a:p>
+            <a:endParaRPr lang="nb-NO"/>
+          </a:p>
+        </p:txBody>
       </p:sp>
       <p:sp>
         <p:nvSpPr>
@@ -8877,7 +8661,7 @@
           <a:bodyPr wrap="square" lIns="0" tIns="0" rIns="0" bIns="0" rtlCol="0" anchor="ctr"/>
           <a:lstStyle/>
           <a:p>
-            <a:pPr algn="ctr" indent="0" marL="0">
+            <a:pPr marL="0" indent="0" algn="ctr">
               <a:buNone/>
             </a:pPr>
             <a:r>
@@ -8897,14 +8681,14 @@
       </p:sp>
       <p:pic>
         <p:nvPicPr>
-          <p:cNvPr id="19" name="Image 5" descr="C:\Code\Work\startuplab-partner-presentation\pptx-templates\media\logo-white.png">    </p:cNvPr>
+          <p:cNvPr id="19" name="Image 5" descr="C:\Code\Work\startuplab-partner-presentation\pptx-templates\media\logo-white.png"/>
           <p:cNvPicPr>
             <a:picLocks noChangeAspect="1"/>
           </p:cNvPicPr>
           <p:nvPr/>
         </p:nvPicPr>
         <p:blipFill>
-          <a:blip r:embed="rId6"/>
+          <a:blip r:embed="rId8"/>
           <a:stretch>
             <a:fillRect/>
           </a:stretch>
@@ -8935,6 +8719,7 @@
         <a:solidFill>
           <a:srgbClr val="FFFFFF"/>
         </a:solidFill>
+        <a:effectLst/>
       </p:bgPr>
     </p:bg>
     <p:spTree>
@@ -8972,11 +8757,11 @@
           <a:bodyPr wrap="square" lIns="0" tIns="0" rIns="0" bIns="0" rtlCol="0" anchor="ctr"/>
           <a:lstStyle/>
           <a:p>
-            <a:pPr indent="0" marL="0">
-              <a:buNone/>
-            </a:pPr>
-            <a:r>
-              <a:rPr lang="en-US" sz="1600" b="1" spc="180" kern="0" dirty="0">
+            <a:pPr marL="0" indent="0">
+              <a:buNone/>
+            </a:pPr>
+            <a:r>
+              <a:rPr lang="en-US" sz="1600" b="1" kern="0" spc="180" dirty="0">
                 <a:solidFill>
                   <a:srgbClr val="FF3333"/>
                 </a:solidFill>
@@ -9011,7 +8796,7 @@
           <a:bodyPr wrap="square" lIns="0" tIns="0" rIns="0" bIns="0" rtlCol="0" anchor="t"/>
           <a:lstStyle/>
           <a:p>
-            <a:pPr indent="0" marL="0">
+            <a:pPr marL="0" indent="0">
               <a:lnSpc>
                 <a:spcPct val="100000"/>
               </a:lnSpc>
@@ -9028,12 +8813,6 @@
               </a:rPr>
               <a:t>Seks konkrete </a:t>
             </a:r>
-            <a:pPr indent="0" marL="0">
-              <a:lnSpc>
-                <a:spcPct val="100000"/>
-              </a:lnSpc>
-              <a:buNone/>
-            </a:pPr>
             <a:r>
               <a:rPr lang="en-US" sz="4000" b="1" dirty="0">
                 <a:solidFill>
@@ -9070,7 +8849,7 @@
           <a:bodyPr wrap="square" lIns="0" tIns="0" rIns="0" bIns="0" rtlCol="0" anchor="ctr"/>
           <a:lstStyle/>
           <a:p>
-            <a:pPr indent="0" marL="0">
+            <a:pPr marL="0" indent="0">
               <a:buNone/>
             </a:pPr>
             <a:r>
@@ -9109,7 +8888,7 @@
           <a:bodyPr wrap="square" lIns="0" tIns="0" rIns="0" bIns="0" rtlCol="0" anchor="ctr"/>
           <a:lstStyle/>
           <a:p>
-            <a:pPr indent="0" marL="0">
+            <a:pPr marL="0" indent="0">
               <a:buNone/>
             </a:pPr>
             <a:r>
@@ -9148,10 +8927,7 @@
           <a:bodyPr wrap="square" lIns="0" tIns="0" rIns="0" bIns="0" rtlCol="0" anchor="t"/>
           <a:lstStyle/>
           <a:p>
-            <a:pPr indent="0" marL="0">
-              <a:lnSpc>
-                <a:spcPct val="130000"/>
-              </a:lnSpc>
+            <a:pPr marL="0" indent="0">
               <a:buNone/>
             </a:pPr>
             <a:r>
@@ -9190,7 +8966,7 @@
           <a:bodyPr wrap="square" lIns="0" tIns="0" rIns="0" bIns="0" rtlCol="0" anchor="ctr"/>
           <a:lstStyle/>
           <a:p>
-            <a:pPr indent="0" marL="0">
+            <a:pPr marL="0" indent="0">
               <a:buNone/>
             </a:pPr>
             <a:r>
@@ -9229,7 +9005,7 @@
           <a:bodyPr wrap="square" lIns="0" tIns="0" rIns="0" bIns="0" rtlCol="0" anchor="ctr"/>
           <a:lstStyle/>
           <a:p>
-            <a:pPr indent="0" marL="0">
+            <a:pPr marL="0" indent="0">
               <a:buNone/>
             </a:pPr>
             <a:r>
@@ -9268,10 +9044,7 @@
           <a:bodyPr wrap="square" lIns="0" tIns="0" rIns="0" bIns="0" rtlCol="0" anchor="t"/>
           <a:lstStyle/>
           <a:p>
-            <a:pPr indent="0" marL="0">
-              <a:lnSpc>
-                <a:spcPct val="130000"/>
-              </a:lnSpc>
+            <a:pPr marL="0" indent="0">
               <a:buNone/>
             </a:pPr>
             <a:r>
@@ -9310,7 +9083,7 @@
           <a:bodyPr wrap="square" lIns="0" tIns="0" rIns="0" bIns="0" rtlCol="0" anchor="ctr"/>
           <a:lstStyle/>
           <a:p>
-            <a:pPr indent="0" marL="0">
+            <a:pPr marL="0" indent="0">
               <a:buNone/>
             </a:pPr>
             <a:r>
@@ -9349,7 +9122,7 @@
           <a:bodyPr wrap="square" lIns="0" tIns="0" rIns="0" bIns="0" rtlCol="0" anchor="ctr"/>
           <a:lstStyle/>
           <a:p>
-            <a:pPr indent="0" marL="0">
+            <a:pPr marL="0" indent="0">
               <a:buNone/>
             </a:pPr>
             <a:r>
@@ -9388,10 +9161,7 @@
           <a:bodyPr wrap="square" lIns="0" tIns="0" rIns="0" bIns="0" rtlCol="0" anchor="t"/>
           <a:lstStyle/>
           <a:p>
-            <a:pPr indent="0" marL="0">
-              <a:lnSpc>
-                <a:spcPct val="130000"/>
-              </a:lnSpc>
+            <a:pPr marL="0" indent="0">
               <a:buNone/>
             </a:pPr>
             <a:r>
@@ -9430,7 +9200,7 @@
           <a:bodyPr wrap="square" lIns="0" tIns="0" rIns="0" bIns="0" rtlCol="0" anchor="ctr"/>
           <a:lstStyle/>
           <a:p>
-            <a:pPr indent="0" marL="0">
+            <a:pPr marL="0" indent="0">
               <a:buNone/>
             </a:pPr>
             <a:r>
@@ -9469,7 +9239,7 @@
           <a:bodyPr wrap="square" lIns="0" tIns="0" rIns="0" bIns="0" rtlCol="0" anchor="ctr"/>
           <a:lstStyle/>
           <a:p>
-            <a:pPr indent="0" marL="0">
+            <a:pPr marL="0" indent="0">
               <a:buNone/>
             </a:pPr>
             <a:r>
@@ -9508,10 +9278,7 @@
           <a:bodyPr wrap="square" lIns="0" tIns="0" rIns="0" bIns="0" rtlCol="0" anchor="t"/>
           <a:lstStyle/>
           <a:p>
-            <a:pPr indent="0" marL="0">
-              <a:lnSpc>
-                <a:spcPct val="130000"/>
-              </a:lnSpc>
+            <a:pPr marL="0" indent="0">
               <a:buNone/>
             </a:pPr>
             <a:r>
@@ -9550,7 +9317,7 @@
           <a:bodyPr wrap="square" lIns="0" tIns="0" rIns="0" bIns="0" rtlCol="0" anchor="ctr"/>
           <a:lstStyle/>
           <a:p>
-            <a:pPr indent="0" marL="0">
+            <a:pPr marL="0" indent="0">
               <a:buNone/>
             </a:pPr>
             <a:r>
@@ -9589,7 +9356,7 @@
           <a:bodyPr wrap="square" lIns="0" tIns="0" rIns="0" bIns="0" rtlCol="0" anchor="ctr"/>
           <a:lstStyle/>
           <a:p>
-            <a:pPr indent="0" marL="0">
+            <a:pPr marL="0" indent="0">
               <a:buNone/>
             </a:pPr>
             <a:r>
@@ -9628,10 +9395,7 @@
           <a:bodyPr wrap="square" lIns="0" tIns="0" rIns="0" bIns="0" rtlCol="0" anchor="t"/>
           <a:lstStyle/>
           <a:p>
-            <a:pPr indent="0" marL="0">
-              <a:lnSpc>
-                <a:spcPct val="130000"/>
-              </a:lnSpc>
+            <a:pPr marL="0" indent="0">
               <a:buNone/>
             </a:pPr>
             <a:r>
@@ -9670,7 +9434,7 @@
           <a:bodyPr wrap="square" lIns="0" tIns="0" rIns="0" bIns="0" rtlCol="0" anchor="ctr"/>
           <a:lstStyle/>
           <a:p>
-            <a:pPr indent="0" marL="0">
+            <a:pPr marL="0" indent="0">
               <a:buNone/>
             </a:pPr>
             <a:r>
@@ -9709,7 +9473,7 @@
           <a:bodyPr wrap="square" lIns="0" tIns="0" rIns="0" bIns="0" rtlCol="0" anchor="ctr"/>
           <a:lstStyle/>
           <a:p>
-            <a:pPr indent="0" marL="0">
+            <a:pPr marL="0" indent="0">
               <a:buNone/>
             </a:pPr>
             <a:r>
@@ -9748,10 +9512,7 @@
           <a:bodyPr wrap="square" lIns="0" tIns="0" rIns="0" bIns="0" rtlCol="0" anchor="t"/>
           <a:lstStyle/>
           <a:p>
-            <a:pPr indent="0" marL="0">
-              <a:lnSpc>
-                <a:spcPct val="130000"/>
-              </a:lnSpc>
+            <a:pPr marL="0" indent="0">
               <a:buNone/>
             </a:pPr>
             <a:r>
@@ -9771,14 +9532,14 @@
       </p:sp>
       <p:pic>
         <p:nvPicPr>
-          <p:cNvPr id="22" name="Image 0" descr="C:\Code\Work\startuplab-partner-presentation\pptx-templates\media\logo-red.png">    </p:cNvPr>
+          <p:cNvPr id="22" name="Image 0" descr="C:\Code\Work\startuplab-partner-presentation\pptx-templates\media\logo-red.png"/>
           <p:cNvPicPr>
             <a:picLocks noChangeAspect="1"/>
           </p:cNvPicPr>
           <p:nvPr/>
         </p:nvPicPr>
         <p:blipFill>
-          <a:blip r:embed="rId1"/>
+          <a:blip r:embed="rId3"/>
           <a:stretch>
             <a:fillRect/>
           </a:stretch>
@@ -10094,4 +9855,319 @@
     </a:ext>
   </a:extLst>
 </a:theme>
+</file>
+
+<file path=ppt/theme/theme2.xml><?xml version="1.0" encoding="utf-8"?>
+<a:theme xmlns:a="http://schemas.openxmlformats.org/drawingml/2006/main" name="Office-tema">
+  <a:themeElements>
+    <a:clrScheme name="Office">
+      <a:dk1>
+        <a:sysClr val="windowText" lastClr="000000"/>
+      </a:dk1>
+      <a:lt1>
+        <a:sysClr val="window" lastClr="FFFFFF"/>
+      </a:lt1>
+      <a:dk2>
+        <a:srgbClr val="0E2841"/>
+      </a:dk2>
+      <a:lt2>
+        <a:srgbClr val="E8E8E8"/>
+      </a:lt2>
+      <a:accent1>
+        <a:srgbClr val="156082"/>
+      </a:accent1>
+      <a:accent2>
+        <a:srgbClr val="E97132"/>
+      </a:accent2>
+      <a:accent3>
+        <a:srgbClr val="196B24"/>
+      </a:accent3>
+      <a:accent4>
+        <a:srgbClr val="0F9ED5"/>
+      </a:accent4>
+      <a:accent5>
+        <a:srgbClr val="A02B93"/>
+      </a:accent5>
+      <a:accent6>
+        <a:srgbClr val="4EA72E"/>
+      </a:accent6>
+      <a:hlink>
+        <a:srgbClr val="467886"/>
+      </a:hlink>
+      <a:folHlink>
+        <a:srgbClr val="96607D"/>
+      </a:folHlink>
+    </a:clrScheme>
+    <a:fontScheme name="Office">
+      <a:majorFont>
+        <a:latin typeface="Aptos Display" panose="02110004020202020204"/>
+        <a:ea typeface=""/>
+        <a:cs typeface=""/>
+        <a:font script="Jpan" typeface="游ゴシック Light"/>
+        <a:font script="Hang" typeface="맑은 고딕"/>
+        <a:font script="Hans" typeface="等线 Light"/>
+        <a:font script="Hant" typeface="新細明體"/>
+        <a:font script="Arab" typeface="Times New Roman"/>
+        <a:font script="Hebr" typeface="Times New Roman"/>
+        <a:font script="Thai" typeface="Angsana New"/>
+        <a:font script="Ethi" typeface="Nyala"/>
+        <a:font script="Beng" typeface="Vrinda"/>
+        <a:font script="Gujr" typeface="Shruti"/>
+        <a:font script="Khmr" typeface="MoolBoran"/>
+        <a:font script="Knda" typeface="Tunga"/>
+        <a:font script="Guru" typeface="Raavi"/>
+        <a:font script="Cans" typeface="Euphemia"/>
+        <a:font script="Cher" typeface="Plantagenet Cherokee"/>
+        <a:font script="Yiii" typeface="Microsoft Yi Baiti"/>
+        <a:font script="Tibt" typeface="Microsoft Himalaya"/>
+        <a:font script="Thaa" typeface="MV Boli"/>
+        <a:font script="Deva" typeface="Mangal"/>
+        <a:font script="Telu" typeface="Gautami"/>
+        <a:font script="Taml" typeface="Latha"/>
+        <a:font script="Syrc" typeface="Estrangelo Edessa"/>
+        <a:font script="Orya" typeface="Kalinga"/>
+        <a:font script="Mlym" typeface="Kartika"/>
+        <a:font script="Laoo" typeface="DokChampa"/>
+        <a:font script="Sinh" typeface="Iskoola Pota"/>
+        <a:font script="Mong" typeface="Mongolian Baiti"/>
+        <a:font script="Viet" typeface="Times New Roman"/>
+        <a:font script="Uigh" typeface="Microsoft Uighur"/>
+        <a:font script="Geor" typeface="Sylfaen"/>
+        <a:font script="Armn" typeface="Arial"/>
+        <a:font script="Bugi" typeface="Leelawadee UI"/>
+        <a:font script="Bopo" typeface="Microsoft JhengHei"/>
+        <a:font script="Java" typeface="Javanese Text"/>
+        <a:font script="Lisu" typeface="Segoe UI"/>
+        <a:font script="Mymr" typeface="Myanmar Text"/>
+        <a:font script="Nkoo" typeface="Ebrima"/>
+        <a:font script="Olck" typeface="Nirmala UI"/>
+        <a:font script="Osma" typeface="Ebrima"/>
+        <a:font script="Phag" typeface="Phagspa"/>
+        <a:font script="Syrn" typeface="Estrangelo Edessa"/>
+        <a:font script="Syrj" typeface="Estrangelo Edessa"/>
+        <a:font script="Syre" typeface="Estrangelo Edessa"/>
+        <a:font script="Sora" typeface="Nirmala UI"/>
+        <a:font script="Tale" typeface="Microsoft Tai Le"/>
+        <a:font script="Talu" typeface="Microsoft New Tai Lue"/>
+        <a:font script="Tfng" typeface="Ebrima"/>
+      </a:majorFont>
+      <a:minorFont>
+        <a:latin typeface="Aptos" panose="02110004020202020204"/>
+        <a:ea typeface=""/>
+        <a:cs typeface=""/>
+        <a:font script="Jpan" typeface="游ゴシック"/>
+        <a:font script="Hang" typeface="맑은 고딕"/>
+        <a:font script="Hans" typeface="等线"/>
+        <a:font script="Hant" typeface="新細明體"/>
+        <a:font script="Arab" typeface="Arial"/>
+        <a:font script="Hebr" typeface="Arial"/>
+        <a:font script="Thai" typeface="Cordia New"/>
+        <a:font script="Ethi" typeface="Nyala"/>
+        <a:font script="Beng" typeface="Vrinda"/>
+        <a:font script="Gujr" typeface="Shruti"/>
+        <a:font script="Khmr" typeface="DaunPenh"/>
+        <a:font script="Knda" typeface="Tunga"/>
+        <a:font script="Guru" typeface="Raavi"/>
+        <a:font script="Cans" typeface="Euphemia"/>
+        <a:font script="Cher" typeface="Plantagenet Cherokee"/>
+        <a:font script="Yiii" typeface="Microsoft Yi Baiti"/>
+        <a:font script="Tibt" typeface="Microsoft Himalaya"/>
+        <a:font script="Thaa" typeface="MV Boli"/>
+        <a:font script="Deva" typeface="Mangal"/>
+        <a:font script="Telu" typeface="Gautami"/>
+        <a:font script="Taml" typeface="Latha"/>
+        <a:font script="Syrc" typeface="Estrangelo Edessa"/>
+        <a:font script="Orya" typeface="Kalinga"/>
+        <a:font script="Mlym" typeface="Kartika"/>
+        <a:font script="Laoo" typeface="DokChampa"/>
+        <a:font script="Sinh" typeface="Iskoola Pota"/>
+        <a:font script="Mong" typeface="Mongolian Baiti"/>
+        <a:font script="Viet" typeface="Arial"/>
+        <a:font script="Uigh" typeface="Microsoft Uighur"/>
+        <a:font script="Geor" typeface="Sylfaen"/>
+        <a:font script="Armn" typeface="Arial"/>
+        <a:font script="Bugi" typeface="Leelawadee UI"/>
+        <a:font script="Bopo" typeface="Microsoft JhengHei"/>
+        <a:font script="Java" typeface="Javanese Text"/>
+        <a:font script="Lisu" typeface="Segoe UI"/>
+        <a:font script="Mymr" typeface="Myanmar Text"/>
+        <a:font script="Nkoo" typeface="Ebrima"/>
+        <a:font script="Olck" typeface="Nirmala UI"/>
+        <a:font script="Osma" typeface="Ebrima"/>
+        <a:font script="Phag" typeface="Phagspa"/>
+        <a:font script="Syrn" typeface="Estrangelo Edessa"/>
+        <a:font script="Syrj" typeface="Estrangelo Edessa"/>
+        <a:font script="Syre" typeface="Estrangelo Edessa"/>
+        <a:font script="Sora" typeface="Nirmala UI"/>
+        <a:font script="Tale" typeface="Microsoft Tai Le"/>
+        <a:font script="Talu" typeface="Microsoft New Tai Lue"/>
+        <a:font script="Tfng" typeface="Ebrima"/>
+      </a:minorFont>
+    </a:fontScheme>
+    <a:fmtScheme name="Office">
+      <a:fillStyleLst>
+        <a:solidFill>
+          <a:schemeClr val="phClr"/>
+        </a:solidFill>
+        <a:gradFill rotWithShape="1">
+          <a:gsLst>
+            <a:gs pos="0">
+              <a:schemeClr val="phClr">
+                <a:lumMod val="110000"/>
+                <a:satMod val="105000"/>
+                <a:tint val="67000"/>
+              </a:schemeClr>
+            </a:gs>
+            <a:gs pos="50000">
+              <a:schemeClr val="phClr">
+                <a:lumMod val="105000"/>
+                <a:satMod val="103000"/>
+                <a:tint val="73000"/>
+              </a:schemeClr>
+            </a:gs>
+            <a:gs pos="100000">
+              <a:schemeClr val="phClr">
+                <a:lumMod val="105000"/>
+                <a:satMod val="109000"/>
+                <a:tint val="81000"/>
+              </a:schemeClr>
+            </a:gs>
+          </a:gsLst>
+          <a:lin ang="5400000" scaled="0"/>
+        </a:gradFill>
+        <a:gradFill rotWithShape="1">
+          <a:gsLst>
+            <a:gs pos="0">
+              <a:schemeClr val="phClr">
+                <a:satMod val="103000"/>
+                <a:lumMod val="102000"/>
+                <a:tint val="94000"/>
+              </a:schemeClr>
+            </a:gs>
+            <a:gs pos="50000">
+              <a:schemeClr val="phClr">
+                <a:satMod val="110000"/>
+                <a:lumMod val="100000"/>
+                <a:shade val="100000"/>
+              </a:schemeClr>
+            </a:gs>
+            <a:gs pos="100000">
+              <a:schemeClr val="phClr">
+                <a:lumMod val="99000"/>
+                <a:satMod val="120000"/>
+                <a:shade val="78000"/>
+              </a:schemeClr>
+            </a:gs>
+          </a:gsLst>
+          <a:lin ang="5400000" scaled="0"/>
+        </a:gradFill>
+      </a:fillStyleLst>
+      <a:lnStyleLst>
+        <a:ln w="12700" cap="flat" cmpd="sng" algn="ctr">
+          <a:solidFill>
+            <a:schemeClr val="phClr"/>
+          </a:solidFill>
+          <a:prstDash val="solid"/>
+          <a:miter lim="800000"/>
+        </a:ln>
+        <a:ln w="19050" cap="flat" cmpd="sng" algn="ctr">
+          <a:solidFill>
+            <a:schemeClr val="phClr"/>
+          </a:solidFill>
+          <a:prstDash val="solid"/>
+          <a:miter lim="800000"/>
+        </a:ln>
+        <a:ln w="25400" cap="flat" cmpd="sng" algn="ctr">
+          <a:solidFill>
+            <a:schemeClr val="phClr"/>
+          </a:solidFill>
+          <a:prstDash val="solid"/>
+          <a:miter lim="800000"/>
+        </a:ln>
+      </a:lnStyleLst>
+      <a:effectStyleLst>
+        <a:effectStyle>
+          <a:effectLst/>
+        </a:effectStyle>
+        <a:effectStyle>
+          <a:effectLst/>
+        </a:effectStyle>
+        <a:effectStyle>
+          <a:effectLst>
+            <a:outerShdw blurRad="57150" dist="19050" dir="5400000" algn="ctr" rotWithShape="0">
+              <a:srgbClr val="000000">
+                <a:alpha val="63000"/>
+              </a:srgbClr>
+            </a:outerShdw>
+          </a:effectLst>
+        </a:effectStyle>
+      </a:effectStyleLst>
+      <a:bgFillStyleLst>
+        <a:solidFill>
+          <a:schemeClr val="phClr"/>
+        </a:solidFill>
+        <a:solidFill>
+          <a:schemeClr val="phClr">
+            <a:tint val="95000"/>
+            <a:satMod val="170000"/>
+          </a:schemeClr>
+        </a:solidFill>
+        <a:gradFill rotWithShape="1">
+          <a:gsLst>
+            <a:gs pos="0">
+              <a:schemeClr val="phClr">
+                <a:tint val="93000"/>
+                <a:satMod val="150000"/>
+                <a:shade val="98000"/>
+                <a:lumMod val="102000"/>
+              </a:schemeClr>
+            </a:gs>
+            <a:gs pos="50000">
+              <a:schemeClr val="phClr">
+                <a:tint val="98000"/>
+                <a:satMod val="130000"/>
+                <a:shade val="90000"/>
+                <a:lumMod val="103000"/>
+              </a:schemeClr>
+            </a:gs>
+            <a:gs pos="100000">
+              <a:schemeClr val="phClr">
+                <a:shade val="63000"/>
+                <a:satMod val="120000"/>
+              </a:schemeClr>
+            </a:gs>
+          </a:gsLst>
+          <a:lin ang="5400000" scaled="0"/>
+        </a:gradFill>
+      </a:bgFillStyleLst>
+    </a:fmtScheme>
+  </a:themeElements>
+  <a:objectDefaults>
+    <a:lnDef>
+      <a:spPr/>
+      <a:bodyPr/>
+      <a:lstStyle/>
+      <a:style>
+        <a:lnRef idx="2">
+          <a:schemeClr val="accent1"/>
+        </a:lnRef>
+        <a:fillRef idx="0">
+          <a:schemeClr val="accent1"/>
+        </a:fillRef>
+        <a:effectRef idx="1">
+          <a:schemeClr val="accent1"/>
+        </a:effectRef>
+        <a:fontRef idx="minor">
+          <a:schemeClr val="tx1"/>
+        </a:fontRef>
+      </a:style>
+    </a:lnDef>
+  </a:objectDefaults>
+  <a:extraClrSchemeLst/>
+  <a:extLst>
+    <a:ext uri="{05A4C25C-085E-4340-85A3-A5531E510DB2}">
+      <thm15:themeFamily xmlns:thm15="http://schemas.microsoft.com/office/thememl/2012/main" name="Office Theme" id="{2E142A2C-CD16-42D6-873A-C26D2A0506FA}" vid="{1BDDFF52-6CD6-40A5-AB3C-68EB2F1E4D0A}"/>
+    </a:ext>
+  </a:extLst>
+</a:theme>
 </file>
</xml_diff>